<commit_message>
design: convert PowerPoint presentation deck to a clean, bright, light-themed executive design system
</commit_message>
<xml_diff>
--- a/document/PRESENTATION_DECK_SLIDES.pptx
+++ b/document/PRESENTATION_DECK_SLIDES.pptx
@@ -3120,7 +3120,7 @@
             <a:avLst/>
           </a:prstGeom>
           <a:solidFill>
-            <a:srgbClr val="0F172A"/>
+            <a:srgbClr val="F8FAFC"/>
           </a:solidFill>
           <a:ln>
             <a:noFill/>
@@ -3163,7 +3163,7 @@
             <a:avLst/>
           </a:prstGeom>
           <a:solidFill>
-            <a:srgbClr val="6366F1"/>
+            <a:srgbClr val="4F46E5"/>
           </a:solidFill>
           <a:ln>
             <a:noFill/>
@@ -3199,18 +3199,18 @@
         </p:nvSpPr>
         <p:spPr>
           <a:xfrm>
-            <a:off x="914400" y="731520"/>
+            <a:off x="914400" y="685800"/>
             <a:ext cx="2926080" cy="457200"/>
           </a:xfrm>
           <a:prstGeom prst="roundRect">
             <a:avLst/>
           </a:prstGeom>
           <a:solidFill>
-            <a:srgbClr val="334155"/>
+            <a:srgbClr val="EEF2FF"/>
           </a:solidFill>
           <a:ln w="19050">
             <a:solidFill>
-              <a:srgbClr val="6366F1"/>
+              <a:srgbClr val="4F46E5"/>
             </a:solidFill>
           </a:ln>
         </p:spPr>
@@ -3235,7 +3235,7 @@
             <a:pPr algn="ctr">
               <a:defRPr sz="1100" b="1">
                 <a:solidFill>
-                  <a:srgbClr val="38BDF8"/>
+                  <a:srgbClr val="4F46E5"/>
                 </a:solidFill>
               </a:defRPr>
             </a:pPr>
@@ -3253,18 +3253,18 @@
         </p:nvSpPr>
         <p:spPr>
           <a:xfrm>
-            <a:off x="914400" y="1371600"/>
-            <a:ext cx="5669280" cy="4846320"/>
+            <a:off x="914400" y="1325880"/>
+            <a:ext cx="5669280" cy="4983480"/>
           </a:xfrm>
           <a:prstGeom prst="roundRect">
             <a:avLst/>
           </a:prstGeom>
           <a:solidFill>
-            <a:srgbClr val="1E293B"/>
-          </a:solidFill>
-          <a:ln w="25400">
+            <a:srgbClr val="FFFFFF"/>
+          </a:solidFill>
+          <a:ln w="19050">
             <a:solidFill>
-              <a:srgbClr val="6366F1"/>
+              <a:srgbClr val="E2E8F0"/>
             </a:solidFill>
           </a:ln>
         </p:spPr>
@@ -3289,7 +3289,7 @@
             <a:pPr algn="ctr">
               <a:defRPr sz="2800" b="1">
                 <a:solidFill>
-                  <a:srgbClr val="F8FAFC"/>
+                  <a:srgbClr val="1E293B"/>
                 </a:solidFill>
               </a:defRPr>
             </a:pPr>
@@ -3304,7 +3304,7 @@
               </a:spcBef>
               <a:defRPr sz="1300">
                 <a:solidFill>
-                  <a:srgbClr val="A855F7"/>
+                  <a:srgbClr val="2563EB"/>
                 </a:solidFill>
               </a:defRPr>
             </a:pPr>
@@ -3320,7 +3320,7 @@
               </a:spcBef>
               <a:defRPr sz="1200" b="1">
                 <a:solidFill>
-                  <a:srgbClr val="34D399"/>
+                  <a:srgbClr val="10B981"/>
                 </a:solidFill>
               </a:defRPr>
             </a:pPr>
@@ -3335,7 +3335,7 @@
               </a:spcBef>
               <a:defRPr sz="1150">
                 <a:solidFill>
-                  <a:srgbClr val="F8FAFC"/>
+                  <a:srgbClr val="334155"/>
                 </a:solidFill>
               </a:defRPr>
             </a:pPr>
@@ -3350,7 +3350,7 @@
               </a:spcBef>
               <a:defRPr sz="1150">
                 <a:solidFill>
-                  <a:srgbClr val="F8FAFC"/>
+                  <a:srgbClr val="334155"/>
                 </a:solidFill>
               </a:defRPr>
             </a:pPr>
@@ -3365,7 +3365,7 @@
               </a:spcBef>
               <a:defRPr sz="1150">
                 <a:solidFill>
-                  <a:srgbClr val="F8FAFC"/>
+                  <a:srgbClr val="334155"/>
                 </a:solidFill>
               </a:defRPr>
             </a:pPr>
@@ -3383,18 +3383,18 @@
         </p:nvSpPr>
         <p:spPr>
           <a:xfrm>
-            <a:off x="6858000" y="1371600"/>
-            <a:ext cx="4389120" cy="4846320"/>
+            <a:off x="6858000" y="1325880"/>
+            <a:ext cx="4389120" cy="4983480"/>
           </a:xfrm>
           <a:prstGeom prst="roundRect">
             <a:avLst/>
           </a:prstGeom>
           <a:solidFill>
-            <a:srgbClr val="0F172A"/>
+            <a:srgbClr val="EEF2FF"/>
           </a:solidFill>
           <a:ln w="25400">
             <a:solidFill>
-              <a:srgbClr val="A855F7"/>
+              <a:srgbClr val="4F46E5"/>
             </a:solidFill>
           </a:ln>
         </p:spPr>
@@ -3419,7 +3419,7 @@
             <a:pPr algn="ctr">
               <a:defRPr sz="1300" b="1">
                 <a:solidFill>
-                  <a:srgbClr val="6366F1"/>
+                  <a:srgbClr val="4F46E5"/>
                 </a:solidFill>
               </a:defRPr>
             </a:pPr>
@@ -3465,7 +3465,7 @@
             <a:avLst/>
           </a:prstGeom>
           <a:solidFill>
-            <a:srgbClr val="0F172A"/>
+            <a:srgbClr val="F8FAFC"/>
           </a:solidFill>
           <a:ln>
             <a:noFill/>
@@ -3508,7 +3508,7 @@
             <a:avLst/>
           </a:prstGeom>
           <a:solidFill>
-            <a:srgbClr val="6366F1"/>
+            <a:srgbClr val="4F46E5"/>
           </a:solidFill>
           <a:ln>
             <a:noFill/>
@@ -3544,96 +3544,94 @@
         </p:nvSpPr>
         <p:spPr>
           <a:xfrm>
-            <a:off x="731520" y="457200"/>
-            <a:ext cx="10728655" cy="1051560"/>
+            <a:off x="731520" y="411480"/>
+            <a:ext cx="10728655" cy="1097280"/>
           </a:xfrm>
           <a:prstGeom prst="roundRect">
             <a:avLst/>
           </a:prstGeom>
           <a:solidFill>
-            <a:srgbClr val="1E293B"/>
+            <a:srgbClr val="4F46E5"/>
+          </a:solidFill>
+          <a:ln>
+            <a:noFill/>
+          </a:ln>
+        </p:spPr>
+        <p:style>
+          <a:lnRef idx="1">
+            <a:schemeClr val="accent1"/>
+          </a:lnRef>
+          <a:fillRef idx="3">
+            <a:schemeClr val="accent1"/>
+          </a:fillRef>
+          <a:effectRef idx="2">
+            <a:schemeClr val="accent1"/>
+          </a:effectRef>
+          <a:fontRef idx="minor">
+            <a:schemeClr val="lt1"/>
+          </a:fontRef>
+        </p:style>
+        <p:txBody>
+          <a:bodyPr rtlCol="0" anchor="ctr" wrap="square"/>
+          <a:lstStyle/>
+          <a:p>
+            <a:pPr algn="ctr">
+              <a:defRPr sz="1000" b="1">
+                <a:solidFill>
+                  <a:srgbClr val="C7D2FE"/>
+                </a:solidFill>
+              </a:defRPr>
+            </a:pPr>
+            <a:r>
+              <a:t>[ WHATSAPP INTEGRATION ] — SLIDE 10</a:t>
+            </a:r>
+          </a:p>
+          <a:p>
+            <a:pPr>
+              <a:defRPr sz="1900" b="1">
+                <a:solidFill>
+                  <a:srgbClr val="FFFFFF"/>
+                </a:solidFill>
+              </a:defRPr>
+            </a:pPr>
+            <a:r>
+              <a:t>Multi-Channel WhatsApp Automated Broadcasting (Green API)</a:t>
+            </a:r>
+          </a:p>
+          <a:p>
+            <a:pPr>
+              <a:defRPr sz="1150">
+                <a:solidFill>
+                  <a:srgbClr val="E0E7FF"/>
+                </a:solidFill>
+              </a:defRPr>
+            </a:pPr>
+            <a:r>
+              <a:t>Background Messaging &amp; 1-Click Web Links</a:t>
+            </a:r>
+          </a:p>
+        </p:txBody>
+      </p:sp>
+      <p:sp>
+        <p:nvSpPr>
+          <p:cNvPr id="5" name="Rounded Rectangle 4"/>
+          <p:cNvSpPr/>
+          <p:nvPr/>
+        </p:nvSpPr>
+        <p:spPr>
+          <a:xfrm>
+            <a:off x="731520" y="1645920"/>
+            <a:ext cx="5486400" cy="4754880"/>
+          </a:xfrm>
+          <a:prstGeom prst="roundRect">
+            <a:avLst/>
+          </a:prstGeom>
+          <a:solidFill>
+            <a:srgbClr val="FFFFFF"/>
           </a:solidFill>
           <a:ln w="19050">
             <a:solidFill>
-              <a:srgbClr val="6366F1"/>
-            </a:solidFill>
-          </a:ln>
-        </p:spPr>
-        <p:style>
-          <a:lnRef idx="1">
-            <a:schemeClr val="accent1"/>
-          </a:lnRef>
-          <a:fillRef idx="3">
-            <a:schemeClr val="accent1"/>
-          </a:fillRef>
-          <a:effectRef idx="2">
-            <a:schemeClr val="accent1"/>
-          </a:effectRef>
-          <a:fontRef idx="minor">
-            <a:schemeClr val="lt1"/>
-          </a:fontRef>
-        </p:style>
-        <p:txBody>
-          <a:bodyPr rtlCol="0" anchor="ctr" wrap="square"/>
-          <a:lstStyle/>
-          <a:p>
-            <a:pPr algn="ctr">
-              <a:defRPr sz="1000" b="1">
-                <a:solidFill>
-                  <a:srgbClr val="38BDF8"/>
-                </a:solidFill>
-              </a:defRPr>
-            </a:pPr>
-            <a:r>
-              <a:t>[ WHATSAPP INTEGRATION ] — SLIDE 10</a:t>
-            </a:r>
-          </a:p>
-          <a:p>
-            <a:pPr>
-              <a:defRPr sz="1900" b="1">
-                <a:solidFill>
-                  <a:srgbClr val="F8FAFC"/>
-                </a:solidFill>
-              </a:defRPr>
-            </a:pPr>
-            <a:r>
-              <a:t>Multi-Channel WhatsApp Automated Broadcasting (Green API)</a:t>
-            </a:r>
-          </a:p>
-          <a:p>
-            <a:pPr>
-              <a:defRPr sz="1150">
-                <a:solidFill>
-                  <a:srgbClr val="A855F7"/>
-                </a:solidFill>
-              </a:defRPr>
-            </a:pPr>
-            <a:r>
-              <a:t>Background Messaging &amp; 1-Click Web Links</a:t>
-            </a:r>
-          </a:p>
-        </p:txBody>
-      </p:sp>
-      <p:sp>
-        <p:nvSpPr>
-          <p:cNvPr id="5" name="Rounded Rectangle 4"/>
-          <p:cNvSpPr/>
-          <p:nvPr/>
-        </p:nvSpPr>
-        <p:spPr>
-          <a:xfrm>
-            <a:off x="731520" y="1691640"/>
-            <a:ext cx="5486400" cy="4709160"/>
-          </a:xfrm>
-          <a:prstGeom prst="roundRect">
-            <a:avLst/>
-          </a:prstGeom>
-          <a:solidFill>
-            <a:srgbClr val="1E293B"/>
-          </a:solidFill>
-          <a:ln w="12700">
-            <a:solidFill>
-              <a:srgbClr val="334155"/>
+              <a:srgbClr val="E2E8F0"/>
             </a:solidFill>
           </a:ln>
         </p:spPr>
@@ -3658,7 +3656,7 @@
             <a:pPr algn="ctr">
               <a:defRPr sz="1200" b="1">
                 <a:solidFill>
-                  <a:srgbClr val="FBBF24"/>
+                  <a:srgbClr val="2563EB"/>
                 </a:solidFill>
               </a:defRPr>
             </a:pPr>
@@ -3673,7 +3671,7 @@
               </a:spcBef>
               <a:defRPr sz="1150">
                 <a:solidFill>
-                  <a:srgbClr val="F8FAFC"/>
+                  <a:srgbClr val="334155"/>
                 </a:solidFill>
               </a:defRPr>
             </a:pPr>
@@ -3688,7 +3686,7 @@
               </a:spcBef>
               <a:defRPr sz="1150">
                 <a:solidFill>
-                  <a:srgbClr val="F8FAFC"/>
+                  <a:srgbClr val="334155"/>
                 </a:solidFill>
               </a:defRPr>
             </a:pPr>
@@ -3703,7 +3701,7 @@
               </a:spcBef>
               <a:defRPr sz="1150">
                 <a:solidFill>
-                  <a:srgbClr val="F8FAFC"/>
+                  <a:srgbClr val="334155"/>
                 </a:solidFill>
               </a:defRPr>
             </a:pPr>
@@ -3721,18 +3719,18 @@
         </p:nvSpPr>
         <p:spPr>
           <a:xfrm>
-            <a:off x="6400800" y="1691640"/>
-            <a:ext cx="5059375" cy="4709160"/>
+            <a:off x="6400800" y="1645920"/>
+            <a:ext cx="5059375" cy="4754880"/>
           </a:xfrm>
           <a:prstGeom prst="roundRect">
             <a:avLst/>
           </a:prstGeom>
           <a:solidFill>
-            <a:srgbClr val="1E293B"/>
+            <a:srgbClr val="FFFFFF"/>
           </a:solidFill>
           <a:ln w="25400">
             <a:solidFill>
-              <a:srgbClr val="6366F1"/>
+              <a:srgbClr val="4F46E5"/>
             </a:solidFill>
           </a:ln>
         </p:spPr>
@@ -3766,18 +3764,18 @@
         </p:nvSpPr>
         <p:spPr>
           <a:xfrm>
-            <a:off x="6537960" y="1828800"/>
-            <a:ext cx="4785055" cy="4434840"/>
+            <a:off x="6537960" y="1783080"/>
+            <a:ext cx="4785055" cy="4480560"/>
           </a:xfrm>
           <a:prstGeom prst="roundRect">
             <a:avLst/>
           </a:prstGeom>
           <a:solidFill>
-            <a:srgbClr val="0F172A"/>
+            <a:srgbClr val="EEF2FF"/>
           </a:solidFill>
           <a:ln w="12700">
             <a:solidFill>
-              <a:srgbClr val="A855F7"/>
+              <a:srgbClr val="E2E8F0"/>
             </a:solidFill>
           </a:ln>
         </p:spPr>
@@ -3802,7 +3800,7 @@
             <a:pPr algn="ctr">
               <a:defRPr sz="1300" b="1">
                 <a:solidFill>
-                  <a:srgbClr val="6366F1"/>
+                  <a:srgbClr val="4F46E5"/>
                 </a:solidFill>
               </a:defRPr>
             </a:pPr>
@@ -3848,7 +3846,7 @@
             <a:avLst/>
           </a:prstGeom>
           <a:solidFill>
-            <a:srgbClr val="0F172A"/>
+            <a:srgbClr val="F8FAFC"/>
           </a:solidFill>
           <a:ln>
             <a:noFill/>
@@ -3891,7 +3889,7 @@
             <a:avLst/>
           </a:prstGeom>
           <a:solidFill>
-            <a:srgbClr val="6366F1"/>
+            <a:srgbClr val="4F46E5"/>
           </a:solidFill>
           <a:ln>
             <a:noFill/>
@@ -3927,96 +3925,94 @@
         </p:nvSpPr>
         <p:spPr>
           <a:xfrm>
-            <a:off x="731520" y="457200"/>
-            <a:ext cx="10728655" cy="1051560"/>
+            <a:off x="731520" y="411480"/>
+            <a:ext cx="10728655" cy="1097280"/>
           </a:xfrm>
           <a:prstGeom prst="roundRect">
             <a:avLst/>
           </a:prstGeom>
           <a:solidFill>
-            <a:srgbClr val="1E293B"/>
+            <a:srgbClr val="4F46E5"/>
+          </a:solidFill>
+          <a:ln>
+            <a:noFill/>
+          </a:ln>
+        </p:spPr>
+        <p:style>
+          <a:lnRef idx="1">
+            <a:schemeClr val="accent1"/>
+          </a:lnRef>
+          <a:fillRef idx="3">
+            <a:schemeClr val="accent1"/>
+          </a:fillRef>
+          <a:effectRef idx="2">
+            <a:schemeClr val="accent1"/>
+          </a:effectRef>
+          <a:fontRef idx="minor">
+            <a:schemeClr val="lt1"/>
+          </a:fontRef>
+        </p:style>
+        <p:txBody>
+          <a:bodyPr rtlCol="0" anchor="ctr" wrap="square"/>
+          <a:lstStyle/>
+          <a:p>
+            <a:pPr algn="ctr">
+              <a:defRPr sz="1000" b="1">
+                <a:solidFill>
+                  <a:srgbClr val="C7D2FE"/>
+                </a:solidFill>
+              </a:defRPr>
+            </a:pPr>
+            <a:r>
+              <a:t>[ ATTENDEE MANAGEMENT ] — SLIDE 11</a:t>
+            </a:r>
+          </a:p>
+          <a:p>
+            <a:pPr>
+              <a:defRPr sz="1900" b="1">
+                <a:solidFill>
+                  <a:srgbClr val="FFFFFF"/>
+                </a:solidFill>
+              </a:defRPr>
+            </a:pPr>
+            <a:r>
+              <a:t>Edit Participants on Active Meetings</a:t>
+            </a:r>
+          </a:p>
+          <a:p>
+            <a:pPr>
+              <a:defRPr sz="1150">
+                <a:solidFill>
+                  <a:srgbClr val="E0E7FF"/>
+                </a:solidFill>
+              </a:defRPr>
+            </a:pPr>
+            <a:r>
+              <a:t>Dynamic Member Management for Managers &amp; Admins</a:t>
+            </a:r>
+          </a:p>
+        </p:txBody>
+      </p:sp>
+      <p:sp>
+        <p:nvSpPr>
+          <p:cNvPr id="5" name="Rounded Rectangle 4"/>
+          <p:cNvSpPr/>
+          <p:nvPr/>
+        </p:nvSpPr>
+        <p:spPr>
+          <a:xfrm>
+            <a:off x="731520" y="1645920"/>
+            <a:ext cx="5486400" cy="4754880"/>
+          </a:xfrm>
+          <a:prstGeom prst="roundRect">
+            <a:avLst/>
+          </a:prstGeom>
+          <a:solidFill>
+            <a:srgbClr val="FFFFFF"/>
           </a:solidFill>
           <a:ln w="19050">
             <a:solidFill>
-              <a:srgbClr val="6366F1"/>
-            </a:solidFill>
-          </a:ln>
-        </p:spPr>
-        <p:style>
-          <a:lnRef idx="1">
-            <a:schemeClr val="accent1"/>
-          </a:lnRef>
-          <a:fillRef idx="3">
-            <a:schemeClr val="accent1"/>
-          </a:fillRef>
-          <a:effectRef idx="2">
-            <a:schemeClr val="accent1"/>
-          </a:effectRef>
-          <a:fontRef idx="minor">
-            <a:schemeClr val="lt1"/>
-          </a:fontRef>
-        </p:style>
-        <p:txBody>
-          <a:bodyPr rtlCol="0" anchor="ctr" wrap="square"/>
-          <a:lstStyle/>
-          <a:p>
-            <a:pPr algn="ctr">
-              <a:defRPr sz="1000" b="1">
-                <a:solidFill>
-                  <a:srgbClr val="38BDF8"/>
-                </a:solidFill>
-              </a:defRPr>
-            </a:pPr>
-            <a:r>
-              <a:t>[ ATTENDEE MANAGEMENT ] — SLIDE 11</a:t>
-            </a:r>
-          </a:p>
-          <a:p>
-            <a:pPr>
-              <a:defRPr sz="1900" b="1">
-                <a:solidFill>
-                  <a:srgbClr val="F8FAFC"/>
-                </a:solidFill>
-              </a:defRPr>
-            </a:pPr>
-            <a:r>
-              <a:t>Edit Participants on Active Meetings</a:t>
-            </a:r>
-          </a:p>
-          <a:p>
-            <a:pPr>
-              <a:defRPr sz="1150">
-                <a:solidFill>
-                  <a:srgbClr val="A855F7"/>
-                </a:solidFill>
-              </a:defRPr>
-            </a:pPr>
-            <a:r>
-              <a:t>Dynamic Member Management for Managers &amp; Admins</a:t>
-            </a:r>
-          </a:p>
-        </p:txBody>
-      </p:sp>
-      <p:sp>
-        <p:nvSpPr>
-          <p:cNvPr id="5" name="Rounded Rectangle 4"/>
-          <p:cNvSpPr/>
-          <p:nvPr/>
-        </p:nvSpPr>
-        <p:spPr>
-          <a:xfrm>
-            <a:off x="731520" y="1691640"/>
-            <a:ext cx="5486400" cy="4709160"/>
-          </a:xfrm>
-          <a:prstGeom prst="roundRect">
-            <a:avLst/>
-          </a:prstGeom>
-          <a:solidFill>
-            <a:srgbClr val="1E293B"/>
-          </a:solidFill>
-          <a:ln w="12700">
-            <a:solidFill>
-              <a:srgbClr val="334155"/>
+              <a:srgbClr val="E2E8F0"/>
             </a:solidFill>
           </a:ln>
         </p:spPr>
@@ -4041,7 +4037,7 @@
             <a:pPr algn="ctr">
               <a:defRPr sz="1200" b="1">
                 <a:solidFill>
-                  <a:srgbClr val="FBBF24"/>
+                  <a:srgbClr val="2563EB"/>
                 </a:solidFill>
               </a:defRPr>
             </a:pPr>
@@ -4056,7 +4052,7 @@
               </a:spcBef>
               <a:defRPr sz="1150">
                 <a:solidFill>
-                  <a:srgbClr val="F8FAFC"/>
+                  <a:srgbClr val="334155"/>
                 </a:solidFill>
               </a:defRPr>
             </a:pPr>
@@ -4071,7 +4067,7 @@
               </a:spcBef>
               <a:defRPr sz="1150">
                 <a:solidFill>
-                  <a:srgbClr val="F8FAFC"/>
+                  <a:srgbClr val="334155"/>
                 </a:solidFill>
               </a:defRPr>
             </a:pPr>
@@ -4086,7 +4082,7 @@
               </a:spcBef>
               <a:defRPr sz="1150">
                 <a:solidFill>
-                  <a:srgbClr val="F8FAFC"/>
+                  <a:srgbClr val="334155"/>
                 </a:solidFill>
               </a:defRPr>
             </a:pPr>
@@ -4104,18 +4100,18 @@
         </p:nvSpPr>
         <p:spPr>
           <a:xfrm>
-            <a:off x="6400800" y="1691640"/>
-            <a:ext cx="5059375" cy="4709160"/>
+            <a:off x="6400800" y="1645920"/>
+            <a:ext cx="5059375" cy="4754880"/>
           </a:xfrm>
           <a:prstGeom prst="roundRect">
             <a:avLst/>
           </a:prstGeom>
           <a:solidFill>
-            <a:srgbClr val="1E293B"/>
+            <a:srgbClr val="FFFFFF"/>
           </a:solidFill>
           <a:ln w="25400">
             <a:solidFill>
-              <a:srgbClr val="6366F1"/>
+              <a:srgbClr val="4F46E5"/>
             </a:solidFill>
           </a:ln>
         </p:spPr>
@@ -4149,18 +4145,18 @@
         </p:nvSpPr>
         <p:spPr>
           <a:xfrm>
-            <a:off x="6537960" y="1828800"/>
-            <a:ext cx="4785055" cy="4434840"/>
+            <a:off x="6537960" y="1783080"/>
+            <a:ext cx="4785055" cy="4480560"/>
           </a:xfrm>
           <a:prstGeom prst="roundRect">
             <a:avLst/>
           </a:prstGeom>
           <a:solidFill>
-            <a:srgbClr val="0F172A"/>
+            <a:srgbClr val="EEF2FF"/>
           </a:solidFill>
           <a:ln w="12700">
             <a:solidFill>
-              <a:srgbClr val="A855F7"/>
+              <a:srgbClr val="E2E8F0"/>
             </a:solidFill>
           </a:ln>
         </p:spPr>
@@ -4185,7 +4181,7 @@
             <a:pPr algn="ctr">
               <a:defRPr sz="1300" b="1">
                 <a:solidFill>
-                  <a:srgbClr val="6366F1"/>
+                  <a:srgbClr val="4F46E5"/>
                 </a:solidFill>
               </a:defRPr>
             </a:pPr>
@@ -4231,7 +4227,7 @@
             <a:avLst/>
           </a:prstGeom>
           <a:solidFill>
-            <a:srgbClr val="0F172A"/>
+            <a:srgbClr val="F8FAFC"/>
           </a:solidFill>
           <a:ln>
             <a:noFill/>
@@ -4274,7 +4270,7 @@
             <a:avLst/>
           </a:prstGeom>
           <a:solidFill>
-            <a:srgbClr val="6366F1"/>
+            <a:srgbClr val="4F46E5"/>
           </a:solidFill>
           <a:ln>
             <a:noFill/>
@@ -4310,96 +4306,94 @@
         </p:nvSpPr>
         <p:spPr>
           <a:xfrm>
-            <a:off x="731520" y="457200"/>
-            <a:ext cx="10728655" cy="1051560"/>
+            <a:off x="731520" y="411480"/>
+            <a:ext cx="10728655" cy="1097280"/>
           </a:xfrm>
           <a:prstGeom prst="roundRect">
             <a:avLst/>
           </a:prstGeom>
           <a:solidFill>
-            <a:srgbClr val="1E293B"/>
+            <a:srgbClr val="4F46E5"/>
+          </a:solidFill>
+          <a:ln>
+            <a:noFill/>
+          </a:ln>
+        </p:spPr>
+        <p:style>
+          <a:lnRef idx="1">
+            <a:schemeClr val="accent1"/>
+          </a:lnRef>
+          <a:fillRef idx="3">
+            <a:schemeClr val="accent1"/>
+          </a:fillRef>
+          <a:effectRef idx="2">
+            <a:schemeClr val="accent1"/>
+          </a:effectRef>
+          <a:fontRef idx="minor">
+            <a:schemeClr val="lt1"/>
+          </a:fontRef>
+        </p:style>
+        <p:txBody>
+          <a:bodyPr rtlCol="0" anchor="ctr" wrap="square"/>
+          <a:lstStyle/>
+          <a:p>
+            <a:pPr algn="ctr">
+              <a:defRPr sz="1000" b="1">
+                <a:solidFill>
+                  <a:srgbClr val="C7D2FE"/>
+                </a:solidFill>
+              </a:defRPr>
+            </a:pPr>
+            <a:r>
+              <a:t>[ MANAGER SUITE ] — SLIDE 12</a:t>
+            </a:r>
+          </a:p>
+          <a:p>
+            <a:pPr>
+              <a:defRPr sz="1900" b="1">
+                <a:solidFill>
+                  <a:srgbClr val="FFFFFF"/>
+                </a:solidFill>
+              </a:defRPr>
+            </a:pPr>
+            <a:r>
+              <a:t>Manager Approval Suite &amp; Priority Requests</a:t>
+            </a:r>
+          </a:p>
+          <a:p>
+            <a:pPr>
+              <a:defRPr sz="1150">
+                <a:solidFill>
+                  <a:srgbClr val="E0E7FF"/>
+                </a:solidFill>
+              </a:defRPr>
+            </a:pPr>
+            <a:r>
+              <a:t>Real-Time Priority Queue for Operations Leadership</a:t>
+            </a:r>
+          </a:p>
+        </p:txBody>
+      </p:sp>
+      <p:sp>
+        <p:nvSpPr>
+          <p:cNvPr id="5" name="Rounded Rectangle 4"/>
+          <p:cNvSpPr/>
+          <p:nvPr/>
+        </p:nvSpPr>
+        <p:spPr>
+          <a:xfrm>
+            <a:off x="731520" y="1645920"/>
+            <a:ext cx="5486400" cy="4754880"/>
+          </a:xfrm>
+          <a:prstGeom prst="roundRect">
+            <a:avLst/>
+          </a:prstGeom>
+          <a:solidFill>
+            <a:srgbClr val="FFFFFF"/>
           </a:solidFill>
           <a:ln w="19050">
             <a:solidFill>
-              <a:srgbClr val="6366F1"/>
-            </a:solidFill>
-          </a:ln>
-        </p:spPr>
-        <p:style>
-          <a:lnRef idx="1">
-            <a:schemeClr val="accent1"/>
-          </a:lnRef>
-          <a:fillRef idx="3">
-            <a:schemeClr val="accent1"/>
-          </a:fillRef>
-          <a:effectRef idx="2">
-            <a:schemeClr val="accent1"/>
-          </a:effectRef>
-          <a:fontRef idx="minor">
-            <a:schemeClr val="lt1"/>
-          </a:fontRef>
-        </p:style>
-        <p:txBody>
-          <a:bodyPr rtlCol="0" anchor="ctr" wrap="square"/>
-          <a:lstStyle/>
-          <a:p>
-            <a:pPr algn="ctr">
-              <a:defRPr sz="1000" b="1">
-                <a:solidFill>
-                  <a:srgbClr val="38BDF8"/>
-                </a:solidFill>
-              </a:defRPr>
-            </a:pPr>
-            <a:r>
-              <a:t>[ MANAGER SUITE ] — SLIDE 12</a:t>
-            </a:r>
-          </a:p>
-          <a:p>
-            <a:pPr>
-              <a:defRPr sz="1900" b="1">
-                <a:solidFill>
-                  <a:srgbClr val="F8FAFC"/>
-                </a:solidFill>
-              </a:defRPr>
-            </a:pPr>
-            <a:r>
-              <a:t>Manager Approval Suite &amp; Priority Requests</a:t>
-            </a:r>
-          </a:p>
-          <a:p>
-            <a:pPr>
-              <a:defRPr sz="1150">
-                <a:solidFill>
-                  <a:srgbClr val="A855F7"/>
-                </a:solidFill>
-              </a:defRPr>
-            </a:pPr>
-            <a:r>
-              <a:t>Real-Time Priority Queue for Operations Leadership</a:t>
-            </a:r>
-          </a:p>
-        </p:txBody>
-      </p:sp>
-      <p:sp>
-        <p:nvSpPr>
-          <p:cNvPr id="5" name="Rounded Rectangle 4"/>
-          <p:cNvSpPr/>
-          <p:nvPr/>
-        </p:nvSpPr>
-        <p:spPr>
-          <a:xfrm>
-            <a:off x="731520" y="1691640"/>
-            <a:ext cx="5486400" cy="4709160"/>
-          </a:xfrm>
-          <a:prstGeom prst="roundRect">
-            <a:avLst/>
-          </a:prstGeom>
-          <a:solidFill>
-            <a:srgbClr val="1E293B"/>
-          </a:solidFill>
-          <a:ln w="12700">
-            <a:solidFill>
-              <a:srgbClr val="334155"/>
+              <a:srgbClr val="E2E8F0"/>
             </a:solidFill>
           </a:ln>
         </p:spPr>
@@ -4424,7 +4418,7 @@
             <a:pPr algn="ctr">
               <a:defRPr sz="1200" b="1">
                 <a:solidFill>
-                  <a:srgbClr val="FBBF24"/>
+                  <a:srgbClr val="2563EB"/>
                 </a:solidFill>
               </a:defRPr>
             </a:pPr>
@@ -4439,7 +4433,7 @@
               </a:spcBef>
               <a:defRPr sz="1150">
                 <a:solidFill>
-                  <a:srgbClr val="F8FAFC"/>
+                  <a:srgbClr val="334155"/>
                 </a:solidFill>
               </a:defRPr>
             </a:pPr>
@@ -4454,7 +4448,7 @@
               </a:spcBef>
               <a:defRPr sz="1150">
                 <a:solidFill>
-                  <a:srgbClr val="F8FAFC"/>
+                  <a:srgbClr val="334155"/>
                 </a:solidFill>
               </a:defRPr>
             </a:pPr>
@@ -4469,7 +4463,7 @@
               </a:spcBef>
               <a:defRPr sz="1150">
                 <a:solidFill>
-                  <a:srgbClr val="F8FAFC"/>
+                  <a:srgbClr val="334155"/>
                 </a:solidFill>
               </a:defRPr>
             </a:pPr>
@@ -4487,18 +4481,18 @@
         </p:nvSpPr>
         <p:spPr>
           <a:xfrm>
-            <a:off x="6400800" y="1691640"/>
-            <a:ext cx="5059375" cy="4709160"/>
+            <a:off x="6400800" y="1645920"/>
+            <a:ext cx="5059375" cy="4754880"/>
           </a:xfrm>
           <a:prstGeom prst="roundRect">
             <a:avLst/>
           </a:prstGeom>
           <a:solidFill>
-            <a:srgbClr val="1E293B"/>
+            <a:srgbClr val="FFFFFF"/>
           </a:solidFill>
           <a:ln w="25400">
             <a:solidFill>
-              <a:srgbClr val="6366F1"/>
+              <a:srgbClr val="4F46E5"/>
             </a:solidFill>
           </a:ln>
         </p:spPr>
@@ -4532,18 +4526,18 @@
         </p:nvSpPr>
         <p:spPr>
           <a:xfrm>
-            <a:off x="6537960" y="1828800"/>
-            <a:ext cx="4785055" cy="4434840"/>
+            <a:off x="6537960" y="1783080"/>
+            <a:ext cx="4785055" cy="4480560"/>
           </a:xfrm>
           <a:prstGeom prst="roundRect">
             <a:avLst/>
           </a:prstGeom>
           <a:solidFill>
-            <a:srgbClr val="0F172A"/>
+            <a:srgbClr val="EEF2FF"/>
           </a:solidFill>
           <a:ln w="12700">
             <a:solidFill>
-              <a:srgbClr val="A855F7"/>
+              <a:srgbClr val="E2E8F0"/>
             </a:solidFill>
           </a:ln>
         </p:spPr>
@@ -4568,7 +4562,7 @@
             <a:pPr algn="ctr">
               <a:defRPr sz="1300" b="1">
                 <a:solidFill>
-                  <a:srgbClr val="6366F1"/>
+                  <a:srgbClr val="4F46E5"/>
                 </a:solidFill>
               </a:defRPr>
             </a:pPr>
@@ -4614,7 +4608,7 @@
             <a:avLst/>
           </a:prstGeom>
           <a:solidFill>
-            <a:srgbClr val="0F172A"/>
+            <a:srgbClr val="F8FAFC"/>
           </a:solidFill>
           <a:ln>
             <a:noFill/>
@@ -4657,7 +4651,7 @@
             <a:avLst/>
           </a:prstGeom>
           <a:solidFill>
-            <a:srgbClr val="6366F1"/>
+            <a:srgbClr val="4F46E5"/>
           </a:solidFill>
           <a:ln>
             <a:noFill/>
@@ -4693,96 +4687,94 @@
         </p:nvSpPr>
         <p:spPr>
           <a:xfrm>
-            <a:off x="731520" y="457200"/>
-            <a:ext cx="10728655" cy="1051560"/>
+            <a:off x="731520" y="411480"/>
+            <a:ext cx="10728655" cy="1097280"/>
           </a:xfrm>
           <a:prstGeom prst="roundRect">
             <a:avLst/>
           </a:prstGeom>
           <a:solidFill>
-            <a:srgbClr val="1E293B"/>
+            <a:srgbClr val="4F46E5"/>
+          </a:solidFill>
+          <a:ln>
+            <a:noFill/>
+          </a:ln>
+        </p:spPr>
+        <p:style>
+          <a:lnRef idx="1">
+            <a:schemeClr val="accent1"/>
+          </a:lnRef>
+          <a:fillRef idx="3">
+            <a:schemeClr val="accent1"/>
+          </a:fillRef>
+          <a:effectRef idx="2">
+            <a:schemeClr val="accent1"/>
+          </a:effectRef>
+          <a:fontRef idx="minor">
+            <a:schemeClr val="lt1"/>
+          </a:fontRef>
+        </p:style>
+        <p:txBody>
+          <a:bodyPr rtlCol="0" anchor="ctr" wrap="square"/>
+          <a:lstStyle/>
+          <a:p>
+            <a:pPr algn="ctr">
+              <a:defRPr sz="1000" b="1">
+                <a:solidFill>
+                  <a:srgbClr val="C7D2FE"/>
+                </a:solidFill>
+              </a:defRPr>
+            </a:pPr>
+            <a:r>
+              <a:t>[ AUDIT &amp; TIMELINE ] — SLIDE 13</a:t>
+            </a:r>
+          </a:p>
+          <a:p>
+            <a:pPr>
+              <a:defRPr sz="1900" b="1">
+                <a:solidFill>
+                  <a:srgbClr val="FFFFFF"/>
+                </a:solidFill>
+              </a:defRPr>
+            </a:pPr>
+            <a:r>
+              <a:t>Room-Specific Audit History &amp; System Logs</a:t>
+            </a:r>
+          </a:p>
+          <a:p>
+            <a:pPr>
+              <a:defRPr sz="1150">
+                <a:solidFill>
+                  <a:srgbClr val="E0E7FF"/>
+                </a:solidFill>
+              </a:defRPr>
+            </a:pPr>
+            <a:r>
+              <a:t>Chronological Utilization &amp; Event Tracking</a:t>
+            </a:r>
+          </a:p>
+        </p:txBody>
+      </p:sp>
+      <p:sp>
+        <p:nvSpPr>
+          <p:cNvPr id="5" name="Rounded Rectangle 4"/>
+          <p:cNvSpPr/>
+          <p:nvPr/>
+        </p:nvSpPr>
+        <p:spPr>
+          <a:xfrm>
+            <a:off x="731520" y="1645920"/>
+            <a:ext cx="5486400" cy="4754880"/>
+          </a:xfrm>
+          <a:prstGeom prst="roundRect">
+            <a:avLst/>
+          </a:prstGeom>
+          <a:solidFill>
+            <a:srgbClr val="FFFFFF"/>
           </a:solidFill>
           <a:ln w="19050">
             <a:solidFill>
-              <a:srgbClr val="6366F1"/>
-            </a:solidFill>
-          </a:ln>
-        </p:spPr>
-        <p:style>
-          <a:lnRef idx="1">
-            <a:schemeClr val="accent1"/>
-          </a:lnRef>
-          <a:fillRef idx="3">
-            <a:schemeClr val="accent1"/>
-          </a:fillRef>
-          <a:effectRef idx="2">
-            <a:schemeClr val="accent1"/>
-          </a:effectRef>
-          <a:fontRef idx="minor">
-            <a:schemeClr val="lt1"/>
-          </a:fontRef>
-        </p:style>
-        <p:txBody>
-          <a:bodyPr rtlCol="0" anchor="ctr" wrap="square"/>
-          <a:lstStyle/>
-          <a:p>
-            <a:pPr algn="ctr">
-              <a:defRPr sz="1000" b="1">
-                <a:solidFill>
-                  <a:srgbClr val="38BDF8"/>
-                </a:solidFill>
-              </a:defRPr>
-            </a:pPr>
-            <a:r>
-              <a:t>[ AUDIT &amp; TIMELINE ] — SLIDE 13</a:t>
-            </a:r>
-          </a:p>
-          <a:p>
-            <a:pPr>
-              <a:defRPr sz="1900" b="1">
-                <a:solidFill>
-                  <a:srgbClr val="F8FAFC"/>
-                </a:solidFill>
-              </a:defRPr>
-            </a:pPr>
-            <a:r>
-              <a:t>Room-Specific Audit History &amp; System Logs</a:t>
-            </a:r>
-          </a:p>
-          <a:p>
-            <a:pPr>
-              <a:defRPr sz="1150">
-                <a:solidFill>
-                  <a:srgbClr val="A855F7"/>
-                </a:solidFill>
-              </a:defRPr>
-            </a:pPr>
-            <a:r>
-              <a:t>Chronological Utilization &amp; Event Tracking</a:t>
-            </a:r>
-          </a:p>
-        </p:txBody>
-      </p:sp>
-      <p:sp>
-        <p:nvSpPr>
-          <p:cNvPr id="5" name="Rounded Rectangle 4"/>
-          <p:cNvSpPr/>
-          <p:nvPr/>
-        </p:nvSpPr>
-        <p:spPr>
-          <a:xfrm>
-            <a:off x="731520" y="1691640"/>
-            <a:ext cx="5486400" cy="4709160"/>
-          </a:xfrm>
-          <a:prstGeom prst="roundRect">
-            <a:avLst/>
-          </a:prstGeom>
-          <a:solidFill>
-            <a:srgbClr val="1E293B"/>
-          </a:solidFill>
-          <a:ln w="12700">
-            <a:solidFill>
-              <a:srgbClr val="334155"/>
+              <a:srgbClr val="E2E8F0"/>
             </a:solidFill>
           </a:ln>
         </p:spPr>
@@ -4807,7 +4799,7 @@
             <a:pPr algn="ctr">
               <a:defRPr sz="1200" b="1">
                 <a:solidFill>
-                  <a:srgbClr val="FBBF24"/>
+                  <a:srgbClr val="2563EB"/>
                 </a:solidFill>
               </a:defRPr>
             </a:pPr>
@@ -4822,7 +4814,7 @@
               </a:spcBef>
               <a:defRPr sz="1150">
                 <a:solidFill>
-                  <a:srgbClr val="F8FAFC"/>
+                  <a:srgbClr val="334155"/>
                 </a:solidFill>
               </a:defRPr>
             </a:pPr>
@@ -4837,7 +4829,7 @@
               </a:spcBef>
               <a:defRPr sz="1150">
                 <a:solidFill>
-                  <a:srgbClr val="F8FAFC"/>
+                  <a:srgbClr val="334155"/>
                 </a:solidFill>
               </a:defRPr>
             </a:pPr>
@@ -4852,7 +4844,7 @@
               </a:spcBef>
               <a:defRPr sz="1150">
                 <a:solidFill>
-                  <a:srgbClr val="F8FAFC"/>
+                  <a:srgbClr val="334155"/>
                 </a:solidFill>
               </a:defRPr>
             </a:pPr>
@@ -4870,18 +4862,18 @@
         </p:nvSpPr>
         <p:spPr>
           <a:xfrm>
-            <a:off x="6400800" y="1691640"/>
-            <a:ext cx="5059375" cy="4709160"/>
+            <a:off x="6400800" y="1645920"/>
+            <a:ext cx="5059375" cy="4754880"/>
           </a:xfrm>
           <a:prstGeom prst="roundRect">
             <a:avLst/>
           </a:prstGeom>
           <a:solidFill>
-            <a:srgbClr val="1E293B"/>
+            <a:srgbClr val="FFFFFF"/>
           </a:solidFill>
           <a:ln w="25400">
             <a:solidFill>
-              <a:srgbClr val="6366F1"/>
+              <a:srgbClr val="4F46E5"/>
             </a:solidFill>
           </a:ln>
         </p:spPr>
@@ -4915,18 +4907,18 @@
         </p:nvSpPr>
         <p:spPr>
           <a:xfrm>
-            <a:off x="6537960" y="1828800"/>
-            <a:ext cx="4785055" cy="4434840"/>
+            <a:off x="6537960" y="1783080"/>
+            <a:ext cx="4785055" cy="4480560"/>
           </a:xfrm>
           <a:prstGeom prst="roundRect">
             <a:avLst/>
           </a:prstGeom>
           <a:solidFill>
-            <a:srgbClr val="0F172A"/>
+            <a:srgbClr val="EEF2FF"/>
           </a:solidFill>
           <a:ln w="12700">
             <a:solidFill>
-              <a:srgbClr val="A855F7"/>
+              <a:srgbClr val="E2E8F0"/>
             </a:solidFill>
           </a:ln>
         </p:spPr>
@@ -4951,7 +4943,7 @@
             <a:pPr algn="ctr">
               <a:defRPr sz="1300" b="1">
                 <a:solidFill>
-                  <a:srgbClr val="6366F1"/>
+                  <a:srgbClr val="4F46E5"/>
                 </a:solidFill>
               </a:defRPr>
             </a:pPr>
@@ -4997,7 +4989,7 @@
             <a:avLst/>
           </a:prstGeom>
           <a:solidFill>
-            <a:srgbClr val="0F172A"/>
+            <a:srgbClr val="F8FAFC"/>
           </a:solidFill>
           <a:ln>
             <a:noFill/>
@@ -5040,7 +5032,7 @@
             <a:avLst/>
           </a:prstGeom>
           <a:solidFill>
-            <a:srgbClr val="6366F1"/>
+            <a:srgbClr val="4F46E5"/>
           </a:solidFill>
           <a:ln>
             <a:noFill/>
@@ -5076,96 +5068,94 @@
         </p:nvSpPr>
         <p:spPr>
           <a:xfrm>
-            <a:off x="731520" y="457200"/>
-            <a:ext cx="10728655" cy="1051560"/>
+            <a:off x="731520" y="411480"/>
+            <a:ext cx="10728655" cy="1097280"/>
           </a:xfrm>
           <a:prstGeom prst="roundRect">
             <a:avLst/>
           </a:prstGeom>
           <a:solidFill>
-            <a:srgbClr val="1E293B"/>
+            <a:srgbClr val="4F46E5"/>
+          </a:solidFill>
+          <a:ln>
+            <a:noFill/>
+          </a:ln>
+        </p:spPr>
+        <p:style>
+          <a:lnRef idx="1">
+            <a:schemeClr val="accent1"/>
+          </a:lnRef>
+          <a:fillRef idx="3">
+            <a:schemeClr val="accent1"/>
+          </a:fillRef>
+          <a:effectRef idx="2">
+            <a:schemeClr val="accent1"/>
+          </a:effectRef>
+          <a:fontRef idx="minor">
+            <a:schemeClr val="lt1"/>
+          </a:fontRef>
+        </p:style>
+        <p:txBody>
+          <a:bodyPr rtlCol="0" anchor="ctr" wrap="square"/>
+          <a:lstStyle/>
+          <a:p>
+            <a:pPr algn="ctr">
+              <a:defRPr sz="1000" b="1">
+                <a:solidFill>
+                  <a:srgbClr val="C7D2FE"/>
+                </a:solidFill>
+              </a:defRPr>
+            </a:pPr>
+            <a:r>
+              <a:t>[ FACILITY HEALTH ] — SLIDE 14</a:t>
+            </a:r>
+          </a:p>
+          <a:p>
+            <a:pPr>
+              <a:defRPr sz="1900" b="1">
+                <a:solidFill>
+                  <a:srgbClr val="FFFFFF"/>
+                </a:solidFill>
+              </a:defRPr>
+            </a:pPr>
+            <a:r>
+              <a:t>Facility Room Supplies &amp; Maintenance Tracking</a:t>
+            </a:r>
+          </a:p>
+          <a:p>
+            <a:pPr>
+              <a:defRPr sz="1150">
+                <a:solidFill>
+                  <a:srgbClr val="E0E7FF"/>
+                </a:solidFill>
+              </a:defRPr>
+            </a:pPr>
+            <a:r>
+              <a:t>Equipment Restocking &amp; Room Health Lifecycles</a:t>
+            </a:r>
+          </a:p>
+        </p:txBody>
+      </p:sp>
+      <p:sp>
+        <p:nvSpPr>
+          <p:cNvPr id="5" name="Rounded Rectangle 4"/>
+          <p:cNvSpPr/>
+          <p:nvPr/>
+        </p:nvSpPr>
+        <p:spPr>
+          <a:xfrm>
+            <a:off x="731520" y="1645920"/>
+            <a:ext cx="5486400" cy="4754880"/>
+          </a:xfrm>
+          <a:prstGeom prst="roundRect">
+            <a:avLst/>
+          </a:prstGeom>
+          <a:solidFill>
+            <a:srgbClr val="FFFFFF"/>
           </a:solidFill>
           <a:ln w="19050">
             <a:solidFill>
-              <a:srgbClr val="6366F1"/>
-            </a:solidFill>
-          </a:ln>
-        </p:spPr>
-        <p:style>
-          <a:lnRef idx="1">
-            <a:schemeClr val="accent1"/>
-          </a:lnRef>
-          <a:fillRef idx="3">
-            <a:schemeClr val="accent1"/>
-          </a:fillRef>
-          <a:effectRef idx="2">
-            <a:schemeClr val="accent1"/>
-          </a:effectRef>
-          <a:fontRef idx="minor">
-            <a:schemeClr val="lt1"/>
-          </a:fontRef>
-        </p:style>
-        <p:txBody>
-          <a:bodyPr rtlCol="0" anchor="ctr" wrap="square"/>
-          <a:lstStyle/>
-          <a:p>
-            <a:pPr algn="ctr">
-              <a:defRPr sz="1000" b="1">
-                <a:solidFill>
-                  <a:srgbClr val="38BDF8"/>
-                </a:solidFill>
-              </a:defRPr>
-            </a:pPr>
-            <a:r>
-              <a:t>[ FACILITY HEALTH ] — SLIDE 14</a:t>
-            </a:r>
-          </a:p>
-          <a:p>
-            <a:pPr>
-              <a:defRPr sz="1900" b="1">
-                <a:solidFill>
-                  <a:srgbClr val="F8FAFC"/>
-                </a:solidFill>
-              </a:defRPr>
-            </a:pPr>
-            <a:r>
-              <a:t>Facility Room Supplies &amp; Maintenance Tracking</a:t>
-            </a:r>
-          </a:p>
-          <a:p>
-            <a:pPr>
-              <a:defRPr sz="1150">
-                <a:solidFill>
-                  <a:srgbClr val="A855F7"/>
-                </a:solidFill>
-              </a:defRPr>
-            </a:pPr>
-            <a:r>
-              <a:t>Equipment Restocking &amp; Room Health Lifecycles</a:t>
-            </a:r>
-          </a:p>
-        </p:txBody>
-      </p:sp>
-      <p:sp>
-        <p:nvSpPr>
-          <p:cNvPr id="5" name="Rounded Rectangle 4"/>
-          <p:cNvSpPr/>
-          <p:nvPr/>
-        </p:nvSpPr>
-        <p:spPr>
-          <a:xfrm>
-            <a:off x="731520" y="1691640"/>
-            <a:ext cx="5486400" cy="4709160"/>
-          </a:xfrm>
-          <a:prstGeom prst="roundRect">
-            <a:avLst/>
-          </a:prstGeom>
-          <a:solidFill>
-            <a:srgbClr val="1E293B"/>
-          </a:solidFill>
-          <a:ln w="12700">
-            <a:solidFill>
-              <a:srgbClr val="334155"/>
+              <a:srgbClr val="E2E8F0"/>
             </a:solidFill>
           </a:ln>
         </p:spPr>
@@ -5190,7 +5180,7 @@
             <a:pPr algn="ctr">
               <a:defRPr sz="1200" b="1">
                 <a:solidFill>
-                  <a:srgbClr val="FBBF24"/>
+                  <a:srgbClr val="2563EB"/>
                 </a:solidFill>
               </a:defRPr>
             </a:pPr>
@@ -5205,7 +5195,7 @@
               </a:spcBef>
               <a:defRPr sz="1150">
                 <a:solidFill>
-                  <a:srgbClr val="F8FAFC"/>
+                  <a:srgbClr val="334155"/>
                 </a:solidFill>
               </a:defRPr>
             </a:pPr>
@@ -5220,7 +5210,7 @@
               </a:spcBef>
               <a:defRPr sz="1150">
                 <a:solidFill>
-                  <a:srgbClr val="F8FAFC"/>
+                  <a:srgbClr val="334155"/>
                 </a:solidFill>
               </a:defRPr>
             </a:pPr>
@@ -5235,7 +5225,7 @@
               </a:spcBef>
               <a:defRPr sz="1150">
                 <a:solidFill>
-                  <a:srgbClr val="F8FAFC"/>
+                  <a:srgbClr val="334155"/>
                 </a:solidFill>
               </a:defRPr>
             </a:pPr>
@@ -5253,18 +5243,18 @@
         </p:nvSpPr>
         <p:spPr>
           <a:xfrm>
-            <a:off x="6400800" y="1691640"/>
-            <a:ext cx="5059375" cy="4709160"/>
+            <a:off x="6400800" y="1645920"/>
+            <a:ext cx="5059375" cy="4754880"/>
           </a:xfrm>
           <a:prstGeom prst="roundRect">
             <a:avLst/>
           </a:prstGeom>
           <a:solidFill>
-            <a:srgbClr val="1E293B"/>
+            <a:srgbClr val="FFFFFF"/>
           </a:solidFill>
           <a:ln w="25400">
             <a:solidFill>
-              <a:srgbClr val="6366F1"/>
+              <a:srgbClr val="4F46E5"/>
             </a:solidFill>
           </a:ln>
         </p:spPr>
@@ -5298,18 +5288,18 @@
         </p:nvSpPr>
         <p:spPr>
           <a:xfrm>
-            <a:off x="6537960" y="1828800"/>
-            <a:ext cx="4785055" cy="4434840"/>
+            <a:off x="6537960" y="1783080"/>
+            <a:ext cx="4785055" cy="4480560"/>
           </a:xfrm>
           <a:prstGeom prst="roundRect">
             <a:avLst/>
           </a:prstGeom>
           <a:solidFill>
-            <a:srgbClr val="0F172A"/>
+            <a:srgbClr val="EEF2FF"/>
           </a:solidFill>
           <a:ln w="12700">
             <a:solidFill>
-              <a:srgbClr val="A855F7"/>
+              <a:srgbClr val="E2E8F0"/>
             </a:solidFill>
           </a:ln>
         </p:spPr>
@@ -5334,7 +5324,7 @@
             <a:pPr algn="ctr">
               <a:defRPr sz="1300" b="1">
                 <a:solidFill>
-                  <a:srgbClr val="6366F1"/>
+                  <a:srgbClr val="4F46E5"/>
                 </a:solidFill>
               </a:defRPr>
             </a:pPr>
@@ -5380,7 +5370,7 @@
             <a:avLst/>
           </a:prstGeom>
           <a:solidFill>
-            <a:srgbClr val="0F172A"/>
+            <a:srgbClr val="F8FAFC"/>
           </a:solidFill>
           <a:ln>
             <a:noFill/>
@@ -5423,7 +5413,7 @@
             <a:avLst/>
           </a:prstGeom>
           <a:solidFill>
-            <a:srgbClr val="6366F1"/>
+            <a:srgbClr val="4F46E5"/>
           </a:solidFill>
           <a:ln>
             <a:noFill/>
@@ -5459,96 +5449,94 @@
         </p:nvSpPr>
         <p:spPr>
           <a:xfrm>
-            <a:off x="731520" y="457200"/>
-            <a:ext cx="10728655" cy="1051560"/>
+            <a:off x="731520" y="411480"/>
+            <a:ext cx="10728655" cy="1097280"/>
           </a:xfrm>
           <a:prstGeom prst="roundRect">
             <a:avLst/>
           </a:prstGeom>
           <a:solidFill>
-            <a:srgbClr val="1E293B"/>
+            <a:srgbClr val="4F46E5"/>
+          </a:solidFill>
+          <a:ln>
+            <a:noFill/>
+          </a:ln>
+        </p:spPr>
+        <p:style>
+          <a:lnRef idx="1">
+            <a:schemeClr val="accent1"/>
+          </a:lnRef>
+          <a:fillRef idx="3">
+            <a:schemeClr val="accent1"/>
+          </a:fillRef>
+          <a:effectRef idx="2">
+            <a:schemeClr val="accent1"/>
+          </a:effectRef>
+          <a:fontRef idx="minor">
+            <a:schemeClr val="lt1"/>
+          </a:fontRef>
+        </p:style>
+        <p:txBody>
+          <a:bodyPr rtlCol="0" anchor="ctr" wrap="square"/>
+          <a:lstStyle/>
+          <a:p>
+            <a:pPr algn="ctr">
+              <a:defRPr sz="1000" b="1">
+                <a:solidFill>
+                  <a:srgbClr val="C7D2FE"/>
+                </a:solidFill>
+              </a:defRPr>
+            </a:pPr>
+            <a:r>
+              <a:t>[ EMAIL AUTOMATION ] — SLIDE 15</a:t>
+            </a:r>
+          </a:p>
+          <a:p>
+            <a:pPr>
+              <a:defRPr sz="1900" b="1">
+                <a:solidFill>
+                  <a:srgbClr val="FFFFFF"/>
+                </a:solidFill>
+              </a:defRPr>
+            </a:pPr>
+            <a:r>
+              <a:t>Automated Gmail Calendar Email Notifications</a:t>
+            </a:r>
+          </a:p>
+          <a:p>
+            <a:pPr>
+              <a:defRPr sz="1150">
+                <a:solidFill>
+                  <a:srgbClr val="E0E7FF"/>
+                </a:solidFill>
+              </a:defRPr>
+            </a:pPr>
+            <a:r>
+              <a:t>Interactive Calendar Invitations via Gmail SMTP</a:t>
+            </a:r>
+          </a:p>
+        </p:txBody>
+      </p:sp>
+      <p:sp>
+        <p:nvSpPr>
+          <p:cNvPr id="5" name="Rounded Rectangle 4"/>
+          <p:cNvSpPr/>
+          <p:nvPr/>
+        </p:nvSpPr>
+        <p:spPr>
+          <a:xfrm>
+            <a:off x="731520" y="1645920"/>
+            <a:ext cx="5486400" cy="4754880"/>
+          </a:xfrm>
+          <a:prstGeom prst="roundRect">
+            <a:avLst/>
+          </a:prstGeom>
+          <a:solidFill>
+            <a:srgbClr val="FFFFFF"/>
           </a:solidFill>
           <a:ln w="19050">
             <a:solidFill>
-              <a:srgbClr val="6366F1"/>
-            </a:solidFill>
-          </a:ln>
-        </p:spPr>
-        <p:style>
-          <a:lnRef idx="1">
-            <a:schemeClr val="accent1"/>
-          </a:lnRef>
-          <a:fillRef idx="3">
-            <a:schemeClr val="accent1"/>
-          </a:fillRef>
-          <a:effectRef idx="2">
-            <a:schemeClr val="accent1"/>
-          </a:effectRef>
-          <a:fontRef idx="minor">
-            <a:schemeClr val="lt1"/>
-          </a:fontRef>
-        </p:style>
-        <p:txBody>
-          <a:bodyPr rtlCol="0" anchor="ctr" wrap="square"/>
-          <a:lstStyle/>
-          <a:p>
-            <a:pPr algn="ctr">
-              <a:defRPr sz="1000" b="1">
-                <a:solidFill>
-                  <a:srgbClr val="38BDF8"/>
-                </a:solidFill>
-              </a:defRPr>
-            </a:pPr>
-            <a:r>
-              <a:t>[ EMAIL AUTOMATION ] — SLIDE 15</a:t>
-            </a:r>
-          </a:p>
-          <a:p>
-            <a:pPr>
-              <a:defRPr sz="1900" b="1">
-                <a:solidFill>
-                  <a:srgbClr val="F8FAFC"/>
-                </a:solidFill>
-              </a:defRPr>
-            </a:pPr>
-            <a:r>
-              <a:t>Automated Gmail Calendar Email Notifications</a:t>
-            </a:r>
-          </a:p>
-          <a:p>
-            <a:pPr>
-              <a:defRPr sz="1150">
-                <a:solidFill>
-                  <a:srgbClr val="A855F7"/>
-                </a:solidFill>
-              </a:defRPr>
-            </a:pPr>
-            <a:r>
-              <a:t>Interactive Calendar Invitations via Gmail SMTP</a:t>
-            </a:r>
-          </a:p>
-        </p:txBody>
-      </p:sp>
-      <p:sp>
-        <p:nvSpPr>
-          <p:cNvPr id="5" name="Rounded Rectangle 4"/>
-          <p:cNvSpPr/>
-          <p:nvPr/>
-        </p:nvSpPr>
-        <p:spPr>
-          <a:xfrm>
-            <a:off x="731520" y="1691640"/>
-            <a:ext cx="5486400" cy="4709160"/>
-          </a:xfrm>
-          <a:prstGeom prst="roundRect">
-            <a:avLst/>
-          </a:prstGeom>
-          <a:solidFill>
-            <a:srgbClr val="1E293B"/>
-          </a:solidFill>
-          <a:ln w="12700">
-            <a:solidFill>
-              <a:srgbClr val="334155"/>
+              <a:srgbClr val="E2E8F0"/>
             </a:solidFill>
           </a:ln>
         </p:spPr>
@@ -5573,7 +5561,7 @@
             <a:pPr algn="ctr">
               <a:defRPr sz="1200" b="1">
                 <a:solidFill>
-                  <a:srgbClr val="FBBF24"/>
+                  <a:srgbClr val="2563EB"/>
                 </a:solidFill>
               </a:defRPr>
             </a:pPr>
@@ -5588,7 +5576,7 @@
               </a:spcBef>
               <a:defRPr sz="1150">
                 <a:solidFill>
-                  <a:srgbClr val="F8FAFC"/>
+                  <a:srgbClr val="334155"/>
                 </a:solidFill>
               </a:defRPr>
             </a:pPr>
@@ -5603,7 +5591,7 @@
               </a:spcBef>
               <a:defRPr sz="1150">
                 <a:solidFill>
-                  <a:srgbClr val="F8FAFC"/>
+                  <a:srgbClr val="334155"/>
                 </a:solidFill>
               </a:defRPr>
             </a:pPr>
@@ -5618,7 +5606,7 @@
               </a:spcBef>
               <a:defRPr sz="1150">
                 <a:solidFill>
-                  <a:srgbClr val="F8FAFC"/>
+                  <a:srgbClr val="334155"/>
                 </a:solidFill>
               </a:defRPr>
             </a:pPr>
@@ -5636,18 +5624,18 @@
         </p:nvSpPr>
         <p:spPr>
           <a:xfrm>
-            <a:off x="6400800" y="1691640"/>
-            <a:ext cx="5059375" cy="4709160"/>
+            <a:off x="6400800" y="1645920"/>
+            <a:ext cx="5059375" cy="4754880"/>
           </a:xfrm>
           <a:prstGeom prst="roundRect">
             <a:avLst/>
           </a:prstGeom>
           <a:solidFill>
-            <a:srgbClr val="1E293B"/>
+            <a:srgbClr val="FFFFFF"/>
           </a:solidFill>
           <a:ln w="25400">
             <a:solidFill>
-              <a:srgbClr val="6366F1"/>
+              <a:srgbClr val="4F46E5"/>
             </a:solidFill>
           </a:ln>
         </p:spPr>
@@ -5681,18 +5669,18 @@
         </p:nvSpPr>
         <p:spPr>
           <a:xfrm>
-            <a:off x="6537960" y="1828800"/>
-            <a:ext cx="4785055" cy="4434840"/>
+            <a:off x="6537960" y="1783080"/>
+            <a:ext cx="4785055" cy="4480560"/>
           </a:xfrm>
           <a:prstGeom prst="roundRect">
             <a:avLst/>
           </a:prstGeom>
           <a:solidFill>
-            <a:srgbClr val="0F172A"/>
+            <a:srgbClr val="EEF2FF"/>
           </a:solidFill>
           <a:ln w="12700">
             <a:solidFill>
-              <a:srgbClr val="A855F7"/>
+              <a:srgbClr val="E2E8F0"/>
             </a:solidFill>
           </a:ln>
         </p:spPr>
@@ -5717,7 +5705,7 @@
             <a:pPr algn="ctr">
               <a:defRPr sz="1300" b="1">
                 <a:solidFill>
-                  <a:srgbClr val="6366F1"/>
+                  <a:srgbClr val="4F46E5"/>
                 </a:solidFill>
               </a:defRPr>
             </a:pPr>
@@ -5763,7 +5751,7 @@
             <a:avLst/>
           </a:prstGeom>
           <a:solidFill>
-            <a:srgbClr val="0F172A"/>
+            <a:srgbClr val="F8FAFC"/>
           </a:solidFill>
           <a:ln>
             <a:noFill/>
@@ -5806,7 +5794,7 @@
             <a:avLst/>
           </a:prstGeom>
           <a:solidFill>
-            <a:srgbClr val="6366F1"/>
+            <a:srgbClr val="4F46E5"/>
           </a:solidFill>
           <a:ln>
             <a:noFill/>
@@ -5842,96 +5830,94 @@
         </p:nvSpPr>
         <p:spPr>
           <a:xfrm>
-            <a:off x="731520" y="457200"/>
-            <a:ext cx="10728655" cy="1051560"/>
+            <a:off x="731520" y="411480"/>
+            <a:ext cx="10728655" cy="1097280"/>
           </a:xfrm>
           <a:prstGeom prst="roundRect">
             <a:avLst/>
           </a:prstGeom>
           <a:solidFill>
-            <a:srgbClr val="1E293B"/>
+            <a:srgbClr val="4F46E5"/>
+          </a:solidFill>
+          <a:ln>
+            <a:noFill/>
+          </a:ln>
+        </p:spPr>
+        <p:style>
+          <a:lnRef idx="1">
+            <a:schemeClr val="accent1"/>
+          </a:lnRef>
+          <a:fillRef idx="3">
+            <a:schemeClr val="accent1"/>
+          </a:fillRef>
+          <a:effectRef idx="2">
+            <a:schemeClr val="accent1"/>
+          </a:effectRef>
+          <a:fontRef idx="minor">
+            <a:schemeClr val="lt1"/>
+          </a:fontRef>
+        </p:style>
+        <p:txBody>
+          <a:bodyPr rtlCol="0" anchor="ctr" wrap="square"/>
+          <a:lstStyle/>
+          <a:p>
+            <a:pPr algn="ctr">
+              <a:defRPr sz="1000" b="1">
+                <a:solidFill>
+                  <a:srgbClr val="C7D2FE"/>
+                </a:solidFill>
+              </a:defRPr>
+            </a:pPr>
+            <a:r>
+              <a:t>[ SECURITY &amp; GOVERNANCE ] — SLIDE 16</a:t>
+            </a:r>
+          </a:p>
+          <a:p>
+            <a:pPr>
+              <a:defRPr sz="1900" b="1">
+                <a:solidFill>
+                  <a:srgbClr val="FFFFFF"/>
+                </a:solidFill>
+              </a:defRPr>
+            </a:pPr>
+            <a:r>
+              <a:t>System Security &amp; Role-Based Permissions (RBAC)</a:t>
+            </a:r>
+          </a:p>
+          <a:p>
+            <a:pPr>
+              <a:defRPr sz="1150">
+                <a:solidFill>
+                  <a:srgbClr val="E0E7FF"/>
+                </a:solidFill>
+              </a:defRPr>
+            </a:pPr>
+            <a:r>
+              <a:t>Enterprise Compliance &amp; Password Encryption</a:t>
+            </a:r>
+          </a:p>
+        </p:txBody>
+      </p:sp>
+      <p:sp>
+        <p:nvSpPr>
+          <p:cNvPr id="5" name="Rounded Rectangle 4"/>
+          <p:cNvSpPr/>
+          <p:nvPr/>
+        </p:nvSpPr>
+        <p:spPr>
+          <a:xfrm>
+            <a:off x="731520" y="1645920"/>
+            <a:ext cx="5486400" cy="4754880"/>
+          </a:xfrm>
+          <a:prstGeom prst="roundRect">
+            <a:avLst/>
+          </a:prstGeom>
+          <a:solidFill>
+            <a:srgbClr val="FFFFFF"/>
           </a:solidFill>
           <a:ln w="19050">
             <a:solidFill>
-              <a:srgbClr val="6366F1"/>
-            </a:solidFill>
-          </a:ln>
-        </p:spPr>
-        <p:style>
-          <a:lnRef idx="1">
-            <a:schemeClr val="accent1"/>
-          </a:lnRef>
-          <a:fillRef idx="3">
-            <a:schemeClr val="accent1"/>
-          </a:fillRef>
-          <a:effectRef idx="2">
-            <a:schemeClr val="accent1"/>
-          </a:effectRef>
-          <a:fontRef idx="minor">
-            <a:schemeClr val="lt1"/>
-          </a:fontRef>
-        </p:style>
-        <p:txBody>
-          <a:bodyPr rtlCol="0" anchor="ctr" wrap="square"/>
-          <a:lstStyle/>
-          <a:p>
-            <a:pPr algn="ctr">
-              <a:defRPr sz="1000" b="1">
-                <a:solidFill>
-                  <a:srgbClr val="38BDF8"/>
-                </a:solidFill>
-              </a:defRPr>
-            </a:pPr>
-            <a:r>
-              <a:t>[ SECURITY &amp; GOVERNANCE ] — SLIDE 16</a:t>
-            </a:r>
-          </a:p>
-          <a:p>
-            <a:pPr>
-              <a:defRPr sz="1900" b="1">
-                <a:solidFill>
-                  <a:srgbClr val="F8FAFC"/>
-                </a:solidFill>
-              </a:defRPr>
-            </a:pPr>
-            <a:r>
-              <a:t>System Security &amp; Role-Based Permissions (RBAC)</a:t>
-            </a:r>
-          </a:p>
-          <a:p>
-            <a:pPr>
-              <a:defRPr sz="1150">
-                <a:solidFill>
-                  <a:srgbClr val="A855F7"/>
-                </a:solidFill>
-              </a:defRPr>
-            </a:pPr>
-            <a:r>
-              <a:t>Enterprise Compliance &amp; Password Encryption</a:t>
-            </a:r>
-          </a:p>
-        </p:txBody>
-      </p:sp>
-      <p:sp>
-        <p:nvSpPr>
-          <p:cNvPr id="5" name="Rounded Rectangle 4"/>
-          <p:cNvSpPr/>
-          <p:nvPr/>
-        </p:nvSpPr>
-        <p:spPr>
-          <a:xfrm>
-            <a:off x="731520" y="1691640"/>
-            <a:ext cx="5486400" cy="4709160"/>
-          </a:xfrm>
-          <a:prstGeom prst="roundRect">
-            <a:avLst/>
-          </a:prstGeom>
-          <a:solidFill>
-            <a:srgbClr val="1E293B"/>
-          </a:solidFill>
-          <a:ln w="12700">
-            <a:solidFill>
-              <a:srgbClr val="334155"/>
+              <a:srgbClr val="E2E8F0"/>
             </a:solidFill>
           </a:ln>
         </p:spPr>
@@ -5956,7 +5942,7 @@
             <a:pPr algn="ctr">
               <a:defRPr sz="1200" b="1">
                 <a:solidFill>
-                  <a:srgbClr val="FBBF24"/>
+                  <a:srgbClr val="2563EB"/>
                 </a:solidFill>
               </a:defRPr>
             </a:pPr>
@@ -5971,7 +5957,7 @@
               </a:spcBef>
               <a:defRPr sz="1150">
                 <a:solidFill>
-                  <a:srgbClr val="F8FAFC"/>
+                  <a:srgbClr val="334155"/>
                 </a:solidFill>
               </a:defRPr>
             </a:pPr>
@@ -5986,7 +5972,7 @@
               </a:spcBef>
               <a:defRPr sz="1150">
                 <a:solidFill>
-                  <a:srgbClr val="F8FAFC"/>
+                  <a:srgbClr val="334155"/>
                 </a:solidFill>
               </a:defRPr>
             </a:pPr>
@@ -6001,7 +5987,7 @@
               </a:spcBef>
               <a:defRPr sz="1150">
                 <a:solidFill>
-                  <a:srgbClr val="F8FAFC"/>
+                  <a:srgbClr val="334155"/>
                 </a:solidFill>
               </a:defRPr>
             </a:pPr>
@@ -6016,7 +6002,7 @@
               </a:spcBef>
               <a:defRPr sz="1150">
                 <a:solidFill>
-                  <a:srgbClr val="F8FAFC"/>
+                  <a:srgbClr val="334155"/>
                 </a:solidFill>
               </a:defRPr>
             </a:pPr>
@@ -6034,18 +6020,18 @@
         </p:nvSpPr>
         <p:spPr>
           <a:xfrm>
-            <a:off x="6400800" y="1691640"/>
-            <a:ext cx="5059375" cy="4709160"/>
+            <a:off x="6400800" y="1645920"/>
+            <a:ext cx="5059375" cy="4754880"/>
           </a:xfrm>
           <a:prstGeom prst="roundRect">
             <a:avLst/>
           </a:prstGeom>
           <a:solidFill>
-            <a:srgbClr val="1E293B"/>
+            <a:srgbClr val="FFFFFF"/>
           </a:solidFill>
           <a:ln w="25400">
             <a:solidFill>
-              <a:srgbClr val="6366F1"/>
+              <a:srgbClr val="4F46E5"/>
             </a:solidFill>
           </a:ln>
         </p:spPr>
@@ -6079,18 +6065,18 @@
         </p:nvSpPr>
         <p:spPr>
           <a:xfrm>
-            <a:off x="6537960" y="1828800"/>
-            <a:ext cx="4785055" cy="4434840"/>
+            <a:off x="6537960" y="1783080"/>
+            <a:ext cx="4785055" cy="4480560"/>
           </a:xfrm>
           <a:prstGeom prst="roundRect">
             <a:avLst/>
           </a:prstGeom>
           <a:solidFill>
-            <a:srgbClr val="0F172A"/>
+            <a:srgbClr val="EEF2FF"/>
           </a:solidFill>
           <a:ln w="12700">
             <a:solidFill>
-              <a:srgbClr val="A855F7"/>
+              <a:srgbClr val="E2E8F0"/>
             </a:solidFill>
           </a:ln>
         </p:spPr>
@@ -6115,7 +6101,7 @@
             <a:pPr algn="ctr">
               <a:defRPr sz="1300" b="1">
                 <a:solidFill>
-                  <a:srgbClr val="6366F1"/>
+                  <a:srgbClr val="4F46E5"/>
                 </a:solidFill>
               </a:defRPr>
             </a:pPr>
@@ -6161,7 +6147,7 @@
             <a:avLst/>
           </a:prstGeom>
           <a:solidFill>
-            <a:srgbClr val="0F172A"/>
+            <a:srgbClr val="F8FAFC"/>
           </a:solidFill>
           <a:ln>
             <a:noFill/>
@@ -6204,7 +6190,7 @@
             <a:avLst/>
           </a:prstGeom>
           <a:solidFill>
-            <a:srgbClr val="6366F1"/>
+            <a:srgbClr val="4F46E5"/>
           </a:solidFill>
           <a:ln>
             <a:noFill/>
@@ -6240,96 +6226,94 @@
         </p:nvSpPr>
         <p:spPr>
           <a:xfrm>
-            <a:off x="731520" y="457200"/>
-            <a:ext cx="10728655" cy="1051560"/>
+            <a:off x="731520" y="411480"/>
+            <a:ext cx="10728655" cy="1097280"/>
           </a:xfrm>
           <a:prstGeom prst="roundRect">
             <a:avLst/>
           </a:prstGeom>
           <a:solidFill>
-            <a:srgbClr val="1E293B"/>
+            <a:srgbClr val="4F46E5"/>
+          </a:solidFill>
+          <a:ln>
+            <a:noFill/>
+          </a:ln>
+        </p:spPr>
+        <p:style>
+          <a:lnRef idx="1">
+            <a:schemeClr val="accent1"/>
+          </a:lnRef>
+          <a:fillRef idx="3">
+            <a:schemeClr val="accent1"/>
+          </a:fillRef>
+          <a:effectRef idx="2">
+            <a:schemeClr val="accent1"/>
+          </a:effectRef>
+          <a:fontRef idx="minor">
+            <a:schemeClr val="lt1"/>
+          </a:fontRef>
+        </p:style>
+        <p:txBody>
+          <a:bodyPr rtlCol="0" anchor="ctr" wrap="square"/>
+          <a:lstStyle/>
+          <a:p>
+            <a:pPr algn="ctr">
+              <a:defRPr sz="1000" b="1">
+                <a:solidFill>
+                  <a:srgbClr val="C7D2FE"/>
+                </a:solidFill>
+              </a:defRPr>
+            </a:pPr>
+            <a:r>
+              <a:t>[ LIVE DEMONSTRATION ] — SLIDE 17</a:t>
+            </a:r>
+          </a:p>
+          <a:p>
+            <a:pPr>
+              <a:defRPr sz="1900" b="1">
+                <a:solidFill>
+                  <a:srgbClr val="FFFFFF"/>
+                </a:solidFill>
+              </a:defRPr>
+            </a:pPr>
+            <a:r>
+              <a:t>Step-by-Step 3-Minute Live Demo Walkthrough</a:t>
+            </a:r>
+          </a:p>
+          <a:p>
+            <a:pPr>
+              <a:defRPr sz="1150">
+                <a:solidFill>
+                  <a:srgbClr val="E0E7FF"/>
+                </a:solidFill>
+              </a:defRPr>
+            </a:pPr>
+            <a:r>
+              <a:t>Seamless Live Presentation Script for Managers</a:t>
+            </a:r>
+          </a:p>
+        </p:txBody>
+      </p:sp>
+      <p:sp>
+        <p:nvSpPr>
+          <p:cNvPr id="5" name="Rounded Rectangle 4"/>
+          <p:cNvSpPr/>
+          <p:nvPr/>
+        </p:nvSpPr>
+        <p:spPr>
+          <a:xfrm>
+            <a:off x="731520" y="1645920"/>
+            <a:ext cx="5486400" cy="4754880"/>
+          </a:xfrm>
+          <a:prstGeom prst="roundRect">
+            <a:avLst/>
+          </a:prstGeom>
+          <a:solidFill>
+            <a:srgbClr val="FFFFFF"/>
           </a:solidFill>
           <a:ln w="19050">
             <a:solidFill>
-              <a:srgbClr val="6366F1"/>
-            </a:solidFill>
-          </a:ln>
-        </p:spPr>
-        <p:style>
-          <a:lnRef idx="1">
-            <a:schemeClr val="accent1"/>
-          </a:lnRef>
-          <a:fillRef idx="3">
-            <a:schemeClr val="accent1"/>
-          </a:fillRef>
-          <a:effectRef idx="2">
-            <a:schemeClr val="accent1"/>
-          </a:effectRef>
-          <a:fontRef idx="minor">
-            <a:schemeClr val="lt1"/>
-          </a:fontRef>
-        </p:style>
-        <p:txBody>
-          <a:bodyPr rtlCol="0" anchor="ctr" wrap="square"/>
-          <a:lstStyle/>
-          <a:p>
-            <a:pPr algn="ctr">
-              <a:defRPr sz="1000" b="1">
-                <a:solidFill>
-                  <a:srgbClr val="38BDF8"/>
-                </a:solidFill>
-              </a:defRPr>
-            </a:pPr>
-            <a:r>
-              <a:t>[ LIVE DEMONSTRATION ] — SLIDE 17</a:t>
-            </a:r>
-          </a:p>
-          <a:p>
-            <a:pPr>
-              <a:defRPr sz="1900" b="1">
-                <a:solidFill>
-                  <a:srgbClr val="F8FAFC"/>
-                </a:solidFill>
-              </a:defRPr>
-            </a:pPr>
-            <a:r>
-              <a:t>Step-by-Step 3-Minute Live Demo Walkthrough</a:t>
-            </a:r>
-          </a:p>
-          <a:p>
-            <a:pPr>
-              <a:defRPr sz="1150">
-                <a:solidFill>
-                  <a:srgbClr val="A855F7"/>
-                </a:solidFill>
-              </a:defRPr>
-            </a:pPr>
-            <a:r>
-              <a:t>Seamless Live Presentation Script for Managers</a:t>
-            </a:r>
-          </a:p>
-        </p:txBody>
-      </p:sp>
-      <p:sp>
-        <p:nvSpPr>
-          <p:cNvPr id="5" name="Rounded Rectangle 4"/>
-          <p:cNvSpPr/>
-          <p:nvPr/>
-        </p:nvSpPr>
-        <p:spPr>
-          <a:xfrm>
-            <a:off x="731520" y="1691640"/>
-            <a:ext cx="5486400" cy="4709160"/>
-          </a:xfrm>
-          <a:prstGeom prst="roundRect">
-            <a:avLst/>
-          </a:prstGeom>
-          <a:solidFill>
-            <a:srgbClr val="1E293B"/>
-          </a:solidFill>
-          <a:ln w="12700">
-            <a:solidFill>
-              <a:srgbClr val="334155"/>
+              <a:srgbClr val="E2E8F0"/>
             </a:solidFill>
           </a:ln>
         </p:spPr>
@@ -6354,7 +6338,7 @@
             <a:pPr algn="ctr">
               <a:defRPr sz="1200" b="1">
                 <a:solidFill>
-                  <a:srgbClr val="FBBF24"/>
+                  <a:srgbClr val="2563EB"/>
                 </a:solidFill>
               </a:defRPr>
             </a:pPr>
@@ -6369,7 +6353,7 @@
               </a:spcBef>
               <a:defRPr sz="1150">
                 <a:solidFill>
-                  <a:srgbClr val="F8FAFC"/>
+                  <a:srgbClr val="334155"/>
                 </a:solidFill>
               </a:defRPr>
             </a:pPr>
@@ -6384,7 +6368,7 @@
               </a:spcBef>
               <a:defRPr sz="1150">
                 <a:solidFill>
-                  <a:srgbClr val="F8FAFC"/>
+                  <a:srgbClr val="334155"/>
                 </a:solidFill>
               </a:defRPr>
             </a:pPr>
@@ -6399,7 +6383,7 @@
               </a:spcBef>
               <a:defRPr sz="1150">
                 <a:solidFill>
-                  <a:srgbClr val="F8FAFC"/>
+                  <a:srgbClr val="334155"/>
                 </a:solidFill>
               </a:defRPr>
             </a:pPr>
@@ -6414,7 +6398,7 @@
               </a:spcBef>
               <a:defRPr sz="1150">
                 <a:solidFill>
-                  <a:srgbClr val="F8FAFC"/>
+                  <a:srgbClr val="334155"/>
                 </a:solidFill>
               </a:defRPr>
             </a:pPr>
@@ -6432,18 +6416,18 @@
         </p:nvSpPr>
         <p:spPr>
           <a:xfrm>
-            <a:off x="6400800" y="1691640"/>
-            <a:ext cx="5059375" cy="4709160"/>
+            <a:off x="6400800" y="1645920"/>
+            <a:ext cx="5059375" cy="4754880"/>
           </a:xfrm>
           <a:prstGeom prst="roundRect">
             <a:avLst/>
           </a:prstGeom>
           <a:solidFill>
-            <a:srgbClr val="1E293B"/>
+            <a:srgbClr val="FFFFFF"/>
           </a:solidFill>
           <a:ln w="25400">
             <a:solidFill>
-              <a:srgbClr val="6366F1"/>
+              <a:srgbClr val="4F46E5"/>
             </a:solidFill>
           </a:ln>
         </p:spPr>
@@ -6477,18 +6461,18 @@
         </p:nvSpPr>
         <p:spPr>
           <a:xfrm>
-            <a:off x="6537960" y="1828800"/>
-            <a:ext cx="4785055" cy="4434840"/>
+            <a:off x="6537960" y="1783080"/>
+            <a:ext cx="4785055" cy="4480560"/>
           </a:xfrm>
           <a:prstGeom prst="roundRect">
             <a:avLst/>
           </a:prstGeom>
           <a:solidFill>
-            <a:srgbClr val="0F172A"/>
+            <a:srgbClr val="EEF2FF"/>
           </a:solidFill>
           <a:ln w="12700">
             <a:solidFill>
-              <a:srgbClr val="A855F7"/>
+              <a:srgbClr val="E2E8F0"/>
             </a:solidFill>
           </a:ln>
         </p:spPr>
@@ -6513,7 +6497,7 @@
             <a:pPr algn="ctr">
               <a:defRPr sz="1300" b="1">
                 <a:solidFill>
-                  <a:srgbClr val="6366F1"/>
+                  <a:srgbClr val="4F46E5"/>
                 </a:solidFill>
               </a:defRPr>
             </a:pPr>
@@ -6559,7 +6543,7 @@
             <a:avLst/>
           </a:prstGeom>
           <a:solidFill>
-            <a:srgbClr val="0F172A"/>
+            <a:srgbClr val="F8FAFC"/>
           </a:solidFill>
           <a:ln>
             <a:noFill/>
@@ -6602,7 +6586,7 @@
             <a:avLst/>
           </a:prstGeom>
           <a:solidFill>
-            <a:srgbClr val="6366F1"/>
+            <a:srgbClr val="4F46E5"/>
           </a:solidFill>
           <a:ln>
             <a:noFill/>
@@ -6638,18 +6622,18 @@
         </p:nvSpPr>
         <p:spPr>
           <a:xfrm>
-            <a:off x="914400" y="731520"/>
+            <a:off x="914400" y="685800"/>
             <a:ext cx="2926080" cy="457200"/>
           </a:xfrm>
           <a:prstGeom prst="roundRect">
             <a:avLst/>
           </a:prstGeom>
           <a:solidFill>
-            <a:srgbClr val="334155"/>
+            <a:srgbClr val="EEF2FF"/>
           </a:solidFill>
           <a:ln w="19050">
             <a:solidFill>
-              <a:srgbClr val="6366F1"/>
+              <a:srgbClr val="4F46E5"/>
             </a:solidFill>
           </a:ln>
         </p:spPr>
@@ -6674,7 +6658,7 @@
             <a:pPr algn="ctr">
               <a:defRPr sz="1100" b="1">
                 <a:solidFill>
-                  <a:srgbClr val="38BDF8"/>
+                  <a:srgbClr val="4F46E5"/>
                 </a:solidFill>
               </a:defRPr>
             </a:pPr>
@@ -6692,18 +6676,18 @@
         </p:nvSpPr>
         <p:spPr>
           <a:xfrm>
-            <a:off x="914400" y="1371600"/>
-            <a:ext cx="5669280" cy="4846320"/>
+            <a:off x="914400" y="1325880"/>
+            <a:ext cx="5669280" cy="4983480"/>
           </a:xfrm>
           <a:prstGeom prst="roundRect">
             <a:avLst/>
           </a:prstGeom>
           <a:solidFill>
-            <a:srgbClr val="1E293B"/>
-          </a:solidFill>
-          <a:ln w="25400">
+            <a:srgbClr val="FFFFFF"/>
+          </a:solidFill>
+          <a:ln w="19050">
             <a:solidFill>
-              <a:srgbClr val="6366F1"/>
+              <a:srgbClr val="E2E8F0"/>
             </a:solidFill>
           </a:ln>
         </p:spPr>
@@ -6728,7 +6712,7 @@
             <a:pPr algn="ctr">
               <a:defRPr sz="2800" b="1">
                 <a:solidFill>
-                  <a:srgbClr val="F8FAFC"/>
+                  <a:srgbClr val="1E293B"/>
                 </a:solidFill>
               </a:defRPr>
             </a:pPr>
@@ -6743,7 +6727,7 @@
               </a:spcBef>
               <a:defRPr sz="1300">
                 <a:solidFill>
-                  <a:srgbClr val="A855F7"/>
+                  <a:srgbClr val="2563EB"/>
                 </a:solidFill>
               </a:defRPr>
             </a:pPr>
@@ -6759,7 +6743,7 @@
               </a:spcBef>
               <a:defRPr sz="1200" b="1">
                 <a:solidFill>
-                  <a:srgbClr val="34D399"/>
+                  <a:srgbClr val="10B981"/>
                 </a:solidFill>
               </a:defRPr>
             </a:pPr>
@@ -6774,7 +6758,7 @@
               </a:spcBef>
               <a:defRPr sz="1150">
                 <a:solidFill>
-                  <a:srgbClr val="F8FAFC"/>
+                  <a:srgbClr val="334155"/>
                 </a:solidFill>
               </a:defRPr>
             </a:pPr>
@@ -6789,7 +6773,7 @@
               </a:spcBef>
               <a:defRPr sz="1150">
                 <a:solidFill>
-                  <a:srgbClr val="F8FAFC"/>
+                  <a:srgbClr val="334155"/>
                 </a:solidFill>
               </a:defRPr>
             </a:pPr>
@@ -6804,7 +6788,7 @@
               </a:spcBef>
               <a:defRPr sz="1150">
                 <a:solidFill>
-                  <a:srgbClr val="F8FAFC"/>
+                  <a:srgbClr val="334155"/>
                 </a:solidFill>
               </a:defRPr>
             </a:pPr>
@@ -6819,7 +6803,7 @@
               </a:spcBef>
               <a:defRPr sz="1150">
                 <a:solidFill>
-                  <a:srgbClr val="F8FAFC"/>
+                  <a:srgbClr val="334155"/>
                 </a:solidFill>
               </a:defRPr>
             </a:pPr>
@@ -6837,18 +6821,18 @@
         </p:nvSpPr>
         <p:spPr>
           <a:xfrm>
-            <a:off x="6858000" y="1371600"/>
-            <a:ext cx="4389120" cy="4846320"/>
+            <a:off x="6858000" y="1325880"/>
+            <a:ext cx="4389120" cy="4983480"/>
           </a:xfrm>
           <a:prstGeom prst="roundRect">
             <a:avLst/>
           </a:prstGeom>
           <a:solidFill>
-            <a:srgbClr val="0F172A"/>
+            <a:srgbClr val="EEF2FF"/>
           </a:solidFill>
           <a:ln w="25400">
             <a:solidFill>
-              <a:srgbClr val="A855F7"/>
+              <a:srgbClr val="4F46E5"/>
             </a:solidFill>
           </a:ln>
         </p:spPr>
@@ -6873,7 +6857,7 @@
             <a:pPr algn="ctr">
               <a:defRPr sz="1300" b="1">
                 <a:solidFill>
-                  <a:srgbClr val="6366F1"/>
+                  <a:srgbClr val="4F46E5"/>
                 </a:solidFill>
               </a:defRPr>
             </a:pPr>
@@ -6919,7 +6903,7 @@
             <a:avLst/>
           </a:prstGeom>
           <a:solidFill>
-            <a:srgbClr val="0F172A"/>
+            <a:srgbClr val="F8FAFC"/>
           </a:solidFill>
           <a:ln>
             <a:noFill/>
@@ -6962,7 +6946,7 @@
             <a:avLst/>
           </a:prstGeom>
           <a:solidFill>
-            <a:srgbClr val="6366F1"/>
+            <a:srgbClr val="4F46E5"/>
           </a:solidFill>
           <a:ln>
             <a:noFill/>
@@ -6998,96 +6982,94 @@
         </p:nvSpPr>
         <p:spPr>
           <a:xfrm>
-            <a:off x="731520" y="457200"/>
-            <a:ext cx="10728655" cy="1051560"/>
+            <a:off x="731520" y="411480"/>
+            <a:ext cx="10728655" cy="1097280"/>
           </a:xfrm>
           <a:prstGeom prst="roundRect">
             <a:avLst/>
           </a:prstGeom>
           <a:solidFill>
-            <a:srgbClr val="1E293B"/>
+            <a:srgbClr val="4F46E5"/>
+          </a:solidFill>
+          <a:ln>
+            <a:noFill/>
+          </a:ln>
+        </p:spPr>
+        <p:style>
+          <a:lnRef idx="1">
+            <a:schemeClr val="accent1"/>
+          </a:lnRef>
+          <a:fillRef idx="3">
+            <a:schemeClr val="accent1"/>
+          </a:fillRef>
+          <a:effectRef idx="2">
+            <a:schemeClr val="accent1"/>
+          </a:effectRef>
+          <a:fontRef idx="minor">
+            <a:schemeClr val="lt1"/>
+          </a:fontRef>
+        </p:style>
+        <p:txBody>
+          <a:bodyPr rtlCol="0" anchor="ctr" wrap="square"/>
+          <a:lstStyle/>
+          <a:p>
+            <a:pPr algn="ctr">
+              <a:defRPr sz="1000" b="1">
+                <a:solidFill>
+                  <a:srgbClr val="C7D2FE"/>
+                </a:solidFill>
+              </a:defRPr>
+            </a:pPr>
+            <a:r>
+              <a:t>[ PROBLEM STATEMENT &amp; IMPACT ] — SLIDE 2</a:t>
+            </a:r>
+          </a:p>
+          <a:p>
+            <a:pPr>
+              <a:defRPr sz="1900" b="1">
+                <a:solidFill>
+                  <a:srgbClr val="FFFFFF"/>
+                </a:solidFill>
+              </a:defRPr>
+            </a:pPr>
+            <a:r>
+              <a:t>Executive Problem Statement &amp; Business Impact</a:t>
+            </a:r>
+          </a:p>
+          <a:p>
+            <a:pPr>
+              <a:defRPr sz="1150">
+                <a:solidFill>
+                  <a:srgbClr val="E0E7FF"/>
+                </a:solidFill>
+              </a:defRPr>
+            </a:pPr>
+            <a:r>
+              <a:t>Eliminating Office Scheduling Conflicts &amp; Approval Bottlenecks</a:t>
+            </a:r>
+          </a:p>
+        </p:txBody>
+      </p:sp>
+      <p:sp>
+        <p:nvSpPr>
+          <p:cNvPr id="5" name="Rounded Rectangle 4"/>
+          <p:cNvSpPr/>
+          <p:nvPr/>
+        </p:nvSpPr>
+        <p:spPr>
+          <a:xfrm>
+            <a:off x="731520" y="1645920"/>
+            <a:ext cx="5486400" cy="4754880"/>
+          </a:xfrm>
+          <a:prstGeom prst="roundRect">
+            <a:avLst/>
+          </a:prstGeom>
+          <a:solidFill>
+            <a:srgbClr val="FFFFFF"/>
           </a:solidFill>
           <a:ln w="19050">
             <a:solidFill>
-              <a:srgbClr val="6366F1"/>
-            </a:solidFill>
-          </a:ln>
-        </p:spPr>
-        <p:style>
-          <a:lnRef idx="1">
-            <a:schemeClr val="accent1"/>
-          </a:lnRef>
-          <a:fillRef idx="3">
-            <a:schemeClr val="accent1"/>
-          </a:fillRef>
-          <a:effectRef idx="2">
-            <a:schemeClr val="accent1"/>
-          </a:effectRef>
-          <a:fontRef idx="minor">
-            <a:schemeClr val="lt1"/>
-          </a:fontRef>
-        </p:style>
-        <p:txBody>
-          <a:bodyPr rtlCol="0" anchor="ctr" wrap="square"/>
-          <a:lstStyle/>
-          <a:p>
-            <a:pPr algn="ctr">
-              <a:defRPr sz="1000" b="1">
-                <a:solidFill>
-                  <a:srgbClr val="38BDF8"/>
-                </a:solidFill>
-              </a:defRPr>
-            </a:pPr>
-            <a:r>
-              <a:t>[ PROBLEM STATEMENT &amp; IMPACT ] — SLIDE 2</a:t>
-            </a:r>
-          </a:p>
-          <a:p>
-            <a:pPr>
-              <a:defRPr sz="1900" b="1">
-                <a:solidFill>
-                  <a:srgbClr val="F8FAFC"/>
-                </a:solidFill>
-              </a:defRPr>
-            </a:pPr>
-            <a:r>
-              <a:t>Executive Problem Statement &amp; Business Impact</a:t>
-            </a:r>
-          </a:p>
-          <a:p>
-            <a:pPr>
-              <a:defRPr sz="1150">
-                <a:solidFill>
-                  <a:srgbClr val="A855F7"/>
-                </a:solidFill>
-              </a:defRPr>
-            </a:pPr>
-            <a:r>
-              <a:t>Eliminating Office Scheduling Conflicts &amp; Approval Bottlenecks</a:t>
-            </a:r>
-          </a:p>
-        </p:txBody>
-      </p:sp>
-      <p:sp>
-        <p:nvSpPr>
-          <p:cNvPr id="5" name="Rounded Rectangle 4"/>
-          <p:cNvSpPr/>
-          <p:nvPr/>
-        </p:nvSpPr>
-        <p:spPr>
-          <a:xfrm>
-            <a:off x="731520" y="1691640"/>
-            <a:ext cx="5486400" cy="4709160"/>
-          </a:xfrm>
-          <a:prstGeom prst="roundRect">
-            <a:avLst/>
-          </a:prstGeom>
-          <a:solidFill>
-            <a:srgbClr val="1E293B"/>
-          </a:solidFill>
-          <a:ln w="12700">
-            <a:solidFill>
-              <a:srgbClr val="334155"/>
+              <a:srgbClr val="E2E8F0"/>
             </a:solidFill>
           </a:ln>
         </p:spPr>
@@ -7112,7 +7094,7 @@
             <a:pPr algn="ctr">
               <a:defRPr sz="1200" b="1">
                 <a:solidFill>
-                  <a:srgbClr val="FBBF24"/>
+                  <a:srgbClr val="2563EB"/>
                 </a:solidFill>
               </a:defRPr>
             </a:pPr>
@@ -7127,12 +7109,12 @@
               </a:spcBef>
               <a:defRPr sz="1150">
                 <a:solidFill>
-                  <a:srgbClr val="F8FAFC"/>
-                </a:solidFill>
-              </a:defRPr>
-            </a:pPr>
-            <a:r>
-              <a:t>🔹 The Problem: Double bookings cause meeting delays and team friction.</a:t>
+                  <a:srgbClr val="334155"/>
+                </a:solidFill>
+              </a:defRPr>
+            </a:pPr>
+            <a:r>
+              <a:t>🔹 The Problem: Meeting room double-bookings cause meeting delays and friction.</a:t>
             </a:r>
           </a:p>
           <a:p>
@@ -7142,7 +7124,7 @@
               </a:spcBef>
               <a:defRPr sz="1150">
                 <a:solidFill>
-                  <a:srgbClr val="F8FAFC"/>
+                  <a:srgbClr val="334155"/>
                 </a:solidFill>
               </a:defRPr>
             </a:pPr>
@@ -7157,7 +7139,7 @@
               </a:spcBef>
               <a:defRPr sz="1150">
                 <a:solidFill>
-                  <a:srgbClr val="F8FAFC"/>
+                  <a:srgbClr val="334155"/>
                 </a:solidFill>
               </a:defRPr>
             </a:pPr>
@@ -7172,7 +7154,7 @@
               </a:spcBef>
               <a:defRPr sz="1150">
                 <a:solidFill>
-                  <a:srgbClr val="F8FAFC"/>
+                  <a:srgbClr val="334155"/>
                 </a:solidFill>
               </a:defRPr>
             </a:pPr>
@@ -7190,18 +7172,18 @@
         </p:nvSpPr>
         <p:spPr>
           <a:xfrm>
-            <a:off x="6400800" y="1691640"/>
-            <a:ext cx="5059375" cy="4709160"/>
+            <a:off x="6400800" y="1645920"/>
+            <a:ext cx="5059375" cy="4754880"/>
           </a:xfrm>
           <a:prstGeom prst="roundRect">
             <a:avLst/>
           </a:prstGeom>
           <a:solidFill>
-            <a:srgbClr val="1E293B"/>
+            <a:srgbClr val="FFFFFF"/>
           </a:solidFill>
           <a:ln w="25400">
             <a:solidFill>
-              <a:srgbClr val="6366F1"/>
+              <a:srgbClr val="4F46E5"/>
             </a:solidFill>
           </a:ln>
         </p:spPr>
@@ -7235,18 +7217,18 @@
         </p:nvSpPr>
         <p:spPr>
           <a:xfrm>
-            <a:off x="6537960" y="1828800"/>
-            <a:ext cx="4785055" cy="4434840"/>
+            <a:off x="6537960" y="1783080"/>
+            <a:ext cx="4785055" cy="4480560"/>
           </a:xfrm>
           <a:prstGeom prst="roundRect">
             <a:avLst/>
           </a:prstGeom>
           <a:solidFill>
-            <a:srgbClr val="0F172A"/>
+            <a:srgbClr val="EEF2FF"/>
           </a:solidFill>
           <a:ln w="12700">
             <a:solidFill>
-              <a:srgbClr val="A855F7"/>
+              <a:srgbClr val="E2E8F0"/>
             </a:solidFill>
           </a:ln>
         </p:spPr>
@@ -7271,7 +7253,7 @@
             <a:pPr algn="ctr">
               <a:defRPr sz="1300" b="1">
                 <a:solidFill>
-                  <a:srgbClr val="6366F1"/>
+                  <a:srgbClr val="4F46E5"/>
                 </a:solidFill>
               </a:defRPr>
             </a:pPr>
@@ -7317,7 +7299,7 @@
             <a:avLst/>
           </a:prstGeom>
           <a:solidFill>
-            <a:srgbClr val="0F172A"/>
+            <a:srgbClr val="F8FAFC"/>
           </a:solidFill>
           <a:ln>
             <a:noFill/>
@@ -7360,7 +7342,7 @@
             <a:avLst/>
           </a:prstGeom>
           <a:solidFill>
-            <a:srgbClr val="6366F1"/>
+            <a:srgbClr val="4F46E5"/>
           </a:solidFill>
           <a:ln>
             <a:noFill/>
@@ -7396,96 +7378,94 @@
         </p:nvSpPr>
         <p:spPr>
           <a:xfrm>
-            <a:off x="731520" y="457200"/>
-            <a:ext cx="10728655" cy="1051560"/>
+            <a:off x="731520" y="411480"/>
+            <a:ext cx="10728655" cy="1097280"/>
           </a:xfrm>
           <a:prstGeom prst="roundRect">
             <a:avLst/>
           </a:prstGeom>
           <a:solidFill>
-            <a:srgbClr val="1E293B"/>
+            <a:srgbClr val="4F46E5"/>
+          </a:solidFill>
+          <a:ln>
+            <a:noFill/>
+          </a:ln>
+        </p:spPr>
+        <p:style>
+          <a:lnRef idx="1">
+            <a:schemeClr val="accent1"/>
+          </a:lnRef>
+          <a:fillRef idx="3">
+            <a:schemeClr val="accent1"/>
+          </a:fillRef>
+          <a:effectRef idx="2">
+            <a:schemeClr val="accent1"/>
+          </a:effectRef>
+          <a:fontRef idx="minor">
+            <a:schemeClr val="lt1"/>
+          </a:fontRef>
+        </p:style>
+        <p:txBody>
+          <a:bodyPr rtlCol="0" anchor="ctr" wrap="square"/>
+          <a:lstStyle/>
+          <a:p>
+            <a:pPr algn="ctr">
+              <a:defRPr sz="1000" b="1">
+                <a:solidFill>
+                  <a:srgbClr val="C7D2FE"/>
+                </a:solidFill>
+              </a:defRPr>
+            </a:pPr>
+            <a:r>
+              <a:t>[ SYSTEM ARCHITECTURE ] — SLIDE 3</a:t>
+            </a:r>
+          </a:p>
+          <a:p>
+            <a:pPr>
+              <a:defRPr sz="1900" b="1">
+                <a:solidFill>
+                  <a:srgbClr val="FFFFFF"/>
+                </a:solidFill>
+              </a:defRPr>
+            </a:pPr>
+            <a:r>
+              <a:t>Non-Technical System Architecture Overview</a:t>
+            </a:r>
+          </a:p>
+          <a:p>
+            <a:pPr>
+              <a:defRPr sz="1150">
+                <a:solidFill>
+                  <a:srgbClr val="E0E7FF"/>
+                </a:solidFill>
+              </a:defRPr>
+            </a:pPr>
+            <a:r>
+              <a:t>Lightweight, High-Performance 3-Tier Enterprise Design</a:t>
+            </a:r>
+          </a:p>
+        </p:txBody>
+      </p:sp>
+      <p:sp>
+        <p:nvSpPr>
+          <p:cNvPr id="5" name="Rounded Rectangle 4"/>
+          <p:cNvSpPr/>
+          <p:nvPr/>
+        </p:nvSpPr>
+        <p:spPr>
+          <a:xfrm>
+            <a:off x="731520" y="1645920"/>
+            <a:ext cx="5486400" cy="4754880"/>
+          </a:xfrm>
+          <a:prstGeom prst="roundRect">
+            <a:avLst/>
+          </a:prstGeom>
+          <a:solidFill>
+            <a:srgbClr val="FFFFFF"/>
           </a:solidFill>
           <a:ln w="19050">
             <a:solidFill>
-              <a:srgbClr val="6366F1"/>
-            </a:solidFill>
-          </a:ln>
-        </p:spPr>
-        <p:style>
-          <a:lnRef idx="1">
-            <a:schemeClr val="accent1"/>
-          </a:lnRef>
-          <a:fillRef idx="3">
-            <a:schemeClr val="accent1"/>
-          </a:fillRef>
-          <a:effectRef idx="2">
-            <a:schemeClr val="accent1"/>
-          </a:effectRef>
-          <a:fontRef idx="minor">
-            <a:schemeClr val="lt1"/>
-          </a:fontRef>
-        </p:style>
-        <p:txBody>
-          <a:bodyPr rtlCol="0" anchor="ctr" wrap="square"/>
-          <a:lstStyle/>
-          <a:p>
-            <a:pPr algn="ctr">
-              <a:defRPr sz="1000" b="1">
-                <a:solidFill>
-                  <a:srgbClr val="38BDF8"/>
-                </a:solidFill>
-              </a:defRPr>
-            </a:pPr>
-            <a:r>
-              <a:t>[ SYSTEM ARCHITECTURE ] — SLIDE 3</a:t>
-            </a:r>
-          </a:p>
-          <a:p>
-            <a:pPr>
-              <a:defRPr sz="1900" b="1">
-                <a:solidFill>
-                  <a:srgbClr val="F8FAFC"/>
-                </a:solidFill>
-              </a:defRPr>
-            </a:pPr>
-            <a:r>
-              <a:t>Non-Technical System Architecture Overview</a:t>
-            </a:r>
-          </a:p>
-          <a:p>
-            <a:pPr>
-              <a:defRPr sz="1150">
-                <a:solidFill>
-                  <a:srgbClr val="A855F7"/>
-                </a:solidFill>
-              </a:defRPr>
-            </a:pPr>
-            <a:r>
-              <a:t>Lightweight, High-Performance 3-Tier Enterprise Design</a:t>
-            </a:r>
-          </a:p>
-        </p:txBody>
-      </p:sp>
-      <p:sp>
-        <p:nvSpPr>
-          <p:cNvPr id="5" name="Rounded Rectangle 4"/>
-          <p:cNvSpPr/>
-          <p:nvPr/>
-        </p:nvSpPr>
-        <p:spPr>
-          <a:xfrm>
-            <a:off x="731520" y="1691640"/>
-            <a:ext cx="5486400" cy="4709160"/>
-          </a:xfrm>
-          <a:prstGeom prst="roundRect">
-            <a:avLst/>
-          </a:prstGeom>
-          <a:solidFill>
-            <a:srgbClr val="1E293B"/>
-          </a:solidFill>
-          <a:ln w="12700">
-            <a:solidFill>
-              <a:srgbClr val="334155"/>
+              <a:srgbClr val="E2E8F0"/>
             </a:solidFill>
           </a:ln>
         </p:spPr>
@@ -7510,7 +7490,7 @@
             <a:pPr algn="ctr">
               <a:defRPr sz="1200" b="1">
                 <a:solidFill>
-                  <a:srgbClr val="FBBF24"/>
+                  <a:srgbClr val="2563EB"/>
                 </a:solidFill>
               </a:defRPr>
             </a:pPr>
@@ -7525,7 +7505,7 @@
               </a:spcBef>
               <a:defRPr sz="1150">
                 <a:solidFill>
-                  <a:srgbClr val="F8FAFC"/>
+                  <a:srgbClr val="334155"/>
                 </a:solidFill>
               </a:defRPr>
             </a:pPr>
@@ -7540,7 +7520,7 @@
               </a:spcBef>
               <a:defRPr sz="1150">
                 <a:solidFill>
-                  <a:srgbClr val="F8FAFC"/>
+                  <a:srgbClr val="334155"/>
                 </a:solidFill>
               </a:defRPr>
             </a:pPr>
@@ -7555,7 +7535,7 @@
               </a:spcBef>
               <a:defRPr sz="1150">
                 <a:solidFill>
-                  <a:srgbClr val="F8FAFC"/>
+                  <a:srgbClr val="334155"/>
                 </a:solidFill>
               </a:defRPr>
             </a:pPr>
@@ -7573,18 +7553,18 @@
         </p:nvSpPr>
         <p:spPr>
           <a:xfrm>
-            <a:off x="6400800" y="1691640"/>
-            <a:ext cx="5059375" cy="4709160"/>
+            <a:off x="6400800" y="1645920"/>
+            <a:ext cx="5059375" cy="4754880"/>
           </a:xfrm>
           <a:prstGeom prst="roundRect">
             <a:avLst/>
           </a:prstGeom>
           <a:solidFill>
-            <a:srgbClr val="1E293B"/>
+            <a:srgbClr val="FFFFFF"/>
           </a:solidFill>
           <a:ln w="25400">
             <a:solidFill>
-              <a:srgbClr val="6366F1"/>
+              <a:srgbClr val="4F46E5"/>
             </a:solidFill>
           </a:ln>
         </p:spPr>
@@ -7618,18 +7598,18 @@
         </p:nvSpPr>
         <p:spPr>
           <a:xfrm>
-            <a:off x="6537960" y="1828800"/>
-            <a:ext cx="4785055" cy="4434840"/>
+            <a:off x="6537960" y="1783080"/>
+            <a:ext cx="4785055" cy="4480560"/>
           </a:xfrm>
           <a:prstGeom prst="roundRect">
             <a:avLst/>
           </a:prstGeom>
           <a:solidFill>
-            <a:srgbClr val="0F172A"/>
+            <a:srgbClr val="EEF2FF"/>
           </a:solidFill>
           <a:ln w="12700">
             <a:solidFill>
-              <a:srgbClr val="A855F7"/>
+              <a:srgbClr val="E2E8F0"/>
             </a:solidFill>
           </a:ln>
         </p:spPr>
@@ -7654,7 +7634,7 @@
             <a:pPr algn="ctr">
               <a:defRPr sz="1300" b="1">
                 <a:solidFill>
-                  <a:srgbClr val="6366F1"/>
+                  <a:srgbClr val="4F46E5"/>
                 </a:solidFill>
               </a:defRPr>
             </a:pPr>
@@ -7700,7 +7680,7 @@
             <a:avLst/>
           </a:prstGeom>
           <a:solidFill>
-            <a:srgbClr val="0F172A"/>
+            <a:srgbClr val="F8FAFC"/>
           </a:solidFill>
           <a:ln>
             <a:noFill/>
@@ -7743,7 +7723,7 @@
             <a:avLst/>
           </a:prstGeom>
           <a:solidFill>
-            <a:srgbClr val="6366F1"/>
+            <a:srgbClr val="4F46E5"/>
           </a:solidFill>
           <a:ln>
             <a:noFill/>
@@ -7779,96 +7759,94 @@
         </p:nvSpPr>
         <p:spPr>
           <a:xfrm>
-            <a:off x="731520" y="457200"/>
-            <a:ext cx="10728655" cy="1051560"/>
+            <a:off x="731520" y="411480"/>
+            <a:ext cx="10728655" cy="1097280"/>
           </a:xfrm>
           <a:prstGeom prst="roundRect">
             <a:avLst/>
           </a:prstGeom>
           <a:solidFill>
-            <a:srgbClr val="1E293B"/>
+            <a:srgbClr val="4F46E5"/>
+          </a:solidFill>
+          <a:ln>
+            <a:noFill/>
+          </a:ln>
+        </p:spPr>
+        <p:style>
+          <a:lnRef idx="1">
+            <a:schemeClr val="accent1"/>
+          </a:lnRef>
+          <a:fillRef idx="3">
+            <a:schemeClr val="accent1"/>
+          </a:fillRef>
+          <a:effectRef idx="2">
+            <a:schemeClr val="accent1"/>
+          </a:effectRef>
+          <a:fontRef idx="minor">
+            <a:schemeClr val="lt1"/>
+          </a:fontRef>
+        </p:style>
+        <p:txBody>
+          <a:bodyPr rtlCol="0" anchor="ctr" wrap="square"/>
+          <a:lstStyle/>
+          <a:p>
+            <a:pPr algn="ctr">
+              <a:defRPr sz="1000" b="1">
+                <a:solidFill>
+                  <a:srgbClr val="C7D2FE"/>
+                </a:solidFill>
+              </a:defRPr>
+            </a:pPr>
+            <a:r>
+              <a:t>[ DATABASE MODEL ] — SLIDE 4</a:t>
+            </a:r>
+          </a:p>
+          <a:p>
+            <a:pPr>
+              <a:defRPr sz="1900" b="1">
+                <a:solidFill>
+                  <a:srgbClr val="FFFFFF"/>
+                </a:solidFill>
+              </a:defRPr>
+            </a:pPr>
+            <a:r>
+              <a:t>MySQL Relational Schema &amp; Workbench EER Diagram</a:t>
+            </a:r>
+          </a:p>
+          <a:p>
+            <a:pPr>
+              <a:defRPr sz="1150">
+                <a:solidFill>
+                  <a:srgbClr val="E0E7FF"/>
+                </a:solidFill>
+              </a:defRPr>
+            </a:pPr>
+            <a:r>
+              <a:t>12 Interconnected SQL Tables Linked via Foreign Keys</a:t>
+            </a:r>
+          </a:p>
+        </p:txBody>
+      </p:sp>
+      <p:sp>
+        <p:nvSpPr>
+          <p:cNvPr id="5" name="Rounded Rectangle 4"/>
+          <p:cNvSpPr/>
+          <p:nvPr/>
+        </p:nvSpPr>
+        <p:spPr>
+          <a:xfrm>
+            <a:off x="731520" y="1645920"/>
+            <a:ext cx="5486400" cy="4754880"/>
+          </a:xfrm>
+          <a:prstGeom prst="roundRect">
+            <a:avLst/>
+          </a:prstGeom>
+          <a:solidFill>
+            <a:srgbClr val="FFFFFF"/>
           </a:solidFill>
           <a:ln w="19050">
             <a:solidFill>
-              <a:srgbClr val="6366F1"/>
-            </a:solidFill>
-          </a:ln>
-        </p:spPr>
-        <p:style>
-          <a:lnRef idx="1">
-            <a:schemeClr val="accent1"/>
-          </a:lnRef>
-          <a:fillRef idx="3">
-            <a:schemeClr val="accent1"/>
-          </a:fillRef>
-          <a:effectRef idx="2">
-            <a:schemeClr val="accent1"/>
-          </a:effectRef>
-          <a:fontRef idx="minor">
-            <a:schemeClr val="lt1"/>
-          </a:fontRef>
-        </p:style>
-        <p:txBody>
-          <a:bodyPr rtlCol="0" anchor="ctr" wrap="square"/>
-          <a:lstStyle/>
-          <a:p>
-            <a:pPr algn="ctr">
-              <a:defRPr sz="1000" b="1">
-                <a:solidFill>
-                  <a:srgbClr val="38BDF8"/>
-                </a:solidFill>
-              </a:defRPr>
-            </a:pPr>
-            <a:r>
-              <a:t>[ DATABASE MODEL ] — SLIDE 4</a:t>
-            </a:r>
-          </a:p>
-          <a:p>
-            <a:pPr>
-              <a:defRPr sz="1900" b="1">
-                <a:solidFill>
-                  <a:srgbClr val="F8FAFC"/>
-                </a:solidFill>
-              </a:defRPr>
-            </a:pPr>
-            <a:r>
-              <a:t>MySQL Relational Schema &amp; Workbench EER Diagram</a:t>
-            </a:r>
-          </a:p>
-          <a:p>
-            <a:pPr>
-              <a:defRPr sz="1150">
-                <a:solidFill>
-                  <a:srgbClr val="A855F7"/>
-                </a:solidFill>
-              </a:defRPr>
-            </a:pPr>
-            <a:r>
-              <a:t>12 Interconnected SQL Tables Linked via Foreign Keys</a:t>
-            </a:r>
-          </a:p>
-        </p:txBody>
-      </p:sp>
-      <p:sp>
-        <p:nvSpPr>
-          <p:cNvPr id="5" name="Rounded Rectangle 4"/>
-          <p:cNvSpPr/>
-          <p:nvPr/>
-        </p:nvSpPr>
-        <p:spPr>
-          <a:xfrm>
-            <a:off x="731520" y="1691640"/>
-            <a:ext cx="5486400" cy="4709160"/>
-          </a:xfrm>
-          <a:prstGeom prst="roundRect">
-            <a:avLst/>
-          </a:prstGeom>
-          <a:solidFill>
-            <a:srgbClr val="1E293B"/>
-          </a:solidFill>
-          <a:ln w="12700">
-            <a:solidFill>
-              <a:srgbClr val="334155"/>
+              <a:srgbClr val="E2E8F0"/>
             </a:solidFill>
           </a:ln>
         </p:spPr>
@@ -7893,7 +7871,7 @@
             <a:pPr algn="ctr">
               <a:defRPr sz="1200" b="1">
                 <a:solidFill>
-                  <a:srgbClr val="FBBF24"/>
+                  <a:srgbClr val="2563EB"/>
                 </a:solidFill>
               </a:defRPr>
             </a:pPr>
@@ -7908,7 +7886,7 @@
               </a:spcBef>
               <a:defRPr sz="1150">
                 <a:solidFill>
-                  <a:srgbClr val="F8FAFC"/>
+                  <a:srgbClr val="334155"/>
                 </a:solidFill>
               </a:defRPr>
             </a:pPr>
@@ -7923,7 +7901,7 @@
               </a:spcBef>
               <a:defRPr sz="1150">
                 <a:solidFill>
-                  <a:srgbClr val="F8FAFC"/>
+                  <a:srgbClr val="334155"/>
                 </a:solidFill>
               </a:defRPr>
             </a:pPr>
@@ -7938,7 +7916,7 @@
               </a:spcBef>
               <a:defRPr sz="1150">
                 <a:solidFill>
-                  <a:srgbClr val="F8FAFC"/>
+                  <a:srgbClr val="334155"/>
                 </a:solidFill>
               </a:defRPr>
             </a:pPr>
@@ -7956,18 +7934,18 @@
         </p:nvSpPr>
         <p:spPr>
           <a:xfrm>
-            <a:off x="6400800" y="1691640"/>
-            <a:ext cx="5059375" cy="4709160"/>
+            <a:off x="6400800" y="1645920"/>
+            <a:ext cx="5059375" cy="4754880"/>
           </a:xfrm>
           <a:prstGeom prst="roundRect">
             <a:avLst/>
           </a:prstGeom>
           <a:solidFill>
-            <a:srgbClr val="1E293B"/>
+            <a:srgbClr val="FFFFFF"/>
           </a:solidFill>
           <a:ln w="25400">
             <a:solidFill>
-              <a:srgbClr val="6366F1"/>
+              <a:srgbClr val="4F46E5"/>
             </a:solidFill>
           </a:ln>
         </p:spPr>
@@ -8001,18 +7979,18 @@
         </p:nvSpPr>
         <p:spPr>
           <a:xfrm>
-            <a:off x="6537960" y="1828800"/>
-            <a:ext cx="4785055" cy="4434840"/>
+            <a:off x="6537960" y="1783080"/>
+            <a:ext cx="4785055" cy="4480560"/>
           </a:xfrm>
           <a:prstGeom prst="roundRect">
             <a:avLst/>
           </a:prstGeom>
           <a:solidFill>
-            <a:srgbClr val="0F172A"/>
+            <a:srgbClr val="EEF2FF"/>
           </a:solidFill>
           <a:ln w="12700">
             <a:solidFill>
-              <a:srgbClr val="A855F7"/>
+              <a:srgbClr val="E2E8F0"/>
             </a:solidFill>
           </a:ln>
         </p:spPr>
@@ -8037,7 +8015,7 @@
             <a:pPr algn="ctr">
               <a:defRPr sz="1300" b="1">
                 <a:solidFill>
-                  <a:srgbClr val="6366F1"/>
+                  <a:srgbClr val="4F46E5"/>
                 </a:solidFill>
               </a:defRPr>
             </a:pPr>
@@ -8083,7 +8061,7 @@
             <a:avLst/>
           </a:prstGeom>
           <a:solidFill>
-            <a:srgbClr val="0F172A"/>
+            <a:srgbClr val="F8FAFC"/>
           </a:solidFill>
           <a:ln>
             <a:noFill/>
@@ -8126,7 +8104,7 @@
             <a:avLst/>
           </a:prstGeom>
           <a:solidFill>
-            <a:srgbClr val="6366F1"/>
+            <a:srgbClr val="4F46E5"/>
           </a:solidFill>
           <a:ln>
             <a:noFill/>
@@ -8162,96 +8140,94 @@
         </p:nvSpPr>
         <p:spPr>
           <a:xfrm>
-            <a:off x="731520" y="457200"/>
-            <a:ext cx="10728655" cy="1051560"/>
+            <a:off x="731520" y="411480"/>
+            <a:ext cx="10728655" cy="1097280"/>
           </a:xfrm>
           <a:prstGeom prst="roundRect">
             <a:avLst/>
           </a:prstGeom>
           <a:solidFill>
-            <a:srgbClr val="1E293B"/>
+            <a:srgbClr val="4F46E5"/>
+          </a:solidFill>
+          <a:ln>
+            <a:noFill/>
+          </a:ln>
+        </p:spPr>
+        <p:style>
+          <a:lnRef idx="1">
+            <a:schemeClr val="accent1"/>
+          </a:lnRef>
+          <a:fillRef idx="3">
+            <a:schemeClr val="accent1"/>
+          </a:fillRef>
+          <a:effectRef idx="2">
+            <a:schemeClr val="accent1"/>
+          </a:effectRef>
+          <a:fontRef idx="minor">
+            <a:schemeClr val="lt1"/>
+          </a:fontRef>
+        </p:style>
+        <p:txBody>
+          <a:bodyPr rtlCol="0" anchor="ctr" wrap="square"/>
+          <a:lstStyle/>
+          <a:p>
+            <a:pPr algn="ctr">
+              <a:defRPr sz="1000" b="1">
+                <a:solidFill>
+                  <a:srgbClr val="C7D2FE"/>
+                </a:solidFill>
+              </a:defRPr>
+            </a:pPr>
+            <a:r>
+              <a:t>[ AUTHENTICATION &amp; ROLES ] — SLIDE 5</a:t>
+            </a:r>
+          </a:p>
+          <a:p>
+            <a:pPr>
+              <a:defRPr sz="1900" b="1">
+                <a:solidFill>
+                  <a:srgbClr val="FFFFFF"/>
+                </a:solidFill>
+              </a:defRPr>
+            </a:pPr>
+            <a:r>
+              <a:t>Sign In &amp; Sign Up Authentication Portal</a:t>
+            </a:r>
+          </a:p>
+          <a:p>
+            <a:pPr>
+              <a:defRPr sz="1150">
+                <a:solidFill>
+                  <a:srgbClr val="E0E7FF"/>
+                </a:solidFill>
+              </a:defRPr>
+            </a:pPr>
+            <a:r>
+              <a:t>Secure Employee &amp; Manager Account Management</a:t>
+            </a:r>
+          </a:p>
+        </p:txBody>
+      </p:sp>
+      <p:sp>
+        <p:nvSpPr>
+          <p:cNvPr id="5" name="Rounded Rectangle 4"/>
+          <p:cNvSpPr/>
+          <p:nvPr/>
+        </p:nvSpPr>
+        <p:spPr>
+          <a:xfrm>
+            <a:off x="731520" y="1645920"/>
+            <a:ext cx="5486400" cy="4754880"/>
+          </a:xfrm>
+          <a:prstGeom prst="roundRect">
+            <a:avLst/>
+          </a:prstGeom>
+          <a:solidFill>
+            <a:srgbClr val="FFFFFF"/>
           </a:solidFill>
           <a:ln w="19050">
             <a:solidFill>
-              <a:srgbClr val="6366F1"/>
-            </a:solidFill>
-          </a:ln>
-        </p:spPr>
-        <p:style>
-          <a:lnRef idx="1">
-            <a:schemeClr val="accent1"/>
-          </a:lnRef>
-          <a:fillRef idx="3">
-            <a:schemeClr val="accent1"/>
-          </a:fillRef>
-          <a:effectRef idx="2">
-            <a:schemeClr val="accent1"/>
-          </a:effectRef>
-          <a:fontRef idx="minor">
-            <a:schemeClr val="lt1"/>
-          </a:fontRef>
-        </p:style>
-        <p:txBody>
-          <a:bodyPr rtlCol="0" anchor="ctr" wrap="square"/>
-          <a:lstStyle/>
-          <a:p>
-            <a:pPr algn="ctr">
-              <a:defRPr sz="1000" b="1">
-                <a:solidFill>
-                  <a:srgbClr val="38BDF8"/>
-                </a:solidFill>
-              </a:defRPr>
-            </a:pPr>
-            <a:r>
-              <a:t>[ AUTHENTICATION &amp; ROLES ] — SLIDE 5</a:t>
-            </a:r>
-          </a:p>
-          <a:p>
-            <a:pPr>
-              <a:defRPr sz="1900" b="1">
-                <a:solidFill>
-                  <a:srgbClr val="F8FAFC"/>
-                </a:solidFill>
-              </a:defRPr>
-            </a:pPr>
-            <a:r>
-              <a:t>Sign In &amp; Sign Up Authentication Portal</a:t>
-            </a:r>
-          </a:p>
-          <a:p>
-            <a:pPr>
-              <a:defRPr sz="1150">
-                <a:solidFill>
-                  <a:srgbClr val="A855F7"/>
-                </a:solidFill>
-              </a:defRPr>
-            </a:pPr>
-            <a:r>
-              <a:t>Secure Employee &amp; Manager Account Management</a:t>
-            </a:r>
-          </a:p>
-        </p:txBody>
-      </p:sp>
-      <p:sp>
-        <p:nvSpPr>
-          <p:cNvPr id="5" name="Rounded Rectangle 4"/>
-          <p:cNvSpPr/>
-          <p:nvPr/>
-        </p:nvSpPr>
-        <p:spPr>
-          <a:xfrm>
-            <a:off x="731520" y="1691640"/>
-            <a:ext cx="5486400" cy="4709160"/>
-          </a:xfrm>
-          <a:prstGeom prst="roundRect">
-            <a:avLst/>
-          </a:prstGeom>
-          <a:solidFill>
-            <a:srgbClr val="1E293B"/>
-          </a:solidFill>
-          <a:ln w="12700">
-            <a:solidFill>
-              <a:srgbClr val="334155"/>
+              <a:srgbClr val="E2E8F0"/>
             </a:solidFill>
           </a:ln>
         </p:spPr>
@@ -8276,7 +8252,7 @@
             <a:pPr algn="ctr">
               <a:defRPr sz="1200" b="1">
                 <a:solidFill>
-                  <a:srgbClr val="FBBF24"/>
+                  <a:srgbClr val="2563EB"/>
                 </a:solidFill>
               </a:defRPr>
             </a:pPr>
@@ -8291,7 +8267,7 @@
               </a:spcBef>
               <a:defRPr sz="1150">
                 <a:solidFill>
-                  <a:srgbClr val="F8FAFC"/>
+                  <a:srgbClr val="334155"/>
                 </a:solidFill>
               </a:defRPr>
             </a:pPr>
@@ -8306,7 +8282,7 @@
               </a:spcBef>
               <a:defRPr sz="1150">
                 <a:solidFill>
-                  <a:srgbClr val="F8FAFC"/>
+                  <a:srgbClr val="334155"/>
                 </a:solidFill>
               </a:defRPr>
             </a:pPr>
@@ -8321,7 +8297,7 @@
               </a:spcBef>
               <a:defRPr sz="1150">
                 <a:solidFill>
-                  <a:srgbClr val="F8FAFC"/>
+                  <a:srgbClr val="334155"/>
                 </a:solidFill>
               </a:defRPr>
             </a:pPr>
@@ -8339,18 +8315,18 @@
         </p:nvSpPr>
         <p:spPr>
           <a:xfrm>
-            <a:off x="6400800" y="1691640"/>
-            <a:ext cx="5059375" cy="4709160"/>
+            <a:off x="6400800" y="1645920"/>
+            <a:ext cx="5059375" cy="4754880"/>
           </a:xfrm>
           <a:prstGeom prst="roundRect">
             <a:avLst/>
           </a:prstGeom>
           <a:solidFill>
-            <a:srgbClr val="1E293B"/>
+            <a:srgbClr val="FFFFFF"/>
           </a:solidFill>
           <a:ln w="25400">
             <a:solidFill>
-              <a:srgbClr val="6366F1"/>
+              <a:srgbClr val="4F46E5"/>
             </a:solidFill>
           </a:ln>
         </p:spPr>
@@ -8384,18 +8360,18 @@
         </p:nvSpPr>
         <p:spPr>
           <a:xfrm>
-            <a:off x="6537960" y="1828800"/>
-            <a:ext cx="4785055" cy="4434840"/>
+            <a:off x="6537960" y="1783080"/>
+            <a:ext cx="4785055" cy="4480560"/>
           </a:xfrm>
           <a:prstGeom prst="roundRect">
             <a:avLst/>
           </a:prstGeom>
           <a:solidFill>
-            <a:srgbClr val="0F172A"/>
+            <a:srgbClr val="EEF2FF"/>
           </a:solidFill>
           <a:ln w="12700">
             <a:solidFill>
-              <a:srgbClr val="A855F7"/>
+              <a:srgbClr val="E2E8F0"/>
             </a:solidFill>
           </a:ln>
         </p:spPr>
@@ -8420,7 +8396,7 @@
             <a:pPr algn="ctr">
               <a:defRPr sz="1300" b="1">
                 <a:solidFill>
-                  <a:srgbClr val="6366F1"/>
+                  <a:srgbClr val="4F46E5"/>
                 </a:solidFill>
               </a:defRPr>
             </a:pPr>
@@ -8466,7 +8442,7 @@
             <a:avLst/>
           </a:prstGeom>
           <a:solidFill>
-            <a:srgbClr val="0F172A"/>
+            <a:srgbClr val="F8FAFC"/>
           </a:solidFill>
           <a:ln>
             <a:noFill/>
@@ -8509,7 +8485,7 @@
             <a:avLst/>
           </a:prstGeom>
           <a:solidFill>
-            <a:srgbClr val="6366F1"/>
+            <a:srgbClr val="4F46E5"/>
           </a:solidFill>
           <a:ln>
             <a:noFill/>
@@ -8545,96 +8521,94 @@
         </p:nvSpPr>
         <p:spPr>
           <a:xfrm>
-            <a:off x="731520" y="457200"/>
-            <a:ext cx="10728655" cy="1051560"/>
+            <a:off x="731520" y="411480"/>
+            <a:ext cx="10728655" cy="1097280"/>
           </a:xfrm>
           <a:prstGeom prst="roundRect">
             <a:avLst/>
           </a:prstGeom>
           <a:solidFill>
-            <a:srgbClr val="1E293B"/>
+            <a:srgbClr val="4F46E5"/>
+          </a:solidFill>
+          <a:ln>
+            <a:noFill/>
+          </a:ln>
+        </p:spPr>
+        <p:style>
+          <a:lnRef idx="1">
+            <a:schemeClr val="accent1"/>
+          </a:lnRef>
+          <a:fillRef idx="3">
+            <a:schemeClr val="accent1"/>
+          </a:fillRef>
+          <a:effectRef idx="2">
+            <a:schemeClr val="accent1"/>
+          </a:effectRef>
+          <a:fontRef idx="minor">
+            <a:schemeClr val="lt1"/>
+          </a:fontRef>
+        </p:style>
+        <p:txBody>
+          <a:bodyPr rtlCol="0" anchor="ctr" wrap="square"/>
+          <a:lstStyle/>
+          <a:p>
+            <a:pPr algn="ctr">
+              <a:defRPr sz="1000" b="1">
+                <a:solidFill>
+                  <a:srgbClr val="C7D2FE"/>
+                </a:solidFill>
+              </a:defRPr>
+            </a:pPr>
+            <a:r>
+              <a:t>[ SPATIAL EXPLORER ] — SLIDE 6</a:t>
+            </a:r>
+          </a:p>
+          <a:p>
+            <a:pPr>
+              <a:defRPr sz="1900" b="1">
+                <a:solidFill>
+                  <a:srgbClr val="FFFFFF"/>
+                </a:solidFill>
+              </a:defRPr>
+            </a:pPr>
+            <a:r>
+              <a:t>All-Rooms Explorer &amp; Filter Engine</a:t>
+            </a:r>
+          </a:p>
+          <a:p>
+            <a:pPr>
+              <a:defRPr sz="1150">
+                <a:solidFill>
+                  <a:srgbClr val="E0E7FF"/>
+                </a:solidFill>
+              </a:defRPr>
+            </a:pPr>
+            <a:r>
+              <a:t>Complete Real-Time Visibility of Corporate Facilities</a:t>
+            </a:r>
+          </a:p>
+        </p:txBody>
+      </p:sp>
+      <p:sp>
+        <p:nvSpPr>
+          <p:cNvPr id="5" name="Rounded Rectangle 4"/>
+          <p:cNvSpPr/>
+          <p:nvPr/>
+        </p:nvSpPr>
+        <p:spPr>
+          <a:xfrm>
+            <a:off x="731520" y="1645920"/>
+            <a:ext cx="5486400" cy="4754880"/>
+          </a:xfrm>
+          <a:prstGeom prst="roundRect">
+            <a:avLst/>
+          </a:prstGeom>
+          <a:solidFill>
+            <a:srgbClr val="FFFFFF"/>
           </a:solidFill>
           <a:ln w="19050">
             <a:solidFill>
-              <a:srgbClr val="6366F1"/>
-            </a:solidFill>
-          </a:ln>
-        </p:spPr>
-        <p:style>
-          <a:lnRef idx="1">
-            <a:schemeClr val="accent1"/>
-          </a:lnRef>
-          <a:fillRef idx="3">
-            <a:schemeClr val="accent1"/>
-          </a:fillRef>
-          <a:effectRef idx="2">
-            <a:schemeClr val="accent1"/>
-          </a:effectRef>
-          <a:fontRef idx="minor">
-            <a:schemeClr val="lt1"/>
-          </a:fontRef>
-        </p:style>
-        <p:txBody>
-          <a:bodyPr rtlCol="0" anchor="ctr" wrap="square"/>
-          <a:lstStyle/>
-          <a:p>
-            <a:pPr algn="ctr">
-              <a:defRPr sz="1000" b="1">
-                <a:solidFill>
-                  <a:srgbClr val="38BDF8"/>
-                </a:solidFill>
-              </a:defRPr>
-            </a:pPr>
-            <a:r>
-              <a:t>[ SPATIAL EXPLORER ] — SLIDE 6</a:t>
-            </a:r>
-          </a:p>
-          <a:p>
-            <a:pPr>
-              <a:defRPr sz="1900" b="1">
-                <a:solidFill>
-                  <a:srgbClr val="F8FAFC"/>
-                </a:solidFill>
-              </a:defRPr>
-            </a:pPr>
-            <a:r>
-              <a:t>All-Rooms Explorer &amp; Filter Engine</a:t>
-            </a:r>
-          </a:p>
-          <a:p>
-            <a:pPr>
-              <a:defRPr sz="1150">
-                <a:solidFill>
-                  <a:srgbClr val="A855F7"/>
-                </a:solidFill>
-              </a:defRPr>
-            </a:pPr>
-            <a:r>
-              <a:t>Complete Real-Time Visibility of Corporate Facilities</a:t>
-            </a:r>
-          </a:p>
-        </p:txBody>
-      </p:sp>
-      <p:sp>
-        <p:nvSpPr>
-          <p:cNvPr id="5" name="Rounded Rectangle 4"/>
-          <p:cNvSpPr/>
-          <p:nvPr/>
-        </p:nvSpPr>
-        <p:spPr>
-          <a:xfrm>
-            <a:off x="731520" y="1691640"/>
-            <a:ext cx="5486400" cy="4709160"/>
-          </a:xfrm>
-          <a:prstGeom prst="roundRect">
-            <a:avLst/>
-          </a:prstGeom>
-          <a:solidFill>
-            <a:srgbClr val="1E293B"/>
-          </a:solidFill>
-          <a:ln w="12700">
-            <a:solidFill>
-              <a:srgbClr val="334155"/>
+              <a:srgbClr val="E2E8F0"/>
             </a:solidFill>
           </a:ln>
         </p:spPr>
@@ -8659,7 +8633,7 @@
             <a:pPr algn="ctr">
               <a:defRPr sz="1200" b="1">
                 <a:solidFill>
-                  <a:srgbClr val="FBBF24"/>
+                  <a:srgbClr val="2563EB"/>
                 </a:solidFill>
               </a:defRPr>
             </a:pPr>
@@ -8674,7 +8648,7 @@
               </a:spcBef>
               <a:defRPr sz="1150">
                 <a:solidFill>
-                  <a:srgbClr val="F8FAFC"/>
+                  <a:srgbClr val="334155"/>
                 </a:solidFill>
               </a:defRPr>
             </a:pPr>
@@ -8689,7 +8663,7 @@
               </a:spcBef>
               <a:defRPr sz="1150">
                 <a:solidFill>
-                  <a:srgbClr val="F8FAFC"/>
+                  <a:srgbClr val="334155"/>
                 </a:solidFill>
               </a:defRPr>
             </a:pPr>
@@ -8704,7 +8678,7 @@
               </a:spcBef>
               <a:defRPr sz="1150">
                 <a:solidFill>
-                  <a:srgbClr val="F8FAFC"/>
+                  <a:srgbClr val="334155"/>
                 </a:solidFill>
               </a:defRPr>
             </a:pPr>
@@ -8722,18 +8696,18 @@
         </p:nvSpPr>
         <p:spPr>
           <a:xfrm>
-            <a:off x="6400800" y="1691640"/>
-            <a:ext cx="5059375" cy="4709160"/>
+            <a:off x="6400800" y="1645920"/>
+            <a:ext cx="5059375" cy="4754880"/>
           </a:xfrm>
           <a:prstGeom prst="roundRect">
             <a:avLst/>
           </a:prstGeom>
           <a:solidFill>
-            <a:srgbClr val="1E293B"/>
+            <a:srgbClr val="FFFFFF"/>
           </a:solidFill>
           <a:ln w="25400">
             <a:solidFill>
-              <a:srgbClr val="6366F1"/>
+              <a:srgbClr val="4F46E5"/>
             </a:solidFill>
           </a:ln>
         </p:spPr>
@@ -8767,18 +8741,18 @@
         </p:nvSpPr>
         <p:spPr>
           <a:xfrm>
-            <a:off x="6537960" y="1828800"/>
-            <a:ext cx="4785055" cy="4434840"/>
+            <a:off x="6537960" y="1783080"/>
+            <a:ext cx="4785055" cy="4480560"/>
           </a:xfrm>
           <a:prstGeom prst="roundRect">
             <a:avLst/>
           </a:prstGeom>
           <a:solidFill>
-            <a:srgbClr val="0F172A"/>
+            <a:srgbClr val="EEF2FF"/>
           </a:solidFill>
           <a:ln w="12700">
             <a:solidFill>
-              <a:srgbClr val="A855F7"/>
+              <a:srgbClr val="E2E8F0"/>
             </a:solidFill>
           </a:ln>
         </p:spPr>
@@ -8803,7 +8777,7 @@
             <a:pPr algn="ctr">
               <a:defRPr sz="1300" b="1">
                 <a:solidFill>
-                  <a:srgbClr val="6366F1"/>
+                  <a:srgbClr val="4F46E5"/>
                 </a:solidFill>
               </a:defRPr>
             </a:pPr>
@@ -8849,7 +8823,7 @@
             <a:avLst/>
           </a:prstGeom>
           <a:solidFill>
-            <a:srgbClr val="0F172A"/>
+            <a:srgbClr val="F8FAFC"/>
           </a:solidFill>
           <a:ln>
             <a:noFill/>
@@ -8892,7 +8866,7 @@
             <a:avLst/>
           </a:prstGeom>
           <a:solidFill>
-            <a:srgbClr val="6366F1"/>
+            <a:srgbClr val="4F46E5"/>
           </a:solidFill>
           <a:ln>
             <a:noFill/>
@@ -8928,96 +8902,94 @@
         </p:nvSpPr>
         <p:spPr>
           <a:xfrm>
-            <a:off x="731520" y="457200"/>
-            <a:ext cx="10728655" cy="1051560"/>
+            <a:off x="731520" y="411480"/>
+            <a:ext cx="10728655" cy="1097280"/>
           </a:xfrm>
           <a:prstGeom prst="roundRect">
             <a:avLst/>
           </a:prstGeom>
           <a:solidFill>
-            <a:srgbClr val="1E293B"/>
+            <a:srgbClr val="4F46E5"/>
+          </a:solidFill>
+          <a:ln>
+            <a:noFill/>
+          </a:ln>
+        </p:spPr>
+        <p:style>
+          <a:lnRef idx="1">
+            <a:schemeClr val="accent1"/>
+          </a:lnRef>
+          <a:fillRef idx="3">
+            <a:schemeClr val="accent1"/>
+          </a:fillRef>
+          <a:effectRef idx="2">
+            <a:schemeClr val="accent1"/>
+          </a:effectRef>
+          <a:fontRef idx="minor">
+            <a:schemeClr val="lt1"/>
+          </a:fontRef>
+        </p:style>
+        <p:txBody>
+          <a:bodyPr rtlCol="0" anchor="ctr" wrap="square"/>
+          <a:lstStyle/>
+          <a:p>
+            <a:pPr algn="ctr">
+              <a:defRPr sz="1000" b="1">
+                <a:solidFill>
+                  <a:srgbClr val="C7D2FE"/>
+                </a:solidFill>
+              </a:defRPr>
+            </a:pPr>
+            <a:r>
+              <a:t>[ MEDIA &amp; ASSETS ] — SLIDE 7</a:t>
+            </a:r>
+          </a:p>
+          <a:p>
+            <a:pPr>
+              <a:defRPr sz="1900" b="1">
+                <a:solidFill>
+                  <a:srgbClr val="FFFFFF"/>
+                </a:solidFill>
+              </a:defRPr>
+            </a:pPr>
+            <a:r>
+              <a:t>Direct Computer Photo File Upload (&lt;input type='file'&gt;)</a:t>
+            </a:r>
+          </a:p>
+          <a:p>
+            <a:pPr>
+              <a:defRPr sz="1150">
+                <a:solidFill>
+                  <a:srgbClr val="E0E7FF"/>
+                </a:solidFill>
+              </a:defRPr>
+            </a:pPr>
+            <a:r>
+              <a:t>Custom Local Computer Hard Drive Image Uploading</a:t>
+            </a:r>
+          </a:p>
+        </p:txBody>
+      </p:sp>
+      <p:sp>
+        <p:nvSpPr>
+          <p:cNvPr id="5" name="Rounded Rectangle 4"/>
+          <p:cNvSpPr/>
+          <p:nvPr/>
+        </p:nvSpPr>
+        <p:spPr>
+          <a:xfrm>
+            <a:off x="731520" y="1645920"/>
+            <a:ext cx="5486400" cy="4754880"/>
+          </a:xfrm>
+          <a:prstGeom prst="roundRect">
+            <a:avLst/>
+          </a:prstGeom>
+          <a:solidFill>
+            <a:srgbClr val="FFFFFF"/>
           </a:solidFill>
           <a:ln w="19050">
             <a:solidFill>
-              <a:srgbClr val="6366F1"/>
-            </a:solidFill>
-          </a:ln>
-        </p:spPr>
-        <p:style>
-          <a:lnRef idx="1">
-            <a:schemeClr val="accent1"/>
-          </a:lnRef>
-          <a:fillRef idx="3">
-            <a:schemeClr val="accent1"/>
-          </a:fillRef>
-          <a:effectRef idx="2">
-            <a:schemeClr val="accent1"/>
-          </a:effectRef>
-          <a:fontRef idx="minor">
-            <a:schemeClr val="lt1"/>
-          </a:fontRef>
-        </p:style>
-        <p:txBody>
-          <a:bodyPr rtlCol="0" anchor="ctr" wrap="square"/>
-          <a:lstStyle/>
-          <a:p>
-            <a:pPr algn="ctr">
-              <a:defRPr sz="1000" b="1">
-                <a:solidFill>
-                  <a:srgbClr val="38BDF8"/>
-                </a:solidFill>
-              </a:defRPr>
-            </a:pPr>
-            <a:r>
-              <a:t>[ MEDIA &amp; ASSETS ] — SLIDE 7</a:t>
-            </a:r>
-          </a:p>
-          <a:p>
-            <a:pPr>
-              <a:defRPr sz="1900" b="1">
-                <a:solidFill>
-                  <a:srgbClr val="F8FAFC"/>
-                </a:solidFill>
-              </a:defRPr>
-            </a:pPr>
-            <a:r>
-              <a:t>Direct Computer Photo File Upload (&lt;input type='file'&gt;)</a:t>
-            </a:r>
-          </a:p>
-          <a:p>
-            <a:pPr>
-              <a:defRPr sz="1150">
-                <a:solidFill>
-                  <a:srgbClr val="A855F7"/>
-                </a:solidFill>
-              </a:defRPr>
-            </a:pPr>
-            <a:r>
-              <a:t>Custom Local Computer Hard Drive Image Uploading</a:t>
-            </a:r>
-          </a:p>
-        </p:txBody>
-      </p:sp>
-      <p:sp>
-        <p:nvSpPr>
-          <p:cNvPr id="5" name="Rounded Rectangle 4"/>
-          <p:cNvSpPr/>
-          <p:nvPr/>
-        </p:nvSpPr>
-        <p:spPr>
-          <a:xfrm>
-            <a:off x="731520" y="1691640"/>
-            <a:ext cx="5486400" cy="4709160"/>
-          </a:xfrm>
-          <a:prstGeom prst="roundRect">
-            <a:avLst/>
-          </a:prstGeom>
-          <a:solidFill>
-            <a:srgbClr val="1E293B"/>
-          </a:solidFill>
-          <a:ln w="12700">
-            <a:solidFill>
-              <a:srgbClr val="334155"/>
+              <a:srgbClr val="E2E8F0"/>
             </a:solidFill>
           </a:ln>
         </p:spPr>
@@ -9042,7 +9014,7 @@
             <a:pPr algn="ctr">
               <a:defRPr sz="1200" b="1">
                 <a:solidFill>
-                  <a:srgbClr val="FBBF24"/>
+                  <a:srgbClr val="2563EB"/>
                 </a:solidFill>
               </a:defRPr>
             </a:pPr>
@@ -9057,7 +9029,7 @@
               </a:spcBef>
               <a:defRPr sz="1150">
                 <a:solidFill>
-                  <a:srgbClr val="F8FAFC"/>
+                  <a:srgbClr val="334155"/>
                 </a:solidFill>
               </a:defRPr>
             </a:pPr>
@@ -9072,7 +9044,7 @@
               </a:spcBef>
               <a:defRPr sz="1150">
                 <a:solidFill>
-                  <a:srgbClr val="F8FAFC"/>
+                  <a:srgbClr val="334155"/>
                 </a:solidFill>
               </a:defRPr>
             </a:pPr>
@@ -9087,7 +9059,7 @@
               </a:spcBef>
               <a:defRPr sz="1150">
                 <a:solidFill>
-                  <a:srgbClr val="F8FAFC"/>
+                  <a:srgbClr val="334155"/>
                 </a:solidFill>
               </a:defRPr>
             </a:pPr>
@@ -9105,18 +9077,18 @@
         </p:nvSpPr>
         <p:spPr>
           <a:xfrm>
-            <a:off x="6400800" y="1691640"/>
-            <a:ext cx="5059375" cy="4709160"/>
+            <a:off x="6400800" y="1645920"/>
+            <a:ext cx="5059375" cy="4754880"/>
           </a:xfrm>
           <a:prstGeom prst="roundRect">
             <a:avLst/>
           </a:prstGeom>
           <a:solidFill>
-            <a:srgbClr val="1E293B"/>
+            <a:srgbClr val="FFFFFF"/>
           </a:solidFill>
           <a:ln w="25400">
             <a:solidFill>
-              <a:srgbClr val="6366F1"/>
+              <a:srgbClr val="4F46E5"/>
             </a:solidFill>
           </a:ln>
         </p:spPr>
@@ -9150,18 +9122,18 @@
         </p:nvSpPr>
         <p:spPr>
           <a:xfrm>
-            <a:off x="6537960" y="1828800"/>
-            <a:ext cx="4785055" cy="4434840"/>
+            <a:off x="6537960" y="1783080"/>
+            <a:ext cx="4785055" cy="4480560"/>
           </a:xfrm>
           <a:prstGeom prst="roundRect">
             <a:avLst/>
           </a:prstGeom>
           <a:solidFill>
-            <a:srgbClr val="0F172A"/>
+            <a:srgbClr val="EEF2FF"/>
           </a:solidFill>
           <a:ln w="12700">
             <a:solidFill>
-              <a:srgbClr val="A855F7"/>
+              <a:srgbClr val="E2E8F0"/>
             </a:solidFill>
           </a:ln>
         </p:spPr>
@@ -9186,7 +9158,7 @@
             <a:pPr algn="ctr">
               <a:defRPr sz="1300" b="1">
                 <a:solidFill>
-                  <a:srgbClr val="6366F1"/>
+                  <a:srgbClr val="4F46E5"/>
                 </a:solidFill>
               </a:defRPr>
             </a:pPr>
@@ -9232,7 +9204,7 @@
             <a:avLst/>
           </a:prstGeom>
           <a:solidFill>
-            <a:srgbClr val="0F172A"/>
+            <a:srgbClr val="F8FAFC"/>
           </a:solidFill>
           <a:ln>
             <a:noFill/>
@@ -9275,7 +9247,7 @@
             <a:avLst/>
           </a:prstGeom>
           <a:solidFill>
-            <a:srgbClr val="6366F1"/>
+            <a:srgbClr val="4F46E5"/>
           </a:solidFill>
           <a:ln>
             <a:noFill/>
@@ -9311,96 +9283,94 @@
         </p:nvSpPr>
         <p:spPr>
           <a:xfrm>
-            <a:off x="731520" y="457200"/>
-            <a:ext cx="10728655" cy="1051560"/>
+            <a:off x="731520" y="411480"/>
+            <a:ext cx="10728655" cy="1097280"/>
           </a:xfrm>
           <a:prstGeom prst="roundRect">
             <a:avLst/>
           </a:prstGeom>
           <a:solidFill>
-            <a:srgbClr val="1E293B"/>
+            <a:srgbClr val="4F46E5"/>
+          </a:solidFill>
+          <a:ln>
+            <a:noFill/>
+          </a:ln>
+        </p:spPr>
+        <p:style>
+          <a:lnRef idx="1">
+            <a:schemeClr val="accent1"/>
+          </a:lnRef>
+          <a:fillRef idx="3">
+            <a:schemeClr val="accent1"/>
+          </a:fillRef>
+          <a:effectRef idx="2">
+            <a:schemeClr val="accent1"/>
+          </a:effectRef>
+          <a:fontRef idx="minor">
+            <a:schemeClr val="lt1"/>
+          </a:fontRef>
+        </p:style>
+        <p:txBody>
+          <a:bodyPr rtlCol="0" anchor="ctr" wrap="square"/>
+          <a:lstStyle/>
+          <a:p>
+            <a:pPr algn="ctr">
+              <a:defRPr sz="1000" b="1">
+                <a:solidFill>
+                  <a:srgbClr val="C7D2FE"/>
+                </a:solidFill>
+              </a:defRPr>
+            </a:pPr>
+            <a:r>
+              <a:t>[ SLOT SCHEDULING ] — SLIDE 8</a:t>
+            </a:r>
+          </a:p>
+          <a:p>
+            <a:pPr>
+              <a:defRPr sz="1900" b="1">
+                <a:solidFill>
+                  <a:srgbClr val="FFFFFF"/>
+                </a:solidFill>
+              </a:defRPr>
+            </a:pPr>
+            <a:r>
+              <a:t>Conflict-Free Real-Time Room Booking</a:t>
+            </a:r>
+          </a:p>
+          <a:p>
+            <a:pPr>
+              <a:defRPr sz="1150">
+                <a:solidFill>
+                  <a:srgbClr val="E0E7FF"/>
+                </a:solidFill>
+              </a:defRPr>
+            </a:pPr>
+            <a:r>
+              <a:t>Interactive Date &amp; Half-Hourly Slot Selector</a:t>
+            </a:r>
+          </a:p>
+        </p:txBody>
+      </p:sp>
+      <p:sp>
+        <p:nvSpPr>
+          <p:cNvPr id="5" name="Rounded Rectangle 4"/>
+          <p:cNvSpPr/>
+          <p:nvPr/>
+        </p:nvSpPr>
+        <p:spPr>
+          <a:xfrm>
+            <a:off x="731520" y="1645920"/>
+            <a:ext cx="5486400" cy="4754880"/>
+          </a:xfrm>
+          <a:prstGeom prst="roundRect">
+            <a:avLst/>
+          </a:prstGeom>
+          <a:solidFill>
+            <a:srgbClr val="FFFFFF"/>
           </a:solidFill>
           <a:ln w="19050">
             <a:solidFill>
-              <a:srgbClr val="6366F1"/>
-            </a:solidFill>
-          </a:ln>
-        </p:spPr>
-        <p:style>
-          <a:lnRef idx="1">
-            <a:schemeClr val="accent1"/>
-          </a:lnRef>
-          <a:fillRef idx="3">
-            <a:schemeClr val="accent1"/>
-          </a:fillRef>
-          <a:effectRef idx="2">
-            <a:schemeClr val="accent1"/>
-          </a:effectRef>
-          <a:fontRef idx="minor">
-            <a:schemeClr val="lt1"/>
-          </a:fontRef>
-        </p:style>
-        <p:txBody>
-          <a:bodyPr rtlCol="0" anchor="ctr" wrap="square"/>
-          <a:lstStyle/>
-          <a:p>
-            <a:pPr algn="ctr">
-              <a:defRPr sz="1000" b="1">
-                <a:solidFill>
-                  <a:srgbClr val="38BDF8"/>
-                </a:solidFill>
-              </a:defRPr>
-            </a:pPr>
-            <a:r>
-              <a:t>[ SLOT SCHEDULING ] — SLIDE 8</a:t>
-            </a:r>
-          </a:p>
-          <a:p>
-            <a:pPr>
-              <a:defRPr sz="1900" b="1">
-                <a:solidFill>
-                  <a:srgbClr val="F8FAFC"/>
-                </a:solidFill>
-              </a:defRPr>
-            </a:pPr>
-            <a:r>
-              <a:t>Conflict-Free Real-Time Room Booking</a:t>
-            </a:r>
-          </a:p>
-          <a:p>
-            <a:pPr>
-              <a:defRPr sz="1150">
-                <a:solidFill>
-                  <a:srgbClr val="A855F7"/>
-                </a:solidFill>
-              </a:defRPr>
-            </a:pPr>
-            <a:r>
-              <a:t>Interactive Date &amp; Half-Hourly Slot Selector</a:t>
-            </a:r>
-          </a:p>
-        </p:txBody>
-      </p:sp>
-      <p:sp>
-        <p:nvSpPr>
-          <p:cNvPr id="5" name="Rounded Rectangle 4"/>
-          <p:cNvSpPr/>
-          <p:nvPr/>
-        </p:nvSpPr>
-        <p:spPr>
-          <a:xfrm>
-            <a:off x="731520" y="1691640"/>
-            <a:ext cx="5486400" cy="4709160"/>
-          </a:xfrm>
-          <a:prstGeom prst="roundRect">
-            <a:avLst/>
-          </a:prstGeom>
-          <a:solidFill>
-            <a:srgbClr val="1E293B"/>
-          </a:solidFill>
-          <a:ln w="12700">
-            <a:solidFill>
-              <a:srgbClr val="334155"/>
+              <a:srgbClr val="E2E8F0"/>
             </a:solidFill>
           </a:ln>
         </p:spPr>
@@ -9425,7 +9395,7 @@
             <a:pPr algn="ctr">
               <a:defRPr sz="1200" b="1">
                 <a:solidFill>
-                  <a:srgbClr val="FBBF24"/>
+                  <a:srgbClr val="2563EB"/>
                 </a:solidFill>
               </a:defRPr>
             </a:pPr>
@@ -9440,7 +9410,7 @@
               </a:spcBef>
               <a:defRPr sz="1150">
                 <a:solidFill>
-                  <a:srgbClr val="F8FAFC"/>
+                  <a:srgbClr val="334155"/>
                 </a:solidFill>
               </a:defRPr>
             </a:pPr>
@@ -9455,7 +9425,7 @@
               </a:spcBef>
               <a:defRPr sz="1150">
                 <a:solidFill>
-                  <a:srgbClr val="F8FAFC"/>
+                  <a:srgbClr val="334155"/>
                 </a:solidFill>
               </a:defRPr>
             </a:pPr>
@@ -9470,7 +9440,7 @@
               </a:spcBef>
               <a:defRPr sz="1150">
                 <a:solidFill>
-                  <a:srgbClr val="F8FAFC"/>
+                  <a:srgbClr val="334155"/>
                 </a:solidFill>
               </a:defRPr>
             </a:pPr>
@@ -9488,18 +9458,18 @@
         </p:nvSpPr>
         <p:spPr>
           <a:xfrm>
-            <a:off x="6400800" y="1691640"/>
-            <a:ext cx="5059375" cy="4709160"/>
+            <a:off x="6400800" y="1645920"/>
+            <a:ext cx="5059375" cy="4754880"/>
           </a:xfrm>
           <a:prstGeom prst="roundRect">
             <a:avLst/>
           </a:prstGeom>
           <a:solidFill>
-            <a:srgbClr val="1E293B"/>
+            <a:srgbClr val="FFFFFF"/>
           </a:solidFill>
           <a:ln w="25400">
             <a:solidFill>
-              <a:srgbClr val="6366F1"/>
+              <a:srgbClr val="4F46E5"/>
             </a:solidFill>
           </a:ln>
         </p:spPr>
@@ -9533,18 +9503,18 @@
         </p:nvSpPr>
         <p:spPr>
           <a:xfrm>
-            <a:off x="6537960" y="1828800"/>
-            <a:ext cx="4785055" cy="4434840"/>
+            <a:off x="6537960" y="1783080"/>
+            <a:ext cx="4785055" cy="4480560"/>
           </a:xfrm>
           <a:prstGeom prst="roundRect">
             <a:avLst/>
           </a:prstGeom>
           <a:solidFill>
-            <a:srgbClr val="0F172A"/>
+            <a:srgbClr val="EEF2FF"/>
           </a:solidFill>
           <a:ln w="12700">
             <a:solidFill>
-              <a:srgbClr val="A855F7"/>
+              <a:srgbClr val="E2E8F0"/>
             </a:solidFill>
           </a:ln>
         </p:spPr>
@@ -9569,7 +9539,7 @@
             <a:pPr algn="ctr">
               <a:defRPr sz="1300" b="1">
                 <a:solidFill>
-                  <a:srgbClr val="6366F1"/>
+                  <a:srgbClr val="4F46E5"/>
                 </a:solidFill>
               </a:defRPr>
             </a:pPr>
@@ -9615,7 +9585,7 @@
             <a:avLst/>
           </a:prstGeom>
           <a:solidFill>
-            <a:srgbClr val="0F172A"/>
+            <a:srgbClr val="F8FAFC"/>
           </a:solidFill>
           <a:ln>
             <a:noFill/>
@@ -9658,7 +9628,7 @@
             <a:avLst/>
           </a:prstGeom>
           <a:solidFill>
-            <a:srgbClr val="6366F1"/>
+            <a:srgbClr val="4F46E5"/>
           </a:solidFill>
           <a:ln>
             <a:noFill/>
@@ -9694,96 +9664,94 @@
         </p:nvSpPr>
         <p:spPr>
           <a:xfrm>
-            <a:off x="731520" y="457200"/>
-            <a:ext cx="10728655" cy="1051560"/>
+            <a:off x="731520" y="411480"/>
+            <a:ext cx="10728655" cy="1097280"/>
           </a:xfrm>
           <a:prstGeom prst="roundRect">
             <a:avLst/>
           </a:prstGeom>
           <a:solidFill>
-            <a:srgbClr val="1E293B"/>
+            <a:srgbClr val="4F46E5"/>
+          </a:solidFill>
+          <a:ln>
+            <a:noFill/>
+          </a:ln>
+        </p:spPr>
+        <p:style>
+          <a:lnRef idx="1">
+            <a:schemeClr val="accent1"/>
+          </a:lnRef>
+          <a:fillRef idx="3">
+            <a:schemeClr val="accent1"/>
+          </a:fillRef>
+          <a:effectRef idx="2">
+            <a:schemeClr val="accent1"/>
+          </a:effectRef>
+          <a:fontRef idx="minor">
+            <a:schemeClr val="lt1"/>
+          </a:fontRef>
+        </p:style>
+        <p:txBody>
+          <a:bodyPr rtlCol="0" anchor="ctr" wrap="square"/>
+          <a:lstStyle/>
+          <a:p>
+            <a:pPr algn="ctr">
+              <a:defRPr sz="1000" b="1">
+                <a:solidFill>
+                  <a:srgbClr val="C7D2FE"/>
+                </a:solidFill>
+              </a:defRPr>
+            </a:pPr>
+            <a:r>
+              <a:t>[ AUTOMATED APPROVALS ] — SLIDE 9</a:t>
+            </a:r>
+          </a:p>
+          <a:p>
+            <a:pPr>
+              <a:defRPr sz="1900" b="1">
+                <a:solidFill>
+                  <a:srgbClr val="FFFFFF"/>
+                </a:solidFill>
+              </a:defRPr>
+            </a:pPr>
+            <a:r>
+              <a:t>15-Minute Auto-Approval Mechanism</a:t>
+            </a:r>
+          </a:p>
+          <a:p>
+            <a:pPr>
+              <a:defRPr sz="1150">
+                <a:solidFill>
+                  <a:srgbClr val="E0E7FF"/>
+                </a:solidFill>
+              </a:defRPr>
+            </a:pPr>
+            <a:r>
+              <a:t>Eliminating Administrative Approval Bottlenecks</a:t>
+            </a:r>
+          </a:p>
+        </p:txBody>
+      </p:sp>
+      <p:sp>
+        <p:nvSpPr>
+          <p:cNvPr id="5" name="Rounded Rectangle 4"/>
+          <p:cNvSpPr/>
+          <p:nvPr/>
+        </p:nvSpPr>
+        <p:spPr>
+          <a:xfrm>
+            <a:off x="731520" y="1645920"/>
+            <a:ext cx="5486400" cy="4754880"/>
+          </a:xfrm>
+          <a:prstGeom prst="roundRect">
+            <a:avLst/>
+          </a:prstGeom>
+          <a:solidFill>
+            <a:srgbClr val="FFFFFF"/>
           </a:solidFill>
           <a:ln w="19050">
             <a:solidFill>
-              <a:srgbClr val="6366F1"/>
-            </a:solidFill>
-          </a:ln>
-        </p:spPr>
-        <p:style>
-          <a:lnRef idx="1">
-            <a:schemeClr val="accent1"/>
-          </a:lnRef>
-          <a:fillRef idx="3">
-            <a:schemeClr val="accent1"/>
-          </a:fillRef>
-          <a:effectRef idx="2">
-            <a:schemeClr val="accent1"/>
-          </a:effectRef>
-          <a:fontRef idx="minor">
-            <a:schemeClr val="lt1"/>
-          </a:fontRef>
-        </p:style>
-        <p:txBody>
-          <a:bodyPr rtlCol="0" anchor="ctr" wrap="square"/>
-          <a:lstStyle/>
-          <a:p>
-            <a:pPr algn="ctr">
-              <a:defRPr sz="1000" b="1">
-                <a:solidFill>
-                  <a:srgbClr val="38BDF8"/>
-                </a:solidFill>
-              </a:defRPr>
-            </a:pPr>
-            <a:r>
-              <a:t>[ AUTOMATED APPROVALS ] — SLIDE 9</a:t>
-            </a:r>
-          </a:p>
-          <a:p>
-            <a:pPr>
-              <a:defRPr sz="1900" b="1">
-                <a:solidFill>
-                  <a:srgbClr val="F8FAFC"/>
-                </a:solidFill>
-              </a:defRPr>
-            </a:pPr>
-            <a:r>
-              <a:t>15-Minute Auto-Approval Mechanism</a:t>
-            </a:r>
-          </a:p>
-          <a:p>
-            <a:pPr>
-              <a:defRPr sz="1150">
-                <a:solidFill>
-                  <a:srgbClr val="A855F7"/>
-                </a:solidFill>
-              </a:defRPr>
-            </a:pPr>
-            <a:r>
-              <a:t>Eliminating Administrative Approval Bottlenecks</a:t>
-            </a:r>
-          </a:p>
-        </p:txBody>
-      </p:sp>
-      <p:sp>
-        <p:nvSpPr>
-          <p:cNvPr id="5" name="Rounded Rectangle 4"/>
-          <p:cNvSpPr/>
-          <p:nvPr/>
-        </p:nvSpPr>
-        <p:spPr>
-          <a:xfrm>
-            <a:off x="731520" y="1691640"/>
-            <a:ext cx="5486400" cy="4709160"/>
-          </a:xfrm>
-          <a:prstGeom prst="roundRect">
-            <a:avLst/>
-          </a:prstGeom>
-          <a:solidFill>
-            <a:srgbClr val="1E293B"/>
-          </a:solidFill>
-          <a:ln w="12700">
-            <a:solidFill>
-              <a:srgbClr val="334155"/>
+              <a:srgbClr val="E2E8F0"/>
             </a:solidFill>
           </a:ln>
         </p:spPr>
@@ -9808,7 +9776,7 @@
             <a:pPr algn="ctr">
               <a:defRPr sz="1200" b="1">
                 <a:solidFill>
-                  <a:srgbClr val="FBBF24"/>
+                  <a:srgbClr val="2563EB"/>
                 </a:solidFill>
               </a:defRPr>
             </a:pPr>
@@ -9823,7 +9791,7 @@
               </a:spcBef>
               <a:defRPr sz="1150">
                 <a:solidFill>
-                  <a:srgbClr val="F8FAFC"/>
+                  <a:srgbClr val="334155"/>
                 </a:solidFill>
               </a:defRPr>
             </a:pPr>
@@ -9838,7 +9806,7 @@
               </a:spcBef>
               <a:defRPr sz="1150">
                 <a:solidFill>
-                  <a:srgbClr val="F8FAFC"/>
+                  <a:srgbClr val="334155"/>
                 </a:solidFill>
               </a:defRPr>
             </a:pPr>
@@ -9853,7 +9821,7 @@
               </a:spcBef>
               <a:defRPr sz="1150">
                 <a:solidFill>
-                  <a:srgbClr val="F8FAFC"/>
+                  <a:srgbClr val="334155"/>
                 </a:solidFill>
               </a:defRPr>
             </a:pPr>
@@ -9871,18 +9839,18 @@
         </p:nvSpPr>
         <p:spPr>
           <a:xfrm>
-            <a:off x="6400800" y="1691640"/>
-            <a:ext cx="5059375" cy="4709160"/>
+            <a:off x="6400800" y="1645920"/>
+            <a:ext cx="5059375" cy="4754880"/>
           </a:xfrm>
           <a:prstGeom prst="roundRect">
             <a:avLst/>
           </a:prstGeom>
           <a:solidFill>
-            <a:srgbClr val="1E293B"/>
+            <a:srgbClr val="FFFFFF"/>
           </a:solidFill>
           <a:ln w="25400">
             <a:solidFill>
-              <a:srgbClr val="6366F1"/>
+              <a:srgbClr val="4F46E5"/>
             </a:solidFill>
           </a:ln>
         </p:spPr>
@@ -9916,18 +9884,18 @@
         </p:nvSpPr>
         <p:spPr>
           <a:xfrm>
-            <a:off x="6537960" y="1828800"/>
-            <a:ext cx="4785055" cy="4434840"/>
+            <a:off x="6537960" y="1783080"/>
+            <a:ext cx="4785055" cy="4480560"/>
           </a:xfrm>
           <a:prstGeom prst="roundRect">
             <a:avLst/>
           </a:prstGeom>
           <a:solidFill>
-            <a:srgbClr val="0F172A"/>
+            <a:srgbClr val="EEF2FF"/>
           </a:solidFill>
           <a:ln w="12700">
             <a:solidFill>
-              <a:srgbClr val="A855F7"/>
+              <a:srgbClr val="E2E8F0"/>
             </a:solidFill>
           </a:ln>
         </p:spPr>
@@ -9952,7 +9920,7 @@
             <a:pPr algn="ctr">
               <a:defRPr sz="1300" b="1">
                 <a:solidFill>
-                  <a:srgbClr val="6366F1"/>
+                  <a:srgbClr val="4F46E5"/>
                 </a:solidFill>
               </a:defRPr>
             </a:pPr>

</xml_diff>

<commit_message>
docs: add simplified System Architecture Diagram image and embed onto Slide 3 in PowerPoint deck
</commit_message>
<xml_diff>
--- a/document/PRESENTATION_DECK_SLIDES.pptx
+++ b/document/PRESENTATION_DECK_SLIDES.pptx
@@ -7545,108 +7545,30 @@
           </a:p>
         </p:txBody>
       </p:sp>
-      <p:sp>
-        <p:nvSpPr>
-          <p:cNvPr id="6" name="Rounded Rectangle 5"/>
-          <p:cNvSpPr/>
-          <p:nvPr/>
-        </p:nvSpPr>
+      <p:pic>
+        <p:nvPicPr>
+          <p:cNvPr id="6" name="Picture 5" descr="SYSTEM_ARCHITECTURE_DIAGRAM.png"/>
+          <p:cNvPicPr>
+            <a:picLocks noChangeAspect="1"/>
+          </p:cNvPicPr>
+          <p:nvPr/>
+        </p:nvPicPr>
+        <p:blipFill>
+          <a:blip r:embed="rId2"/>
+          <a:stretch>
+            <a:fillRect/>
+          </a:stretch>
+        </p:blipFill>
         <p:spPr>
           <a:xfrm>
             <a:off x="6400800" y="1645920"/>
-            <a:ext cx="5059375" cy="4754880"/>
-          </a:xfrm>
-          <a:prstGeom prst="roundRect">
-            <a:avLst/>
-          </a:prstGeom>
-          <a:solidFill>
-            <a:srgbClr val="FFFFFF"/>
-          </a:solidFill>
-          <a:ln w="25400">
-            <a:solidFill>
-              <a:srgbClr val="4F46E5"/>
-            </a:solidFill>
-          </a:ln>
-        </p:spPr>
-        <p:style>
-          <a:lnRef idx="1">
-            <a:schemeClr val="accent1"/>
-          </a:lnRef>
-          <a:fillRef idx="3">
-            <a:schemeClr val="accent1"/>
-          </a:fillRef>
-          <a:effectRef idx="2">
-            <a:schemeClr val="accent1"/>
-          </a:effectRef>
-          <a:fontRef idx="minor">
-            <a:schemeClr val="lt1"/>
-          </a:fontRef>
-        </p:style>
-        <p:txBody>
-          <a:bodyPr rtlCol="0" anchor="ctr"/>
-          <a:lstStyle/>
-          <a:p>
-            <a:pPr algn="ctr"/>
-          </a:p>
-        </p:txBody>
-      </p:sp>
-      <p:sp>
-        <p:nvSpPr>
-          <p:cNvPr id="7" name="Rounded Rectangle 6"/>
-          <p:cNvSpPr/>
-          <p:nvPr/>
-        </p:nvSpPr>
-        <p:spPr>
-          <a:xfrm>
-            <a:off x="6537960" y="1783080"/>
-            <a:ext cx="4785055" cy="4480560"/>
-          </a:xfrm>
-          <a:prstGeom prst="roundRect">
-            <a:avLst/>
-          </a:prstGeom>
-          <a:solidFill>
-            <a:srgbClr val="EEF2FF"/>
-          </a:solidFill>
-          <a:ln w="12700">
-            <a:solidFill>
-              <a:srgbClr val="E2E8F0"/>
-            </a:solidFill>
-          </a:ln>
-        </p:spPr>
-        <p:style>
-          <a:lnRef idx="1">
-            <a:schemeClr val="accent1"/>
-          </a:lnRef>
-          <a:fillRef idx="3">
-            <a:schemeClr val="accent1"/>
-          </a:fillRef>
-          <a:effectRef idx="2">
-            <a:schemeClr val="accent1"/>
-          </a:effectRef>
-          <a:fontRef idx="minor">
-            <a:schemeClr val="lt1"/>
-          </a:fontRef>
-        </p:style>
-        <p:txBody>
-          <a:bodyPr rtlCol="0" anchor="ctr" wrap="square"/>
-          <a:lstStyle/>
-          <a:p>
-            <a:pPr algn="ctr">
-              <a:defRPr sz="1300" b="1">
-                <a:solidFill>
-                  <a:srgbClr val="4F46E5"/>
-                </a:solidFill>
-              </a:defRPr>
-            </a:pPr>
-            <a:br/>
-            <a:br/>
-            <a:br/>
-            <a:r>
-              <a:t>📸 [INSERT SCREENSHOT HERE: System Architecture &amp; Flow Diagram]</a:t>
-            </a:r>
-          </a:p>
-        </p:txBody>
-      </p:sp>
+            <a:ext cx="5059375" cy="2823837"/>
+          </a:xfrm>
+          <a:prstGeom prst="rect">
+            <a:avLst/>
+          </a:prstGeom>
+        </p:spPr>
+      </p:pic>
     </p:spTree>
   </p:cSld>
   <p:clrMapOvr>

</xml_diff>

<commit_message>
docs: generate visual graphic cards and attach images directly onto EVERY slide (Slides 1-18) in PowerPoint deck
</commit_message>
<xml_diff>
--- a/document/PRESENTATION_DECK_SLIDES.pptx
+++ b/document/PRESENTATION_DECK_SLIDES.pptx
@@ -3199,7 +3199,7 @@
         </p:nvSpPr>
         <p:spPr>
           <a:xfrm>
-            <a:off x="914400" y="685800"/>
+            <a:off x="731520" y="685800"/>
             <a:ext cx="2926080" cy="457200"/>
           </a:xfrm>
           <a:prstGeom prst="roundRect">
@@ -3253,8 +3253,8 @@
         </p:nvSpPr>
         <p:spPr>
           <a:xfrm>
-            <a:off x="914400" y="1325880"/>
-            <a:ext cx="5669280" cy="4983480"/>
+            <a:off x="731520" y="1325880"/>
+            <a:ext cx="5486400" cy="4983480"/>
           </a:xfrm>
           <a:prstGeom prst="roundRect">
             <a:avLst/>
@@ -3375,63 +3375,30 @@
           </a:p>
         </p:txBody>
       </p:sp>
-      <p:sp>
-        <p:nvSpPr>
-          <p:cNvPr id="6" name="Rounded Rectangle 5"/>
-          <p:cNvSpPr/>
+      <p:pic>
+        <p:nvPicPr>
+          <p:cNvPr id="6" name="Picture 5" descr="SLIDE_1_HERO.png"/>
+          <p:cNvPicPr>
+            <a:picLocks noChangeAspect="1"/>
+          </p:cNvPicPr>
           <p:nvPr/>
-        </p:nvSpPr>
-        <p:spPr>
-          <a:xfrm>
-            <a:off x="6858000" y="1325880"/>
-            <a:ext cx="4389120" cy="4983480"/>
-          </a:xfrm>
-          <a:prstGeom prst="roundRect">
-            <a:avLst/>
-          </a:prstGeom>
-          <a:solidFill>
-            <a:srgbClr val="EEF2FF"/>
-          </a:solidFill>
-          <a:ln w="25400">
-            <a:solidFill>
-              <a:srgbClr val="4F46E5"/>
-            </a:solidFill>
-          </a:ln>
-        </p:spPr>
-        <p:style>
-          <a:lnRef idx="1">
-            <a:schemeClr val="accent1"/>
-          </a:lnRef>
-          <a:fillRef idx="3">
-            <a:schemeClr val="accent1"/>
-          </a:fillRef>
-          <a:effectRef idx="2">
-            <a:schemeClr val="accent1"/>
-          </a:effectRef>
-          <a:fontRef idx="minor">
-            <a:schemeClr val="lt1"/>
-          </a:fontRef>
-        </p:style>
-        <p:txBody>
-          <a:bodyPr rtlCol="0" anchor="ctr" wrap="square"/>
-          <a:lstStyle/>
-          <a:p>
-            <a:pPr algn="ctr">
-              <a:defRPr sz="1300" b="1">
-                <a:solidFill>
-                  <a:srgbClr val="4F46E5"/>
-                </a:solidFill>
-              </a:defRPr>
-            </a:pPr>
-            <a:br/>
-            <a:br/>
-            <a:br/>
-            <a:r>
-              <a:t>📸 [INSERT SCREENSHOT HERE: Lumina Reserve App Logo &amp; Hero Homepage]</a:t>
-            </a:r>
-          </a:p>
-        </p:txBody>
-      </p:sp>
+        </p:nvPicPr>
+        <p:blipFill>
+          <a:blip r:embed="rId2"/>
+          <a:stretch>
+            <a:fillRect/>
+          </a:stretch>
+        </p:blipFill>
+        <p:spPr>
+          <a:xfrm>
+            <a:off x="6492240" y="1325880"/>
+            <a:ext cx="4937760" cy="3291840"/>
+          </a:xfrm>
+          <a:prstGeom prst="rect">
+            <a:avLst/>
+          </a:prstGeom>
+        </p:spPr>
+      </p:pic>
     </p:spTree>
   </p:cSld>
   <p:clrMapOvr>
@@ -3711,108 +3678,30 @@
           </a:p>
         </p:txBody>
       </p:sp>
-      <p:sp>
-        <p:nvSpPr>
-          <p:cNvPr id="6" name="Rounded Rectangle 5"/>
-          <p:cNvSpPr/>
+      <p:pic>
+        <p:nvPicPr>
+          <p:cNvPr id="6" name="Picture 5" descr="SLIDE_10_WHATSAPP_SHARE.png"/>
+          <p:cNvPicPr>
+            <a:picLocks noChangeAspect="1"/>
+          </p:cNvPicPr>
           <p:nvPr/>
-        </p:nvSpPr>
-        <p:spPr>
-          <a:xfrm>
-            <a:off x="6400800" y="1645920"/>
-            <a:ext cx="5059375" cy="4754880"/>
-          </a:xfrm>
-          <a:prstGeom prst="roundRect">
-            <a:avLst/>
-          </a:prstGeom>
-          <a:solidFill>
-            <a:srgbClr val="FFFFFF"/>
-          </a:solidFill>
-          <a:ln w="25400">
-            <a:solidFill>
-              <a:srgbClr val="4F46E5"/>
-            </a:solidFill>
-          </a:ln>
-        </p:spPr>
-        <p:style>
-          <a:lnRef idx="1">
-            <a:schemeClr val="accent1"/>
-          </a:lnRef>
-          <a:fillRef idx="3">
-            <a:schemeClr val="accent1"/>
-          </a:fillRef>
-          <a:effectRef idx="2">
-            <a:schemeClr val="accent1"/>
-          </a:effectRef>
-          <a:fontRef idx="minor">
-            <a:schemeClr val="lt1"/>
-          </a:fontRef>
-        </p:style>
-        <p:txBody>
-          <a:bodyPr rtlCol="0" anchor="ctr"/>
-          <a:lstStyle/>
-          <a:p>
-            <a:pPr algn="ctr"/>
-          </a:p>
-        </p:txBody>
-      </p:sp>
-      <p:sp>
-        <p:nvSpPr>
-          <p:cNvPr id="7" name="Rounded Rectangle 6"/>
-          <p:cNvSpPr/>
-          <p:nvPr/>
-        </p:nvSpPr>
-        <p:spPr>
-          <a:xfrm>
-            <a:off x="6537960" y="1783080"/>
-            <a:ext cx="4785055" cy="4480560"/>
-          </a:xfrm>
-          <a:prstGeom prst="roundRect">
-            <a:avLst/>
-          </a:prstGeom>
-          <a:solidFill>
-            <a:srgbClr val="EEF2FF"/>
-          </a:solidFill>
-          <a:ln w="12700">
-            <a:solidFill>
-              <a:srgbClr val="E2E8F0"/>
-            </a:solidFill>
-          </a:ln>
-        </p:spPr>
-        <p:style>
-          <a:lnRef idx="1">
-            <a:schemeClr val="accent1"/>
-          </a:lnRef>
-          <a:fillRef idx="3">
-            <a:schemeClr val="accent1"/>
-          </a:fillRef>
-          <a:effectRef idx="2">
-            <a:schemeClr val="accent1"/>
-          </a:effectRef>
-          <a:fontRef idx="minor">
-            <a:schemeClr val="lt1"/>
-          </a:fontRef>
-        </p:style>
-        <p:txBody>
-          <a:bodyPr rtlCol="0" anchor="ctr" wrap="square"/>
-          <a:lstStyle/>
-          <a:p>
-            <a:pPr algn="ctr">
-              <a:defRPr sz="1300" b="1">
-                <a:solidFill>
-                  <a:srgbClr val="4F46E5"/>
-                </a:solidFill>
-              </a:defRPr>
-            </a:pPr>
-            <a:br/>
-            <a:br/>
-            <a:br/>
-            <a:r>
-              <a:t>📸 [INSERT SCREENSHOT HERE: WhatsApp Button &amp; Pre-Filled Text Preview]</a:t>
-            </a:r>
-          </a:p>
-        </p:txBody>
-      </p:sp>
+        </p:nvPicPr>
+        <p:blipFill>
+          <a:blip r:embed="rId2"/>
+          <a:stretch>
+            <a:fillRect/>
+          </a:stretch>
+        </p:blipFill>
+        <p:spPr>
+          <a:xfrm>
+            <a:off x="6492240" y="1645920"/>
+            <a:ext cx="4937760" cy="3291840"/>
+          </a:xfrm>
+          <a:prstGeom prst="rect">
+            <a:avLst/>
+          </a:prstGeom>
+        </p:spPr>
+      </p:pic>
     </p:spTree>
   </p:cSld>
   <p:clrMapOvr>
@@ -4092,108 +3981,30 @@
           </a:p>
         </p:txBody>
       </p:sp>
-      <p:sp>
-        <p:nvSpPr>
-          <p:cNvPr id="6" name="Rounded Rectangle 5"/>
-          <p:cNvSpPr/>
+      <p:pic>
+        <p:nvPicPr>
+          <p:cNvPr id="6" name="Picture 5" descr="SLIDE_11_EDIT_MEMBERS.png"/>
+          <p:cNvPicPr>
+            <a:picLocks noChangeAspect="1"/>
+          </p:cNvPicPr>
           <p:nvPr/>
-        </p:nvSpPr>
-        <p:spPr>
-          <a:xfrm>
-            <a:off x="6400800" y="1645920"/>
-            <a:ext cx="5059375" cy="4754880"/>
-          </a:xfrm>
-          <a:prstGeom prst="roundRect">
-            <a:avLst/>
-          </a:prstGeom>
-          <a:solidFill>
-            <a:srgbClr val="FFFFFF"/>
-          </a:solidFill>
-          <a:ln w="25400">
-            <a:solidFill>
-              <a:srgbClr val="4F46E5"/>
-            </a:solidFill>
-          </a:ln>
-        </p:spPr>
-        <p:style>
-          <a:lnRef idx="1">
-            <a:schemeClr val="accent1"/>
-          </a:lnRef>
-          <a:fillRef idx="3">
-            <a:schemeClr val="accent1"/>
-          </a:fillRef>
-          <a:effectRef idx="2">
-            <a:schemeClr val="accent1"/>
-          </a:effectRef>
-          <a:fontRef idx="minor">
-            <a:schemeClr val="lt1"/>
-          </a:fontRef>
-        </p:style>
-        <p:txBody>
-          <a:bodyPr rtlCol="0" anchor="ctr"/>
-          <a:lstStyle/>
-          <a:p>
-            <a:pPr algn="ctr"/>
-          </a:p>
-        </p:txBody>
-      </p:sp>
-      <p:sp>
-        <p:nvSpPr>
-          <p:cNvPr id="7" name="Rounded Rectangle 6"/>
-          <p:cNvSpPr/>
-          <p:nvPr/>
-        </p:nvSpPr>
-        <p:spPr>
-          <a:xfrm>
-            <a:off x="6537960" y="1783080"/>
-            <a:ext cx="4785055" cy="4480560"/>
-          </a:xfrm>
-          <a:prstGeom prst="roundRect">
-            <a:avLst/>
-          </a:prstGeom>
-          <a:solidFill>
-            <a:srgbClr val="EEF2FF"/>
-          </a:solidFill>
-          <a:ln w="12700">
-            <a:solidFill>
-              <a:srgbClr val="E2E8F0"/>
-            </a:solidFill>
-          </a:ln>
-        </p:spPr>
-        <p:style>
-          <a:lnRef idx="1">
-            <a:schemeClr val="accent1"/>
-          </a:lnRef>
-          <a:fillRef idx="3">
-            <a:schemeClr val="accent1"/>
-          </a:fillRef>
-          <a:effectRef idx="2">
-            <a:schemeClr val="accent1"/>
-          </a:effectRef>
-          <a:fontRef idx="minor">
-            <a:schemeClr val="lt1"/>
-          </a:fontRef>
-        </p:style>
-        <p:txBody>
-          <a:bodyPr rtlCol="0" anchor="ctr" wrap="square"/>
-          <a:lstStyle/>
-          <a:p>
-            <a:pPr algn="ctr">
-              <a:defRPr sz="1300" b="1">
-                <a:solidFill>
-                  <a:srgbClr val="4F46E5"/>
-                </a:solidFill>
-              </a:defRPr>
-            </a:pPr>
-            <a:br/>
-            <a:br/>
-            <a:br/>
-            <a:r>
-              <a:t>📸 [INSERT SCREENSHOT HERE: Edit Participants Modal]</a:t>
-            </a:r>
-          </a:p>
-        </p:txBody>
-      </p:sp>
+        </p:nvPicPr>
+        <p:blipFill>
+          <a:blip r:embed="rId2"/>
+          <a:stretch>
+            <a:fillRect/>
+          </a:stretch>
+        </p:blipFill>
+        <p:spPr>
+          <a:xfrm>
+            <a:off x="6492240" y="1645920"/>
+            <a:ext cx="4937760" cy="3291840"/>
+          </a:xfrm>
+          <a:prstGeom prst="rect">
+            <a:avLst/>
+          </a:prstGeom>
+        </p:spPr>
+      </p:pic>
     </p:spTree>
   </p:cSld>
   <p:clrMapOvr>
@@ -4473,108 +4284,30 @@
           </a:p>
         </p:txBody>
       </p:sp>
-      <p:sp>
-        <p:nvSpPr>
-          <p:cNvPr id="6" name="Rounded Rectangle 5"/>
-          <p:cNvSpPr/>
+      <p:pic>
+        <p:nvPicPr>
+          <p:cNvPr id="6" name="Picture 5" descr="SLIDE_12_MANAGER_QUEUE.png"/>
+          <p:cNvPicPr>
+            <a:picLocks noChangeAspect="1"/>
+          </p:cNvPicPr>
           <p:nvPr/>
-        </p:nvSpPr>
-        <p:spPr>
-          <a:xfrm>
-            <a:off x="6400800" y="1645920"/>
-            <a:ext cx="5059375" cy="4754880"/>
-          </a:xfrm>
-          <a:prstGeom prst="roundRect">
-            <a:avLst/>
-          </a:prstGeom>
-          <a:solidFill>
-            <a:srgbClr val="FFFFFF"/>
-          </a:solidFill>
-          <a:ln w="25400">
-            <a:solidFill>
-              <a:srgbClr val="4F46E5"/>
-            </a:solidFill>
-          </a:ln>
-        </p:spPr>
-        <p:style>
-          <a:lnRef idx="1">
-            <a:schemeClr val="accent1"/>
-          </a:lnRef>
-          <a:fillRef idx="3">
-            <a:schemeClr val="accent1"/>
-          </a:fillRef>
-          <a:effectRef idx="2">
-            <a:schemeClr val="accent1"/>
-          </a:effectRef>
-          <a:fontRef idx="minor">
-            <a:schemeClr val="lt1"/>
-          </a:fontRef>
-        </p:style>
-        <p:txBody>
-          <a:bodyPr rtlCol="0" anchor="ctr"/>
-          <a:lstStyle/>
-          <a:p>
-            <a:pPr algn="ctr"/>
-          </a:p>
-        </p:txBody>
-      </p:sp>
-      <p:sp>
-        <p:nvSpPr>
-          <p:cNvPr id="7" name="Rounded Rectangle 6"/>
-          <p:cNvSpPr/>
-          <p:nvPr/>
-        </p:nvSpPr>
-        <p:spPr>
-          <a:xfrm>
-            <a:off x="6537960" y="1783080"/>
-            <a:ext cx="4785055" cy="4480560"/>
-          </a:xfrm>
-          <a:prstGeom prst="roundRect">
-            <a:avLst/>
-          </a:prstGeom>
-          <a:solidFill>
-            <a:srgbClr val="EEF2FF"/>
-          </a:solidFill>
-          <a:ln w="12700">
-            <a:solidFill>
-              <a:srgbClr val="E2E8F0"/>
-            </a:solidFill>
-          </a:ln>
-        </p:spPr>
-        <p:style>
-          <a:lnRef idx="1">
-            <a:schemeClr val="accent1"/>
-          </a:lnRef>
-          <a:fillRef idx="3">
-            <a:schemeClr val="accent1"/>
-          </a:fillRef>
-          <a:effectRef idx="2">
-            <a:schemeClr val="accent1"/>
-          </a:effectRef>
-          <a:fontRef idx="minor">
-            <a:schemeClr val="lt1"/>
-          </a:fontRef>
-        </p:style>
-        <p:txBody>
-          <a:bodyPr rtlCol="0" anchor="ctr" wrap="square"/>
-          <a:lstStyle/>
-          <a:p>
-            <a:pPr algn="ctr">
-              <a:defRPr sz="1300" b="1">
-                <a:solidFill>
-                  <a:srgbClr val="4F46E5"/>
-                </a:solidFill>
-              </a:defRPr>
-            </a:pPr>
-            <a:br/>
-            <a:br/>
-            <a:br/>
-            <a:r>
-              <a:t>📸 [INSERT SCREENSHOT HERE: Manager Dashboard Approval Queue]</a:t>
-            </a:r>
-          </a:p>
-        </p:txBody>
-      </p:sp>
+        </p:nvPicPr>
+        <p:blipFill>
+          <a:blip r:embed="rId2"/>
+          <a:stretch>
+            <a:fillRect/>
+          </a:stretch>
+        </p:blipFill>
+        <p:spPr>
+          <a:xfrm>
+            <a:off x="6492240" y="1645920"/>
+            <a:ext cx="4937760" cy="3291840"/>
+          </a:xfrm>
+          <a:prstGeom prst="rect">
+            <a:avLst/>
+          </a:prstGeom>
+        </p:spPr>
+      </p:pic>
     </p:spTree>
   </p:cSld>
   <p:clrMapOvr>
@@ -4854,108 +4587,30 @@
           </a:p>
         </p:txBody>
       </p:sp>
-      <p:sp>
-        <p:nvSpPr>
-          <p:cNvPr id="6" name="Rounded Rectangle 5"/>
-          <p:cNvSpPr/>
+      <p:pic>
+        <p:nvPicPr>
+          <p:cNvPr id="6" name="Picture 5" descr="SLIDE_13_ROOM_HISTORY.png"/>
+          <p:cNvPicPr>
+            <a:picLocks noChangeAspect="1"/>
+          </p:cNvPicPr>
           <p:nvPr/>
-        </p:nvSpPr>
-        <p:spPr>
-          <a:xfrm>
-            <a:off x="6400800" y="1645920"/>
-            <a:ext cx="5059375" cy="4754880"/>
-          </a:xfrm>
-          <a:prstGeom prst="roundRect">
-            <a:avLst/>
-          </a:prstGeom>
-          <a:solidFill>
-            <a:srgbClr val="FFFFFF"/>
-          </a:solidFill>
-          <a:ln w="25400">
-            <a:solidFill>
-              <a:srgbClr val="4F46E5"/>
-            </a:solidFill>
-          </a:ln>
-        </p:spPr>
-        <p:style>
-          <a:lnRef idx="1">
-            <a:schemeClr val="accent1"/>
-          </a:lnRef>
-          <a:fillRef idx="3">
-            <a:schemeClr val="accent1"/>
-          </a:fillRef>
-          <a:effectRef idx="2">
-            <a:schemeClr val="accent1"/>
-          </a:effectRef>
-          <a:fontRef idx="minor">
-            <a:schemeClr val="lt1"/>
-          </a:fontRef>
-        </p:style>
-        <p:txBody>
-          <a:bodyPr rtlCol="0" anchor="ctr"/>
-          <a:lstStyle/>
-          <a:p>
-            <a:pPr algn="ctr"/>
-          </a:p>
-        </p:txBody>
-      </p:sp>
-      <p:sp>
-        <p:nvSpPr>
-          <p:cNvPr id="7" name="Rounded Rectangle 6"/>
-          <p:cNvSpPr/>
-          <p:nvPr/>
-        </p:nvSpPr>
-        <p:spPr>
-          <a:xfrm>
-            <a:off x="6537960" y="1783080"/>
-            <a:ext cx="4785055" cy="4480560"/>
-          </a:xfrm>
-          <a:prstGeom prst="roundRect">
-            <a:avLst/>
-          </a:prstGeom>
-          <a:solidFill>
-            <a:srgbClr val="EEF2FF"/>
-          </a:solidFill>
-          <a:ln w="12700">
-            <a:solidFill>
-              <a:srgbClr val="E2E8F0"/>
-            </a:solidFill>
-          </a:ln>
-        </p:spPr>
-        <p:style>
-          <a:lnRef idx="1">
-            <a:schemeClr val="accent1"/>
-          </a:lnRef>
-          <a:fillRef idx="3">
-            <a:schemeClr val="accent1"/>
-          </a:fillRef>
-          <a:effectRef idx="2">
-            <a:schemeClr val="accent1"/>
-          </a:effectRef>
-          <a:fontRef idx="minor">
-            <a:schemeClr val="lt1"/>
-          </a:fontRef>
-        </p:style>
-        <p:txBody>
-          <a:bodyPr rtlCol="0" anchor="ctr" wrap="square"/>
-          <a:lstStyle/>
-          <a:p>
-            <a:pPr algn="ctr">
-              <a:defRPr sz="1300" b="1">
-                <a:solidFill>
-                  <a:srgbClr val="4F46E5"/>
-                </a:solidFill>
-              </a:defRPr>
-            </a:pPr>
-            <a:br/>
-            <a:br/>
-            <a:br/>
-            <a:r>
-              <a:t>📸 [INSERT SCREENSHOT HERE: Room History Audit Log Modal]</a:t>
-            </a:r>
-          </a:p>
-        </p:txBody>
-      </p:sp>
+        </p:nvPicPr>
+        <p:blipFill>
+          <a:blip r:embed="rId2"/>
+          <a:stretch>
+            <a:fillRect/>
+          </a:stretch>
+        </p:blipFill>
+        <p:spPr>
+          <a:xfrm>
+            <a:off x="6492240" y="1645920"/>
+            <a:ext cx="4937760" cy="3291840"/>
+          </a:xfrm>
+          <a:prstGeom prst="rect">
+            <a:avLst/>
+          </a:prstGeom>
+        </p:spPr>
+      </p:pic>
     </p:spTree>
   </p:cSld>
   <p:clrMapOvr>
@@ -5235,108 +4890,30 @@
           </a:p>
         </p:txBody>
       </p:sp>
-      <p:sp>
-        <p:nvSpPr>
-          <p:cNvPr id="6" name="Rounded Rectangle 5"/>
-          <p:cNvSpPr/>
+      <p:pic>
+        <p:nvPicPr>
+          <p:cNvPr id="6" name="Picture 5" descr="SLIDE_14_ROOM_SUPPLIES.png"/>
+          <p:cNvPicPr>
+            <a:picLocks noChangeAspect="1"/>
+          </p:cNvPicPr>
           <p:nvPr/>
-        </p:nvSpPr>
-        <p:spPr>
-          <a:xfrm>
-            <a:off x="6400800" y="1645920"/>
-            <a:ext cx="5059375" cy="4754880"/>
-          </a:xfrm>
-          <a:prstGeom prst="roundRect">
-            <a:avLst/>
-          </a:prstGeom>
-          <a:solidFill>
-            <a:srgbClr val="FFFFFF"/>
-          </a:solidFill>
-          <a:ln w="25400">
-            <a:solidFill>
-              <a:srgbClr val="4F46E5"/>
-            </a:solidFill>
-          </a:ln>
-        </p:spPr>
-        <p:style>
-          <a:lnRef idx="1">
-            <a:schemeClr val="accent1"/>
-          </a:lnRef>
-          <a:fillRef idx="3">
-            <a:schemeClr val="accent1"/>
-          </a:fillRef>
-          <a:effectRef idx="2">
-            <a:schemeClr val="accent1"/>
-          </a:effectRef>
-          <a:fontRef idx="minor">
-            <a:schemeClr val="lt1"/>
-          </a:fontRef>
-        </p:style>
-        <p:txBody>
-          <a:bodyPr rtlCol="0" anchor="ctr"/>
-          <a:lstStyle/>
-          <a:p>
-            <a:pPr algn="ctr"/>
-          </a:p>
-        </p:txBody>
-      </p:sp>
-      <p:sp>
-        <p:nvSpPr>
-          <p:cNvPr id="7" name="Rounded Rectangle 6"/>
-          <p:cNvSpPr/>
-          <p:nvPr/>
-        </p:nvSpPr>
-        <p:spPr>
-          <a:xfrm>
-            <a:off x="6537960" y="1783080"/>
-            <a:ext cx="4785055" cy="4480560"/>
-          </a:xfrm>
-          <a:prstGeom prst="roundRect">
-            <a:avLst/>
-          </a:prstGeom>
-          <a:solidFill>
-            <a:srgbClr val="EEF2FF"/>
-          </a:solidFill>
-          <a:ln w="12700">
-            <a:solidFill>
-              <a:srgbClr val="E2E8F0"/>
-            </a:solidFill>
-          </a:ln>
-        </p:spPr>
-        <p:style>
-          <a:lnRef idx="1">
-            <a:schemeClr val="accent1"/>
-          </a:lnRef>
-          <a:fillRef idx="3">
-            <a:schemeClr val="accent1"/>
-          </a:fillRef>
-          <a:effectRef idx="2">
-            <a:schemeClr val="accent1"/>
-          </a:effectRef>
-          <a:fontRef idx="minor">
-            <a:schemeClr val="lt1"/>
-          </a:fontRef>
-        </p:style>
-        <p:txBody>
-          <a:bodyPr rtlCol="0" anchor="ctr" wrap="square"/>
-          <a:lstStyle/>
-          <a:p>
-            <a:pPr algn="ctr">
-              <a:defRPr sz="1300" b="1">
-                <a:solidFill>
-                  <a:srgbClr val="4F46E5"/>
-                </a:solidFill>
-              </a:defRPr>
-            </a:pPr>
-            <a:br/>
-            <a:br/>
-            <a:br/>
-            <a:r>
-              <a:t>📸 [INSERT SCREENSHOT HERE: Room Supplies Status Cards Grid]</a:t>
-            </a:r>
-          </a:p>
-        </p:txBody>
-      </p:sp>
+        </p:nvPicPr>
+        <p:blipFill>
+          <a:blip r:embed="rId2"/>
+          <a:stretch>
+            <a:fillRect/>
+          </a:stretch>
+        </p:blipFill>
+        <p:spPr>
+          <a:xfrm>
+            <a:off x="6492240" y="1645920"/>
+            <a:ext cx="4937760" cy="3291840"/>
+          </a:xfrm>
+          <a:prstGeom prst="rect">
+            <a:avLst/>
+          </a:prstGeom>
+        </p:spPr>
+      </p:pic>
     </p:spTree>
   </p:cSld>
   <p:clrMapOvr>
@@ -5616,108 +5193,30 @@
           </a:p>
         </p:txBody>
       </p:sp>
-      <p:sp>
-        <p:nvSpPr>
-          <p:cNvPr id="6" name="Rounded Rectangle 5"/>
-          <p:cNvSpPr/>
+      <p:pic>
+        <p:nvPicPr>
+          <p:cNvPr id="6" name="Picture 5" descr="SLIDE_15_GMAIL_CALENDAR.png"/>
+          <p:cNvPicPr>
+            <a:picLocks noChangeAspect="1"/>
+          </p:cNvPicPr>
           <p:nvPr/>
-        </p:nvSpPr>
-        <p:spPr>
-          <a:xfrm>
-            <a:off x="6400800" y="1645920"/>
-            <a:ext cx="5059375" cy="4754880"/>
-          </a:xfrm>
-          <a:prstGeom prst="roundRect">
-            <a:avLst/>
-          </a:prstGeom>
-          <a:solidFill>
-            <a:srgbClr val="FFFFFF"/>
-          </a:solidFill>
-          <a:ln w="25400">
-            <a:solidFill>
-              <a:srgbClr val="4F46E5"/>
-            </a:solidFill>
-          </a:ln>
-        </p:spPr>
-        <p:style>
-          <a:lnRef idx="1">
-            <a:schemeClr val="accent1"/>
-          </a:lnRef>
-          <a:fillRef idx="3">
-            <a:schemeClr val="accent1"/>
-          </a:fillRef>
-          <a:effectRef idx="2">
-            <a:schemeClr val="accent1"/>
-          </a:effectRef>
-          <a:fontRef idx="minor">
-            <a:schemeClr val="lt1"/>
-          </a:fontRef>
-        </p:style>
-        <p:txBody>
-          <a:bodyPr rtlCol="0" anchor="ctr"/>
-          <a:lstStyle/>
-          <a:p>
-            <a:pPr algn="ctr"/>
-          </a:p>
-        </p:txBody>
-      </p:sp>
-      <p:sp>
-        <p:nvSpPr>
-          <p:cNvPr id="7" name="Rounded Rectangle 6"/>
-          <p:cNvSpPr/>
-          <p:nvPr/>
-        </p:nvSpPr>
-        <p:spPr>
-          <a:xfrm>
-            <a:off x="6537960" y="1783080"/>
-            <a:ext cx="4785055" cy="4480560"/>
-          </a:xfrm>
-          <a:prstGeom prst="roundRect">
-            <a:avLst/>
-          </a:prstGeom>
-          <a:solidFill>
-            <a:srgbClr val="EEF2FF"/>
-          </a:solidFill>
-          <a:ln w="12700">
-            <a:solidFill>
-              <a:srgbClr val="E2E8F0"/>
-            </a:solidFill>
-          </a:ln>
-        </p:spPr>
-        <p:style>
-          <a:lnRef idx="1">
-            <a:schemeClr val="accent1"/>
-          </a:lnRef>
-          <a:fillRef idx="3">
-            <a:schemeClr val="accent1"/>
-          </a:fillRef>
-          <a:effectRef idx="2">
-            <a:schemeClr val="accent1"/>
-          </a:effectRef>
-          <a:fontRef idx="minor">
-            <a:schemeClr val="lt1"/>
-          </a:fontRef>
-        </p:style>
-        <p:txBody>
-          <a:bodyPr rtlCol="0" anchor="ctr" wrap="square"/>
-          <a:lstStyle/>
-          <a:p>
-            <a:pPr algn="ctr">
-              <a:defRPr sz="1300" b="1">
-                <a:solidFill>
-                  <a:srgbClr val="4F46E5"/>
-                </a:solidFill>
-              </a:defRPr>
-            </a:pPr>
-            <a:br/>
-            <a:br/>
-            <a:br/>
-            <a:r>
-              <a:t>📸 [INSERT SCREENSHOT HERE: Gmail Confirmation Email in Inbox]</a:t>
-            </a:r>
-          </a:p>
-        </p:txBody>
-      </p:sp>
+        </p:nvPicPr>
+        <p:blipFill>
+          <a:blip r:embed="rId2"/>
+          <a:stretch>
+            <a:fillRect/>
+          </a:stretch>
+        </p:blipFill>
+        <p:spPr>
+          <a:xfrm>
+            <a:off x="6492240" y="1645920"/>
+            <a:ext cx="4937760" cy="3291840"/>
+          </a:xfrm>
+          <a:prstGeom prst="rect">
+            <a:avLst/>
+          </a:prstGeom>
+        </p:spPr>
+      </p:pic>
     </p:spTree>
   </p:cSld>
   <p:clrMapOvr>
@@ -6012,108 +5511,30 @@
           </a:p>
         </p:txBody>
       </p:sp>
-      <p:sp>
-        <p:nvSpPr>
-          <p:cNvPr id="6" name="Rounded Rectangle 5"/>
-          <p:cNvSpPr/>
+      <p:pic>
+        <p:nvPicPr>
+          <p:cNvPr id="6" name="Picture 5" descr="SLIDE_16_SECURITY_ROLES.png"/>
+          <p:cNvPicPr>
+            <a:picLocks noChangeAspect="1"/>
+          </p:cNvPicPr>
           <p:nvPr/>
-        </p:nvSpPr>
-        <p:spPr>
-          <a:xfrm>
-            <a:off x="6400800" y="1645920"/>
-            <a:ext cx="5059375" cy="4754880"/>
-          </a:xfrm>
-          <a:prstGeom prst="roundRect">
-            <a:avLst/>
-          </a:prstGeom>
-          <a:solidFill>
-            <a:srgbClr val="FFFFFF"/>
-          </a:solidFill>
-          <a:ln w="25400">
-            <a:solidFill>
-              <a:srgbClr val="4F46E5"/>
-            </a:solidFill>
-          </a:ln>
-        </p:spPr>
-        <p:style>
-          <a:lnRef idx="1">
-            <a:schemeClr val="accent1"/>
-          </a:lnRef>
-          <a:fillRef idx="3">
-            <a:schemeClr val="accent1"/>
-          </a:fillRef>
-          <a:effectRef idx="2">
-            <a:schemeClr val="accent1"/>
-          </a:effectRef>
-          <a:fontRef idx="minor">
-            <a:schemeClr val="lt1"/>
-          </a:fontRef>
-        </p:style>
-        <p:txBody>
-          <a:bodyPr rtlCol="0" anchor="ctr"/>
-          <a:lstStyle/>
-          <a:p>
-            <a:pPr algn="ctr"/>
-          </a:p>
-        </p:txBody>
-      </p:sp>
-      <p:sp>
-        <p:nvSpPr>
-          <p:cNvPr id="7" name="Rounded Rectangle 6"/>
-          <p:cNvSpPr/>
-          <p:nvPr/>
-        </p:nvSpPr>
-        <p:spPr>
-          <a:xfrm>
-            <a:off x="6537960" y="1783080"/>
-            <a:ext cx="4785055" cy="4480560"/>
-          </a:xfrm>
-          <a:prstGeom prst="roundRect">
-            <a:avLst/>
-          </a:prstGeom>
-          <a:solidFill>
-            <a:srgbClr val="EEF2FF"/>
-          </a:solidFill>
-          <a:ln w="12700">
-            <a:solidFill>
-              <a:srgbClr val="E2E8F0"/>
-            </a:solidFill>
-          </a:ln>
-        </p:spPr>
-        <p:style>
-          <a:lnRef idx="1">
-            <a:schemeClr val="accent1"/>
-          </a:lnRef>
-          <a:fillRef idx="3">
-            <a:schemeClr val="accent1"/>
-          </a:fillRef>
-          <a:effectRef idx="2">
-            <a:schemeClr val="accent1"/>
-          </a:effectRef>
-          <a:fontRef idx="minor">
-            <a:schemeClr val="lt1"/>
-          </a:fontRef>
-        </p:style>
-        <p:txBody>
-          <a:bodyPr rtlCol="0" anchor="ctr" wrap="square"/>
-          <a:lstStyle/>
-          <a:p>
-            <a:pPr algn="ctr">
-              <a:defRPr sz="1300" b="1">
-                <a:solidFill>
-                  <a:srgbClr val="4F46E5"/>
-                </a:solidFill>
-              </a:defRPr>
-            </a:pPr>
-            <a:br/>
-            <a:br/>
-            <a:br/>
-            <a:r>
-              <a:t>📸 [INSERT SCREENSHOT HERE: User Roles Matrix Table]</a:t>
-            </a:r>
-          </a:p>
-        </p:txBody>
-      </p:sp>
+        </p:nvPicPr>
+        <p:blipFill>
+          <a:blip r:embed="rId2"/>
+          <a:stretch>
+            <a:fillRect/>
+          </a:stretch>
+        </p:blipFill>
+        <p:spPr>
+          <a:xfrm>
+            <a:off x="6492240" y="1645920"/>
+            <a:ext cx="4937760" cy="3291840"/>
+          </a:xfrm>
+          <a:prstGeom prst="rect">
+            <a:avLst/>
+          </a:prstGeom>
+        </p:spPr>
+      </p:pic>
     </p:spTree>
   </p:cSld>
   <p:clrMapOvr>
@@ -6408,108 +5829,30 @@
           </a:p>
         </p:txBody>
       </p:sp>
-      <p:sp>
-        <p:nvSpPr>
-          <p:cNvPr id="6" name="Rounded Rectangle 5"/>
-          <p:cNvSpPr/>
+      <p:pic>
+        <p:nvPicPr>
+          <p:cNvPr id="6" name="Picture 5" descr="SLIDE_17_LIVE_DEMO.png"/>
+          <p:cNvPicPr>
+            <a:picLocks noChangeAspect="1"/>
+          </p:cNvPicPr>
           <p:nvPr/>
-        </p:nvSpPr>
-        <p:spPr>
-          <a:xfrm>
-            <a:off x="6400800" y="1645920"/>
-            <a:ext cx="5059375" cy="4754880"/>
-          </a:xfrm>
-          <a:prstGeom prst="roundRect">
-            <a:avLst/>
-          </a:prstGeom>
-          <a:solidFill>
-            <a:srgbClr val="FFFFFF"/>
-          </a:solidFill>
-          <a:ln w="25400">
-            <a:solidFill>
-              <a:srgbClr val="4F46E5"/>
-            </a:solidFill>
-          </a:ln>
-        </p:spPr>
-        <p:style>
-          <a:lnRef idx="1">
-            <a:schemeClr val="accent1"/>
-          </a:lnRef>
-          <a:fillRef idx="3">
-            <a:schemeClr val="accent1"/>
-          </a:fillRef>
-          <a:effectRef idx="2">
-            <a:schemeClr val="accent1"/>
-          </a:effectRef>
-          <a:fontRef idx="minor">
-            <a:schemeClr val="lt1"/>
-          </a:fontRef>
-        </p:style>
-        <p:txBody>
-          <a:bodyPr rtlCol="0" anchor="ctr"/>
-          <a:lstStyle/>
-          <a:p>
-            <a:pPr algn="ctr"/>
-          </a:p>
-        </p:txBody>
-      </p:sp>
-      <p:sp>
-        <p:nvSpPr>
-          <p:cNvPr id="7" name="Rounded Rectangle 6"/>
-          <p:cNvSpPr/>
-          <p:nvPr/>
-        </p:nvSpPr>
-        <p:spPr>
-          <a:xfrm>
-            <a:off x="6537960" y="1783080"/>
-            <a:ext cx="4785055" cy="4480560"/>
-          </a:xfrm>
-          <a:prstGeom prst="roundRect">
-            <a:avLst/>
-          </a:prstGeom>
-          <a:solidFill>
-            <a:srgbClr val="EEF2FF"/>
-          </a:solidFill>
-          <a:ln w="12700">
-            <a:solidFill>
-              <a:srgbClr val="E2E8F0"/>
-            </a:solidFill>
-          </a:ln>
-        </p:spPr>
-        <p:style>
-          <a:lnRef idx="1">
-            <a:schemeClr val="accent1"/>
-          </a:lnRef>
-          <a:fillRef idx="3">
-            <a:schemeClr val="accent1"/>
-          </a:fillRef>
-          <a:effectRef idx="2">
-            <a:schemeClr val="accent1"/>
-          </a:effectRef>
-          <a:fontRef idx="minor">
-            <a:schemeClr val="lt1"/>
-          </a:fontRef>
-        </p:style>
-        <p:txBody>
-          <a:bodyPr rtlCol="0" anchor="ctr" wrap="square"/>
-          <a:lstStyle/>
-          <a:p>
-            <a:pPr algn="ctr">
-              <a:defRPr sz="1300" b="1">
-                <a:solidFill>
-                  <a:srgbClr val="4F46E5"/>
-                </a:solidFill>
-              </a:defRPr>
-            </a:pPr>
-            <a:br/>
-            <a:br/>
-            <a:br/>
-            <a:r>
-              <a:t>📸 [INSERT SCREENSHOT HERE: Multi-Window Demo Overview]</a:t>
-            </a:r>
-          </a:p>
-        </p:txBody>
-      </p:sp>
+        </p:nvPicPr>
+        <p:blipFill>
+          <a:blip r:embed="rId2"/>
+          <a:stretch>
+            <a:fillRect/>
+          </a:stretch>
+        </p:blipFill>
+        <p:spPr>
+          <a:xfrm>
+            <a:off x="6492240" y="1645920"/>
+            <a:ext cx="4937760" cy="3291840"/>
+          </a:xfrm>
+          <a:prstGeom prst="rect">
+            <a:avLst/>
+          </a:prstGeom>
+        </p:spPr>
+      </p:pic>
     </p:spTree>
   </p:cSld>
   <p:clrMapOvr>
@@ -6622,7 +5965,7 @@
         </p:nvSpPr>
         <p:spPr>
           <a:xfrm>
-            <a:off x="914400" y="685800"/>
+            <a:off x="731520" y="685800"/>
             <a:ext cx="2926080" cy="457200"/>
           </a:xfrm>
           <a:prstGeom prst="roundRect">
@@ -6676,8 +6019,8 @@
         </p:nvSpPr>
         <p:spPr>
           <a:xfrm>
-            <a:off x="914400" y="1325880"/>
-            <a:ext cx="5669280" cy="4983480"/>
+            <a:off x="731520" y="1325880"/>
+            <a:ext cx="5486400" cy="4983480"/>
           </a:xfrm>
           <a:prstGeom prst="roundRect">
             <a:avLst/>
@@ -6813,63 +6156,30 @@
           </a:p>
         </p:txBody>
       </p:sp>
-      <p:sp>
-        <p:nvSpPr>
-          <p:cNvPr id="6" name="Rounded Rectangle 5"/>
-          <p:cNvSpPr/>
+      <p:pic>
+        <p:nvPicPr>
+          <p:cNvPr id="6" name="Picture 5" descr="SLIDE_18_CONCLUSION.png"/>
+          <p:cNvPicPr>
+            <a:picLocks noChangeAspect="1"/>
+          </p:cNvPicPr>
           <p:nvPr/>
-        </p:nvSpPr>
-        <p:spPr>
-          <a:xfrm>
-            <a:off x="6858000" y="1325880"/>
-            <a:ext cx="4389120" cy="4983480"/>
-          </a:xfrm>
-          <a:prstGeom prst="roundRect">
-            <a:avLst/>
-          </a:prstGeom>
-          <a:solidFill>
-            <a:srgbClr val="EEF2FF"/>
-          </a:solidFill>
-          <a:ln w="25400">
-            <a:solidFill>
-              <a:srgbClr val="4F46E5"/>
-            </a:solidFill>
-          </a:ln>
-        </p:spPr>
-        <p:style>
-          <a:lnRef idx="1">
-            <a:schemeClr val="accent1"/>
-          </a:lnRef>
-          <a:fillRef idx="3">
-            <a:schemeClr val="accent1"/>
-          </a:fillRef>
-          <a:effectRef idx="2">
-            <a:schemeClr val="accent1"/>
-          </a:effectRef>
-          <a:fontRef idx="minor">
-            <a:schemeClr val="lt1"/>
-          </a:fontRef>
-        </p:style>
-        <p:txBody>
-          <a:bodyPr rtlCol="0" anchor="ctr" wrap="square"/>
-          <a:lstStyle/>
-          <a:p>
-            <a:pPr algn="ctr">
-              <a:defRPr sz="1300" b="1">
-                <a:solidFill>
-                  <a:srgbClr val="4F46E5"/>
-                </a:solidFill>
-              </a:defRPr>
-            </a:pPr>
-            <a:br/>
-            <a:br/>
-            <a:br/>
-            <a:r>
-              <a:t>📸 [INSERT SCREENSHOT HERE: Final Closing Slide / Login Portal]</a:t>
-            </a:r>
-          </a:p>
-        </p:txBody>
-      </p:sp>
+        </p:nvPicPr>
+        <p:blipFill>
+          <a:blip r:embed="rId2"/>
+          <a:stretch>
+            <a:fillRect/>
+          </a:stretch>
+        </p:blipFill>
+        <p:spPr>
+          <a:xfrm>
+            <a:off x="6492240" y="1325880"/>
+            <a:ext cx="4937760" cy="3291840"/>
+          </a:xfrm>
+          <a:prstGeom prst="rect">
+            <a:avLst/>
+          </a:prstGeom>
+        </p:spPr>
+      </p:pic>
     </p:spTree>
   </p:cSld>
   <p:clrMapOvr>
@@ -7164,108 +6474,30 @@
           </a:p>
         </p:txBody>
       </p:sp>
-      <p:sp>
-        <p:nvSpPr>
-          <p:cNvPr id="6" name="Rounded Rectangle 5"/>
-          <p:cNvSpPr/>
+      <p:pic>
+        <p:nvPicPr>
+          <p:cNvPr id="6" name="Picture 5" descr="SLIDE_2_EMPLOYEE_DASHBOARD.png"/>
+          <p:cNvPicPr>
+            <a:picLocks noChangeAspect="1"/>
+          </p:cNvPicPr>
           <p:nvPr/>
-        </p:nvSpPr>
-        <p:spPr>
-          <a:xfrm>
-            <a:off x="6400800" y="1645920"/>
-            <a:ext cx="5059375" cy="4754880"/>
-          </a:xfrm>
-          <a:prstGeom prst="roundRect">
-            <a:avLst/>
-          </a:prstGeom>
-          <a:solidFill>
-            <a:srgbClr val="FFFFFF"/>
-          </a:solidFill>
-          <a:ln w="25400">
-            <a:solidFill>
-              <a:srgbClr val="4F46E5"/>
-            </a:solidFill>
-          </a:ln>
-        </p:spPr>
-        <p:style>
-          <a:lnRef idx="1">
-            <a:schemeClr val="accent1"/>
-          </a:lnRef>
-          <a:fillRef idx="3">
-            <a:schemeClr val="accent1"/>
-          </a:fillRef>
-          <a:effectRef idx="2">
-            <a:schemeClr val="accent1"/>
-          </a:effectRef>
-          <a:fontRef idx="minor">
-            <a:schemeClr val="lt1"/>
-          </a:fontRef>
-        </p:style>
-        <p:txBody>
-          <a:bodyPr rtlCol="0" anchor="ctr"/>
-          <a:lstStyle/>
-          <a:p>
-            <a:pPr algn="ctr"/>
-          </a:p>
-        </p:txBody>
-      </p:sp>
-      <p:sp>
-        <p:nvSpPr>
-          <p:cNvPr id="7" name="Rounded Rectangle 6"/>
-          <p:cNvSpPr/>
-          <p:nvPr/>
-        </p:nvSpPr>
-        <p:spPr>
-          <a:xfrm>
-            <a:off x="6537960" y="1783080"/>
-            <a:ext cx="4785055" cy="4480560"/>
-          </a:xfrm>
-          <a:prstGeom prst="roundRect">
-            <a:avLst/>
-          </a:prstGeom>
-          <a:solidFill>
-            <a:srgbClr val="EEF2FF"/>
-          </a:solidFill>
-          <a:ln w="12700">
-            <a:solidFill>
-              <a:srgbClr val="E2E8F0"/>
-            </a:solidFill>
-          </a:ln>
-        </p:spPr>
-        <p:style>
-          <a:lnRef idx="1">
-            <a:schemeClr val="accent1"/>
-          </a:lnRef>
-          <a:fillRef idx="3">
-            <a:schemeClr val="accent1"/>
-          </a:fillRef>
-          <a:effectRef idx="2">
-            <a:schemeClr val="accent1"/>
-          </a:effectRef>
-          <a:fontRef idx="minor">
-            <a:schemeClr val="lt1"/>
-          </a:fontRef>
-        </p:style>
-        <p:txBody>
-          <a:bodyPr rtlCol="0" anchor="ctr" wrap="square"/>
-          <a:lstStyle/>
-          <a:p>
-            <a:pPr algn="ctr">
-              <a:defRPr sz="1300" b="1">
-                <a:solidFill>
-                  <a:srgbClr val="4F46E5"/>
-                </a:solidFill>
-              </a:defRPr>
-            </a:pPr>
-            <a:br/>
-            <a:br/>
-            <a:br/>
-            <a:r>
-              <a:t>📸 [INSERT SCREENSHOT HERE: Employee Dashboard &amp; Active Reservations]</a:t>
-            </a:r>
-          </a:p>
-        </p:txBody>
-      </p:sp>
+        </p:nvPicPr>
+        <p:blipFill>
+          <a:blip r:embed="rId2"/>
+          <a:stretch>
+            <a:fillRect/>
+          </a:stretch>
+        </p:blipFill>
+        <p:spPr>
+          <a:xfrm>
+            <a:off x="6492240" y="1645920"/>
+            <a:ext cx="4937760" cy="3291840"/>
+          </a:xfrm>
+          <a:prstGeom prst="rect">
+            <a:avLst/>
+          </a:prstGeom>
+        </p:spPr>
+      </p:pic>
     </p:spTree>
   </p:cSld>
   <p:clrMapOvr>
@@ -7561,8 +6793,8 @@
         </p:blipFill>
         <p:spPr>
           <a:xfrm>
-            <a:off x="6400800" y="1645920"/>
-            <a:ext cx="5059375" cy="2823837"/>
+            <a:off x="6492240" y="1645920"/>
+            <a:ext cx="4937760" cy="2755959"/>
           </a:xfrm>
           <a:prstGeom prst="rect">
             <a:avLst/>
@@ -7848,108 +7080,30 @@
           </a:p>
         </p:txBody>
       </p:sp>
-      <p:sp>
-        <p:nvSpPr>
-          <p:cNvPr id="6" name="Rounded Rectangle 5"/>
-          <p:cNvSpPr/>
+      <p:pic>
+        <p:nvPicPr>
+          <p:cNvPr id="6" name="Picture 5" descr="SLIDE_4_EER_DIAGRAM.png"/>
+          <p:cNvPicPr>
+            <a:picLocks noChangeAspect="1"/>
+          </p:cNvPicPr>
           <p:nvPr/>
-        </p:nvSpPr>
-        <p:spPr>
-          <a:xfrm>
-            <a:off x="6400800" y="1645920"/>
-            <a:ext cx="5059375" cy="4754880"/>
-          </a:xfrm>
-          <a:prstGeom prst="roundRect">
-            <a:avLst/>
-          </a:prstGeom>
-          <a:solidFill>
-            <a:srgbClr val="FFFFFF"/>
-          </a:solidFill>
-          <a:ln w="25400">
-            <a:solidFill>
-              <a:srgbClr val="4F46E5"/>
-            </a:solidFill>
-          </a:ln>
-        </p:spPr>
-        <p:style>
-          <a:lnRef idx="1">
-            <a:schemeClr val="accent1"/>
-          </a:lnRef>
-          <a:fillRef idx="3">
-            <a:schemeClr val="accent1"/>
-          </a:fillRef>
-          <a:effectRef idx="2">
-            <a:schemeClr val="accent1"/>
-          </a:effectRef>
-          <a:fontRef idx="minor">
-            <a:schemeClr val="lt1"/>
-          </a:fontRef>
-        </p:style>
-        <p:txBody>
-          <a:bodyPr rtlCol="0" anchor="ctr"/>
-          <a:lstStyle/>
-          <a:p>
-            <a:pPr algn="ctr"/>
-          </a:p>
-        </p:txBody>
-      </p:sp>
-      <p:sp>
-        <p:nvSpPr>
-          <p:cNvPr id="7" name="Rounded Rectangle 6"/>
-          <p:cNvSpPr/>
-          <p:nvPr/>
-        </p:nvSpPr>
-        <p:spPr>
-          <a:xfrm>
-            <a:off x="6537960" y="1783080"/>
-            <a:ext cx="4785055" cy="4480560"/>
-          </a:xfrm>
-          <a:prstGeom prst="roundRect">
-            <a:avLst/>
-          </a:prstGeom>
-          <a:solidFill>
-            <a:srgbClr val="EEF2FF"/>
-          </a:solidFill>
-          <a:ln w="12700">
-            <a:solidFill>
-              <a:srgbClr val="E2E8F0"/>
-            </a:solidFill>
-          </a:ln>
-        </p:spPr>
-        <p:style>
-          <a:lnRef idx="1">
-            <a:schemeClr val="accent1"/>
-          </a:lnRef>
-          <a:fillRef idx="3">
-            <a:schemeClr val="accent1"/>
-          </a:fillRef>
-          <a:effectRef idx="2">
-            <a:schemeClr val="accent1"/>
-          </a:effectRef>
-          <a:fontRef idx="minor">
-            <a:schemeClr val="lt1"/>
-          </a:fontRef>
-        </p:style>
-        <p:txBody>
-          <a:bodyPr rtlCol="0" anchor="ctr" wrap="square"/>
-          <a:lstStyle/>
-          <a:p>
-            <a:pPr algn="ctr">
-              <a:defRPr sz="1300" b="1">
-                <a:solidFill>
-                  <a:srgbClr val="4F46E5"/>
-                </a:solidFill>
-              </a:defRPr>
-            </a:pPr>
-            <a:br/>
-            <a:br/>
-            <a:br/>
-            <a:r>
-              <a:t>📸 [INSERT SCREENSHOT HERE: MySQL Workbench Ctrl + R EER Diagram]</a:t>
-            </a:r>
-          </a:p>
-        </p:txBody>
-      </p:sp>
+        </p:nvPicPr>
+        <p:blipFill>
+          <a:blip r:embed="rId2"/>
+          <a:stretch>
+            <a:fillRect/>
+          </a:stretch>
+        </p:blipFill>
+        <p:spPr>
+          <a:xfrm>
+            <a:off x="6492240" y="1645920"/>
+            <a:ext cx="4937760" cy="3291840"/>
+          </a:xfrm>
+          <a:prstGeom prst="rect">
+            <a:avLst/>
+          </a:prstGeom>
+        </p:spPr>
+      </p:pic>
     </p:spTree>
   </p:cSld>
   <p:clrMapOvr>
@@ -8229,108 +7383,30 @@
           </a:p>
         </p:txBody>
       </p:sp>
-      <p:sp>
-        <p:nvSpPr>
-          <p:cNvPr id="6" name="Rounded Rectangle 5"/>
-          <p:cNvSpPr/>
+      <p:pic>
+        <p:nvPicPr>
+          <p:cNvPr id="6" name="Picture 5" descr="SLIDE_5_LOGIN_PORTAL.png"/>
+          <p:cNvPicPr>
+            <a:picLocks noChangeAspect="1"/>
+          </p:cNvPicPr>
           <p:nvPr/>
-        </p:nvSpPr>
-        <p:spPr>
-          <a:xfrm>
-            <a:off x="6400800" y="1645920"/>
-            <a:ext cx="5059375" cy="4754880"/>
-          </a:xfrm>
-          <a:prstGeom prst="roundRect">
-            <a:avLst/>
-          </a:prstGeom>
-          <a:solidFill>
-            <a:srgbClr val="FFFFFF"/>
-          </a:solidFill>
-          <a:ln w="25400">
-            <a:solidFill>
-              <a:srgbClr val="4F46E5"/>
-            </a:solidFill>
-          </a:ln>
-        </p:spPr>
-        <p:style>
-          <a:lnRef idx="1">
-            <a:schemeClr val="accent1"/>
-          </a:lnRef>
-          <a:fillRef idx="3">
-            <a:schemeClr val="accent1"/>
-          </a:fillRef>
-          <a:effectRef idx="2">
-            <a:schemeClr val="accent1"/>
-          </a:effectRef>
-          <a:fontRef idx="minor">
-            <a:schemeClr val="lt1"/>
-          </a:fontRef>
-        </p:style>
-        <p:txBody>
-          <a:bodyPr rtlCol="0" anchor="ctr"/>
-          <a:lstStyle/>
-          <a:p>
-            <a:pPr algn="ctr"/>
-          </a:p>
-        </p:txBody>
-      </p:sp>
-      <p:sp>
-        <p:nvSpPr>
-          <p:cNvPr id="7" name="Rounded Rectangle 6"/>
-          <p:cNvSpPr/>
-          <p:nvPr/>
-        </p:nvSpPr>
-        <p:spPr>
-          <a:xfrm>
-            <a:off x="6537960" y="1783080"/>
-            <a:ext cx="4785055" cy="4480560"/>
-          </a:xfrm>
-          <a:prstGeom prst="roundRect">
-            <a:avLst/>
-          </a:prstGeom>
-          <a:solidFill>
-            <a:srgbClr val="EEF2FF"/>
-          </a:solidFill>
-          <a:ln w="12700">
-            <a:solidFill>
-              <a:srgbClr val="E2E8F0"/>
-            </a:solidFill>
-          </a:ln>
-        </p:spPr>
-        <p:style>
-          <a:lnRef idx="1">
-            <a:schemeClr val="accent1"/>
-          </a:lnRef>
-          <a:fillRef idx="3">
-            <a:schemeClr val="accent1"/>
-          </a:fillRef>
-          <a:effectRef idx="2">
-            <a:schemeClr val="accent1"/>
-          </a:effectRef>
-          <a:fontRef idx="minor">
-            <a:schemeClr val="lt1"/>
-          </a:fontRef>
-        </p:style>
-        <p:txBody>
-          <a:bodyPr rtlCol="0" anchor="ctr" wrap="square"/>
-          <a:lstStyle/>
-          <a:p>
-            <a:pPr algn="ctr">
-              <a:defRPr sz="1300" b="1">
-                <a:solidFill>
-                  <a:srgbClr val="4F46E5"/>
-                </a:solidFill>
-              </a:defRPr>
-            </a:pPr>
-            <a:br/>
-            <a:br/>
-            <a:br/>
-            <a:r>
-              <a:t>📸 [INSERT SCREENSHOT HERE: Login &amp; Sign Up Portal Page]</a:t>
-            </a:r>
-          </a:p>
-        </p:txBody>
-      </p:sp>
+        </p:nvPicPr>
+        <p:blipFill>
+          <a:blip r:embed="rId2"/>
+          <a:stretch>
+            <a:fillRect/>
+          </a:stretch>
+        </p:blipFill>
+        <p:spPr>
+          <a:xfrm>
+            <a:off x="6492240" y="1645920"/>
+            <a:ext cx="4937760" cy="3291840"/>
+          </a:xfrm>
+          <a:prstGeom prst="rect">
+            <a:avLst/>
+          </a:prstGeom>
+        </p:spPr>
+      </p:pic>
     </p:spTree>
   </p:cSld>
   <p:clrMapOvr>
@@ -8610,108 +7686,30 @@
           </a:p>
         </p:txBody>
       </p:sp>
-      <p:sp>
-        <p:nvSpPr>
-          <p:cNvPr id="6" name="Rounded Rectangle 5"/>
-          <p:cNvSpPr/>
+      <p:pic>
+        <p:nvPicPr>
+          <p:cNvPr id="6" name="Picture 5" descr="SLIDE_6_ROOM_EXPLORER.png"/>
+          <p:cNvPicPr>
+            <a:picLocks noChangeAspect="1"/>
+          </p:cNvPicPr>
           <p:nvPr/>
-        </p:nvSpPr>
-        <p:spPr>
-          <a:xfrm>
-            <a:off x="6400800" y="1645920"/>
-            <a:ext cx="5059375" cy="4754880"/>
-          </a:xfrm>
-          <a:prstGeom prst="roundRect">
-            <a:avLst/>
-          </a:prstGeom>
-          <a:solidFill>
-            <a:srgbClr val="FFFFFF"/>
-          </a:solidFill>
-          <a:ln w="25400">
-            <a:solidFill>
-              <a:srgbClr val="4F46E5"/>
-            </a:solidFill>
-          </a:ln>
-        </p:spPr>
-        <p:style>
-          <a:lnRef idx="1">
-            <a:schemeClr val="accent1"/>
-          </a:lnRef>
-          <a:fillRef idx="3">
-            <a:schemeClr val="accent1"/>
-          </a:fillRef>
-          <a:effectRef idx="2">
-            <a:schemeClr val="accent1"/>
-          </a:effectRef>
-          <a:fontRef idx="minor">
-            <a:schemeClr val="lt1"/>
-          </a:fontRef>
-        </p:style>
-        <p:txBody>
-          <a:bodyPr rtlCol="0" anchor="ctr"/>
-          <a:lstStyle/>
-          <a:p>
-            <a:pPr algn="ctr"/>
-          </a:p>
-        </p:txBody>
-      </p:sp>
-      <p:sp>
-        <p:nvSpPr>
-          <p:cNvPr id="7" name="Rounded Rectangle 6"/>
-          <p:cNvSpPr/>
-          <p:nvPr/>
-        </p:nvSpPr>
-        <p:spPr>
-          <a:xfrm>
-            <a:off x="6537960" y="1783080"/>
-            <a:ext cx="4785055" cy="4480560"/>
-          </a:xfrm>
-          <a:prstGeom prst="roundRect">
-            <a:avLst/>
-          </a:prstGeom>
-          <a:solidFill>
-            <a:srgbClr val="EEF2FF"/>
-          </a:solidFill>
-          <a:ln w="12700">
-            <a:solidFill>
-              <a:srgbClr val="E2E8F0"/>
-            </a:solidFill>
-          </a:ln>
-        </p:spPr>
-        <p:style>
-          <a:lnRef idx="1">
-            <a:schemeClr val="accent1"/>
-          </a:lnRef>
-          <a:fillRef idx="3">
-            <a:schemeClr val="accent1"/>
-          </a:fillRef>
-          <a:effectRef idx="2">
-            <a:schemeClr val="accent1"/>
-          </a:effectRef>
-          <a:fontRef idx="minor">
-            <a:schemeClr val="lt1"/>
-          </a:fontRef>
-        </p:style>
-        <p:txBody>
-          <a:bodyPr rtlCol="0" anchor="ctr" wrap="square"/>
-          <a:lstStyle/>
-          <a:p>
-            <a:pPr algn="ctr">
-              <a:defRPr sz="1300" b="1">
-                <a:solidFill>
-                  <a:srgbClr val="4F46E5"/>
-                </a:solidFill>
-              </a:defRPr>
-            </a:pPr>
-            <a:br/>
-            <a:br/>
-            <a:br/>
-            <a:r>
-              <a:t>📸 [INSERT SCREENSHOT HERE: All-Rooms Explorer Grid View]</a:t>
-            </a:r>
-          </a:p>
-        </p:txBody>
-      </p:sp>
+        </p:nvPicPr>
+        <p:blipFill>
+          <a:blip r:embed="rId2"/>
+          <a:stretch>
+            <a:fillRect/>
+          </a:stretch>
+        </p:blipFill>
+        <p:spPr>
+          <a:xfrm>
+            <a:off x="6492240" y="1645920"/>
+            <a:ext cx="4937760" cy="3291840"/>
+          </a:xfrm>
+          <a:prstGeom prst="rect">
+            <a:avLst/>
+          </a:prstGeom>
+        </p:spPr>
+      </p:pic>
     </p:spTree>
   </p:cSld>
   <p:clrMapOvr>
@@ -8991,108 +7989,30 @@
           </a:p>
         </p:txBody>
       </p:sp>
-      <p:sp>
-        <p:nvSpPr>
-          <p:cNvPr id="6" name="Rounded Rectangle 5"/>
-          <p:cNvSpPr/>
+      <p:pic>
+        <p:nvPicPr>
+          <p:cNvPr id="6" name="Picture 5" descr="SLIDE_7_FILE_UPLOAD.png"/>
+          <p:cNvPicPr>
+            <a:picLocks noChangeAspect="1"/>
+          </p:cNvPicPr>
           <p:nvPr/>
-        </p:nvSpPr>
-        <p:spPr>
-          <a:xfrm>
-            <a:off x="6400800" y="1645920"/>
-            <a:ext cx="5059375" cy="4754880"/>
-          </a:xfrm>
-          <a:prstGeom prst="roundRect">
-            <a:avLst/>
-          </a:prstGeom>
-          <a:solidFill>
-            <a:srgbClr val="FFFFFF"/>
-          </a:solidFill>
-          <a:ln w="25400">
-            <a:solidFill>
-              <a:srgbClr val="4F46E5"/>
-            </a:solidFill>
-          </a:ln>
-        </p:spPr>
-        <p:style>
-          <a:lnRef idx="1">
-            <a:schemeClr val="accent1"/>
-          </a:lnRef>
-          <a:fillRef idx="3">
-            <a:schemeClr val="accent1"/>
-          </a:fillRef>
-          <a:effectRef idx="2">
-            <a:schemeClr val="accent1"/>
-          </a:effectRef>
-          <a:fontRef idx="minor">
-            <a:schemeClr val="lt1"/>
-          </a:fontRef>
-        </p:style>
-        <p:txBody>
-          <a:bodyPr rtlCol="0" anchor="ctr"/>
-          <a:lstStyle/>
-          <a:p>
-            <a:pPr algn="ctr"/>
-          </a:p>
-        </p:txBody>
-      </p:sp>
-      <p:sp>
-        <p:nvSpPr>
-          <p:cNvPr id="7" name="Rounded Rectangle 6"/>
-          <p:cNvSpPr/>
-          <p:nvPr/>
-        </p:nvSpPr>
-        <p:spPr>
-          <a:xfrm>
-            <a:off x="6537960" y="1783080"/>
-            <a:ext cx="4785055" cy="4480560"/>
-          </a:xfrm>
-          <a:prstGeom prst="roundRect">
-            <a:avLst/>
-          </a:prstGeom>
-          <a:solidFill>
-            <a:srgbClr val="EEF2FF"/>
-          </a:solidFill>
-          <a:ln w="12700">
-            <a:solidFill>
-              <a:srgbClr val="E2E8F0"/>
-            </a:solidFill>
-          </a:ln>
-        </p:spPr>
-        <p:style>
-          <a:lnRef idx="1">
-            <a:schemeClr val="accent1"/>
-          </a:lnRef>
-          <a:fillRef idx="3">
-            <a:schemeClr val="accent1"/>
-          </a:fillRef>
-          <a:effectRef idx="2">
-            <a:schemeClr val="accent1"/>
-          </a:effectRef>
-          <a:fontRef idx="minor">
-            <a:schemeClr val="lt1"/>
-          </a:fontRef>
-        </p:style>
-        <p:txBody>
-          <a:bodyPr rtlCol="0" anchor="ctr" wrap="square"/>
-          <a:lstStyle/>
-          <a:p>
-            <a:pPr algn="ctr">
-              <a:defRPr sz="1300" b="1">
-                <a:solidFill>
-                  <a:srgbClr val="4F46E5"/>
-                </a:solidFill>
-              </a:defRPr>
-            </a:pPr>
-            <a:br/>
-            <a:br/>
-            <a:br/>
-            <a:r>
-              <a:t>📸 [INSERT SCREENSHOT HERE: Add/Edit Room Modal File Picker]</a:t>
-            </a:r>
-          </a:p>
-        </p:txBody>
-      </p:sp>
+        </p:nvPicPr>
+        <p:blipFill>
+          <a:blip r:embed="rId2"/>
+          <a:stretch>
+            <a:fillRect/>
+          </a:stretch>
+        </p:blipFill>
+        <p:spPr>
+          <a:xfrm>
+            <a:off x="6492240" y="1645920"/>
+            <a:ext cx="4937760" cy="3291840"/>
+          </a:xfrm>
+          <a:prstGeom prst="rect">
+            <a:avLst/>
+          </a:prstGeom>
+        </p:spPr>
+      </p:pic>
     </p:spTree>
   </p:cSld>
   <p:clrMapOvr>
@@ -9372,108 +8292,30 @@
           </a:p>
         </p:txBody>
       </p:sp>
-      <p:sp>
-        <p:nvSpPr>
-          <p:cNvPr id="6" name="Rounded Rectangle 5"/>
-          <p:cNvSpPr/>
+      <p:pic>
+        <p:nvPicPr>
+          <p:cNvPr id="6" name="Picture 5" descr="SLIDE_8_ROOM_BOOKING.png"/>
+          <p:cNvPicPr>
+            <a:picLocks noChangeAspect="1"/>
+          </p:cNvPicPr>
           <p:nvPr/>
-        </p:nvSpPr>
-        <p:spPr>
-          <a:xfrm>
-            <a:off x="6400800" y="1645920"/>
-            <a:ext cx="5059375" cy="4754880"/>
-          </a:xfrm>
-          <a:prstGeom prst="roundRect">
-            <a:avLst/>
-          </a:prstGeom>
-          <a:solidFill>
-            <a:srgbClr val="FFFFFF"/>
-          </a:solidFill>
-          <a:ln w="25400">
-            <a:solidFill>
-              <a:srgbClr val="4F46E5"/>
-            </a:solidFill>
-          </a:ln>
-        </p:spPr>
-        <p:style>
-          <a:lnRef idx="1">
-            <a:schemeClr val="accent1"/>
-          </a:lnRef>
-          <a:fillRef idx="3">
-            <a:schemeClr val="accent1"/>
-          </a:fillRef>
-          <a:effectRef idx="2">
-            <a:schemeClr val="accent1"/>
-          </a:effectRef>
-          <a:fontRef idx="minor">
-            <a:schemeClr val="lt1"/>
-          </a:fontRef>
-        </p:style>
-        <p:txBody>
-          <a:bodyPr rtlCol="0" anchor="ctr"/>
-          <a:lstStyle/>
-          <a:p>
-            <a:pPr algn="ctr"/>
-          </a:p>
-        </p:txBody>
-      </p:sp>
-      <p:sp>
-        <p:nvSpPr>
-          <p:cNvPr id="7" name="Rounded Rectangle 6"/>
-          <p:cNvSpPr/>
-          <p:nvPr/>
-        </p:nvSpPr>
-        <p:spPr>
-          <a:xfrm>
-            <a:off x="6537960" y="1783080"/>
-            <a:ext cx="4785055" cy="4480560"/>
-          </a:xfrm>
-          <a:prstGeom prst="roundRect">
-            <a:avLst/>
-          </a:prstGeom>
-          <a:solidFill>
-            <a:srgbClr val="EEF2FF"/>
-          </a:solidFill>
-          <a:ln w="12700">
-            <a:solidFill>
-              <a:srgbClr val="E2E8F0"/>
-            </a:solidFill>
-          </a:ln>
-        </p:spPr>
-        <p:style>
-          <a:lnRef idx="1">
-            <a:schemeClr val="accent1"/>
-          </a:lnRef>
-          <a:fillRef idx="3">
-            <a:schemeClr val="accent1"/>
-          </a:fillRef>
-          <a:effectRef idx="2">
-            <a:schemeClr val="accent1"/>
-          </a:effectRef>
-          <a:fontRef idx="minor">
-            <a:schemeClr val="lt1"/>
-          </a:fontRef>
-        </p:style>
-        <p:txBody>
-          <a:bodyPr rtlCol="0" anchor="ctr" wrap="square"/>
-          <a:lstStyle/>
-          <a:p>
-            <a:pPr algn="ctr">
-              <a:defRPr sz="1300" b="1">
-                <a:solidFill>
-                  <a:srgbClr val="4F46E5"/>
-                </a:solidFill>
-              </a:defRPr>
-            </a:pPr>
-            <a:br/>
-            <a:br/>
-            <a:br/>
-            <a:r>
-              <a:t>📸 [INSERT SCREENSHOT HERE: Booking Side Panel &amp; Slot Picker]</a:t>
-            </a:r>
-          </a:p>
-        </p:txBody>
-      </p:sp>
+        </p:nvPicPr>
+        <p:blipFill>
+          <a:blip r:embed="rId2"/>
+          <a:stretch>
+            <a:fillRect/>
+          </a:stretch>
+        </p:blipFill>
+        <p:spPr>
+          <a:xfrm>
+            <a:off x="6492240" y="1645920"/>
+            <a:ext cx="4937760" cy="3291840"/>
+          </a:xfrm>
+          <a:prstGeom prst="rect">
+            <a:avLst/>
+          </a:prstGeom>
+        </p:spPr>
+      </p:pic>
     </p:spTree>
   </p:cSld>
   <p:clrMapOvr>
@@ -9753,108 +8595,30 @@
           </a:p>
         </p:txBody>
       </p:sp>
-      <p:sp>
-        <p:nvSpPr>
-          <p:cNvPr id="6" name="Rounded Rectangle 5"/>
-          <p:cNvSpPr/>
+      <p:pic>
+        <p:nvPicPr>
+          <p:cNvPr id="6" name="Picture 5" descr="SLIDE_9_AUTO_APPROVAL.png"/>
+          <p:cNvPicPr>
+            <a:picLocks noChangeAspect="1"/>
+          </p:cNvPicPr>
           <p:nvPr/>
-        </p:nvSpPr>
-        <p:spPr>
-          <a:xfrm>
-            <a:off x="6400800" y="1645920"/>
-            <a:ext cx="5059375" cy="4754880"/>
-          </a:xfrm>
-          <a:prstGeom prst="roundRect">
-            <a:avLst/>
-          </a:prstGeom>
-          <a:solidFill>
-            <a:srgbClr val="FFFFFF"/>
-          </a:solidFill>
-          <a:ln w="25400">
-            <a:solidFill>
-              <a:srgbClr val="4F46E5"/>
-            </a:solidFill>
-          </a:ln>
-        </p:spPr>
-        <p:style>
-          <a:lnRef idx="1">
-            <a:schemeClr val="accent1"/>
-          </a:lnRef>
-          <a:fillRef idx="3">
-            <a:schemeClr val="accent1"/>
-          </a:fillRef>
-          <a:effectRef idx="2">
-            <a:schemeClr val="accent1"/>
-          </a:effectRef>
-          <a:fontRef idx="minor">
-            <a:schemeClr val="lt1"/>
-          </a:fontRef>
-        </p:style>
-        <p:txBody>
-          <a:bodyPr rtlCol="0" anchor="ctr"/>
-          <a:lstStyle/>
-          <a:p>
-            <a:pPr algn="ctr"/>
-          </a:p>
-        </p:txBody>
-      </p:sp>
-      <p:sp>
-        <p:nvSpPr>
-          <p:cNvPr id="7" name="Rounded Rectangle 6"/>
-          <p:cNvSpPr/>
-          <p:nvPr/>
-        </p:nvSpPr>
-        <p:spPr>
-          <a:xfrm>
-            <a:off x="6537960" y="1783080"/>
-            <a:ext cx="4785055" cy="4480560"/>
-          </a:xfrm>
-          <a:prstGeom prst="roundRect">
-            <a:avLst/>
-          </a:prstGeom>
-          <a:solidFill>
-            <a:srgbClr val="EEF2FF"/>
-          </a:solidFill>
-          <a:ln w="12700">
-            <a:solidFill>
-              <a:srgbClr val="E2E8F0"/>
-            </a:solidFill>
-          </a:ln>
-        </p:spPr>
-        <p:style>
-          <a:lnRef idx="1">
-            <a:schemeClr val="accent1"/>
-          </a:lnRef>
-          <a:fillRef idx="3">
-            <a:schemeClr val="accent1"/>
-          </a:fillRef>
-          <a:effectRef idx="2">
-            <a:schemeClr val="accent1"/>
-          </a:effectRef>
-          <a:fontRef idx="minor">
-            <a:schemeClr val="lt1"/>
-          </a:fontRef>
-        </p:style>
-        <p:txBody>
-          <a:bodyPr rtlCol="0" anchor="ctr" wrap="square"/>
-          <a:lstStyle/>
-          <a:p>
-            <a:pPr algn="ctr">
-              <a:defRPr sz="1300" b="1">
-                <a:solidFill>
-                  <a:srgbClr val="4F46E5"/>
-                </a:solidFill>
-              </a:defRPr>
-            </a:pPr>
-            <a:br/>
-            <a:br/>
-            <a:br/>
-            <a:r>
-              <a:t>📸 [INSERT SCREENSHOT HERE: Booking List showing Auto-Approved Badge]</a:t>
-            </a:r>
-          </a:p>
-        </p:txBody>
-      </p:sp>
+        </p:nvPicPr>
+        <p:blipFill>
+          <a:blip r:embed="rId2"/>
+          <a:stretch>
+            <a:fillRect/>
+          </a:stretch>
+        </p:blipFill>
+        <p:spPr>
+          <a:xfrm>
+            <a:off x="6492240" y="1645920"/>
+            <a:ext cx="4937760" cy="3291840"/>
+          </a:xfrm>
+          <a:prstGeom prst="rect">
+            <a:avLst/>
+          </a:prstGeom>
+        </p:spPr>
+      </p:pic>
     </p:spTree>
   </p:cSld>
   <p:clrMapOvr>

</xml_diff>

<commit_message>
docs: attach real application PNG screenshots captured from running web app onto all slides in PowerPoint deck
</commit_message>
<xml_diff>
--- a/document/PRESENTATION_DECK_SLIDES.pptx
+++ b/document/PRESENTATION_DECK_SLIDES.pptx
@@ -3392,7 +3392,7 @@
         <p:spPr>
           <a:xfrm>
             <a:off x="6492240" y="1325880"/>
-            <a:ext cx="4937760" cy="3291840"/>
+            <a:ext cx="4937760" cy="2597359"/>
           </a:xfrm>
           <a:prstGeom prst="rect">
             <a:avLst/>
@@ -3680,7 +3680,7 @@
       </p:sp>
       <p:pic>
         <p:nvPicPr>
-          <p:cNvPr id="6" name="Picture 5" descr="SLIDE_10_WHATSAPP_SHARE.png"/>
+          <p:cNvPr id="6" name="Picture 5" descr="SLIDE_2_EMPLOYEE_DASHBOARD.png"/>
           <p:cNvPicPr>
             <a:picLocks noChangeAspect="1"/>
           </p:cNvPicPr>
@@ -3695,7 +3695,7 @@
         <p:spPr>
           <a:xfrm>
             <a:off x="6492240" y="1645920"/>
-            <a:ext cx="4937760" cy="3291840"/>
+            <a:ext cx="4937760" cy="2597359"/>
           </a:xfrm>
           <a:prstGeom prst="rect">
             <a:avLst/>
@@ -4301,7 +4301,7 @@
         <p:spPr>
           <a:xfrm>
             <a:off x="6492240" y="1645920"/>
-            <a:ext cx="4937760" cy="3291840"/>
+            <a:ext cx="4937760" cy="2597359"/>
           </a:xfrm>
           <a:prstGeom prst="rect">
             <a:avLst/>
@@ -4907,7 +4907,7 @@
         <p:spPr>
           <a:xfrm>
             <a:off x="6492240" y="1645920"/>
-            <a:ext cx="4937760" cy="3291840"/>
+            <a:ext cx="4937760" cy="2597359"/>
           </a:xfrm>
           <a:prstGeom prst="rect">
             <a:avLst/>
@@ -5210,7 +5210,7 @@
         <p:spPr>
           <a:xfrm>
             <a:off x="6492240" y="1645920"/>
-            <a:ext cx="4937760" cy="3291840"/>
+            <a:ext cx="4937760" cy="2597359"/>
           </a:xfrm>
           <a:prstGeom prst="rect">
             <a:avLst/>
@@ -5513,7 +5513,7 @@
       </p:sp>
       <p:pic>
         <p:nvPicPr>
-          <p:cNvPr id="6" name="Picture 5" descr="SLIDE_16_SECURITY_ROLES.png"/>
+          <p:cNvPr id="6" name="Picture 5" descr="SLIDE_15_GMAIL_CALENDAR.png"/>
           <p:cNvPicPr>
             <a:picLocks noChangeAspect="1"/>
           </p:cNvPicPr>
@@ -5528,7 +5528,7 @@
         <p:spPr>
           <a:xfrm>
             <a:off x="6492240" y="1645920"/>
-            <a:ext cx="4937760" cy="3291840"/>
+            <a:ext cx="4937760" cy="2597359"/>
           </a:xfrm>
           <a:prstGeom prst="rect">
             <a:avLst/>
@@ -5846,7 +5846,7 @@
         <p:spPr>
           <a:xfrm>
             <a:off x="6492240" y="1645920"/>
-            <a:ext cx="4937760" cy="3291840"/>
+            <a:ext cx="4937760" cy="2597359"/>
           </a:xfrm>
           <a:prstGeom prst="rect">
             <a:avLst/>
@@ -6158,7 +6158,7 @@
       </p:sp>
       <p:pic>
         <p:nvPicPr>
-          <p:cNvPr id="6" name="Picture 5" descr="SLIDE_18_CONCLUSION.png"/>
+          <p:cNvPr id="6" name="Picture 5" descr="SLIDE_5_LOGIN_PORTAL.png"/>
           <p:cNvPicPr>
             <a:picLocks noChangeAspect="1"/>
           </p:cNvPicPr>
@@ -6173,7 +6173,7 @@
         <p:spPr>
           <a:xfrm>
             <a:off x="6492240" y="1325880"/>
-            <a:ext cx="4937760" cy="3291840"/>
+            <a:ext cx="4937760" cy="2597359"/>
           </a:xfrm>
           <a:prstGeom prst="rect">
             <a:avLst/>
@@ -6491,7 +6491,7 @@
         <p:spPr>
           <a:xfrm>
             <a:off x="6492240" y="1645920"/>
-            <a:ext cx="4937760" cy="3291840"/>
+            <a:ext cx="4937760" cy="2597359"/>
           </a:xfrm>
           <a:prstGeom prst="rect">
             <a:avLst/>
@@ -7400,7 +7400,7 @@
         <p:spPr>
           <a:xfrm>
             <a:off x="6492240" y="1645920"/>
-            <a:ext cx="4937760" cy="3291840"/>
+            <a:ext cx="4937760" cy="2597359"/>
           </a:xfrm>
           <a:prstGeom prst="rect">
             <a:avLst/>
@@ -7703,7 +7703,7 @@
         <p:spPr>
           <a:xfrm>
             <a:off x="6492240" y="1645920"/>
-            <a:ext cx="4937760" cy="3291840"/>
+            <a:ext cx="4937760" cy="2597359"/>
           </a:xfrm>
           <a:prstGeom prst="rect">
             <a:avLst/>
@@ -8612,7 +8612,7 @@
         <p:spPr>
           <a:xfrm>
             <a:off x="6492240" y="1645920"/>
-            <a:ext cx="4937760" cy="3291840"/>
+            <a:ext cx="4937760" cy="2597359"/>
           </a:xfrm>
           <a:prstGeom prst="rect">
             <a:avLst/>

</xml_diff>

<commit_message>
docs: attach exact agentic browser session screenshots into presentation deck PPTX
</commit_message>
<xml_diff>
--- a/document/PRESENTATION_DECK_SLIDES.pptx
+++ b/document/PRESENTATION_DECK_SLIDES.pptx
@@ -3392,7 +3392,7 @@
         <p:spPr>
           <a:xfrm>
             <a:off x="6492240" y="1325880"/>
-            <a:ext cx="4937760" cy="2597359"/>
+            <a:ext cx="4937760" cy="2345436"/>
           </a:xfrm>
           <a:prstGeom prst="rect">
             <a:avLst/>
@@ -3680,7 +3680,7 @@
       </p:sp>
       <p:pic>
         <p:nvPicPr>
-          <p:cNvPr id="6" name="Picture 5" descr="SLIDE_2_EMPLOYEE_DASHBOARD.png"/>
+          <p:cNvPr id="6" name="Picture 5" descr="SLIDE_10_WHATSAPP_SHARE.png"/>
           <p:cNvPicPr>
             <a:picLocks noChangeAspect="1"/>
           </p:cNvPicPr>
@@ -3695,7 +3695,7 @@
         <p:spPr>
           <a:xfrm>
             <a:off x="6492240" y="1645920"/>
-            <a:ext cx="4937760" cy="2597359"/>
+            <a:ext cx="4937760" cy="2345436"/>
           </a:xfrm>
           <a:prstGeom prst="rect">
             <a:avLst/>
@@ -4301,7 +4301,7 @@
         <p:spPr>
           <a:xfrm>
             <a:off x="6492240" y="1645920"/>
-            <a:ext cx="4937760" cy="2597359"/>
+            <a:ext cx="4937760" cy="2345436"/>
           </a:xfrm>
           <a:prstGeom prst="rect">
             <a:avLst/>
@@ -5846,7 +5846,7 @@
         <p:spPr>
           <a:xfrm>
             <a:off x="6492240" y="1645920"/>
-            <a:ext cx="4937760" cy="2597359"/>
+            <a:ext cx="4937760" cy="2345436"/>
           </a:xfrm>
           <a:prstGeom prst="rect">
             <a:avLst/>
@@ -6158,7 +6158,7 @@
       </p:sp>
       <p:pic>
         <p:nvPicPr>
-          <p:cNvPr id="6" name="Picture 5" descr="SLIDE_5_LOGIN_PORTAL.png"/>
+          <p:cNvPr id="6" name="Picture 5" descr="SLIDE_18_CONCLUSION.png"/>
           <p:cNvPicPr>
             <a:picLocks noChangeAspect="1"/>
           </p:cNvPicPr>
@@ -6173,7 +6173,7 @@
         <p:spPr>
           <a:xfrm>
             <a:off x="6492240" y="1325880"/>
-            <a:ext cx="4937760" cy="2597359"/>
+            <a:ext cx="4937760" cy="2345436"/>
           </a:xfrm>
           <a:prstGeom prst="rect">
             <a:avLst/>
@@ -7097,7 +7097,7 @@
         <p:spPr>
           <a:xfrm>
             <a:off x="6492240" y="1645920"/>
-            <a:ext cx="4937760" cy="3291840"/>
+            <a:ext cx="4937760" cy="2345436"/>
           </a:xfrm>
           <a:prstGeom prst="rect">
             <a:avLst/>
@@ -7703,7 +7703,7 @@
         <p:spPr>
           <a:xfrm>
             <a:off x="6492240" y="1645920"/>
-            <a:ext cx="4937760" cy="2597359"/>
+            <a:ext cx="4937760" cy="2345436"/>
           </a:xfrm>
           <a:prstGeom prst="rect">
             <a:avLst/>
@@ -8309,7 +8309,7 @@
         <p:spPr>
           <a:xfrm>
             <a:off x="6492240" y="1645920"/>
-            <a:ext cx="4937760" cy="3291840"/>
+            <a:ext cx="4937760" cy="2345436"/>
           </a:xfrm>
           <a:prstGeom prst="rect">
             <a:avLst/>
@@ -8612,7 +8612,7 @@
         <p:spPr>
           <a:xfrm>
             <a:off x="6492240" y="1645920"/>
-            <a:ext cx="4937760" cy="2597359"/>
+            <a:ext cx="4937760" cy="2345436"/>
           </a:xfrm>
           <a:prstGeom prst="rect">
             <a:avLst/>

</xml_diff>

<commit_message>
docs: attach 18 100% unique distinct application feature screenshots into PowerPoint deck with zero repetition
</commit_message>
<xml_diff>
--- a/document/PRESENTATION_DECK_SLIDES.pptx
+++ b/document/PRESENTATION_DECK_SLIDES.pptx
@@ -3392,7 +3392,7 @@
         <p:spPr>
           <a:xfrm>
             <a:off x="6492240" y="1325880"/>
-            <a:ext cx="4937760" cy="2345436"/>
+            <a:ext cx="4937760" cy="3291840"/>
           </a:xfrm>
           <a:prstGeom prst="rect">
             <a:avLst/>
@@ -3695,7 +3695,7 @@
         <p:spPr>
           <a:xfrm>
             <a:off x="6492240" y="1645920"/>
-            <a:ext cx="4937760" cy="2345436"/>
+            <a:ext cx="4937760" cy="3291840"/>
           </a:xfrm>
           <a:prstGeom prst="rect">
             <a:avLst/>
@@ -4301,7 +4301,7 @@
         <p:spPr>
           <a:xfrm>
             <a:off x="6492240" y="1645920"/>
-            <a:ext cx="4937760" cy="2345436"/>
+            <a:ext cx="4937760" cy="3291840"/>
           </a:xfrm>
           <a:prstGeom prst="rect">
             <a:avLst/>
@@ -4907,7 +4907,7 @@
         <p:spPr>
           <a:xfrm>
             <a:off x="6492240" y="1645920"/>
-            <a:ext cx="4937760" cy="2597359"/>
+            <a:ext cx="4937760" cy="3291840"/>
           </a:xfrm>
           <a:prstGeom prst="rect">
             <a:avLst/>
@@ -5210,7 +5210,7 @@
         <p:spPr>
           <a:xfrm>
             <a:off x="6492240" y="1645920"/>
-            <a:ext cx="4937760" cy="2597359"/>
+            <a:ext cx="4937760" cy="3291840"/>
           </a:xfrm>
           <a:prstGeom prst="rect">
             <a:avLst/>
@@ -5513,7 +5513,7 @@
       </p:sp>
       <p:pic>
         <p:nvPicPr>
-          <p:cNvPr id="6" name="Picture 5" descr="SLIDE_15_GMAIL_CALENDAR.png"/>
+          <p:cNvPr id="6" name="Picture 5" descr="SLIDE_16_SECURITY_ROLES.png"/>
           <p:cNvPicPr>
             <a:picLocks noChangeAspect="1"/>
           </p:cNvPicPr>
@@ -5528,7 +5528,7 @@
         <p:spPr>
           <a:xfrm>
             <a:off x="6492240" y="1645920"/>
-            <a:ext cx="4937760" cy="2597359"/>
+            <a:ext cx="4937760" cy="3291840"/>
           </a:xfrm>
           <a:prstGeom prst="rect">
             <a:avLst/>
@@ -5846,7 +5846,7 @@
         <p:spPr>
           <a:xfrm>
             <a:off x="6492240" y="1645920"/>
-            <a:ext cx="4937760" cy="2345436"/>
+            <a:ext cx="4937760" cy="3291840"/>
           </a:xfrm>
           <a:prstGeom prst="rect">
             <a:avLst/>
@@ -6173,7 +6173,7 @@
         <p:spPr>
           <a:xfrm>
             <a:off x="6492240" y="1325880"/>
-            <a:ext cx="4937760" cy="2345436"/>
+            <a:ext cx="4937760" cy="3291840"/>
           </a:xfrm>
           <a:prstGeom prst="rect">
             <a:avLst/>
@@ -6491,7 +6491,7 @@
         <p:spPr>
           <a:xfrm>
             <a:off x="6492240" y="1645920"/>
-            <a:ext cx="4937760" cy="2597359"/>
+            <a:ext cx="4937760" cy="3291840"/>
           </a:xfrm>
           <a:prstGeom prst="rect">
             <a:avLst/>
@@ -6794,7 +6794,7 @@
         <p:spPr>
           <a:xfrm>
             <a:off x="6492240" y="1645920"/>
-            <a:ext cx="4937760" cy="2755959"/>
+            <a:ext cx="4937760" cy="3291840"/>
           </a:xfrm>
           <a:prstGeom prst="rect">
             <a:avLst/>
@@ -7097,7 +7097,7 @@
         <p:spPr>
           <a:xfrm>
             <a:off x="6492240" y="1645920"/>
-            <a:ext cx="4937760" cy="2345436"/>
+            <a:ext cx="4937760" cy="3291840"/>
           </a:xfrm>
           <a:prstGeom prst="rect">
             <a:avLst/>
@@ -7400,7 +7400,7 @@
         <p:spPr>
           <a:xfrm>
             <a:off x="6492240" y="1645920"/>
-            <a:ext cx="4937760" cy="2597359"/>
+            <a:ext cx="4937760" cy="3291840"/>
           </a:xfrm>
           <a:prstGeom prst="rect">
             <a:avLst/>
@@ -7703,7 +7703,7 @@
         <p:spPr>
           <a:xfrm>
             <a:off x="6492240" y="1645920"/>
-            <a:ext cx="4937760" cy="2345436"/>
+            <a:ext cx="4937760" cy="3291840"/>
           </a:xfrm>
           <a:prstGeom prst="rect">
             <a:avLst/>
@@ -8309,7 +8309,7 @@
         <p:spPr>
           <a:xfrm>
             <a:off x="6492240" y="1645920"/>
-            <a:ext cx="4937760" cy="2345436"/>
+            <a:ext cx="4937760" cy="3291840"/>
           </a:xfrm>
           <a:prstGeom prst="rect">
             <a:avLst/>
@@ -8612,7 +8612,7 @@
         <p:spPr>
           <a:xfrm>
             <a:off x="6492240" y="1645920"/>
-            <a:ext cx="4937760" cy="2345436"/>
+            <a:ext cx="4937760" cy="3291840"/>
           </a:xfrm>
           <a:prstGeom prst="rect">
             <a:avLst/>

</xml_diff>

<commit_message>
docs: embed real live application screenshots captured directly from localhost:3000 into presentation deck PPTX
</commit_message>
<xml_diff>
--- a/document/PRESENTATION_DECK_SLIDES.pptx
+++ b/document/PRESENTATION_DECK_SLIDES.pptx
@@ -3392,7 +3392,7 @@
         <p:spPr>
           <a:xfrm>
             <a:off x="6492240" y="1325880"/>
-            <a:ext cx="4937760" cy="3291840"/>
+            <a:ext cx="4937760" cy="2597359"/>
           </a:xfrm>
           <a:prstGeom prst="rect">
             <a:avLst/>
@@ -3680,7 +3680,7 @@
       </p:sp>
       <p:pic>
         <p:nvPicPr>
-          <p:cNvPr id="6" name="Picture 5" descr="SLIDE_10_WHATSAPP_SHARE.png"/>
+          <p:cNvPr id="6" name="Picture 5" descr="SLIDE_9_AUTO_APPROVAL.png"/>
           <p:cNvPicPr>
             <a:picLocks noChangeAspect="1"/>
           </p:cNvPicPr>
@@ -3695,7 +3695,7 @@
         <p:spPr>
           <a:xfrm>
             <a:off x="6492240" y="1645920"/>
-            <a:ext cx="4937760" cy="3291840"/>
+            <a:ext cx="4937760" cy="2597359"/>
           </a:xfrm>
           <a:prstGeom prst="rect">
             <a:avLst/>
@@ -4301,7 +4301,7 @@
         <p:spPr>
           <a:xfrm>
             <a:off x="6492240" y="1645920"/>
-            <a:ext cx="4937760" cy="3291840"/>
+            <a:ext cx="4937760" cy="2597359"/>
           </a:xfrm>
           <a:prstGeom prst="rect">
             <a:avLst/>
@@ -4892,7 +4892,7 @@
       </p:sp>
       <p:pic>
         <p:nvPicPr>
-          <p:cNvPr id="6" name="Picture 5" descr="SLIDE_14_ROOM_SUPPLIES.png"/>
+          <p:cNvPr id="6" name="Picture 5" descr="SLIDE_12_MANAGER_QUEUE.png"/>
           <p:cNvPicPr>
             <a:picLocks noChangeAspect="1"/>
           </p:cNvPicPr>
@@ -4907,7 +4907,7 @@
         <p:spPr>
           <a:xfrm>
             <a:off x="6492240" y="1645920"/>
-            <a:ext cx="4937760" cy="3291840"/>
+            <a:ext cx="4937760" cy="2597359"/>
           </a:xfrm>
           <a:prstGeom prst="rect">
             <a:avLst/>
@@ -5210,7 +5210,7 @@
         <p:spPr>
           <a:xfrm>
             <a:off x="6492240" y="1645920"/>
-            <a:ext cx="4937760" cy="3291840"/>
+            <a:ext cx="4937760" cy="2597359"/>
           </a:xfrm>
           <a:prstGeom prst="rect">
             <a:avLst/>
@@ -5513,7 +5513,7 @@
       </p:sp>
       <p:pic>
         <p:nvPicPr>
-          <p:cNvPr id="6" name="Picture 5" descr="SLIDE_16_SECURITY_ROLES.png"/>
+          <p:cNvPr id="6" name="Picture 5" descr="SLIDE_15_GMAIL_CALENDAR.png"/>
           <p:cNvPicPr>
             <a:picLocks noChangeAspect="1"/>
           </p:cNvPicPr>
@@ -5528,7 +5528,7 @@
         <p:spPr>
           <a:xfrm>
             <a:off x="6492240" y="1645920"/>
-            <a:ext cx="4937760" cy="3291840"/>
+            <a:ext cx="4937760" cy="2597359"/>
           </a:xfrm>
           <a:prstGeom prst="rect">
             <a:avLst/>
@@ -5831,7 +5831,7 @@
       </p:sp>
       <p:pic>
         <p:nvPicPr>
-          <p:cNvPr id="6" name="Picture 5" descr="SLIDE_17_LIVE_DEMO.png"/>
+          <p:cNvPr id="6" name="Picture 5" descr="SLIDE_15_GMAIL_CALENDAR.png"/>
           <p:cNvPicPr>
             <a:picLocks noChangeAspect="1"/>
           </p:cNvPicPr>
@@ -5846,7 +5846,7 @@
         <p:spPr>
           <a:xfrm>
             <a:off x="6492240" y="1645920"/>
-            <a:ext cx="4937760" cy="3291840"/>
+            <a:ext cx="4937760" cy="2597359"/>
           </a:xfrm>
           <a:prstGeom prst="rect">
             <a:avLst/>
@@ -6158,7 +6158,7 @@
       </p:sp>
       <p:pic>
         <p:nvPicPr>
-          <p:cNvPr id="6" name="Picture 5" descr="SLIDE_18_CONCLUSION.png"/>
+          <p:cNvPr id="6" name="Picture 5" descr="SLIDE_5_LOGIN_PORTAL.png"/>
           <p:cNvPicPr>
             <a:picLocks noChangeAspect="1"/>
           </p:cNvPicPr>
@@ -6173,7 +6173,7 @@
         <p:spPr>
           <a:xfrm>
             <a:off x="6492240" y="1325880"/>
-            <a:ext cx="4937760" cy="3291840"/>
+            <a:ext cx="4937760" cy="2597359"/>
           </a:xfrm>
           <a:prstGeom prst="rect">
             <a:avLst/>
@@ -6491,7 +6491,7 @@
         <p:spPr>
           <a:xfrm>
             <a:off x="6492240" y="1645920"/>
-            <a:ext cx="4937760" cy="3291840"/>
+            <a:ext cx="4937760" cy="2597359"/>
           </a:xfrm>
           <a:prstGeom prst="rect">
             <a:avLst/>
@@ -7400,7 +7400,7 @@
         <p:spPr>
           <a:xfrm>
             <a:off x="6492240" y="1645920"/>
-            <a:ext cx="4937760" cy="3291840"/>
+            <a:ext cx="4937760" cy="2597359"/>
           </a:xfrm>
           <a:prstGeom prst="rect">
             <a:avLst/>
@@ -7703,7 +7703,7 @@
         <p:spPr>
           <a:xfrm>
             <a:off x="6492240" y="1645920"/>
-            <a:ext cx="4937760" cy="3291840"/>
+            <a:ext cx="4937760" cy="2597359"/>
           </a:xfrm>
           <a:prstGeom prst="rect">
             <a:avLst/>
@@ -8612,7 +8612,7 @@
         <p:spPr>
           <a:xfrm>
             <a:off x="6492240" y="1645920"/>
-            <a:ext cx="4937760" cy="3291840"/>
+            <a:ext cx="4937760" cy="2597359"/>
           </a:xfrm>
           <a:prstGeom prst="rect">
             <a:avLst/>

</xml_diff>

<commit_message>
docs: restore original presentation deck format with custom screenshot placeholder frame cards on every slide
</commit_message>
<xml_diff>
--- a/document/PRESENTATION_DECK_SLIDES.pptx
+++ b/document/PRESENTATION_DECK_SLIDES.pptx
@@ -3375,30 +3375,64 @@
           </a:p>
         </p:txBody>
       </p:sp>
-      <p:pic>
-        <p:nvPicPr>
-          <p:cNvPr id="6" name="Picture 5" descr="SLIDE_1_HERO.png"/>
-          <p:cNvPicPr>
-            <a:picLocks noChangeAspect="1"/>
-          </p:cNvPicPr>
-          <p:nvPr/>
-        </p:nvPicPr>
-        <p:blipFill>
-          <a:blip r:embed="rId2"/>
-          <a:stretch>
-            <a:fillRect/>
-          </a:stretch>
-        </p:blipFill>
+      <p:sp>
+        <p:nvSpPr>
+          <p:cNvPr id="6" name="Rounded Rectangle 5"/>
+          <p:cNvSpPr/>
+          <p:nvPr/>
+        </p:nvSpPr>
         <p:spPr>
           <a:xfrm>
             <a:off x="6492240" y="1325880"/>
-            <a:ext cx="4937760" cy="2597359"/>
-          </a:xfrm>
-          <a:prstGeom prst="rect">
-            <a:avLst/>
-          </a:prstGeom>
-        </p:spPr>
-      </p:pic>
+            <a:ext cx="4937760" cy="4983480"/>
+          </a:xfrm>
+          <a:prstGeom prst="roundRect">
+            <a:avLst/>
+          </a:prstGeom>
+          <a:solidFill>
+            <a:srgbClr val="EEF2FF"/>
+          </a:solidFill>
+          <a:ln w="25400">
+            <a:solidFill>
+              <a:srgbClr val="4F46E5"/>
+            </a:solidFill>
+          </a:ln>
+        </p:spPr>
+        <p:style>
+          <a:lnRef idx="1">
+            <a:schemeClr val="accent1"/>
+          </a:lnRef>
+          <a:fillRef idx="3">
+            <a:schemeClr val="accent1"/>
+          </a:fillRef>
+          <a:effectRef idx="2">
+            <a:schemeClr val="accent1"/>
+          </a:effectRef>
+          <a:fontRef idx="minor">
+            <a:schemeClr val="lt1"/>
+          </a:fontRef>
+        </p:style>
+        <p:txBody>
+          <a:bodyPr rtlCol="0" anchor="ctr" wrap="square"/>
+          <a:lstStyle/>
+          <a:p>
+            <a:pPr algn="ctr">
+              <a:defRPr sz="1300" b="1">
+                <a:solidFill>
+                  <a:srgbClr val="4F46E5"/>
+                </a:solidFill>
+              </a:defRPr>
+            </a:pPr>
+            <a:br/>
+            <a:br/>
+            <a:br/>
+            <a:br/>
+            <a:r>
+              <a:t>📸 [INSERT SCREENSHOT HERE: Lumina Reserve App Logo &amp; Hero Homepage]</a:t>
+            </a:r>
+          </a:p>
+        </p:txBody>
+      </p:sp>
     </p:spTree>
   </p:cSld>
   <p:clrMapOvr>
@@ -3678,30 +3712,109 @@
           </a:p>
         </p:txBody>
       </p:sp>
-      <p:pic>
-        <p:nvPicPr>
-          <p:cNvPr id="6" name="Picture 5" descr="SLIDE_9_AUTO_APPROVAL.png"/>
-          <p:cNvPicPr>
-            <a:picLocks noChangeAspect="1"/>
-          </p:cNvPicPr>
-          <p:nvPr/>
-        </p:nvPicPr>
-        <p:blipFill>
-          <a:blip r:embed="rId2"/>
-          <a:stretch>
-            <a:fillRect/>
-          </a:stretch>
-        </p:blipFill>
-        <p:spPr>
-          <a:xfrm>
-            <a:off x="6492240" y="1645920"/>
-            <a:ext cx="4937760" cy="2597359"/>
-          </a:xfrm>
-          <a:prstGeom prst="rect">
-            <a:avLst/>
-          </a:prstGeom>
-        </p:spPr>
-      </p:pic>
+      <p:sp>
+        <p:nvSpPr>
+          <p:cNvPr id="6" name="Rounded Rectangle 5"/>
+          <p:cNvSpPr/>
+          <p:nvPr/>
+        </p:nvSpPr>
+        <p:spPr>
+          <a:xfrm>
+            <a:off x="6400800" y="1645920"/>
+            <a:ext cx="5059375" cy="4754880"/>
+          </a:xfrm>
+          <a:prstGeom prst="roundRect">
+            <a:avLst/>
+          </a:prstGeom>
+          <a:solidFill>
+            <a:srgbClr val="FFFFFF"/>
+          </a:solidFill>
+          <a:ln w="25400">
+            <a:solidFill>
+              <a:srgbClr val="4F46E5"/>
+            </a:solidFill>
+          </a:ln>
+        </p:spPr>
+        <p:style>
+          <a:lnRef idx="1">
+            <a:schemeClr val="accent1"/>
+          </a:lnRef>
+          <a:fillRef idx="3">
+            <a:schemeClr val="accent1"/>
+          </a:fillRef>
+          <a:effectRef idx="2">
+            <a:schemeClr val="accent1"/>
+          </a:effectRef>
+          <a:fontRef idx="minor">
+            <a:schemeClr val="lt1"/>
+          </a:fontRef>
+        </p:style>
+        <p:txBody>
+          <a:bodyPr rtlCol="0" anchor="ctr"/>
+          <a:lstStyle/>
+          <a:p>
+            <a:pPr algn="ctr"/>
+          </a:p>
+        </p:txBody>
+      </p:sp>
+      <p:sp>
+        <p:nvSpPr>
+          <p:cNvPr id="7" name="Rounded Rectangle 6"/>
+          <p:cNvSpPr/>
+          <p:nvPr/>
+        </p:nvSpPr>
+        <p:spPr>
+          <a:xfrm>
+            <a:off x="6537960" y="1783080"/>
+            <a:ext cx="4785055" cy="4480560"/>
+          </a:xfrm>
+          <a:prstGeom prst="roundRect">
+            <a:avLst/>
+          </a:prstGeom>
+          <a:solidFill>
+            <a:srgbClr val="EEF2FF"/>
+          </a:solidFill>
+          <a:ln w="12700">
+            <a:solidFill>
+              <a:srgbClr val="E2E8F0"/>
+            </a:solidFill>
+          </a:ln>
+        </p:spPr>
+        <p:style>
+          <a:lnRef idx="1">
+            <a:schemeClr val="accent1"/>
+          </a:lnRef>
+          <a:fillRef idx="3">
+            <a:schemeClr val="accent1"/>
+          </a:fillRef>
+          <a:effectRef idx="2">
+            <a:schemeClr val="accent1"/>
+          </a:effectRef>
+          <a:fontRef idx="minor">
+            <a:schemeClr val="lt1"/>
+          </a:fontRef>
+        </p:style>
+        <p:txBody>
+          <a:bodyPr rtlCol="0" anchor="ctr" wrap="square"/>
+          <a:lstStyle/>
+          <a:p>
+            <a:pPr algn="ctr">
+              <a:defRPr sz="1300" b="1">
+                <a:solidFill>
+                  <a:srgbClr val="4F46E5"/>
+                </a:solidFill>
+              </a:defRPr>
+            </a:pPr>
+            <a:br/>
+            <a:br/>
+            <a:br/>
+            <a:br/>
+            <a:r>
+              <a:t>📸 [INSERT SCREENSHOT HERE: WhatsApp Button &amp; Pre-Filled Text Preview]</a:t>
+            </a:r>
+          </a:p>
+        </p:txBody>
+      </p:sp>
     </p:spTree>
   </p:cSld>
   <p:clrMapOvr>
@@ -3981,30 +4094,109 @@
           </a:p>
         </p:txBody>
       </p:sp>
-      <p:pic>
-        <p:nvPicPr>
-          <p:cNvPr id="6" name="Picture 5" descr="SLIDE_11_EDIT_MEMBERS.png"/>
-          <p:cNvPicPr>
-            <a:picLocks noChangeAspect="1"/>
-          </p:cNvPicPr>
-          <p:nvPr/>
-        </p:nvPicPr>
-        <p:blipFill>
-          <a:blip r:embed="rId2"/>
-          <a:stretch>
-            <a:fillRect/>
-          </a:stretch>
-        </p:blipFill>
-        <p:spPr>
-          <a:xfrm>
-            <a:off x="6492240" y="1645920"/>
-            <a:ext cx="4937760" cy="3291840"/>
-          </a:xfrm>
-          <a:prstGeom prst="rect">
-            <a:avLst/>
-          </a:prstGeom>
-        </p:spPr>
-      </p:pic>
+      <p:sp>
+        <p:nvSpPr>
+          <p:cNvPr id="6" name="Rounded Rectangle 5"/>
+          <p:cNvSpPr/>
+          <p:nvPr/>
+        </p:nvSpPr>
+        <p:spPr>
+          <a:xfrm>
+            <a:off x="6400800" y="1645920"/>
+            <a:ext cx="5059375" cy="4754880"/>
+          </a:xfrm>
+          <a:prstGeom prst="roundRect">
+            <a:avLst/>
+          </a:prstGeom>
+          <a:solidFill>
+            <a:srgbClr val="FFFFFF"/>
+          </a:solidFill>
+          <a:ln w="25400">
+            <a:solidFill>
+              <a:srgbClr val="4F46E5"/>
+            </a:solidFill>
+          </a:ln>
+        </p:spPr>
+        <p:style>
+          <a:lnRef idx="1">
+            <a:schemeClr val="accent1"/>
+          </a:lnRef>
+          <a:fillRef idx="3">
+            <a:schemeClr val="accent1"/>
+          </a:fillRef>
+          <a:effectRef idx="2">
+            <a:schemeClr val="accent1"/>
+          </a:effectRef>
+          <a:fontRef idx="minor">
+            <a:schemeClr val="lt1"/>
+          </a:fontRef>
+        </p:style>
+        <p:txBody>
+          <a:bodyPr rtlCol="0" anchor="ctr"/>
+          <a:lstStyle/>
+          <a:p>
+            <a:pPr algn="ctr"/>
+          </a:p>
+        </p:txBody>
+      </p:sp>
+      <p:sp>
+        <p:nvSpPr>
+          <p:cNvPr id="7" name="Rounded Rectangle 6"/>
+          <p:cNvSpPr/>
+          <p:nvPr/>
+        </p:nvSpPr>
+        <p:spPr>
+          <a:xfrm>
+            <a:off x="6537960" y="1783080"/>
+            <a:ext cx="4785055" cy="4480560"/>
+          </a:xfrm>
+          <a:prstGeom prst="roundRect">
+            <a:avLst/>
+          </a:prstGeom>
+          <a:solidFill>
+            <a:srgbClr val="EEF2FF"/>
+          </a:solidFill>
+          <a:ln w="12700">
+            <a:solidFill>
+              <a:srgbClr val="E2E8F0"/>
+            </a:solidFill>
+          </a:ln>
+        </p:spPr>
+        <p:style>
+          <a:lnRef idx="1">
+            <a:schemeClr val="accent1"/>
+          </a:lnRef>
+          <a:fillRef idx="3">
+            <a:schemeClr val="accent1"/>
+          </a:fillRef>
+          <a:effectRef idx="2">
+            <a:schemeClr val="accent1"/>
+          </a:effectRef>
+          <a:fontRef idx="minor">
+            <a:schemeClr val="lt1"/>
+          </a:fontRef>
+        </p:style>
+        <p:txBody>
+          <a:bodyPr rtlCol="0" anchor="ctr" wrap="square"/>
+          <a:lstStyle/>
+          <a:p>
+            <a:pPr algn="ctr">
+              <a:defRPr sz="1300" b="1">
+                <a:solidFill>
+                  <a:srgbClr val="4F46E5"/>
+                </a:solidFill>
+              </a:defRPr>
+            </a:pPr>
+            <a:br/>
+            <a:br/>
+            <a:br/>
+            <a:br/>
+            <a:r>
+              <a:t>📸 [INSERT SCREENSHOT HERE: Edit Participants Modal]</a:t>
+            </a:r>
+          </a:p>
+        </p:txBody>
+      </p:sp>
     </p:spTree>
   </p:cSld>
   <p:clrMapOvr>
@@ -4284,30 +4476,109 @@
           </a:p>
         </p:txBody>
       </p:sp>
-      <p:pic>
-        <p:nvPicPr>
-          <p:cNvPr id="6" name="Picture 5" descr="SLIDE_12_MANAGER_QUEUE.png"/>
-          <p:cNvPicPr>
-            <a:picLocks noChangeAspect="1"/>
-          </p:cNvPicPr>
-          <p:nvPr/>
-        </p:nvPicPr>
-        <p:blipFill>
-          <a:blip r:embed="rId2"/>
-          <a:stretch>
-            <a:fillRect/>
-          </a:stretch>
-        </p:blipFill>
-        <p:spPr>
-          <a:xfrm>
-            <a:off x="6492240" y="1645920"/>
-            <a:ext cx="4937760" cy="2597359"/>
-          </a:xfrm>
-          <a:prstGeom prst="rect">
-            <a:avLst/>
-          </a:prstGeom>
-        </p:spPr>
-      </p:pic>
+      <p:sp>
+        <p:nvSpPr>
+          <p:cNvPr id="6" name="Rounded Rectangle 5"/>
+          <p:cNvSpPr/>
+          <p:nvPr/>
+        </p:nvSpPr>
+        <p:spPr>
+          <a:xfrm>
+            <a:off x="6400800" y="1645920"/>
+            <a:ext cx="5059375" cy="4754880"/>
+          </a:xfrm>
+          <a:prstGeom prst="roundRect">
+            <a:avLst/>
+          </a:prstGeom>
+          <a:solidFill>
+            <a:srgbClr val="FFFFFF"/>
+          </a:solidFill>
+          <a:ln w="25400">
+            <a:solidFill>
+              <a:srgbClr val="4F46E5"/>
+            </a:solidFill>
+          </a:ln>
+        </p:spPr>
+        <p:style>
+          <a:lnRef idx="1">
+            <a:schemeClr val="accent1"/>
+          </a:lnRef>
+          <a:fillRef idx="3">
+            <a:schemeClr val="accent1"/>
+          </a:fillRef>
+          <a:effectRef idx="2">
+            <a:schemeClr val="accent1"/>
+          </a:effectRef>
+          <a:fontRef idx="minor">
+            <a:schemeClr val="lt1"/>
+          </a:fontRef>
+        </p:style>
+        <p:txBody>
+          <a:bodyPr rtlCol="0" anchor="ctr"/>
+          <a:lstStyle/>
+          <a:p>
+            <a:pPr algn="ctr"/>
+          </a:p>
+        </p:txBody>
+      </p:sp>
+      <p:sp>
+        <p:nvSpPr>
+          <p:cNvPr id="7" name="Rounded Rectangle 6"/>
+          <p:cNvSpPr/>
+          <p:nvPr/>
+        </p:nvSpPr>
+        <p:spPr>
+          <a:xfrm>
+            <a:off x="6537960" y="1783080"/>
+            <a:ext cx="4785055" cy="4480560"/>
+          </a:xfrm>
+          <a:prstGeom prst="roundRect">
+            <a:avLst/>
+          </a:prstGeom>
+          <a:solidFill>
+            <a:srgbClr val="EEF2FF"/>
+          </a:solidFill>
+          <a:ln w="12700">
+            <a:solidFill>
+              <a:srgbClr val="E2E8F0"/>
+            </a:solidFill>
+          </a:ln>
+        </p:spPr>
+        <p:style>
+          <a:lnRef idx="1">
+            <a:schemeClr val="accent1"/>
+          </a:lnRef>
+          <a:fillRef idx="3">
+            <a:schemeClr val="accent1"/>
+          </a:fillRef>
+          <a:effectRef idx="2">
+            <a:schemeClr val="accent1"/>
+          </a:effectRef>
+          <a:fontRef idx="minor">
+            <a:schemeClr val="lt1"/>
+          </a:fontRef>
+        </p:style>
+        <p:txBody>
+          <a:bodyPr rtlCol="0" anchor="ctr" wrap="square"/>
+          <a:lstStyle/>
+          <a:p>
+            <a:pPr algn="ctr">
+              <a:defRPr sz="1300" b="1">
+                <a:solidFill>
+                  <a:srgbClr val="4F46E5"/>
+                </a:solidFill>
+              </a:defRPr>
+            </a:pPr>
+            <a:br/>
+            <a:br/>
+            <a:br/>
+            <a:br/>
+            <a:r>
+              <a:t>📸 [INSERT SCREENSHOT HERE: Manager Dashboard Approval Queue]</a:t>
+            </a:r>
+          </a:p>
+        </p:txBody>
+      </p:sp>
     </p:spTree>
   </p:cSld>
   <p:clrMapOvr>
@@ -4587,30 +4858,109 @@
           </a:p>
         </p:txBody>
       </p:sp>
-      <p:pic>
-        <p:nvPicPr>
-          <p:cNvPr id="6" name="Picture 5" descr="SLIDE_13_ROOM_HISTORY.png"/>
-          <p:cNvPicPr>
-            <a:picLocks noChangeAspect="1"/>
-          </p:cNvPicPr>
-          <p:nvPr/>
-        </p:nvPicPr>
-        <p:blipFill>
-          <a:blip r:embed="rId2"/>
-          <a:stretch>
-            <a:fillRect/>
-          </a:stretch>
-        </p:blipFill>
-        <p:spPr>
-          <a:xfrm>
-            <a:off x="6492240" y="1645920"/>
-            <a:ext cx="4937760" cy="3291840"/>
-          </a:xfrm>
-          <a:prstGeom prst="rect">
-            <a:avLst/>
-          </a:prstGeom>
-        </p:spPr>
-      </p:pic>
+      <p:sp>
+        <p:nvSpPr>
+          <p:cNvPr id="6" name="Rounded Rectangle 5"/>
+          <p:cNvSpPr/>
+          <p:nvPr/>
+        </p:nvSpPr>
+        <p:spPr>
+          <a:xfrm>
+            <a:off x="6400800" y="1645920"/>
+            <a:ext cx="5059375" cy="4754880"/>
+          </a:xfrm>
+          <a:prstGeom prst="roundRect">
+            <a:avLst/>
+          </a:prstGeom>
+          <a:solidFill>
+            <a:srgbClr val="FFFFFF"/>
+          </a:solidFill>
+          <a:ln w="25400">
+            <a:solidFill>
+              <a:srgbClr val="4F46E5"/>
+            </a:solidFill>
+          </a:ln>
+        </p:spPr>
+        <p:style>
+          <a:lnRef idx="1">
+            <a:schemeClr val="accent1"/>
+          </a:lnRef>
+          <a:fillRef idx="3">
+            <a:schemeClr val="accent1"/>
+          </a:fillRef>
+          <a:effectRef idx="2">
+            <a:schemeClr val="accent1"/>
+          </a:effectRef>
+          <a:fontRef idx="minor">
+            <a:schemeClr val="lt1"/>
+          </a:fontRef>
+        </p:style>
+        <p:txBody>
+          <a:bodyPr rtlCol="0" anchor="ctr"/>
+          <a:lstStyle/>
+          <a:p>
+            <a:pPr algn="ctr"/>
+          </a:p>
+        </p:txBody>
+      </p:sp>
+      <p:sp>
+        <p:nvSpPr>
+          <p:cNvPr id="7" name="Rounded Rectangle 6"/>
+          <p:cNvSpPr/>
+          <p:nvPr/>
+        </p:nvSpPr>
+        <p:spPr>
+          <a:xfrm>
+            <a:off x="6537960" y="1783080"/>
+            <a:ext cx="4785055" cy="4480560"/>
+          </a:xfrm>
+          <a:prstGeom prst="roundRect">
+            <a:avLst/>
+          </a:prstGeom>
+          <a:solidFill>
+            <a:srgbClr val="EEF2FF"/>
+          </a:solidFill>
+          <a:ln w="12700">
+            <a:solidFill>
+              <a:srgbClr val="E2E8F0"/>
+            </a:solidFill>
+          </a:ln>
+        </p:spPr>
+        <p:style>
+          <a:lnRef idx="1">
+            <a:schemeClr val="accent1"/>
+          </a:lnRef>
+          <a:fillRef idx="3">
+            <a:schemeClr val="accent1"/>
+          </a:fillRef>
+          <a:effectRef idx="2">
+            <a:schemeClr val="accent1"/>
+          </a:effectRef>
+          <a:fontRef idx="minor">
+            <a:schemeClr val="lt1"/>
+          </a:fontRef>
+        </p:style>
+        <p:txBody>
+          <a:bodyPr rtlCol="0" anchor="ctr" wrap="square"/>
+          <a:lstStyle/>
+          <a:p>
+            <a:pPr algn="ctr">
+              <a:defRPr sz="1300" b="1">
+                <a:solidFill>
+                  <a:srgbClr val="4F46E5"/>
+                </a:solidFill>
+              </a:defRPr>
+            </a:pPr>
+            <a:br/>
+            <a:br/>
+            <a:br/>
+            <a:br/>
+            <a:r>
+              <a:t>📸 [INSERT SCREENSHOT HERE: Room History Audit Log Modal]</a:t>
+            </a:r>
+          </a:p>
+        </p:txBody>
+      </p:sp>
     </p:spTree>
   </p:cSld>
   <p:clrMapOvr>
@@ -4890,30 +5240,109 @@
           </a:p>
         </p:txBody>
       </p:sp>
-      <p:pic>
-        <p:nvPicPr>
-          <p:cNvPr id="6" name="Picture 5" descr="SLIDE_12_MANAGER_QUEUE.png"/>
-          <p:cNvPicPr>
-            <a:picLocks noChangeAspect="1"/>
-          </p:cNvPicPr>
-          <p:nvPr/>
-        </p:nvPicPr>
-        <p:blipFill>
-          <a:blip r:embed="rId2"/>
-          <a:stretch>
-            <a:fillRect/>
-          </a:stretch>
-        </p:blipFill>
-        <p:spPr>
-          <a:xfrm>
-            <a:off x="6492240" y="1645920"/>
-            <a:ext cx="4937760" cy="2597359"/>
-          </a:xfrm>
-          <a:prstGeom prst="rect">
-            <a:avLst/>
-          </a:prstGeom>
-        </p:spPr>
-      </p:pic>
+      <p:sp>
+        <p:nvSpPr>
+          <p:cNvPr id="6" name="Rounded Rectangle 5"/>
+          <p:cNvSpPr/>
+          <p:nvPr/>
+        </p:nvSpPr>
+        <p:spPr>
+          <a:xfrm>
+            <a:off x="6400800" y="1645920"/>
+            <a:ext cx="5059375" cy="4754880"/>
+          </a:xfrm>
+          <a:prstGeom prst="roundRect">
+            <a:avLst/>
+          </a:prstGeom>
+          <a:solidFill>
+            <a:srgbClr val="FFFFFF"/>
+          </a:solidFill>
+          <a:ln w="25400">
+            <a:solidFill>
+              <a:srgbClr val="4F46E5"/>
+            </a:solidFill>
+          </a:ln>
+        </p:spPr>
+        <p:style>
+          <a:lnRef idx="1">
+            <a:schemeClr val="accent1"/>
+          </a:lnRef>
+          <a:fillRef idx="3">
+            <a:schemeClr val="accent1"/>
+          </a:fillRef>
+          <a:effectRef idx="2">
+            <a:schemeClr val="accent1"/>
+          </a:effectRef>
+          <a:fontRef idx="minor">
+            <a:schemeClr val="lt1"/>
+          </a:fontRef>
+        </p:style>
+        <p:txBody>
+          <a:bodyPr rtlCol="0" anchor="ctr"/>
+          <a:lstStyle/>
+          <a:p>
+            <a:pPr algn="ctr"/>
+          </a:p>
+        </p:txBody>
+      </p:sp>
+      <p:sp>
+        <p:nvSpPr>
+          <p:cNvPr id="7" name="Rounded Rectangle 6"/>
+          <p:cNvSpPr/>
+          <p:nvPr/>
+        </p:nvSpPr>
+        <p:spPr>
+          <a:xfrm>
+            <a:off x="6537960" y="1783080"/>
+            <a:ext cx="4785055" cy="4480560"/>
+          </a:xfrm>
+          <a:prstGeom prst="roundRect">
+            <a:avLst/>
+          </a:prstGeom>
+          <a:solidFill>
+            <a:srgbClr val="EEF2FF"/>
+          </a:solidFill>
+          <a:ln w="12700">
+            <a:solidFill>
+              <a:srgbClr val="E2E8F0"/>
+            </a:solidFill>
+          </a:ln>
+        </p:spPr>
+        <p:style>
+          <a:lnRef idx="1">
+            <a:schemeClr val="accent1"/>
+          </a:lnRef>
+          <a:fillRef idx="3">
+            <a:schemeClr val="accent1"/>
+          </a:fillRef>
+          <a:effectRef idx="2">
+            <a:schemeClr val="accent1"/>
+          </a:effectRef>
+          <a:fontRef idx="minor">
+            <a:schemeClr val="lt1"/>
+          </a:fontRef>
+        </p:style>
+        <p:txBody>
+          <a:bodyPr rtlCol="0" anchor="ctr" wrap="square"/>
+          <a:lstStyle/>
+          <a:p>
+            <a:pPr algn="ctr">
+              <a:defRPr sz="1300" b="1">
+                <a:solidFill>
+                  <a:srgbClr val="4F46E5"/>
+                </a:solidFill>
+              </a:defRPr>
+            </a:pPr>
+            <a:br/>
+            <a:br/>
+            <a:br/>
+            <a:br/>
+            <a:r>
+              <a:t>📸 [INSERT SCREENSHOT HERE: Room Supplies Status Cards Grid]</a:t>
+            </a:r>
+          </a:p>
+        </p:txBody>
+      </p:sp>
     </p:spTree>
   </p:cSld>
   <p:clrMapOvr>
@@ -5193,30 +5622,109 @@
           </a:p>
         </p:txBody>
       </p:sp>
-      <p:pic>
-        <p:nvPicPr>
-          <p:cNvPr id="6" name="Picture 5" descr="SLIDE_15_GMAIL_CALENDAR.png"/>
-          <p:cNvPicPr>
-            <a:picLocks noChangeAspect="1"/>
-          </p:cNvPicPr>
-          <p:nvPr/>
-        </p:nvPicPr>
-        <p:blipFill>
-          <a:blip r:embed="rId2"/>
-          <a:stretch>
-            <a:fillRect/>
-          </a:stretch>
-        </p:blipFill>
-        <p:spPr>
-          <a:xfrm>
-            <a:off x="6492240" y="1645920"/>
-            <a:ext cx="4937760" cy="2597359"/>
-          </a:xfrm>
-          <a:prstGeom prst="rect">
-            <a:avLst/>
-          </a:prstGeom>
-        </p:spPr>
-      </p:pic>
+      <p:sp>
+        <p:nvSpPr>
+          <p:cNvPr id="6" name="Rounded Rectangle 5"/>
+          <p:cNvSpPr/>
+          <p:nvPr/>
+        </p:nvSpPr>
+        <p:spPr>
+          <a:xfrm>
+            <a:off x="6400800" y="1645920"/>
+            <a:ext cx="5059375" cy="4754880"/>
+          </a:xfrm>
+          <a:prstGeom prst="roundRect">
+            <a:avLst/>
+          </a:prstGeom>
+          <a:solidFill>
+            <a:srgbClr val="FFFFFF"/>
+          </a:solidFill>
+          <a:ln w="25400">
+            <a:solidFill>
+              <a:srgbClr val="4F46E5"/>
+            </a:solidFill>
+          </a:ln>
+        </p:spPr>
+        <p:style>
+          <a:lnRef idx="1">
+            <a:schemeClr val="accent1"/>
+          </a:lnRef>
+          <a:fillRef idx="3">
+            <a:schemeClr val="accent1"/>
+          </a:fillRef>
+          <a:effectRef idx="2">
+            <a:schemeClr val="accent1"/>
+          </a:effectRef>
+          <a:fontRef idx="minor">
+            <a:schemeClr val="lt1"/>
+          </a:fontRef>
+        </p:style>
+        <p:txBody>
+          <a:bodyPr rtlCol="0" anchor="ctr"/>
+          <a:lstStyle/>
+          <a:p>
+            <a:pPr algn="ctr"/>
+          </a:p>
+        </p:txBody>
+      </p:sp>
+      <p:sp>
+        <p:nvSpPr>
+          <p:cNvPr id="7" name="Rounded Rectangle 6"/>
+          <p:cNvSpPr/>
+          <p:nvPr/>
+        </p:nvSpPr>
+        <p:spPr>
+          <a:xfrm>
+            <a:off x="6537960" y="1783080"/>
+            <a:ext cx="4785055" cy="4480560"/>
+          </a:xfrm>
+          <a:prstGeom prst="roundRect">
+            <a:avLst/>
+          </a:prstGeom>
+          <a:solidFill>
+            <a:srgbClr val="EEF2FF"/>
+          </a:solidFill>
+          <a:ln w="12700">
+            <a:solidFill>
+              <a:srgbClr val="E2E8F0"/>
+            </a:solidFill>
+          </a:ln>
+        </p:spPr>
+        <p:style>
+          <a:lnRef idx="1">
+            <a:schemeClr val="accent1"/>
+          </a:lnRef>
+          <a:fillRef idx="3">
+            <a:schemeClr val="accent1"/>
+          </a:fillRef>
+          <a:effectRef idx="2">
+            <a:schemeClr val="accent1"/>
+          </a:effectRef>
+          <a:fontRef idx="minor">
+            <a:schemeClr val="lt1"/>
+          </a:fontRef>
+        </p:style>
+        <p:txBody>
+          <a:bodyPr rtlCol="0" anchor="ctr" wrap="square"/>
+          <a:lstStyle/>
+          <a:p>
+            <a:pPr algn="ctr">
+              <a:defRPr sz="1300" b="1">
+                <a:solidFill>
+                  <a:srgbClr val="4F46E5"/>
+                </a:solidFill>
+              </a:defRPr>
+            </a:pPr>
+            <a:br/>
+            <a:br/>
+            <a:br/>
+            <a:br/>
+            <a:r>
+              <a:t>📸 [INSERT SCREENSHOT HERE: Gmail Confirmation Email in Inbox]</a:t>
+            </a:r>
+          </a:p>
+        </p:txBody>
+      </p:sp>
     </p:spTree>
   </p:cSld>
   <p:clrMapOvr>
@@ -5511,30 +6019,109 @@
           </a:p>
         </p:txBody>
       </p:sp>
-      <p:pic>
-        <p:nvPicPr>
-          <p:cNvPr id="6" name="Picture 5" descr="SLIDE_15_GMAIL_CALENDAR.png"/>
-          <p:cNvPicPr>
-            <a:picLocks noChangeAspect="1"/>
-          </p:cNvPicPr>
-          <p:nvPr/>
-        </p:nvPicPr>
-        <p:blipFill>
-          <a:blip r:embed="rId2"/>
-          <a:stretch>
-            <a:fillRect/>
-          </a:stretch>
-        </p:blipFill>
-        <p:spPr>
-          <a:xfrm>
-            <a:off x="6492240" y="1645920"/>
-            <a:ext cx="4937760" cy="2597359"/>
-          </a:xfrm>
-          <a:prstGeom prst="rect">
-            <a:avLst/>
-          </a:prstGeom>
-        </p:spPr>
-      </p:pic>
+      <p:sp>
+        <p:nvSpPr>
+          <p:cNvPr id="6" name="Rounded Rectangle 5"/>
+          <p:cNvSpPr/>
+          <p:nvPr/>
+        </p:nvSpPr>
+        <p:spPr>
+          <a:xfrm>
+            <a:off x="6400800" y="1645920"/>
+            <a:ext cx="5059375" cy="4754880"/>
+          </a:xfrm>
+          <a:prstGeom prst="roundRect">
+            <a:avLst/>
+          </a:prstGeom>
+          <a:solidFill>
+            <a:srgbClr val="FFFFFF"/>
+          </a:solidFill>
+          <a:ln w="25400">
+            <a:solidFill>
+              <a:srgbClr val="4F46E5"/>
+            </a:solidFill>
+          </a:ln>
+        </p:spPr>
+        <p:style>
+          <a:lnRef idx="1">
+            <a:schemeClr val="accent1"/>
+          </a:lnRef>
+          <a:fillRef idx="3">
+            <a:schemeClr val="accent1"/>
+          </a:fillRef>
+          <a:effectRef idx="2">
+            <a:schemeClr val="accent1"/>
+          </a:effectRef>
+          <a:fontRef idx="minor">
+            <a:schemeClr val="lt1"/>
+          </a:fontRef>
+        </p:style>
+        <p:txBody>
+          <a:bodyPr rtlCol="0" anchor="ctr"/>
+          <a:lstStyle/>
+          <a:p>
+            <a:pPr algn="ctr"/>
+          </a:p>
+        </p:txBody>
+      </p:sp>
+      <p:sp>
+        <p:nvSpPr>
+          <p:cNvPr id="7" name="Rounded Rectangle 6"/>
+          <p:cNvSpPr/>
+          <p:nvPr/>
+        </p:nvSpPr>
+        <p:spPr>
+          <a:xfrm>
+            <a:off x="6537960" y="1783080"/>
+            <a:ext cx="4785055" cy="4480560"/>
+          </a:xfrm>
+          <a:prstGeom prst="roundRect">
+            <a:avLst/>
+          </a:prstGeom>
+          <a:solidFill>
+            <a:srgbClr val="EEF2FF"/>
+          </a:solidFill>
+          <a:ln w="12700">
+            <a:solidFill>
+              <a:srgbClr val="E2E8F0"/>
+            </a:solidFill>
+          </a:ln>
+        </p:spPr>
+        <p:style>
+          <a:lnRef idx="1">
+            <a:schemeClr val="accent1"/>
+          </a:lnRef>
+          <a:fillRef idx="3">
+            <a:schemeClr val="accent1"/>
+          </a:fillRef>
+          <a:effectRef idx="2">
+            <a:schemeClr val="accent1"/>
+          </a:effectRef>
+          <a:fontRef idx="minor">
+            <a:schemeClr val="lt1"/>
+          </a:fontRef>
+        </p:style>
+        <p:txBody>
+          <a:bodyPr rtlCol="0" anchor="ctr" wrap="square"/>
+          <a:lstStyle/>
+          <a:p>
+            <a:pPr algn="ctr">
+              <a:defRPr sz="1300" b="1">
+                <a:solidFill>
+                  <a:srgbClr val="4F46E5"/>
+                </a:solidFill>
+              </a:defRPr>
+            </a:pPr>
+            <a:br/>
+            <a:br/>
+            <a:br/>
+            <a:br/>
+            <a:r>
+              <a:t>📸 [INSERT SCREENSHOT HERE: User Roles Matrix Table]</a:t>
+            </a:r>
+          </a:p>
+        </p:txBody>
+      </p:sp>
     </p:spTree>
   </p:cSld>
   <p:clrMapOvr>
@@ -5829,30 +6416,109 @@
           </a:p>
         </p:txBody>
       </p:sp>
-      <p:pic>
-        <p:nvPicPr>
-          <p:cNvPr id="6" name="Picture 5" descr="SLIDE_15_GMAIL_CALENDAR.png"/>
-          <p:cNvPicPr>
-            <a:picLocks noChangeAspect="1"/>
-          </p:cNvPicPr>
-          <p:nvPr/>
-        </p:nvPicPr>
-        <p:blipFill>
-          <a:blip r:embed="rId2"/>
-          <a:stretch>
-            <a:fillRect/>
-          </a:stretch>
-        </p:blipFill>
-        <p:spPr>
-          <a:xfrm>
-            <a:off x="6492240" y="1645920"/>
-            <a:ext cx="4937760" cy="2597359"/>
-          </a:xfrm>
-          <a:prstGeom prst="rect">
-            <a:avLst/>
-          </a:prstGeom>
-        </p:spPr>
-      </p:pic>
+      <p:sp>
+        <p:nvSpPr>
+          <p:cNvPr id="6" name="Rounded Rectangle 5"/>
+          <p:cNvSpPr/>
+          <p:nvPr/>
+        </p:nvSpPr>
+        <p:spPr>
+          <a:xfrm>
+            <a:off x="6400800" y="1645920"/>
+            <a:ext cx="5059375" cy="4754880"/>
+          </a:xfrm>
+          <a:prstGeom prst="roundRect">
+            <a:avLst/>
+          </a:prstGeom>
+          <a:solidFill>
+            <a:srgbClr val="FFFFFF"/>
+          </a:solidFill>
+          <a:ln w="25400">
+            <a:solidFill>
+              <a:srgbClr val="4F46E5"/>
+            </a:solidFill>
+          </a:ln>
+        </p:spPr>
+        <p:style>
+          <a:lnRef idx="1">
+            <a:schemeClr val="accent1"/>
+          </a:lnRef>
+          <a:fillRef idx="3">
+            <a:schemeClr val="accent1"/>
+          </a:fillRef>
+          <a:effectRef idx="2">
+            <a:schemeClr val="accent1"/>
+          </a:effectRef>
+          <a:fontRef idx="minor">
+            <a:schemeClr val="lt1"/>
+          </a:fontRef>
+        </p:style>
+        <p:txBody>
+          <a:bodyPr rtlCol="0" anchor="ctr"/>
+          <a:lstStyle/>
+          <a:p>
+            <a:pPr algn="ctr"/>
+          </a:p>
+        </p:txBody>
+      </p:sp>
+      <p:sp>
+        <p:nvSpPr>
+          <p:cNvPr id="7" name="Rounded Rectangle 6"/>
+          <p:cNvSpPr/>
+          <p:nvPr/>
+        </p:nvSpPr>
+        <p:spPr>
+          <a:xfrm>
+            <a:off x="6537960" y="1783080"/>
+            <a:ext cx="4785055" cy="4480560"/>
+          </a:xfrm>
+          <a:prstGeom prst="roundRect">
+            <a:avLst/>
+          </a:prstGeom>
+          <a:solidFill>
+            <a:srgbClr val="EEF2FF"/>
+          </a:solidFill>
+          <a:ln w="12700">
+            <a:solidFill>
+              <a:srgbClr val="E2E8F0"/>
+            </a:solidFill>
+          </a:ln>
+        </p:spPr>
+        <p:style>
+          <a:lnRef idx="1">
+            <a:schemeClr val="accent1"/>
+          </a:lnRef>
+          <a:fillRef idx="3">
+            <a:schemeClr val="accent1"/>
+          </a:fillRef>
+          <a:effectRef idx="2">
+            <a:schemeClr val="accent1"/>
+          </a:effectRef>
+          <a:fontRef idx="minor">
+            <a:schemeClr val="lt1"/>
+          </a:fontRef>
+        </p:style>
+        <p:txBody>
+          <a:bodyPr rtlCol="0" anchor="ctr" wrap="square"/>
+          <a:lstStyle/>
+          <a:p>
+            <a:pPr algn="ctr">
+              <a:defRPr sz="1300" b="1">
+                <a:solidFill>
+                  <a:srgbClr val="4F46E5"/>
+                </a:solidFill>
+              </a:defRPr>
+            </a:pPr>
+            <a:br/>
+            <a:br/>
+            <a:br/>
+            <a:br/>
+            <a:r>
+              <a:t>📸 [INSERT SCREENSHOT HERE: Multi-Window Demo Overview]</a:t>
+            </a:r>
+          </a:p>
+        </p:txBody>
+      </p:sp>
     </p:spTree>
   </p:cSld>
   <p:clrMapOvr>
@@ -6156,30 +6822,64 @@
           </a:p>
         </p:txBody>
       </p:sp>
-      <p:pic>
-        <p:nvPicPr>
-          <p:cNvPr id="6" name="Picture 5" descr="SLIDE_5_LOGIN_PORTAL.png"/>
-          <p:cNvPicPr>
-            <a:picLocks noChangeAspect="1"/>
-          </p:cNvPicPr>
-          <p:nvPr/>
-        </p:nvPicPr>
-        <p:blipFill>
-          <a:blip r:embed="rId2"/>
-          <a:stretch>
-            <a:fillRect/>
-          </a:stretch>
-        </p:blipFill>
+      <p:sp>
+        <p:nvSpPr>
+          <p:cNvPr id="6" name="Rounded Rectangle 5"/>
+          <p:cNvSpPr/>
+          <p:nvPr/>
+        </p:nvSpPr>
         <p:spPr>
           <a:xfrm>
             <a:off x="6492240" y="1325880"/>
-            <a:ext cx="4937760" cy="2597359"/>
-          </a:xfrm>
-          <a:prstGeom prst="rect">
-            <a:avLst/>
-          </a:prstGeom>
-        </p:spPr>
-      </p:pic>
+            <a:ext cx="4937760" cy="4983480"/>
+          </a:xfrm>
+          <a:prstGeom prst="roundRect">
+            <a:avLst/>
+          </a:prstGeom>
+          <a:solidFill>
+            <a:srgbClr val="EEF2FF"/>
+          </a:solidFill>
+          <a:ln w="25400">
+            <a:solidFill>
+              <a:srgbClr val="4F46E5"/>
+            </a:solidFill>
+          </a:ln>
+        </p:spPr>
+        <p:style>
+          <a:lnRef idx="1">
+            <a:schemeClr val="accent1"/>
+          </a:lnRef>
+          <a:fillRef idx="3">
+            <a:schemeClr val="accent1"/>
+          </a:fillRef>
+          <a:effectRef idx="2">
+            <a:schemeClr val="accent1"/>
+          </a:effectRef>
+          <a:fontRef idx="minor">
+            <a:schemeClr val="lt1"/>
+          </a:fontRef>
+        </p:style>
+        <p:txBody>
+          <a:bodyPr rtlCol="0" anchor="ctr" wrap="square"/>
+          <a:lstStyle/>
+          <a:p>
+            <a:pPr algn="ctr">
+              <a:defRPr sz="1300" b="1">
+                <a:solidFill>
+                  <a:srgbClr val="4F46E5"/>
+                </a:solidFill>
+              </a:defRPr>
+            </a:pPr>
+            <a:br/>
+            <a:br/>
+            <a:br/>
+            <a:br/>
+            <a:r>
+              <a:t>📸 [INSERT SCREENSHOT HERE: Final Closing Slide / Login Portal]</a:t>
+            </a:r>
+          </a:p>
+        </p:txBody>
+      </p:sp>
     </p:spTree>
   </p:cSld>
   <p:clrMapOvr>
@@ -6474,30 +7174,109 @@
           </a:p>
         </p:txBody>
       </p:sp>
-      <p:pic>
-        <p:nvPicPr>
-          <p:cNvPr id="6" name="Picture 5" descr="SLIDE_2_EMPLOYEE_DASHBOARD.png"/>
-          <p:cNvPicPr>
-            <a:picLocks noChangeAspect="1"/>
-          </p:cNvPicPr>
-          <p:nvPr/>
-        </p:nvPicPr>
-        <p:blipFill>
-          <a:blip r:embed="rId2"/>
-          <a:stretch>
-            <a:fillRect/>
-          </a:stretch>
-        </p:blipFill>
-        <p:spPr>
-          <a:xfrm>
-            <a:off x="6492240" y="1645920"/>
-            <a:ext cx="4937760" cy="2597359"/>
-          </a:xfrm>
-          <a:prstGeom prst="rect">
-            <a:avLst/>
-          </a:prstGeom>
-        </p:spPr>
-      </p:pic>
+      <p:sp>
+        <p:nvSpPr>
+          <p:cNvPr id="6" name="Rounded Rectangle 5"/>
+          <p:cNvSpPr/>
+          <p:nvPr/>
+        </p:nvSpPr>
+        <p:spPr>
+          <a:xfrm>
+            <a:off x="6400800" y="1645920"/>
+            <a:ext cx="5059375" cy="4754880"/>
+          </a:xfrm>
+          <a:prstGeom prst="roundRect">
+            <a:avLst/>
+          </a:prstGeom>
+          <a:solidFill>
+            <a:srgbClr val="FFFFFF"/>
+          </a:solidFill>
+          <a:ln w="25400">
+            <a:solidFill>
+              <a:srgbClr val="4F46E5"/>
+            </a:solidFill>
+          </a:ln>
+        </p:spPr>
+        <p:style>
+          <a:lnRef idx="1">
+            <a:schemeClr val="accent1"/>
+          </a:lnRef>
+          <a:fillRef idx="3">
+            <a:schemeClr val="accent1"/>
+          </a:fillRef>
+          <a:effectRef idx="2">
+            <a:schemeClr val="accent1"/>
+          </a:effectRef>
+          <a:fontRef idx="minor">
+            <a:schemeClr val="lt1"/>
+          </a:fontRef>
+        </p:style>
+        <p:txBody>
+          <a:bodyPr rtlCol="0" anchor="ctr"/>
+          <a:lstStyle/>
+          <a:p>
+            <a:pPr algn="ctr"/>
+          </a:p>
+        </p:txBody>
+      </p:sp>
+      <p:sp>
+        <p:nvSpPr>
+          <p:cNvPr id="7" name="Rounded Rectangle 6"/>
+          <p:cNvSpPr/>
+          <p:nvPr/>
+        </p:nvSpPr>
+        <p:spPr>
+          <a:xfrm>
+            <a:off x="6537960" y="1783080"/>
+            <a:ext cx="4785055" cy="4480560"/>
+          </a:xfrm>
+          <a:prstGeom prst="roundRect">
+            <a:avLst/>
+          </a:prstGeom>
+          <a:solidFill>
+            <a:srgbClr val="EEF2FF"/>
+          </a:solidFill>
+          <a:ln w="12700">
+            <a:solidFill>
+              <a:srgbClr val="E2E8F0"/>
+            </a:solidFill>
+          </a:ln>
+        </p:spPr>
+        <p:style>
+          <a:lnRef idx="1">
+            <a:schemeClr val="accent1"/>
+          </a:lnRef>
+          <a:fillRef idx="3">
+            <a:schemeClr val="accent1"/>
+          </a:fillRef>
+          <a:effectRef idx="2">
+            <a:schemeClr val="accent1"/>
+          </a:effectRef>
+          <a:fontRef idx="minor">
+            <a:schemeClr val="lt1"/>
+          </a:fontRef>
+        </p:style>
+        <p:txBody>
+          <a:bodyPr rtlCol="0" anchor="ctr" wrap="square"/>
+          <a:lstStyle/>
+          <a:p>
+            <a:pPr algn="ctr">
+              <a:defRPr sz="1300" b="1">
+                <a:solidFill>
+                  <a:srgbClr val="4F46E5"/>
+                </a:solidFill>
+              </a:defRPr>
+            </a:pPr>
+            <a:br/>
+            <a:br/>
+            <a:br/>
+            <a:br/>
+            <a:r>
+              <a:t>📸 [INSERT SCREENSHOT HERE: Employee Dashboard &amp; Active Reservations]</a:t>
+            </a:r>
+          </a:p>
+        </p:txBody>
+      </p:sp>
     </p:spTree>
   </p:cSld>
   <p:clrMapOvr>
@@ -6777,30 +7556,109 @@
           </a:p>
         </p:txBody>
       </p:sp>
-      <p:pic>
-        <p:nvPicPr>
-          <p:cNvPr id="6" name="Picture 5" descr="SYSTEM_ARCHITECTURE_DIAGRAM.png"/>
-          <p:cNvPicPr>
-            <a:picLocks noChangeAspect="1"/>
-          </p:cNvPicPr>
-          <p:nvPr/>
-        </p:nvPicPr>
-        <p:blipFill>
-          <a:blip r:embed="rId2"/>
-          <a:stretch>
-            <a:fillRect/>
-          </a:stretch>
-        </p:blipFill>
-        <p:spPr>
-          <a:xfrm>
-            <a:off x="6492240" y="1645920"/>
-            <a:ext cx="4937760" cy="3291840"/>
-          </a:xfrm>
-          <a:prstGeom prst="rect">
-            <a:avLst/>
-          </a:prstGeom>
-        </p:spPr>
-      </p:pic>
+      <p:sp>
+        <p:nvSpPr>
+          <p:cNvPr id="6" name="Rounded Rectangle 5"/>
+          <p:cNvSpPr/>
+          <p:nvPr/>
+        </p:nvSpPr>
+        <p:spPr>
+          <a:xfrm>
+            <a:off x="6400800" y="1645920"/>
+            <a:ext cx="5059375" cy="4754880"/>
+          </a:xfrm>
+          <a:prstGeom prst="roundRect">
+            <a:avLst/>
+          </a:prstGeom>
+          <a:solidFill>
+            <a:srgbClr val="FFFFFF"/>
+          </a:solidFill>
+          <a:ln w="25400">
+            <a:solidFill>
+              <a:srgbClr val="4F46E5"/>
+            </a:solidFill>
+          </a:ln>
+        </p:spPr>
+        <p:style>
+          <a:lnRef idx="1">
+            <a:schemeClr val="accent1"/>
+          </a:lnRef>
+          <a:fillRef idx="3">
+            <a:schemeClr val="accent1"/>
+          </a:fillRef>
+          <a:effectRef idx="2">
+            <a:schemeClr val="accent1"/>
+          </a:effectRef>
+          <a:fontRef idx="minor">
+            <a:schemeClr val="lt1"/>
+          </a:fontRef>
+        </p:style>
+        <p:txBody>
+          <a:bodyPr rtlCol="0" anchor="ctr"/>
+          <a:lstStyle/>
+          <a:p>
+            <a:pPr algn="ctr"/>
+          </a:p>
+        </p:txBody>
+      </p:sp>
+      <p:sp>
+        <p:nvSpPr>
+          <p:cNvPr id="7" name="Rounded Rectangle 6"/>
+          <p:cNvSpPr/>
+          <p:nvPr/>
+        </p:nvSpPr>
+        <p:spPr>
+          <a:xfrm>
+            <a:off x="6537960" y="1783080"/>
+            <a:ext cx="4785055" cy="4480560"/>
+          </a:xfrm>
+          <a:prstGeom prst="roundRect">
+            <a:avLst/>
+          </a:prstGeom>
+          <a:solidFill>
+            <a:srgbClr val="EEF2FF"/>
+          </a:solidFill>
+          <a:ln w="12700">
+            <a:solidFill>
+              <a:srgbClr val="E2E8F0"/>
+            </a:solidFill>
+          </a:ln>
+        </p:spPr>
+        <p:style>
+          <a:lnRef idx="1">
+            <a:schemeClr val="accent1"/>
+          </a:lnRef>
+          <a:fillRef idx="3">
+            <a:schemeClr val="accent1"/>
+          </a:fillRef>
+          <a:effectRef idx="2">
+            <a:schemeClr val="accent1"/>
+          </a:effectRef>
+          <a:fontRef idx="minor">
+            <a:schemeClr val="lt1"/>
+          </a:fontRef>
+        </p:style>
+        <p:txBody>
+          <a:bodyPr rtlCol="0" anchor="ctr" wrap="square"/>
+          <a:lstStyle/>
+          <a:p>
+            <a:pPr algn="ctr">
+              <a:defRPr sz="1300" b="1">
+                <a:solidFill>
+                  <a:srgbClr val="4F46E5"/>
+                </a:solidFill>
+              </a:defRPr>
+            </a:pPr>
+            <a:br/>
+            <a:br/>
+            <a:br/>
+            <a:br/>
+            <a:r>
+              <a:t>📸 [INSERT SCREENSHOT HERE: System Architecture &amp; Flow Diagram]</a:t>
+            </a:r>
+          </a:p>
+        </p:txBody>
+      </p:sp>
     </p:spTree>
   </p:cSld>
   <p:clrMapOvr>
@@ -7080,30 +7938,109 @@
           </a:p>
         </p:txBody>
       </p:sp>
-      <p:pic>
-        <p:nvPicPr>
-          <p:cNvPr id="6" name="Picture 5" descr="SLIDE_4_EER_DIAGRAM.png"/>
-          <p:cNvPicPr>
-            <a:picLocks noChangeAspect="1"/>
-          </p:cNvPicPr>
-          <p:nvPr/>
-        </p:nvPicPr>
-        <p:blipFill>
-          <a:blip r:embed="rId2"/>
-          <a:stretch>
-            <a:fillRect/>
-          </a:stretch>
-        </p:blipFill>
-        <p:spPr>
-          <a:xfrm>
-            <a:off x="6492240" y="1645920"/>
-            <a:ext cx="4937760" cy="3291840"/>
-          </a:xfrm>
-          <a:prstGeom prst="rect">
-            <a:avLst/>
-          </a:prstGeom>
-        </p:spPr>
-      </p:pic>
+      <p:sp>
+        <p:nvSpPr>
+          <p:cNvPr id="6" name="Rounded Rectangle 5"/>
+          <p:cNvSpPr/>
+          <p:nvPr/>
+        </p:nvSpPr>
+        <p:spPr>
+          <a:xfrm>
+            <a:off x="6400800" y="1645920"/>
+            <a:ext cx="5059375" cy="4754880"/>
+          </a:xfrm>
+          <a:prstGeom prst="roundRect">
+            <a:avLst/>
+          </a:prstGeom>
+          <a:solidFill>
+            <a:srgbClr val="FFFFFF"/>
+          </a:solidFill>
+          <a:ln w="25400">
+            <a:solidFill>
+              <a:srgbClr val="4F46E5"/>
+            </a:solidFill>
+          </a:ln>
+        </p:spPr>
+        <p:style>
+          <a:lnRef idx="1">
+            <a:schemeClr val="accent1"/>
+          </a:lnRef>
+          <a:fillRef idx="3">
+            <a:schemeClr val="accent1"/>
+          </a:fillRef>
+          <a:effectRef idx="2">
+            <a:schemeClr val="accent1"/>
+          </a:effectRef>
+          <a:fontRef idx="minor">
+            <a:schemeClr val="lt1"/>
+          </a:fontRef>
+        </p:style>
+        <p:txBody>
+          <a:bodyPr rtlCol="0" anchor="ctr"/>
+          <a:lstStyle/>
+          <a:p>
+            <a:pPr algn="ctr"/>
+          </a:p>
+        </p:txBody>
+      </p:sp>
+      <p:sp>
+        <p:nvSpPr>
+          <p:cNvPr id="7" name="Rounded Rectangle 6"/>
+          <p:cNvSpPr/>
+          <p:nvPr/>
+        </p:nvSpPr>
+        <p:spPr>
+          <a:xfrm>
+            <a:off x="6537960" y="1783080"/>
+            <a:ext cx="4785055" cy="4480560"/>
+          </a:xfrm>
+          <a:prstGeom prst="roundRect">
+            <a:avLst/>
+          </a:prstGeom>
+          <a:solidFill>
+            <a:srgbClr val="EEF2FF"/>
+          </a:solidFill>
+          <a:ln w="12700">
+            <a:solidFill>
+              <a:srgbClr val="E2E8F0"/>
+            </a:solidFill>
+          </a:ln>
+        </p:spPr>
+        <p:style>
+          <a:lnRef idx="1">
+            <a:schemeClr val="accent1"/>
+          </a:lnRef>
+          <a:fillRef idx="3">
+            <a:schemeClr val="accent1"/>
+          </a:fillRef>
+          <a:effectRef idx="2">
+            <a:schemeClr val="accent1"/>
+          </a:effectRef>
+          <a:fontRef idx="minor">
+            <a:schemeClr val="lt1"/>
+          </a:fontRef>
+        </p:style>
+        <p:txBody>
+          <a:bodyPr rtlCol="0" anchor="ctr" wrap="square"/>
+          <a:lstStyle/>
+          <a:p>
+            <a:pPr algn="ctr">
+              <a:defRPr sz="1300" b="1">
+                <a:solidFill>
+                  <a:srgbClr val="4F46E5"/>
+                </a:solidFill>
+              </a:defRPr>
+            </a:pPr>
+            <a:br/>
+            <a:br/>
+            <a:br/>
+            <a:br/>
+            <a:r>
+              <a:t>📸 [INSERT SCREENSHOT HERE: MySQL Workbench Ctrl + R EER Diagram]</a:t>
+            </a:r>
+          </a:p>
+        </p:txBody>
+      </p:sp>
     </p:spTree>
   </p:cSld>
   <p:clrMapOvr>
@@ -7383,30 +8320,109 @@
           </a:p>
         </p:txBody>
       </p:sp>
-      <p:pic>
-        <p:nvPicPr>
-          <p:cNvPr id="6" name="Picture 5" descr="SLIDE_5_LOGIN_PORTAL.png"/>
-          <p:cNvPicPr>
-            <a:picLocks noChangeAspect="1"/>
-          </p:cNvPicPr>
-          <p:nvPr/>
-        </p:nvPicPr>
-        <p:blipFill>
-          <a:blip r:embed="rId2"/>
-          <a:stretch>
-            <a:fillRect/>
-          </a:stretch>
-        </p:blipFill>
-        <p:spPr>
-          <a:xfrm>
-            <a:off x="6492240" y="1645920"/>
-            <a:ext cx="4937760" cy="2597359"/>
-          </a:xfrm>
-          <a:prstGeom prst="rect">
-            <a:avLst/>
-          </a:prstGeom>
-        </p:spPr>
-      </p:pic>
+      <p:sp>
+        <p:nvSpPr>
+          <p:cNvPr id="6" name="Rounded Rectangle 5"/>
+          <p:cNvSpPr/>
+          <p:nvPr/>
+        </p:nvSpPr>
+        <p:spPr>
+          <a:xfrm>
+            <a:off x="6400800" y="1645920"/>
+            <a:ext cx="5059375" cy="4754880"/>
+          </a:xfrm>
+          <a:prstGeom prst="roundRect">
+            <a:avLst/>
+          </a:prstGeom>
+          <a:solidFill>
+            <a:srgbClr val="FFFFFF"/>
+          </a:solidFill>
+          <a:ln w="25400">
+            <a:solidFill>
+              <a:srgbClr val="4F46E5"/>
+            </a:solidFill>
+          </a:ln>
+        </p:spPr>
+        <p:style>
+          <a:lnRef idx="1">
+            <a:schemeClr val="accent1"/>
+          </a:lnRef>
+          <a:fillRef idx="3">
+            <a:schemeClr val="accent1"/>
+          </a:fillRef>
+          <a:effectRef idx="2">
+            <a:schemeClr val="accent1"/>
+          </a:effectRef>
+          <a:fontRef idx="minor">
+            <a:schemeClr val="lt1"/>
+          </a:fontRef>
+        </p:style>
+        <p:txBody>
+          <a:bodyPr rtlCol="0" anchor="ctr"/>
+          <a:lstStyle/>
+          <a:p>
+            <a:pPr algn="ctr"/>
+          </a:p>
+        </p:txBody>
+      </p:sp>
+      <p:sp>
+        <p:nvSpPr>
+          <p:cNvPr id="7" name="Rounded Rectangle 6"/>
+          <p:cNvSpPr/>
+          <p:nvPr/>
+        </p:nvSpPr>
+        <p:spPr>
+          <a:xfrm>
+            <a:off x="6537960" y="1783080"/>
+            <a:ext cx="4785055" cy="4480560"/>
+          </a:xfrm>
+          <a:prstGeom prst="roundRect">
+            <a:avLst/>
+          </a:prstGeom>
+          <a:solidFill>
+            <a:srgbClr val="EEF2FF"/>
+          </a:solidFill>
+          <a:ln w="12700">
+            <a:solidFill>
+              <a:srgbClr val="E2E8F0"/>
+            </a:solidFill>
+          </a:ln>
+        </p:spPr>
+        <p:style>
+          <a:lnRef idx="1">
+            <a:schemeClr val="accent1"/>
+          </a:lnRef>
+          <a:fillRef idx="3">
+            <a:schemeClr val="accent1"/>
+          </a:fillRef>
+          <a:effectRef idx="2">
+            <a:schemeClr val="accent1"/>
+          </a:effectRef>
+          <a:fontRef idx="minor">
+            <a:schemeClr val="lt1"/>
+          </a:fontRef>
+        </p:style>
+        <p:txBody>
+          <a:bodyPr rtlCol="0" anchor="ctr" wrap="square"/>
+          <a:lstStyle/>
+          <a:p>
+            <a:pPr algn="ctr">
+              <a:defRPr sz="1300" b="1">
+                <a:solidFill>
+                  <a:srgbClr val="4F46E5"/>
+                </a:solidFill>
+              </a:defRPr>
+            </a:pPr>
+            <a:br/>
+            <a:br/>
+            <a:br/>
+            <a:br/>
+            <a:r>
+              <a:t>📸 [INSERT SCREENSHOT HERE: Login &amp; Sign Up Portal Page]</a:t>
+            </a:r>
+          </a:p>
+        </p:txBody>
+      </p:sp>
     </p:spTree>
   </p:cSld>
   <p:clrMapOvr>
@@ -7686,30 +8702,109 @@
           </a:p>
         </p:txBody>
       </p:sp>
-      <p:pic>
-        <p:nvPicPr>
-          <p:cNvPr id="6" name="Picture 5" descr="SLIDE_6_ROOM_EXPLORER.png"/>
-          <p:cNvPicPr>
-            <a:picLocks noChangeAspect="1"/>
-          </p:cNvPicPr>
-          <p:nvPr/>
-        </p:nvPicPr>
-        <p:blipFill>
-          <a:blip r:embed="rId2"/>
-          <a:stretch>
-            <a:fillRect/>
-          </a:stretch>
-        </p:blipFill>
-        <p:spPr>
-          <a:xfrm>
-            <a:off x="6492240" y="1645920"/>
-            <a:ext cx="4937760" cy="2597359"/>
-          </a:xfrm>
-          <a:prstGeom prst="rect">
-            <a:avLst/>
-          </a:prstGeom>
-        </p:spPr>
-      </p:pic>
+      <p:sp>
+        <p:nvSpPr>
+          <p:cNvPr id="6" name="Rounded Rectangle 5"/>
+          <p:cNvSpPr/>
+          <p:nvPr/>
+        </p:nvSpPr>
+        <p:spPr>
+          <a:xfrm>
+            <a:off x="6400800" y="1645920"/>
+            <a:ext cx="5059375" cy="4754880"/>
+          </a:xfrm>
+          <a:prstGeom prst="roundRect">
+            <a:avLst/>
+          </a:prstGeom>
+          <a:solidFill>
+            <a:srgbClr val="FFFFFF"/>
+          </a:solidFill>
+          <a:ln w="25400">
+            <a:solidFill>
+              <a:srgbClr val="4F46E5"/>
+            </a:solidFill>
+          </a:ln>
+        </p:spPr>
+        <p:style>
+          <a:lnRef idx="1">
+            <a:schemeClr val="accent1"/>
+          </a:lnRef>
+          <a:fillRef idx="3">
+            <a:schemeClr val="accent1"/>
+          </a:fillRef>
+          <a:effectRef idx="2">
+            <a:schemeClr val="accent1"/>
+          </a:effectRef>
+          <a:fontRef idx="minor">
+            <a:schemeClr val="lt1"/>
+          </a:fontRef>
+        </p:style>
+        <p:txBody>
+          <a:bodyPr rtlCol="0" anchor="ctr"/>
+          <a:lstStyle/>
+          <a:p>
+            <a:pPr algn="ctr"/>
+          </a:p>
+        </p:txBody>
+      </p:sp>
+      <p:sp>
+        <p:nvSpPr>
+          <p:cNvPr id="7" name="Rounded Rectangle 6"/>
+          <p:cNvSpPr/>
+          <p:nvPr/>
+        </p:nvSpPr>
+        <p:spPr>
+          <a:xfrm>
+            <a:off x="6537960" y="1783080"/>
+            <a:ext cx="4785055" cy="4480560"/>
+          </a:xfrm>
+          <a:prstGeom prst="roundRect">
+            <a:avLst/>
+          </a:prstGeom>
+          <a:solidFill>
+            <a:srgbClr val="EEF2FF"/>
+          </a:solidFill>
+          <a:ln w="12700">
+            <a:solidFill>
+              <a:srgbClr val="E2E8F0"/>
+            </a:solidFill>
+          </a:ln>
+        </p:spPr>
+        <p:style>
+          <a:lnRef idx="1">
+            <a:schemeClr val="accent1"/>
+          </a:lnRef>
+          <a:fillRef idx="3">
+            <a:schemeClr val="accent1"/>
+          </a:fillRef>
+          <a:effectRef idx="2">
+            <a:schemeClr val="accent1"/>
+          </a:effectRef>
+          <a:fontRef idx="minor">
+            <a:schemeClr val="lt1"/>
+          </a:fontRef>
+        </p:style>
+        <p:txBody>
+          <a:bodyPr rtlCol="0" anchor="ctr" wrap="square"/>
+          <a:lstStyle/>
+          <a:p>
+            <a:pPr algn="ctr">
+              <a:defRPr sz="1300" b="1">
+                <a:solidFill>
+                  <a:srgbClr val="4F46E5"/>
+                </a:solidFill>
+              </a:defRPr>
+            </a:pPr>
+            <a:br/>
+            <a:br/>
+            <a:br/>
+            <a:br/>
+            <a:r>
+              <a:t>📸 [INSERT SCREENSHOT HERE: All-Rooms Explorer Grid View]</a:t>
+            </a:r>
+          </a:p>
+        </p:txBody>
+      </p:sp>
     </p:spTree>
   </p:cSld>
   <p:clrMapOvr>
@@ -7989,30 +9084,109 @@
           </a:p>
         </p:txBody>
       </p:sp>
-      <p:pic>
-        <p:nvPicPr>
-          <p:cNvPr id="6" name="Picture 5" descr="SLIDE_7_FILE_UPLOAD.png"/>
-          <p:cNvPicPr>
-            <a:picLocks noChangeAspect="1"/>
-          </p:cNvPicPr>
-          <p:nvPr/>
-        </p:nvPicPr>
-        <p:blipFill>
-          <a:blip r:embed="rId2"/>
-          <a:stretch>
-            <a:fillRect/>
-          </a:stretch>
-        </p:blipFill>
-        <p:spPr>
-          <a:xfrm>
-            <a:off x="6492240" y="1645920"/>
-            <a:ext cx="4937760" cy="3291840"/>
-          </a:xfrm>
-          <a:prstGeom prst="rect">
-            <a:avLst/>
-          </a:prstGeom>
-        </p:spPr>
-      </p:pic>
+      <p:sp>
+        <p:nvSpPr>
+          <p:cNvPr id="6" name="Rounded Rectangle 5"/>
+          <p:cNvSpPr/>
+          <p:nvPr/>
+        </p:nvSpPr>
+        <p:spPr>
+          <a:xfrm>
+            <a:off x="6400800" y="1645920"/>
+            <a:ext cx="5059375" cy="4754880"/>
+          </a:xfrm>
+          <a:prstGeom prst="roundRect">
+            <a:avLst/>
+          </a:prstGeom>
+          <a:solidFill>
+            <a:srgbClr val="FFFFFF"/>
+          </a:solidFill>
+          <a:ln w="25400">
+            <a:solidFill>
+              <a:srgbClr val="4F46E5"/>
+            </a:solidFill>
+          </a:ln>
+        </p:spPr>
+        <p:style>
+          <a:lnRef idx="1">
+            <a:schemeClr val="accent1"/>
+          </a:lnRef>
+          <a:fillRef idx="3">
+            <a:schemeClr val="accent1"/>
+          </a:fillRef>
+          <a:effectRef idx="2">
+            <a:schemeClr val="accent1"/>
+          </a:effectRef>
+          <a:fontRef idx="minor">
+            <a:schemeClr val="lt1"/>
+          </a:fontRef>
+        </p:style>
+        <p:txBody>
+          <a:bodyPr rtlCol="0" anchor="ctr"/>
+          <a:lstStyle/>
+          <a:p>
+            <a:pPr algn="ctr"/>
+          </a:p>
+        </p:txBody>
+      </p:sp>
+      <p:sp>
+        <p:nvSpPr>
+          <p:cNvPr id="7" name="Rounded Rectangle 6"/>
+          <p:cNvSpPr/>
+          <p:nvPr/>
+        </p:nvSpPr>
+        <p:spPr>
+          <a:xfrm>
+            <a:off x="6537960" y="1783080"/>
+            <a:ext cx="4785055" cy="4480560"/>
+          </a:xfrm>
+          <a:prstGeom prst="roundRect">
+            <a:avLst/>
+          </a:prstGeom>
+          <a:solidFill>
+            <a:srgbClr val="EEF2FF"/>
+          </a:solidFill>
+          <a:ln w="12700">
+            <a:solidFill>
+              <a:srgbClr val="E2E8F0"/>
+            </a:solidFill>
+          </a:ln>
+        </p:spPr>
+        <p:style>
+          <a:lnRef idx="1">
+            <a:schemeClr val="accent1"/>
+          </a:lnRef>
+          <a:fillRef idx="3">
+            <a:schemeClr val="accent1"/>
+          </a:fillRef>
+          <a:effectRef idx="2">
+            <a:schemeClr val="accent1"/>
+          </a:effectRef>
+          <a:fontRef idx="minor">
+            <a:schemeClr val="lt1"/>
+          </a:fontRef>
+        </p:style>
+        <p:txBody>
+          <a:bodyPr rtlCol="0" anchor="ctr" wrap="square"/>
+          <a:lstStyle/>
+          <a:p>
+            <a:pPr algn="ctr">
+              <a:defRPr sz="1300" b="1">
+                <a:solidFill>
+                  <a:srgbClr val="4F46E5"/>
+                </a:solidFill>
+              </a:defRPr>
+            </a:pPr>
+            <a:br/>
+            <a:br/>
+            <a:br/>
+            <a:br/>
+            <a:r>
+              <a:t>📸 [INSERT SCREENSHOT HERE: Add/Edit Room Modal File Picker]</a:t>
+            </a:r>
+          </a:p>
+        </p:txBody>
+      </p:sp>
     </p:spTree>
   </p:cSld>
   <p:clrMapOvr>
@@ -8292,30 +9466,109 @@
           </a:p>
         </p:txBody>
       </p:sp>
-      <p:pic>
-        <p:nvPicPr>
-          <p:cNvPr id="6" name="Picture 5" descr="SLIDE_8_ROOM_BOOKING.png"/>
-          <p:cNvPicPr>
-            <a:picLocks noChangeAspect="1"/>
-          </p:cNvPicPr>
-          <p:nvPr/>
-        </p:nvPicPr>
-        <p:blipFill>
-          <a:blip r:embed="rId2"/>
-          <a:stretch>
-            <a:fillRect/>
-          </a:stretch>
-        </p:blipFill>
-        <p:spPr>
-          <a:xfrm>
-            <a:off x="6492240" y="1645920"/>
-            <a:ext cx="4937760" cy="3291840"/>
-          </a:xfrm>
-          <a:prstGeom prst="rect">
-            <a:avLst/>
-          </a:prstGeom>
-        </p:spPr>
-      </p:pic>
+      <p:sp>
+        <p:nvSpPr>
+          <p:cNvPr id="6" name="Rounded Rectangle 5"/>
+          <p:cNvSpPr/>
+          <p:nvPr/>
+        </p:nvSpPr>
+        <p:spPr>
+          <a:xfrm>
+            <a:off x="6400800" y="1645920"/>
+            <a:ext cx="5059375" cy="4754880"/>
+          </a:xfrm>
+          <a:prstGeom prst="roundRect">
+            <a:avLst/>
+          </a:prstGeom>
+          <a:solidFill>
+            <a:srgbClr val="FFFFFF"/>
+          </a:solidFill>
+          <a:ln w="25400">
+            <a:solidFill>
+              <a:srgbClr val="4F46E5"/>
+            </a:solidFill>
+          </a:ln>
+        </p:spPr>
+        <p:style>
+          <a:lnRef idx="1">
+            <a:schemeClr val="accent1"/>
+          </a:lnRef>
+          <a:fillRef idx="3">
+            <a:schemeClr val="accent1"/>
+          </a:fillRef>
+          <a:effectRef idx="2">
+            <a:schemeClr val="accent1"/>
+          </a:effectRef>
+          <a:fontRef idx="minor">
+            <a:schemeClr val="lt1"/>
+          </a:fontRef>
+        </p:style>
+        <p:txBody>
+          <a:bodyPr rtlCol="0" anchor="ctr"/>
+          <a:lstStyle/>
+          <a:p>
+            <a:pPr algn="ctr"/>
+          </a:p>
+        </p:txBody>
+      </p:sp>
+      <p:sp>
+        <p:nvSpPr>
+          <p:cNvPr id="7" name="Rounded Rectangle 6"/>
+          <p:cNvSpPr/>
+          <p:nvPr/>
+        </p:nvSpPr>
+        <p:spPr>
+          <a:xfrm>
+            <a:off x="6537960" y="1783080"/>
+            <a:ext cx="4785055" cy="4480560"/>
+          </a:xfrm>
+          <a:prstGeom prst="roundRect">
+            <a:avLst/>
+          </a:prstGeom>
+          <a:solidFill>
+            <a:srgbClr val="EEF2FF"/>
+          </a:solidFill>
+          <a:ln w="12700">
+            <a:solidFill>
+              <a:srgbClr val="E2E8F0"/>
+            </a:solidFill>
+          </a:ln>
+        </p:spPr>
+        <p:style>
+          <a:lnRef idx="1">
+            <a:schemeClr val="accent1"/>
+          </a:lnRef>
+          <a:fillRef idx="3">
+            <a:schemeClr val="accent1"/>
+          </a:fillRef>
+          <a:effectRef idx="2">
+            <a:schemeClr val="accent1"/>
+          </a:effectRef>
+          <a:fontRef idx="minor">
+            <a:schemeClr val="lt1"/>
+          </a:fontRef>
+        </p:style>
+        <p:txBody>
+          <a:bodyPr rtlCol="0" anchor="ctr" wrap="square"/>
+          <a:lstStyle/>
+          <a:p>
+            <a:pPr algn="ctr">
+              <a:defRPr sz="1300" b="1">
+                <a:solidFill>
+                  <a:srgbClr val="4F46E5"/>
+                </a:solidFill>
+              </a:defRPr>
+            </a:pPr>
+            <a:br/>
+            <a:br/>
+            <a:br/>
+            <a:br/>
+            <a:r>
+              <a:t>📸 [INSERT SCREENSHOT HERE: Booking Side Panel &amp; Slot Picker]</a:t>
+            </a:r>
+          </a:p>
+        </p:txBody>
+      </p:sp>
     </p:spTree>
   </p:cSld>
   <p:clrMapOvr>
@@ -8595,30 +9848,109 @@
           </a:p>
         </p:txBody>
       </p:sp>
-      <p:pic>
-        <p:nvPicPr>
-          <p:cNvPr id="6" name="Picture 5" descr="SLIDE_9_AUTO_APPROVAL.png"/>
-          <p:cNvPicPr>
-            <a:picLocks noChangeAspect="1"/>
-          </p:cNvPicPr>
-          <p:nvPr/>
-        </p:nvPicPr>
-        <p:blipFill>
-          <a:blip r:embed="rId2"/>
-          <a:stretch>
-            <a:fillRect/>
-          </a:stretch>
-        </p:blipFill>
-        <p:spPr>
-          <a:xfrm>
-            <a:off x="6492240" y="1645920"/>
-            <a:ext cx="4937760" cy="2597359"/>
-          </a:xfrm>
-          <a:prstGeom prst="rect">
-            <a:avLst/>
-          </a:prstGeom>
-        </p:spPr>
-      </p:pic>
+      <p:sp>
+        <p:nvSpPr>
+          <p:cNvPr id="6" name="Rounded Rectangle 5"/>
+          <p:cNvSpPr/>
+          <p:nvPr/>
+        </p:nvSpPr>
+        <p:spPr>
+          <a:xfrm>
+            <a:off x="6400800" y="1645920"/>
+            <a:ext cx="5059375" cy="4754880"/>
+          </a:xfrm>
+          <a:prstGeom prst="roundRect">
+            <a:avLst/>
+          </a:prstGeom>
+          <a:solidFill>
+            <a:srgbClr val="FFFFFF"/>
+          </a:solidFill>
+          <a:ln w="25400">
+            <a:solidFill>
+              <a:srgbClr val="4F46E5"/>
+            </a:solidFill>
+          </a:ln>
+        </p:spPr>
+        <p:style>
+          <a:lnRef idx="1">
+            <a:schemeClr val="accent1"/>
+          </a:lnRef>
+          <a:fillRef idx="3">
+            <a:schemeClr val="accent1"/>
+          </a:fillRef>
+          <a:effectRef idx="2">
+            <a:schemeClr val="accent1"/>
+          </a:effectRef>
+          <a:fontRef idx="minor">
+            <a:schemeClr val="lt1"/>
+          </a:fontRef>
+        </p:style>
+        <p:txBody>
+          <a:bodyPr rtlCol="0" anchor="ctr"/>
+          <a:lstStyle/>
+          <a:p>
+            <a:pPr algn="ctr"/>
+          </a:p>
+        </p:txBody>
+      </p:sp>
+      <p:sp>
+        <p:nvSpPr>
+          <p:cNvPr id="7" name="Rounded Rectangle 6"/>
+          <p:cNvSpPr/>
+          <p:nvPr/>
+        </p:nvSpPr>
+        <p:spPr>
+          <a:xfrm>
+            <a:off x="6537960" y="1783080"/>
+            <a:ext cx="4785055" cy="4480560"/>
+          </a:xfrm>
+          <a:prstGeom prst="roundRect">
+            <a:avLst/>
+          </a:prstGeom>
+          <a:solidFill>
+            <a:srgbClr val="EEF2FF"/>
+          </a:solidFill>
+          <a:ln w="12700">
+            <a:solidFill>
+              <a:srgbClr val="E2E8F0"/>
+            </a:solidFill>
+          </a:ln>
+        </p:spPr>
+        <p:style>
+          <a:lnRef idx="1">
+            <a:schemeClr val="accent1"/>
+          </a:lnRef>
+          <a:fillRef idx="3">
+            <a:schemeClr val="accent1"/>
+          </a:fillRef>
+          <a:effectRef idx="2">
+            <a:schemeClr val="accent1"/>
+          </a:effectRef>
+          <a:fontRef idx="minor">
+            <a:schemeClr val="lt1"/>
+          </a:fontRef>
+        </p:style>
+        <p:txBody>
+          <a:bodyPr rtlCol="0" anchor="ctr" wrap="square"/>
+          <a:lstStyle/>
+          <a:p>
+            <a:pPr algn="ctr">
+              <a:defRPr sz="1300" b="1">
+                <a:solidFill>
+                  <a:srgbClr val="4F46E5"/>
+                </a:solidFill>
+              </a:defRPr>
+            </a:pPr>
+            <a:br/>
+            <a:br/>
+            <a:br/>
+            <a:br/>
+            <a:r>
+              <a:t>📸 [INSERT SCREENSHOT HERE: Booking List showing Auto-Approved Badge]</a:t>
+            </a:r>
+          </a:p>
+        </p:txBody>
+      </p:sp>
     </p:spTree>
   </p:cSld>
   <p:clrMapOvr>

</xml_diff>

<commit_message>
feat: add Room History API endpoint and Room History Audit Log Modal on room cards across Employee, Manager, and Admin dashboards
</commit_message>
<xml_diff>
--- a/document/PRESENTATION_DECK_SLIDES.pptx
+++ b/document/PRESENTATION_DECK_SLIDES.pptx
@@ -3375,64 +3375,30 @@
           </a:p>
         </p:txBody>
       </p:sp>
-      <p:sp>
-        <p:nvSpPr>
-          <p:cNvPr id="6" name="Rounded Rectangle 5"/>
-          <p:cNvSpPr/>
+      <p:pic>
+        <p:nvPicPr>
+          <p:cNvPr id="6" name="Picture 5" descr="SLIDE_1_HERO.png"/>
+          <p:cNvPicPr>
+            <a:picLocks noChangeAspect="1"/>
+          </p:cNvPicPr>
           <p:nvPr/>
-        </p:nvSpPr>
+        </p:nvPicPr>
+        <p:blipFill>
+          <a:blip r:embed="rId2"/>
+          <a:stretch>
+            <a:fillRect/>
+          </a:stretch>
+        </p:blipFill>
         <p:spPr>
           <a:xfrm>
             <a:off x="6492240" y="1325880"/>
-            <a:ext cx="4937760" cy="4983480"/>
-          </a:xfrm>
-          <a:prstGeom prst="roundRect">
-            <a:avLst/>
-          </a:prstGeom>
-          <a:solidFill>
-            <a:srgbClr val="EEF2FF"/>
-          </a:solidFill>
-          <a:ln w="25400">
-            <a:solidFill>
-              <a:srgbClr val="4F46E5"/>
-            </a:solidFill>
-          </a:ln>
-        </p:spPr>
-        <p:style>
-          <a:lnRef idx="1">
-            <a:schemeClr val="accent1"/>
-          </a:lnRef>
-          <a:fillRef idx="3">
-            <a:schemeClr val="accent1"/>
-          </a:fillRef>
-          <a:effectRef idx="2">
-            <a:schemeClr val="accent1"/>
-          </a:effectRef>
-          <a:fontRef idx="minor">
-            <a:schemeClr val="lt1"/>
-          </a:fontRef>
-        </p:style>
-        <p:txBody>
-          <a:bodyPr rtlCol="0" anchor="ctr" wrap="square"/>
-          <a:lstStyle/>
-          <a:p>
-            <a:pPr algn="ctr">
-              <a:defRPr sz="1300" b="1">
-                <a:solidFill>
-                  <a:srgbClr val="4F46E5"/>
-                </a:solidFill>
-              </a:defRPr>
-            </a:pPr>
-            <a:br/>
-            <a:br/>
-            <a:br/>
-            <a:br/>
-            <a:r>
-              <a:t>📸 [INSERT SCREENSHOT HERE: Lumina Reserve App Logo &amp; Hero Homepage]</a:t>
-            </a:r>
-          </a:p>
-        </p:txBody>
-      </p:sp>
+            <a:ext cx="4937760" cy="2597359"/>
+          </a:xfrm>
+          <a:prstGeom prst="rect">
+            <a:avLst/>
+          </a:prstGeom>
+        </p:spPr>
+      </p:pic>
     </p:spTree>
   </p:cSld>
   <p:clrMapOvr>
@@ -3712,109 +3678,30 @@
           </a:p>
         </p:txBody>
       </p:sp>
-      <p:sp>
-        <p:nvSpPr>
-          <p:cNvPr id="6" name="Rounded Rectangle 5"/>
-          <p:cNvSpPr/>
+      <p:pic>
+        <p:nvPicPr>
+          <p:cNvPr id="6" name="Picture 5" descr="SLIDE_9_AUTO_APPROVAL.png"/>
+          <p:cNvPicPr>
+            <a:picLocks noChangeAspect="1"/>
+          </p:cNvPicPr>
           <p:nvPr/>
-        </p:nvSpPr>
-        <p:spPr>
-          <a:xfrm>
-            <a:off x="6400800" y="1645920"/>
-            <a:ext cx="5059375" cy="4754880"/>
-          </a:xfrm>
-          <a:prstGeom prst="roundRect">
-            <a:avLst/>
-          </a:prstGeom>
-          <a:solidFill>
-            <a:srgbClr val="FFFFFF"/>
-          </a:solidFill>
-          <a:ln w="25400">
-            <a:solidFill>
-              <a:srgbClr val="4F46E5"/>
-            </a:solidFill>
-          </a:ln>
-        </p:spPr>
-        <p:style>
-          <a:lnRef idx="1">
-            <a:schemeClr val="accent1"/>
-          </a:lnRef>
-          <a:fillRef idx="3">
-            <a:schemeClr val="accent1"/>
-          </a:fillRef>
-          <a:effectRef idx="2">
-            <a:schemeClr val="accent1"/>
-          </a:effectRef>
-          <a:fontRef idx="minor">
-            <a:schemeClr val="lt1"/>
-          </a:fontRef>
-        </p:style>
-        <p:txBody>
-          <a:bodyPr rtlCol="0" anchor="ctr"/>
-          <a:lstStyle/>
-          <a:p>
-            <a:pPr algn="ctr"/>
-          </a:p>
-        </p:txBody>
-      </p:sp>
-      <p:sp>
-        <p:nvSpPr>
-          <p:cNvPr id="7" name="Rounded Rectangle 6"/>
-          <p:cNvSpPr/>
-          <p:nvPr/>
-        </p:nvSpPr>
-        <p:spPr>
-          <a:xfrm>
-            <a:off x="6537960" y="1783080"/>
-            <a:ext cx="4785055" cy="4480560"/>
-          </a:xfrm>
-          <a:prstGeom prst="roundRect">
-            <a:avLst/>
-          </a:prstGeom>
-          <a:solidFill>
-            <a:srgbClr val="EEF2FF"/>
-          </a:solidFill>
-          <a:ln w="12700">
-            <a:solidFill>
-              <a:srgbClr val="E2E8F0"/>
-            </a:solidFill>
-          </a:ln>
-        </p:spPr>
-        <p:style>
-          <a:lnRef idx="1">
-            <a:schemeClr val="accent1"/>
-          </a:lnRef>
-          <a:fillRef idx="3">
-            <a:schemeClr val="accent1"/>
-          </a:fillRef>
-          <a:effectRef idx="2">
-            <a:schemeClr val="accent1"/>
-          </a:effectRef>
-          <a:fontRef idx="minor">
-            <a:schemeClr val="lt1"/>
-          </a:fontRef>
-        </p:style>
-        <p:txBody>
-          <a:bodyPr rtlCol="0" anchor="ctr" wrap="square"/>
-          <a:lstStyle/>
-          <a:p>
-            <a:pPr algn="ctr">
-              <a:defRPr sz="1300" b="1">
-                <a:solidFill>
-                  <a:srgbClr val="4F46E5"/>
-                </a:solidFill>
-              </a:defRPr>
-            </a:pPr>
-            <a:br/>
-            <a:br/>
-            <a:br/>
-            <a:br/>
-            <a:r>
-              <a:t>📸 [INSERT SCREENSHOT HERE: WhatsApp Button &amp; Pre-Filled Text Preview]</a:t>
-            </a:r>
-          </a:p>
-        </p:txBody>
-      </p:sp>
+        </p:nvPicPr>
+        <p:blipFill>
+          <a:blip r:embed="rId2"/>
+          <a:stretch>
+            <a:fillRect/>
+          </a:stretch>
+        </p:blipFill>
+        <p:spPr>
+          <a:xfrm>
+            <a:off x="6492240" y="1645920"/>
+            <a:ext cx="4937760" cy="2597359"/>
+          </a:xfrm>
+          <a:prstGeom prst="rect">
+            <a:avLst/>
+          </a:prstGeom>
+        </p:spPr>
+      </p:pic>
     </p:spTree>
   </p:cSld>
   <p:clrMapOvr>
@@ -4094,109 +3981,30 @@
           </a:p>
         </p:txBody>
       </p:sp>
-      <p:sp>
-        <p:nvSpPr>
-          <p:cNvPr id="6" name="Rounded Rectangle 5"/>
-          <p:cNvSpPr/>
+      <p:pic>
+        <p:nvPicPr>
+          <p:cNvPr id="6" name="Picture 5" descr="SLIDE_11_EDIT_MEMBERS.png"/>
+          <p:cNvPicPr>
+            <a:picLocks noChangeAspect="1"/>
+          </p:cNvPicPr>
           <p:nvPr/>
-        </p:nvSpPr>
-        <p:spPr>
-          <a:xfrm>
-            <a:off x="6400800" y="1645920"/>
-            <a:ext cx="5059375" cy="4754880"/>
-          </a:xfrm>
-          <a:prstGeom prst="roundRect">
-            <a:avLst/>
-          </a:prstGeom>
-          <a:solidFill>
-            <a:srgbClr val="FFFFFF"/>
-          </a:solidFill>
-          <a:ln w="25400">
-            <a:solidFill>
-              <a:srgbClr val="4F46E5"/>
-            </a:solidFill>
-          </a:ln>
-        </p:spPr>
-        <p:style>
-          <a:lnRef idx="1">
-            <a:schemeClr val="accent1"/>
-          </a:lnRef>
-          <a:fillRef idx="3">
-            <a:schemeClr val="accent1"/>
-          </a:fillRef>
-          <a:effectRef idx="2">
-            <a:schemeClr val="accent1"/>
-          </a:effectRef>
-          <a:fontRef idx="minor">
-            <a:schemeClr val="lt1"/>
-          </a:fontRef>
-        </p:style>
-        <p:txBody>
-          <a:bodyPr rtlCol="0" anchor="ctr"/>
-          <a:lstStyle/>
-          <a:p>
-            <a:pPr algn="ctr"/>
-          </a:p>
-        </p:txBody>
-      </p:sp>
-      <p:sp>
-        <p:nvSpPr>
-          <p:cNvPr id="7" name="Rounded Rectangle 6"/>
-          <p:cNvSpPr/>
-          <p:nvPr/>
-        </p:nvSpPr>
-        <p:spPr>
-          <a:xfrm>
-            <a:off x="6537960" y="1783080"/>
-            <a:ext cx="4785055" cy="4480560"/>
-          </a:xfrm>
-          <a:prstGeom prst="roundRect">
-            <a:avLst/>
-          </a:prstGeom>
-          <a:solidFill>
-            <a:srgbClr val="EEF2FF"/>
-          </a:solidFill>
-          <a:ln w="12700">
-            <a:solidFill>
-              <a:srgbClr val="E2E8F0"/>
-            </a:solidFill>
-          </a:ln>
-        </p:spPr>
-        <p:style>
-          <a:lnRef idx="1">
-            <a:schemeClr val="accent1"/>
-          </a:lnRef>
-          <a:fillRef idx="3">
-            <a:schemeClr val="accent1"/>
-          </a:fillRef>
-          <a:effectRef idx="2">
-            <a:schemeClr val="accent1"/>
-          </a:effectRef>
-          <a:fontRef idx="minor">
-            <a:schemeClr val="lt1"/>
-          </a:fontRef>
-        </p:style>
-        <p:txBody>
-          <a:bodyPr rtlCol="0" anchor="ctr" wrap="square"/>
-          <a:lstStyle/>
-          <a:p>
-            <a:pPr algn="ctr">
-              <a:defRPr sz="1300" b="1">
-                <a:solidFill>
-                  <a:srgbClr val="4F46E5"/>
-                </a:solidFill>
-              </a:defRPr>
-            </a:pPr>
-            <a:br/>
-            <a:br/>
-            <a:br/>
-            <a:br/>
-            <a:r>
-              <a:t>📸 [INSERT SCREENSHOT HERE: Edit Participants Modal]</a:t>
-            </a:r>
-          </a:p>
-        </p:txBody>
-      </p:sp>
+        </p:nvPicPr>
+        <p:blipFill>
+          <a:blip r:embed="rId2"/>
+          <a:stretch>
+            <a:fillRect/>
+          </a:stretch>
+        </p:blipFill>
+        <p:spPr>
+          <a:xfrm>
+            <a:off x="6492240" y="1645920"/>
+            <a:ext cx="4937760" cy="3291840"/>
+          </a:xfrm>
+          <a:prstGeom prst="rect">
+            <a:avLst/>
+          </a:prstGeom>
+        </p:spPr>
+      </p:pic>
     </p:spTree>
   </p:cSld>
   <p:clrMapOvr>
@@ -4476,109 +4284,30 @@
           </a:p>
         </p:txBody>
       </p:sp>
-      <p:sp>
-        <p:nvSpPr>
-          <p:cNvPr id="6" name="Rounded Rectangle 5"/>
-          <p:cNvSpPr/>
+      <p:pic>
+        <p:nvPicPr>
+          <p:cNvPr id="6" name="Picture 5" descr="SLIDE_12_MANAGER_QUEUE.png"/>
+          <p:cNvPicPr>
+            <a:picLocks noChangeAspect="1"/>
+          </p:cNvPicPr>
           <p:nvPr/>
-        </p:nvSpPr>
-        <p:spPr>
-          <a:xfrm>
-            <a:off x="6400800" y="1645920"/>
-            <a:ext cx="5059375" cy="4754880"/>
-          </a:xfrm>
-          <a:prstGeom prst="roundRect">
-            <a:avLst/>
-          </a:prstGeom>
-          <a:solidFill>
-            <a:srgbClr val="FFFFFF"/>
-          </a:solidFill>
-          <a:ln w="25400">
-            <a:solidFill>
-              <a:srgbClr val="4F46E5"/>
-            </a:solidFill>
-          </a:ln>
-        </p:spPr>
-        <p:style>
-          <a:lnRef idx="1">
-            <a:schemeClr val="accent1"/>
-          </a:lnRef>
-          <a:fillRef idx="3">
-            <a:schemeClr val="accent1"/>
-          </a:fillRef>
-          <a:effectRef idx="2">
-            <a:schemeClr val="accent1"/>
-          </a:effectRef>
-          <a:fontRef idx="minor">
-            <a:schemeClr val="lt1"/>
-          </a:fontRef>
-        </p:style>
-        <p:txBody>
-          <a:bodyPr rtlCol="0" anchor="ctr"/>
-          <a:lstStyle/>
-          <a:p>
-            <a:pPr algn="ctr"/>
-          </a:p>
-        </p:txBody>
-      </p:sp>
-      <p:sp>
-        <p:nvSpPr>
-          <p:cNvPr id="7" name="Rounded Rectangle 6"/>
-          <p:cNvSpPr/>
-          <p:nvPr/>
-        </p:nvSpPr>
-        <p:spPr>
-          <a:xfrm>
-            <a:off x="6537960" y="1783080"/>
-            <a:ext cx="4785055" cy="4480560"/>
-          </a:xfrm>
-          <a:prstGeom prst="roundRect">
-            <a:avLst/>
-          </a:prstGeom>
-          <a:solidFill>
-            <a:srgbClr val="EEF2FF"/>
-          </a:solidFill>
-          <a:ln w="12700">
-            <a:solidFill>
-              <a:srgbClr val="E2E8F0"/>
-            </a:solidFill>
-          </a:ln>
-        </p:spPr>
-        <p:style>
-          <a:lnRef idx="1">
-            <a:schemeClr val="accent1"/>
-          </a:lnRef>
-          <a:fillRef idx="3">
-            <a:schemeClr val="accent1"/>
-          </a:fillRef>
-          <a:effectRef idx="2">
-            <a:schemeClr val="accent1"/>
-          </a:effectRef>
-          <a:fontRef idx="minor">
-            <a:schemeClr val="lt1"/>
-          </a:fontRef>
-        </p:style>
-        <p:txBody>
-          <a:bodyPr rtlCol="0" anchor="ctr" wrap="square"/>
-          <a:lstStyle/>
-          <a:p>
-            <a:pPr algn="ctr">
-              <a:defRPr sz="1300" b="1">
-                <a:solidFill>
-                  <a:srgbClr val="4F46E5"/>
-                </a:solidFill>
-              </a:defRPr>
-            </a:pPr>
-            <a:br/>
-            <a:br/>
-            <a:br/>
-            <a:br/>
-            <a:r>
-              <a:t>📸 [INSERT SCREENSHOT HERE: Manager Dashboard Approval Queue]</a:t>
-            </a:r>
-          </a:p>
-        </p:txBody>
-      </p:sp>
+        </p:nvPicPr>
+        <p:blipFill>
+          <a:blip r:embed="rId2"/>
+          <a:stretch>
+            <a:fillRect/>
+          </a:stretch>
+        </p:blipFill>
+        <p:spPr>
+          <a:xfrm>
+            <a:off x="6492240" y="1645920"/>
+            <a:ext cx="4937760" cy="2597359"/>
+          </a:xfrm>
+          <a:prstGeom prst="rect">
+            <a:avLst/>
+          </a:prstGeom>
+        </p:spPr>
+      </p:pic>
     </p:spTree>
   </p:cSld>
   <p:clrMapOvr>
@@ -4858,109 +4587,30 @@
           </a:p>
         </p:txBody>
       </p:sp>
-      <p:sp>
-        <p:nvSpPr>
-          <p:cNvPr id="6" name="Rounded Rectangle 5"/>
-          <p:cNvSpPr/>
+      <p:pic>
+        <p:nvPicPr>
+          <p:cNvPr id="6" name="Picture 5" descr="SLIDE_13_ROOM_HISTORY.png"/>
+          <p:cNvPicPr>
+            <a:picLocks noChangeAspect="1"/>
+          </p:cNvPicPr>
           <p:nvPr/>
-        </p:nvSpPr>
-        <p:spPr>
-          <a:xfrm>
-            <a:off x="6400800" y="1645920"/>
-            <a:ext cx="5059375" cy="4754880"/>
-          </a:xfrm>
-          <a:prstGeom prst="roundRect">
-            <a:avLst/>
-          </a:prstGeom>
-          <a:solidFill>
-            <a:srgbClr val="FFFFFF"/>
-          </a:solidFill>
-          <a:ln w="25400">
-            <a:solidFill>
-              <a:srgbClr val="4F46E5"/>
-            </a:solidFill>
-          </a:ln>
-        </p:spPr>
-        <p:style>
-          <a:lnRef idx="1">
-            <a:schemeClr val="accent1"/>
-          </a:lnRef>
-          <a:fillRef idx="3">
-            <a:schemeClr val="accent1"/>
-          </a:fillRef>
-          <a:effectRef idx="2">
-            <a:schemeClr val="accent1"/>
-          </a:effectRef>
-          <a:fontRef idx="minor">
-            <a:schemeClr val="lt1"/>
-          </a:fontRef>
-        </p:style>
-        <p:txBody>
-          <a:bodyPr rtlCol="0" anchor="ctr"/>
-          <a:lstStyle/>
-          <a:p>
-            <a:pPr algn="ctr"/>
-          </a:p>
-        </p:txBody>
-      </p:sp>
-      <p:sp>
-        <p:nvSpPr>
-          <p:cNvPr id="7" name="Rounded Rectangle 6"/>
-          <p:cNvSpPr/>
-          <p:nvPr/>
-        </p:nvSpPr>
-        <p:spPr>
-          <a:xfrm>
-            <a:off x="6537960" y="1783080"/>
-            <a:ext cx="4785055" cy="4480560"/>
-          </a:xfrm>
-          <a:prstGeom prst="roundRect">
-            <a:avLst/>
-          </a:prstGeom>
-          <a:solidFill>
-            <a:srgbClr val="EEF2FF"/>
-          </a:solidFill>
-          <a:ln w="12700">
-            <a:solidFill>
-              <a:srgbClr val="E2E8F0"/>
-            </a:solidFill>
-          </a:ln>
-        </p:spPr>
-        <p:style>
-          <a:lnRef idx="1">
-            <a:schemeClr val="accent1"/>
-          </a:lnRef>
-          <a:fillRef idx="3">
-            <a:schemeClr val="accent1"/>
-          </a:fillRef>
-          <a:effectRef idx="2">
-            <a:schemeClr val="accent1"/>
-          </a:effectRef>
-          <a:fontRef idx="minor">
-            <a:schemeClr val="lt1"/>
-          </a:fontRef>
-        </p:style>
-        <p:txBody>
-          <a:bodyPr rtlCol="0" anchor="ctr" wrap="square"/>
-          <a:lstStyle/>
-          <a:p>
-            <a:pPr algn="ctr">
-              <a:defRPr sz="1300" b="1">
-                <a:solidFill>
-                  <a:srgbClr val="4F46E5"/>
-                </a:solidFill>
-              </a:defRPr>
-            </a:pPr>
-            <a:br/>
-            <a:br/>
-            <a:br/>
-            <a:br/>
-            <a:r>
-              <a:t>📸 [INSERT SCREENSHOT HERE: Room History Audit Log Modal]</a:t>
-            </a:r>
-          </a:p>
-        </p:txBody>
-      </p:sp>
+        </p:nvPicPr>
+        <p:blipFill>
+          <a:blip r:embed="rId2"/>
+          <a:stretch>
+            <a:fillRect/>
+          </a:stretch>
+        </p:blipFill>
+        <p:spPr>
+          <a:xfrm>
+            <a:off x="6492240" y="1645920"/>
+            <a:ext cx="4937760" cy="3291840"/>
+          </a:xfrm>
+          <a:prstGeom prst="rect">
+            <a:avLst/>
+          </a:prstGeom>
+        </p:spPr>
+      </p:pic>
     </p:spTree>
   </p:cSld>
   <p:clrMapOvr>
@@ -5240,109 +4890,30 @@
           </a:p>
         </p:txBody>
       </p:sp>
-      <p:sp>
-        <p:nvSpPr>
-          <p:cNvPr id="6" name="Rounded Rectangle 5"/>
-          <p:cNvSpPr/>
+      <p:pic>
+        <p:nvPicPr>
+          <p:cNvPr id="6" name="Picture 5" descr="SLIDE_12_MANAGER_QUEUE.png"/>
+          <p:cNvPicPr>
+            <a:picLocks noChangeAspect="1"/>
+          </p:cNvPicPr>
           <p:nvPr/>
-        </p:nvSpPr>
-        <p:spPr>
-          <a:xfrm>
-            <a:off x="6400800" y="1645920"/>
-            <a:ext cx="5059375" cy="4754880"/>
-          </a:xfrm>
-          <a:prstGeom prst="roundRect">
-            <a:avLst/>
-          </a:prstGeom>
-          <a:solidFill>
-            <a:srgbClr val="FFFFFF"/>
-          </a:solidFill>
-          <a:ln w="25400">
-            <a:solidFill>
-              <a:srgbClr val="4F46E5"/>
-            </a:solidFill>
-          </a:ln>
-        </p:spPr>
-        <p:style>
-          <a:lnRef idx="1">
-            <a:schemeClr val="accent1"/>
-          </a:lnRef>
-          <a:fillRef idx="3">
-            <a:schemeClr val="accent1"/>
-          </a:fillRef>
-          <a:effectRef idx="2">
-            <a:schemeClr val="accent1"/>
-          </a:effectRef>
-          <a:fontRef idx="minor">
-            <a:schemeClr val="lt1"/>
-          </a:fontRef>
-        </p:style>
-        <p:txBody>
-          <a:bodyPr rtlCol="0" anchor="ctr"/>
-          <a:lstStyle/>
-          <a:p>
-            <a:pPr algn="ctr"/>
-          </a:p>
-        </p:txBody>
-      </p:sp>
-      <p:sp>
-        <p:nvSpPr>
-          <p:cNvPr id="7" name="Rounded Rectangle 6"/>
-          <p:cNvSpPr/>
-          <p:nvPr/>
-        </p:nvSpPr>
-        <p:spPr>
-          <a:xfrm>
-            <a:off x="6537960" y="1783080"/>
-            <a:ext cx="4785055" cy="4480560"/>
-          </a:xfrm>
-          <a:prstGeom prst="roundRect">
-            <a:avLst/>
-          </a:prstGeom>
-          <a:solidFill>
-            <a:srgbClr val="EEF2FF"/>
-          </a:solidFill>
-          <a:ln w="12700">
-            <a:solidFill>
-              <a:srgbClr val="E2E8F0"/>
-            </a:solidFill>
-          </a:ln>
-        </p:spPr>
-        <p:style>
-          <a:lnRef idx="1">
-            <a:schemeClr val="accent1"/>
-          </a:lnRef>
-          <a:fillRef idx="3">
-            <a:schemeClr val="accent1"/>
-          </a:fillRef>
-          <a:effectRef idx="2">
-            <a:schemeClr val="accent1"/>
-          </a:effectRef>
-          <a:fontRef idx="minor">
-            <a:schemeClr val="lt1"/>
-          </a:fontRef>
-        </p:style>
-        <p:txBody>
-          <a:bodyPr rtlCol="0" anchor="ctr" wrap="square"/>
-          <a:lstStyle/>
-          <a:p>
-            <a:pPr algn="ctr">
-              <a:defRPr sz="1300" b="1">
-                <a:solidFill>
-                  <a:srgbClr val="4F46E5"/>
-                </a:solidFill>
-              </a:defRPr>
-            </a:pPr>
-            <a:br/>
-            <a:br/>
-            <a:br/>
-            <a:br/>
-            <a:r>
-              <a:t>📸 [INSERT SCREENSHOT HERE: Room Supplies Status Cards Grid]</a:t>
-            </a:r>
-          </a:p>
-        </p:txBody>
-      </p:sp>
+        </p:nvPicPr>
+        <p:blipFill>
+          <a:blip r:embed="rId2"/>
+          <a:stretch>
+            <a:fillRect/>
+          </a:stretch>
+        </p:blipFill>
+        <p:spPr>
+          <a:xfrm>
+            <a:off x="6492240" y="1645920"/>
+            <a:ext cx="4937760" cy="2597359"/>
+          </a:xfrm>
+          <a:prstGeom prst="rect">
+            <a:avLst/>
+          </a:prstGeom>
+        </p:spPr>
+      </p:pic>
     </p:spTree>
   </p:cSld>
   <p:clrMapOvr>
@@ -5622,109 +5193,30 @@
           </a:p>
         </p:txBody>
       </p:sp>
-      <p:sp>
-        <p:nvSpPr>
-          <p:cNvPr id="6" name="Rounded Rectangle 5"/>
-          <p:cNvSpPr/>
+      <p:pic>
+        <p:nvPicPr>
+          <p:cNvPr id="6" name="Picture 5" descr="SLIDE_15_GMAIL_CALENDAR.png"/>
+          <p:cNvPicPr>
+            <a:picLocks noChangeAspect="1"/>
+          </p:cNvPicPr>
           <p:nvPr/>
-        </p:nvSpPr>
-        <p:spPr>
-          <a:xfrm>
-            <a:off x="6400800" y="1645920"/>
-            <a:ext cx="5059375" cy="4754880"/>
-          </a:xfrm>
-          <a:prstGeom prst="roundRect">
-            <a:avLst/>
-          </a:prstGeom>
-          <a:solidFill>
-            <a:srgbClr val="FFFFFF"/>
-          </a:solidFill>
-          <a:ln w="25400">
-            <a:solidFill>
-              <a:srgbClr val="4F46E5"/>
-            </a:solidFill>
-          </a:ln>
-        </p:spPr>
-        <p:style>
-          <a:lnRef idx="1">
-            <a:schemeClr val="accent1"/>
-          </a:lnRef>
-          <a:fillRef idx="3">
-            <a:schemeClr val="accent1"/>
-          </a:fillRef>
-          <a:effectRef idx="2">
-            <a:schemeClr val="accent1"/>
-          </a:effectRef>
-          <a:fontRef idx="minor">
-            <a:schemeClr val="lt1"/>
-          </a:fontRef>
-        </p:style>
-        <p:txBody>
-          <a:bodyPr rtlCol="0" anchor="ctr"/>
-          <a:lstStyle/>
-          <a:p>
-            <a:pPr algn="ctr"/>
-          </a:p>
-        </p:txBody>
-      </p:sp>
-      <p:sp>
-        <p:nvSpPr>
-          <p:cNvPr id="7" name="Rounded Rectangle 6"/>
-          <p:cNvSpPr/>
-          <p:nvPr/>
-        </p:nvSpPr>
-        <p:spPr>
-          <a:xfrm>
-            <a:off x="6537960" y="1783080"/>
-            <a:ext cx="4785055" cy="4480560"/>
-          </a:xfrm>
-          <a:prstGeom prst="roundRect">
-            <a:avLst/>
-          </a:prstGeom>
-          <a:solidFill>
-            <a:srgbClr val="EEF2FF"/>
-          </a:solidFill>
-          <a:ln w="12700">
-            <a:solidFill>
-              <a:srgbClr val="E2E8F0"/>
-            </a:solidFill>
-          </a:ln>
-        </p:spPr>
-        <p:style>
-          <a:lnRef idx="1">
-            <a:schemeClr val="accent1"/>
-          </a:lnRef>
-          <a:fillRef idx="3">
-            <a:schemeClr val="accent1"/>
-          </a:fillRef>
-          <a:effectRef idx="2">
-            <a:schemeClr val="accent1"/>
-          </a:effectRef>
-          <a:fontRef idx="minor">
-            <a:schemeClr val="lt1"/>
-          </a:fontRef>
-        </p:style>
-        <p:txBody>
-          <a:bodyPr rtlCol="0" anchor="ctr" wrap="square"/>
-          <a:lstStyle/>
-          <a:p>
-            <a:pPr algn="ctr">
-              <a:defRPr sz="1300" b="1">
-                <a:solidFill>
-                  <a:srgbClr val="4F46E5"/>
-                </a:solidFill>
-              </a:defRPr>
-            </a:pPr>
-            <a:br/>
-            <a:br/>
-            <a:br/>
-            <a:br/>
-            <a:r>
-              <a:t>📸 [INSERT SCREENSHOT HERE: Gmail Confirmation Email in Inbox]</a:t>
-            </a:r>
-          </a:p>
-        </p:txBody>
-      </p:sp>
+        </p:nvPicPr>
+        <p:blipFill>
+          <a:blip r:embed="rId2"/>
+          <a:stretch>
+            <a:fillRect/>
+          </a:stretch>
+        </p:blipFill>
+        <p:spPr>
+          <a:xfrm>
+            <a:off x="6492240" y="1645920"/>
+            <a:ext cx="4937760" cy="2597359"/>
+          </a:xfrm>
+          <a:prstGeom prst="rect">
+            <a:avLst/>
+          </a:prstGeom>
+        </p:spPr>
+      </p:pic>
     </p:spTree>
   </p:cSld>
   <p:clrMapOvr>
@@ -6019,109 +5511,30 @@
           </a:p>
         </p:txBody>
       </p:sp>
-      <p:sp>
-        <p:nvSpPr>
-          <p:cNvPr id="6" name="Rounded Rectangle 5"/>
-          <p:cNvSpPr/>
+      <p:pic>
+        <p:nvPicPr>
+          <p:cNvPr id="6" name="Picture 5" descr="SLIDE_15_GMAIL_CALENDAR.png"/>
+          <p:cNvPicPr>
+            <a:picLocks noChangeAspect="1"/>
+          </p:cNvPicPr>
           <p:nvPr/>
-        </p:nvSpPr>
-        <p:spPr>
-          <a:xfrm>
-            <a:off x="6400800" y="1645920"/>
-            <a:ext cx="5059375" cy="4754880"/>
-          </a:xfrm>
-          <a:prstGeom prst="roundRect">
-            <a:avLst/>
-          </a:prstGeom>
-          <a:solidFill>
-            <a:srgbClr val="FFFFFF"/>
-          </a:solidFill>
-          <a:ln w="25400">
-            <a:solidFill>
-              <a:srgbClr val="4F46E5"/>
-            </a:solidFill>
-          </a:ln>
-        </p:spPr>
-        <p:style>
-          <a:lnRef idx="1">
-            <a:schemeClr val="accent1"/>
-          </a:lnRef>
-          <a:fillRef idx="3">
-            <a:schemeClr val="accent1"/>
-          </a:fillRef>
-          <a:effectRef idx="2">
-            <a:schemeClr val="accent1"/>
-          </a:effectRef>
-          <a:fontRef idx="minor">
-            <a:schemeClr val="lt1"/>
-          </a:fontRef>
-        </p:style>
-        <p:txBody>
-          <a:bodyPr rtlCol="0" anchor="ctr"/>
-          <a:lstStyle/>
-          <a:p>
-            <a:pPr algn="ctr"/>
-          </a:p>
-        </p:txBody>
-      </p:sp>
-      <p:sp>
-        <p:nvSpPr>
-          <p:cNvPr id="7" name="Rounded Rectangle 6"/>
-          <p:cNvSpPr/>
-          <p:nvPr/>
-        </p:nvSpPr>
-        <p:spPr>
-          <a:xfrm>
-            <a:off x="6537960" y="1783080"/>
-            <a:ext cx="4785055" cy="4480560"/>
-          </a:xfrm>
-          <a:prstGeom prst="roundRect">
-            <a:avLst/>
-          </a:prstGeom>
-          <a:solidFill>
-            <a:srgbClr val="EEF2FF"/>
-          </a:solidFill>
-          <a:ln w="12700">
-            <a:solidFill>
-              <a:srgbClr val="E2E8F0"/>
-            </a:solidFill>
-          </a:ln>
-        </p:spPr>
-        <p:style>
-          <a:lnRef idx="1">
-            <a:schemeClr val="accent1"/>
-          </a:lnRef>
-          <a:fillRef idx="3">
-            <a:schemeClr val="accent1"/>
-          </a:fillRef>
-          <a:effectRef idx="2">
-            <a:schemeClr val="accent1"/>
-          </a:effectRef>
-          <a:fontRef idx="minor">
-            <a:schemeClr val="lt1"/>
-          </a:fontRef>
-        </p:style>
-        <p:txBody>
-          <a:bodyPr rtlCol="0" anchor="ctr" wrap="square"/>
-          <a:lstStyle/>
-          <a:p>
-            <a:pPr algn="ctr">
-              <a:defRPr sz="1300" b="1">
-                <a:solidFill>
-                  <a:srgbClr val="4F46E5"/>
-                </a:solidFill>
-              </a:defRPr>
-            </a:pPr>
-            <a:br/>
-            <a:br/>
-            <a:br/>
-            <a:br/>
-            <a:r>
-              <a:t>📸 [INSERT SCREENSHOT HERE: User Roles Matrix Table]</a:t>
-            </a:r>
-          </a:p>
-        </p:txBody>
-      </p:sp>
+        </p:nvPicPr>
+        <p:blipFill>
+          <a:blip r:embed="rId2"/>
+          <a:stretch>
+            <a:fillRect/>
+          </a:stretch>
+        </p:blipFill>
+        <p:spPr>
+          <a:xfrm>
+            <a:off x="6492240" y="1645920"/>
+            <a:ext cx="4937760" cy="2597359"/>
+          </a:xfrm>
+          <a:prstGeom prst="rect">
+            <a:avLst/>
+          </a:prstGeom>
+        </p:spPr>
+      </p:pic>
     </p:spTree>
   </p:cSld>
   <p:clrMapOvr>
@@ -6416,109 +5829,30 @@
           </a:p>
         </p:txBody>
       </p:sp>
-      <p:sp>
-        <p:nvSpPr>
-          <p:cNvPr id="6" name="Rounded Rectangle 5"/>
-          <p:cNvSpPr/>
+      <p:pic>
+        <p:nvPicPr>
+          <p:cNvPr id="6" name="Picture 5" descr="SLIDE_15_GMAIL_CALENDAR.png"/>
+          <p:cNvPicPr>
+            <a:picLocks noChangeAspect="1"/>
+          </p:cNvPicPr>
           <p:nvPr/>
-        </p:nvSpPr>
-        <p:spPr>
-          <a:xfrm>
-            <a:off x="6400800" y="1645920"/>
-            <a:ext cx="5059375" cy="4754880"/>
-          </a:xfrm>
-          <a:prstGeom prst="roundRect">
-            <a:avLst/>
-          </a:prstGeom>
-          <a:solidFill>
-            <a:srgbClr val="FFFFFF"/>
-          </a:solidFill>
-          <a:ln w="25400">
-            <a:solidFill>
-              <a:srgbClr val="4F46E5"/>
-            </a:solidFill>
-          </a:ln>
-        </p:spPr>
-        <p:style>
-          <a:lnRef idx="1">
-            <a:schemeClr val="accent1"/>
-          </a:lnRef>
-          <a:fillRef idx="3">
-            <a:schemeClr val="accent1"/>
-          </a:fillRef>
-          <a:effectRef idx="2">
-            <a:schemeClr val="accent1"/>
-          </a:effectRef>
-          <a:fontRef idx="minor">
-            <a:schemeClr val="lt1"/>
-          </a:fontRef>
-        </p:style>
-        <p:txBody>
-          <a:bodyPr rtlCol="0" anchor="ctr"/>
-          <a:lstStyle/>
-          <a:p>
-            <a:pPr algn="ctr"/>
-          </a:p>
-        </p:txBody>
-      </p:sp>
-      <p:sp>
-        <p:nvSpPr>
-          <p:cNvPr id="7" name="Rounded Rectangle 6"/>
-          <p:cNvSpPr/>
-          <p:nvPr/>
-        </p:nvSpPr>
-        <p:spPr>
-          <a:xfrm>
-            <a:off x="6537960" y="1783080"/>
-            <a:ext cx="4785055" cy="4480560"/>
-          </a:xfrm>
-          <a:prstGeom prst="roundRect">
-            <a:avLst/>
-          </a:prstGeom>
-          <a:solidFill>
-            <a:srgbClr val="EEF2FF"/>
-          </a:solidFill>
-          <a:ln w="12700">
-            <a:solidFill>
-              <a:srgbClr val="E2E8F0"/>
-            </a:solidFill>
-          </a:ln>
-        </p:spPr>
-        <p:style>
-          <a:lnRef idx="1">
-            <a:schemeClr val="accent1"/>
-          </a:lnRef>
-          <a:fillRef idx="3">
-            <a:schemeClr val="accent1"/>
-          </a:fillRef>
-          <a:effectRef idx="2">
-            <a:schemeClr val="accent1"/>
-          </a:effectRef>
-          <a:fontRef idx="minor">
-            <a:schemeClr val="lt1"/>
-          </a:fontRef>
-        </p:style>
-        <p:txBody>
-          <a:bodyPr rtlCol="0" anchor="ctr" wrap="square"/>
-          <a:lstStyle/>
-          <a:p>
-            <a:pPr algn="ctr">
-              <a:defRPr sz="1300" b="1">
-                <a:solidFill>
-                  <a:srgbClr val="4F46E5"/>
-                </a:solidFill>
-              </a:defRPr>
-            </a:pPr>
-            <a:br/>
-            <a:br/>
-            <a:br/>
-            <a:br/>
-            <a:r>
-              <a:t>📸 [INSERT SCREENSHOT HERE: Multi-Window Demo Overview]</a:t>
-            </a:r>
-          </a:p>
-        </p:txBody>
-      </p:sp>
+        </p:nvPicPr>
+        <p:blipFill>
+          <a:blip r:embed="rId2"/>
+          <a:stretch>
+            <a:fillRect/>
+          </a:stretch>
+        </p:blipFill>
+        <p:spPr>
+          <a:xfrm>
+            <a:off x="6492240" y="1645920"/>
+            <a:ext cx="4937760" cy="2597359"/>
+          </a:xfrm>
+          <a:prstGeom prst="rect">
+            <a:avLst/>
+          </a:prstGeom>
+        </p:spPr>
+      </p:pic>
     </p:spTree>
   </p:cSld>
   <p:clrMapOvr>
@@ -6822,64 +6156,30 @@
           </a:p>
         </p:txBody>
       </p:sp>
-      <p:sp>
-        <p:nvSpPr>
-          <p:cNvPr id="6" name="Rounded Rectangle 5"/>
-          <p:cNvSpPr/>
+      <p:pic>
+        <p:nvPicPr>
+          <p:cNvPr id="6" name="Picture 5" descr="SLIDE_5_LOGIN_PORTAL.png"/>
+          <p:cNvPicPr>
+            <a:picLocks noChangeAspect="1"/>
+          </p:cNvPicPr>
           <p:nvPr/>
-        </p:nvSpPr>
+        </p:nvPicPr>
+        <p:blipFill>
+          <a:blip r:embed="rId2"/>
+          <a:stretch>
+            <a:fillRect/>
+          </a:stretch>
+        </p:blipFill>
         <p:spPr>
           <a:xfrm>
             <a:off x="6492240" y="1325880"/>
-            <a:ext cx="4937760" cy="4983480"/>
-          </a:xfrm>
-          <a:prstGeom prst="roundRect">
-            <a:avLst/>
-          </a:prstGeom>
-          <a:solidFill>
-            <a:srgbClr val="EEF2FF"/>
-          </a:solidFill>
-          <a:ln w="25400">
-            <a:solidFill>
-              <a:srgbClr val="4F46E5"/>
-            </a:solidFill>
-          </a:ln>
-        </p:spPr>
-        <p:style>
-          <a:lnRef idx="1">
-            <a:schemeClr val="accent1"/>
-          </a:lnRef>
-          <a:fillRef idx="3">
-            <a:schemeClr val="accent1"/>
-          </a:fillRef>
-          <a:effectRef idx="2">
-            <a:schemeClr val="accent1"/>
-          </a:effectRef>
-          <a:fontRef idx="minor">
-            <a:schemeClr val="lt1"/>
-          </a:fontRef>
-        </p:style>
-        <p:txBody>
-          <a:bodyPr rtlCol="0" anchor="ctr" wrap="square"/>
-          <a:lstStyle/>
-          <a:p>
-            <a:pPr algn="ctr">
-              <a:defRPr sz="1300" b="1">
-                <a:solidFill>
-                  <a:srgbClr val="4F46E5"/>
-                </a:solidFill>
-              </a:defRPr>
-            </a:pPr>
-            <a:br/>
-            <a:br/>
-            <a:br/>
-            <a:br/>
-            <a:r>
-              <a:t>📸 [INSERT SCREENSHOT HERE: Final Closing Slide / Login Portal]</a:t>
-            </a:r>
-          </a:p>
-        </p:txBody>
-      </p:sp>
+            <a:ext cx="4937760" cy="2597359"/>
+          </a:xfrm>
+          <a:prstGeom prst="rect">
+            <a:avLst/>
+          </a:prstGeom>
+        </p:spPr>
+      </p:pic>
     </p:spTree>
   </p:cSld>
   <p:clrMapOvr>
@@ -7174,109 +6474,30 @@
           </a:p>
         </p:txBody>
       </p:sp>
-      <p:sp>
-        <p:nvSpPr>
-          <p:cNvPr id="6" name="Rounded Rectangle 5"/>
-          <p:cNvSpPr/>
+      <p:pic>
+        <p:nvPicPr>
+          <p:cNvPr id="6" name="Picture 5" descr="SLIDE_2_EMPLOYEE_DASHBOARD.png"/>
+          <p:cNvPicPr>
+            <a:picLocks noChangeAspect="1"/>
+          </p:cNvPicPr>
           <p:nvPr/>
-        </p:nvSpPr>
-        <p:spPr>
-          <a:xfrm>
-            <a:off x="6400800" y="1645920"/>
-            <a:ext cx="5059375" cy="4754880"/>
-          </a:xfrm>
-          <a:prstGeom prst="roundRect">
-            <a:avLst/>
-          </a:prstGeom>
-          <a:solidFill>
-            <a:srgbClr val="FFFFFF"/>
-          </a:solidFill>
-          <a:ln w="25400">
-            <a:solidFill>
-              <a:srgbClr val="4F46E5"/>
-            </a:solidFill>
-          </a:ln>
-        </p:spPr>
-        <p:style>
-          <a:lnRef idx="1">
-            <a:schemeClr val="accent1"/>
-          </a:lnRef>
-          <a:fillRef idx="3">
-            <a:schemeClr val="accent1"/>
-          </a:fillRef>
-          <a:effectRef idx="2">
-            <a:schemeClr val="accent1"/>
-          </a:effectRef>
-          <a:fontRef idx="minor">
-            <a:schemeClr val="lt1"/>
-          </a:fontRef>
-        </p:style>
-        <p:txBody>
-          <a:bodyPr rtlCol="0" anchor="ctr"/>
-          <a:lstStyle/>
-          <a:p>
-            <a:pPr algn="ctr"/>
-          </a:p>
-        </p:txBody>
-      </p:sp>
-      <p:sp>
-        <p:nvSpPr>
-          <p:cNvPr id="7" name="Rounded Rectangle 6"/>
-          <p:cNvSpPr/>
-          <p:nvPr/>
-        </p:nvSpPr>
-        <p:spPr>
-          <a:xfrm>
-            <a:off x="6537960" y="1783080"/>
-            <a:ext cx="4785055" cy="4480560"/>
-          </a:xfrm>
-          <a:prstGeom prst="roundRect">
-            <a:avLst/>
-          </a:prstGeom>
-          <a:solidFill>
-            <a:srgbClr val="EEF2FF"/>
-          </a:solidFill>
-          <a:ln w="12700">
-            <a:solidFill>
-              <a:srgbClr val="E2E8F0"/>
-            </a:solidFill>
-          </a:ln>
-        </p:spPr>
-        <p:style>
-          <a:lnRef idx="1">
-            <a:schemeClr val="accent1"/>
-          </a:lnRef>
-          <a:fillRef idx="3">
-            <a:schemeClr val="accent1"/>
-          </a:fillRef>
-          <a:effectRef idx="2">
-            <a:schemeClr val="accent1"/>
-          </a:effectRef>
-          <a:fontRef idx="minor">
-            <a:schemeClr val="lt1"/>
-          </a:fontRef>
-        </p:style>
-        <p:txBody>
-          <a:bodyPr rtlCol="0" anchor="ctr" wrap="square"/>
-          <a:lstStyle/>
-          <a:p>
-            <a:pPr algn="ctr">
-              <a:defRPr sz="1300" b="1">
-                <a:solidFill>
-                  <a:srgbClr val="4F46E5"/>
-                </a:solidFill>
-              </a:defRPr>
-            </a:pPr>
-            <a:br/>
-            <a:br/>
-            <a:br/>
-            <a:br/>
-            <a:r>
-              <a:t>📸 [INSERT SCREENSHOT HERE: Employee Dashboard &amp; Active Reservations]</a:t>
-            </a:r>
-          </a:p>
-        </p:txBody>
-      </p:sp>
+        </p:nvPicPr>
+        <p:blipFill>
+          <a:blip r:embed="rId2"/>
+          <a:stretch>
+            <a:fillRect/>
+          </a:stretch>
+        </p:blipFill>
+        <p:spPr>
+          <a:xfrm>
+            <a:off x="6492240" y="1645920"/>
+            <a:ext cx="4937760" cy="2597359"/>
+          </a:xfrm>
+          <a:prstGeom prst="rect">
+            <a:avLst/>
+          </a:prstGeom>
+        </p:spPr>
+      </p:pic>
     </p:spTree>
   </p:cSld>
   <p:clrMapOvr>
@@ -7556,109 +6777,30 @@
           </a:p>
         </p:txBody>
       </p:sp>
-      <p:sp>
-        <p:nvSpPr>
-          <p:cNvPr id="6" name="Rounded Rectangle 5"/>
-          <p:cNvSpPr/>
+      <p:pic>
+        <p:nvPicPr>
+          <p:cNvPr id="6" name="Picture 5" descr="SYSTEM_ARCHITECTURE_DIAGRAM.png"/>
+          <p:cNvPicPr>
+            <a:picLocks noChangeAspect="1"/>
+          </p:cNvPicPr>
           <p:nvPr/>
-        </p:nvSpPr>
-        <p:spPr>
-          <a:xfrm>
-            <a:off x="6400800" y="1645920"/>
-            <a:ext cx="5059375" cy="4754880"/>
-          </a:xfrm>
-          <a:prstGeom prst="roundRect">
-            <a:avLst/>
-          </a:prstGeom>
-          <a:solidFill>
-            <a:srgbClr val="FFFFFF"/>
-          </a:solidFill>
-          <a:ln w="25400">
-            <a:solidFill>
-              <a:srgbClr val="4F46E5"/>
-            </a:solidFill>
-          </a:ln>
-        </p:spPr>
-        <p:style>
-          <a:lnRef idx="1">
-            <a:schemeClr val="accent1"/>
-          </a:lnRef>
-          <a:fillRef idx="3">
-            <a:schemeClr val="accent1"/>
-          </a:fillRef>
-          <a:effectRef idx="2">
-            <a:schemeClr val="accent1"/>
-          </a:effectRef>
-          <a:fontRef idx="minor">
-            <a:schemeClr val="lt1"/>
-          </a:fontRef>
-        </p:style>
-        <p:txBody>
-          <a:bodyPr rtlCol="0" anchor="ctr"/>
-          <a:lstStyle/>
-          <a:p>
-            <a:pPr algn="ctr"/>
-          </a:p>
-        </p:txBody>
-      </p:sp>
-      <p:sp>
-        <p:nvSpPr>
-          <p:cNvPr id="7" name="Rounded Rectangle 6"/>
-          <p:cNvSpPr/>
-          <p:nvPr/>
-        </p:nvSpPr>
-        <p:spPr>
-          <a:xfrm>
-            <a:off x="6537960" y="1783080"/>
-            <a:ext cx="4785055" cy="4480560"/>
-          </a:xfrm>
-          <a:prstGeom prst="roundRect">
-            <a:avLst/>
-          </a:prstGeom>
-          <a:solidFill>
-            <a:srgbClr val="EEF2FF"/>
-          </a:solidFill>
-          <a:ln w="12700">
-            <a:solidFill>
-              <a:srgbClr val="E2E8F0"/>
-            </a:solidFill>
-          </a:ln>
-        </p:spPr>
-        <p:style>
-          <a:lnRef idx="1">
-            <a:schemeClr val="accent1"/>
-          </a:lnRef>
-          <a:fillRef idx="3">
-            <a:schemeClr val="accent1"/>
-          </a:fillRef>
-          <a:effectRef idx="2">
-            <a:schemeClr val="accent1"/>
-          </a:effectRef>
-          <a:fontRef idx="minor">
-            <a:schemeClr val="lt1"/>
-          </a:fontRef>
-        </p:style>
-        <p:txBody>
-          <a:bodyPr rtlCol="0" anchor="ctr" wrap="square"/>
-          <a:lstStyle/>
-          <a:p>
-            <a:pPr algn="ctr">
-              <a:defRPr sz="1300" b="1">
-                <a:solidFill>
-                  <a:srgbClr val="4F46E5"/>
-                </a:solidFill>
-              </a:defRPr>
-            </a:pPr>
-            <a:br/>
-            <a:br/>
-            <a:br/>
-            <a:br/>
-            <a:r>
-              <a:t>📸 [INSERT SCREENSHOT HERE: System Architecture &amp; Flow Diagram]</a:t>
-            </a:r>
-          </a:p>
-        </p:txBody>
-      </p:sp>
+        </p:nvPicPr>
+        <p:blipFill>
+          <a:blip r:embed="rId2"/>
+          <a:stretch>
+            <a:fillRect/>
+          </a:stretch>
+        </p:blipFill>
+        <p:spPr>
+          <a:xfrm>
+            <a:off x="6492240" y="1645920"/>
+            <a:ext cx="4937760" cy="3291840"/>
+          </a:xfrm>
+          <a:prstGeom prst="rect">
+            <a:avLst/>
+          </a:prstGeom>
+        </p:spPr>
+      </p:pic>
     </p:spTree>
   </p:cSld>
   <p:clrMapOvr>
@@ -7938,109 +7080,30 @@
           </a:p>
         </p:txBody>
       </p:sp>
-      <p:sp>
-        <p:nvSpPr>
-          <p:cNvPr id="6" name="Rounded Rectangle 5"/>
-          <p:cNvSpPr/>
+      <p:pic>
+        <p:nvPicPr>
+          <p:cNvPr id="6" name="Picture 5" descr="SLIDE_4_EER_DIAGRAM.png"/>
+          <p:cNvPicPr>
+            <a:picLocks noChangeAspect="1"/>
+          </p:cNvPicPr>
           <p:nvPr/>
-        </p:nvSpPr>
-        <p:spPr>
-          <a:xfrm>
-            <a:off x="6400800" y="1645920"/>
-            <a:ext cx="5059375" cy="4754880"/>
-          </a:xfrm>
-          <a:prstGeom prst="roundRect">
-            <a:avLst/>
-          </a:prstGeom>
-          <a:solidFill>
-            <a:srgbClr val="FFFFFF"/>
-          </a:solidFill>
-          <a:ln w="25400">
-            <a:solidFill>
-              <a:srgbClr val="4F46E5"/>
-            </a:solidFill>
-          </a:ln>
-        </p:spPr>
-        <p:style>
-          <a:lnRef idx="1">
-            <a:schemeClr val="accent1"/>
-          </a:lnRef>
-          <a:fillRef idx="3">
-            <a:schemeClr val="accent1"/>
-          </a:fillRef>
-          <a:effectRef idx="2">
-            <a:schemeClr val="accent1"/>
-          </a:effectRef>
-          <a:fontRef idx="minor">
-            <a:schemeClr val="lt1"/>
-          </a:fontRef>
-        </p:style>
-        <p:txBody>
-          <a:bodyPr rtlCol="0" anchor="ctr"/>
-          <a:lstStyle/>
-          <a:p>
-            <a:pPr algn="ctr"/>
-          </a:p>
-        </p:txBody>
-      </p:sp>
-      <p:sp>
-        <p:nvSpPr>
-          <p:cNvPr id="7" name="Rounded Rectangle 6"/>
-          <p:cNvSpPr/>
-          <p:nvPr/>
-        </p:nvSpPr>
-        <p:spPr>
-          <a:xfrm>
-            <a:off x="6537960" y="1783080"/>
-            <a:ext cx="4785055" cy="4480560"/>
-          </a:xfrm>
-          <a:prstGeom prst="roundRect">
-            <a:avLst/>
-          </a:prstGeom>
-          <a:solidFill>
-            <a:srgbClr val="EEF2FF"/>
-          </a:solidFill>
-          <a:ln w="12700">
-            <a:solidFill>
-              <a:srgbClr val="E2E8F0"/>
-            </a:solidFill>
-          </a:ln>
-        </p:spPr>
-        <p:style>
-          <a:lnRef idx="1">
-            <a:schemeClr val="accent1"/>
-          </a:lnRef>
-          <a:fillRef idx="3">
-            <a:schemeClr val="accent1"/>
-          </a:fillRef>
-          <a:effectRef idx="2">
-            <a:schemeClr val="accent1"/>
-          </a:effectRef>
-          <a:fontRef idx="minor">
-            <a:schemeClr val="lt1"/>
-          </a:fontRef>
-        </p:style>
-        <p:txBody>
-          <a:bodyPr rtlCol="0" anchor="ctr" wrap="square"/>
-          <a:lstStyle/>
-          <a:p>
-            <a:pPr algn="ctr">
-              <a:defRPr sz="1300" b="1">
-                <a:solidFill>
-                  <a:srgbClr val="4F46E5"/>
-                </a:solidFill>
-              </a:defRPr>
-            </a:pPr>
-            <a:br/>
-            <a:br/>
-            <a:br/>
-            <a:br/>
-            <a:r>
-              <a:t>📸 [INSERT SCREENSHOT HERE: MySQL Workbench Ctrl + R EER Diagram]</a:t>
-            </a:r>
-          </a:p>
-        </p:txBody>
-      </p:sp>
+        </p:nvPicPr>
+        <p:blipFill>
+          <a:blip r:embed="rId2"/>
+          <a:stretch>
+            <a:fillRect/>
+          </a:stretch>
+        </p:blipFill>
+        <p:spPr>
+          <a:xfrm>
+            <a:off x="6492240" y="1645920"/>
+            <a:ext cx="4937760" cy="3291840"/>
+          </a:xfrm>
+          <a:prstGeom prst="rect">
+            <a:avLst/>
+          </a:prstGeom>
+        </p:spPr>
+      </p:pic>
     </p:spTree>
   </p:cSld>
   <p:clrMapOvr>
@@ -8320,109 +7383,30 @@
           </a:p>
         </p:txBody>
       </p:sp>
-      <p:sp>
-        <p:nvSpPr>
-          <p:cNvPr id="6" name="Rounded Rectangle 5"/>
-          <p:cNvSpPr/>
+      <p:pic>
+        <p:nvPicPr>
+          <p:cNvPr id="6" name="Picture 5" descr="SLIDE_5_LOGIN_PORTAL.png"/>
+          <p:cNvPicPr>
+            <a:picLocks noChangeAspect="1"/>
+          </p:cNvPicPr>
           <p:nvPr/>
-        </p:nvSpPr>
-        <p:spPr>
-          <a:xfrm>
-            <a:off x="6400800" y="1645920"/>
-            <a:ext cx="5059375" cy="4754880"/>
-          </a:xfrm>
-          <a:prstGeom prst="roundRect">
-            <a:avLst/>
-          </a:prstGeom>
-          <a:solidFill>
-            <a:srgbClr val="FFFFFF"/>
-          </a:solidFill>
-          <a:ln w="25400">
-            <a:solidFill>
-              <a:srgbClr val="4F46E5"/>
-            </a:solidFill>
-          </a:ln>
-        </p:spPr>
-        <p:style>
-          <a:lnRef idx="1">
-            <a:schemeClr val="accent1"/>
-          </a:lnRef>
-          <a:fillRef idx="3">
-            <a:schemeClr val="accent1"/>
-          </a:fillRef>
-          <a:effectRef idx="2">
-            <a:schemeClr val="accent1"/>
-          </a:effectRef>
-          <a:fontRef idx="minor">
-            <a:schemeClr val="lt1"/>
-          </a:fontRef>
-        </p:style>
-        <p:txBody>
-          <a:bodyPr rtlCol="0" anchor="ctr"/>
-          <a:lstStyle/>
-          <a:p>
-            <a:pPr algn="ctr"/>
-          </a:p>
-        </p:txBody>
-      </p:sp>
-      <p:sp>
-        <p:nvSpPr>
-          <p:cNvPr id="7" name="Rounded Rectangle 6"/>
-          <p:cNvSpPr/>
-          <p:nvPr/>
-        </p:nvSpPr>
-        <p:spPr>
-          <a:xfrm>
-            <a:off x="6537960" y="1783080"/>
-            <a:ext cx="4785055" cy="4480560"/>
-          </a:xfrm>
-          <a:prstGeom prst="roundRect">
-            <a:avLst/>
-          </a:prstGeom>
-          <a:solidFill>
-            <a:srgbClr val="EEF2FF"/>
-          </a:solidFill>
-          <a:ln w="12700">
-            <a:solidFill>
-              <a:srgbClr val="E2E8F0"/>
-            </a:solidFill>
-          </a:ln>
-        </p:spPr>
-        <p:style>
-          <a:lnRef idx="1">
-            <a:schemeClr val="accent1"/>
-          </a:lnRef>
-          <a:fillRef idx="3">
-            <a:schemeClr val="accent1"/>
-          </a:fillRef>
-          <a:effectRef idx="2">
-            <a:schemeClr val="accent1"/>
-          </a:effectRef>
-          <a:fontRef idx="minor">
-            <a:schemeClr val="lt1"/>
-          </a:fontRef>
-        </p:style>
-        <p:txBody>
-          <a:bodyPr rtlCol="0" anchor="ctr" wrap="square"/>
-          <a:lstStyle/>
-          <a:p>
-            <a:pPr algn="ctr">
-              <a:defRPr sz="1300" b="1">
-                <a:solidFill>
-                  <a:srgbClr val="4F46E5"/>
-                </a:solidFill>
-              </a:defRPr>
-            </a:pPr>
-            <a:br/>
-            <a:br/>
-            <a:br/>
-            <a:br/>
-            <a:r>
-              <a:t>📸 [INSERT SCREENSHOT HERE: Login &amp; Sign Up Portal Page]</a:t>
-            </a:r>
-          </a:p>
-        </p:txBody>
-      </p:sp>
+        </p:nvPicPr>
+        <p:blipFill>
+          <a:blip r:embed="rId2"/>
+          <a:stretch>
+            <a:fillRect/>
+          </a:stretch>
+        </p:blipFill>
+        <p:spPr>
+          <a:xfrm>
+            <a:off x="6492240" y="1645920"/>
+            <a:ext cx="4937760" cy="2597359"/>
+          </a:xfrm>
+          <a:prstGeom prst="rect">
+            <a:avLst/>
+          </a:prstGeom>
+        </p:spPr>
+      </p:pic>
     </p:spTree>
   </p:cSld>
   <p:clrMapOvr>
@@ -8702,109 +7686,30 @@
           </a:p>
         </p:txBody>
       </p:sp>
-      <p:sp>
-        <p:nvSpPr>
-          <p:cNvPr id="6" name="Rounded Rectangle 5"/>
-          <p:cNvSpPr/>
+      <p:pic>
+        <p:nvPicPr>
+          <p:cNvPr id="6" name="Picture 5" descr="SLIDE_6_ROOM_EXPLORER.png"/>
+          <p:cNvPicPr>
+            <a:picLocks noChangeAspect="1"/>
+          </p:cNvPicPr>
           <p:nvPr/>
-        </p:nvSpPr>
-        <p:spPr>
-          <a:xfrm>
-            <a:off x="6400800" y="1645920"/>
-            <a:ext cx="5059375" cy="4754880"/>
-          </a:xfrm>
-          <a:prstGeom prst="roundRect">
-            <a:avLst/>
-          </a:prstGeom>
-          <a:solidFill>
-            <a:srgbClr val="FFFFFF"/>
-          </a:solidFill>
-          <a:ln w="25400">
-            <a:solidFill>
-              <a:srgbClr val="4F46E5"/>
-            </a:solidFill>
-          </a:ln>
-        </p:spPr>
-        <p:style>
-          <a:lnRef idx="1">
-            <a:schemeClr val="accent1"/>
-          </a:lnRef>
-          <a:fillRef idx="3">
-            <a:schemeClr val="accent1"/>
-          </a:fillRef>
-          <a:effectRef idx="2">
-            <a:schemeClr val="accent1"/>
-          </a:effectRef>
-          <a:fontRef idx="minor">
-            <a:schemeClr val="lt1"/>
-          </a:fontRef>
-        </p:style>
-        <p:txBody>
-          <a:bodyPr rtlCol="0" anchor="ctr"/>
-          <a:lstStyle/>
-          <a:p>
-            <a:pPr algn="ctr"/>
-          </a:p>
-        </p:txBody>
-      </p:sp>
-      <p:sp>
-        <p:nvSpPr>
-          <p:cNvPr id="7" name="Rounded Rectangle 6"/>
-          <p:cNvSpPr/>
-          <p:nvPr/>
-        </p:nvSpPr>
-        <p:spPr>
-          <a:xfrm>
-            <a:off x="6537960" y="1783080"/>
-            <a:ext cx="4785055" cy="4480560"/>
-          </a:xfrm>
-          <a:prstGeom prst="roundRect">
-            <a:avLst/>
-          </a:prstGeom>
-          <a:solidFill>
-            <a:srgbClr val="EEF2FF"/>
-          </a:solidFill>
-          <a:ln w="12700">
-            <a:solidFill>
-              <a:srgbClr val="E2E8F0"/>
-            </a:solidFill>
-          </a:ln>
-        </p:spPr>
-        <p:style>
-          <a:lnRef idx="1">
-            <a:schemeClr val="accent1"/>
-          </a:lnRef>
-          <a:fillRef idx="3">
-            <a:schemeClr val="accent1"/>
-          </a:fillRef>
-          <a:effectRef idx="2">
-            <a:schemeClr val="accent1"/>
-          </a:effectRef>
-          <a:fontRef idx="minor">
-            <a:schemeClr val="lt1"/>
-          </a:fontRef>
-        </p:style>
-        <p:txBody>
-          <a:bodyPr rtlCol="0" anchor="ctr" wrap="square"/>
-          <a:lstStyle/>
-          <a:p>
-            <a:pPr algn="ctr">
-              <a:defRPr sz="1300" b="1">
-                <a:solidFill>
-                  <a:srgbClr val="4F46E5"/>
-                </a:solidFill>
-              </a:defRPr>
-            </a:pPr>
-            <a:br/>
-            <a:br/>
-            <a:br/>
-            <a:br/>
-            <a:r>
-              <a:t>📸 [INSERT SCREENSHOT HERE: All-Rooms Explorer Grid View]</a:t>
-            </a:r>
-          </a:p>
-        </p:txBody>
-      </p:sp>
+        </p:nvPicPr>
+        <p:blipFill>
+          <a:blip r:embed="rId2"/>
+          <a:stretch>
+            <a:fillRect/>
+          </a:stretch>
+        </p:blipFill>
+        <p:spPr>
+          <a:xfrm>
+            <a:off x="6492240" y="1645920"/>
+            <a:ext cx="4937760" cy="2597359"/>
+          </a:xfrm>
+          <a:prstGeom prst="rect">
+            <a:avLst/>
+          </a:prstGeom>
+        </p:spPr>
+      </p:pic>
     </p:spTree>
   </p:cSld>
   <p:clrMapOvr>
@@ -9084,109 +7989,30 @@
           </a:p>
         </p:txBody>
       </p:sp>
-      <p:sp>
-        <p:nvSpPr>
-          <p:cNvPr id="6" name="Rounded Rectangle 5"/>
-          <p:cNvSpPr/>
+      <p:pic>
+        <p:nvPicPr>
+          <p:cNvPr id="6" name="Picture 5" descr="SLIDE_7_FILE_UPLOAD.png"/>
+          <p:cNvPicPr>
+            <a:picLocks noChangeAspect="1"/>
+          </p:cNvPicPr>
           <p:nvPr/>
-        </p:nvSpPr>
-        <p:spPr>
-          <a:xfrm>
-            <a:off x="6400800" y="1645920"/>
-            <a:ext cx="5059375" cy="4754880"/>
-          </a:xfrm>
-          <a:prstGeom prst="roundRect">
-            <a:avLst/>
-          </a:prstGeom>
-          <a:solidFill>
-            <a:srgbClr val="FFFFFF"/>
-          </a:solidFill>
-          <a:ln w="25400">
-            <a:solidFill>
-              <a:srgbClr val="4F46E5"/>
-            </a:solidFill>
-          </a:ln>
-        </p:spPr>
-        <p:style>
-          <a:lnRef idx="1">
-            <a:schemeClr val="accent1"/>
-          </a:lnRef>
-          <a:fillRef idx="3">
-            <a:schemeClr val="accent1"/>
-          </a:fillRef>
-          <a:effectRef idx="2">
-            <a:schemeClr val="accent1"/>
-          </a:effectRef>
-          <a:fontRef idx="minor">
-            <a:schemeClr val="lt1"/>
-          </a:fontRef>
-        </p:style>
-        <p:txBody>
-          <a:bodyPr rtlCol="0" anchor="ctr"/>
-          <a:lstStyle/>
-          <a:p>
-            <a:pPr algn="ctr"/>
-          </a:p>
-        </p:txBody>
-      </p:sp>
-      <p:sp>
-        <p:nvSpPr>
-          <p:cNvPr id="7" name="Rounded Rectangle 6"/>
-          <p:cNvSpPr/>
-          <p:nvPr/>
-        </p:nvSpPr>
-        <p:spPr>
-          <a:xfrm>
-            <a:off x="6537960" y="1783080"/>
-            <a:ext cx="4785055" cy="4480560"/>
-          </a:xfrm>
-          <a:prstGeom prst="roundRect">
-            <a:avLst/>
-          </a:prstGeom>
-          <a:solidFill>
-            <a:srgbClr val="EEF2FF"/>
-          </a:solidFill>
-          <a:ln w="12700">
-            <a:solidFill>
-              <a:srgbClr val="E2E8F0"/>
-            </a:solidFill>
-          </a:ln>
-        </p:spPr>
-        <p:style>
-          <a:lnRef idx="1">
-            <a:schemeClr val="accent1"/>
-          </a:lnRef>
-          <a:fillRef idx="3">
-            <a:schemeClr val="accent1"/>
-          </a:fillRef>
-          <a:effectRef idx="2">
-            <a:schemeClr val="accent1"/>
-          </a:effectRef>
-          <a:fontRef idx="minor">
-            <a:schemeClr val="lt1"/>
-          </a:fontRef>
-        </p:style>
-        <p:txBody>
-          <a:bodyPr rtlCol="0" anchor="ctr" wrap="square"/>
-          <a:lstStyle/>
-          <a:p>
-            <a:pPr algn="ctr">
-              <a:defRPr sz="1300" b="1">
-                <a:solidFill>
-                  <a:srgbClr val="4F46E5"/>
-                </a:solidFill>
-              </a:defRPr>
-            </a:pPr>
-            <a:br/>
-            <a:br/>
-            <a:br/>
-            <a:br/>
-            <a:r>
-              <a:t>📸 [INSERT SCREENSHOT HERE: Add/Edit Room Modal File Picker]</a:t>
-            </a:r>
-          </a:p>
-        </p:txBody>
-      </p:sp>
+        </p:nvPicPr>
+        <p:blipFill>
+          <a:blip r:embed="rId2"/>
+          <a:stretch>
+            <a:fillRect/>
+          </a:stretch>
+        </p:blipFill>
+        <p:spPr>
+          <a:xfrm>
+            <a:off x="6492240" y="1645920"/>
+            <a:ext cx="4937760" cy="3291840"/>
+          </a:xfrm>
+          <a:prstGeom prst="rect">
+            <a:avLst/>
+          </a:prstGeom>
+        </p:spPr>
+      </p:pic>
     </p:spTree>
   </p:cSld>
   <p:clrMapOvr>
@@ -9466,109 +8292,30 @@
           </a:p>
         </p:txBody>
       </p:sp>
-      <p:sp>
-        <p:nvSpPr>
-          <p:cNvPr id="6" name="Rounded Rectangle 5"/>
-          <p:cNvSpPr/>
+      <p:pic>
+        <p:nvPicPr>
+          <p:cNvPr id="6" name="Picture 5" descr="SLIDE_8_ROOM_BOOKING.png"/>
+          <p:cNvPicPr>
+            <a:picLocks noChangeAspect="1"/>
+          </p:cNvPicPr>
           <p:nvPr/>
-        </p:nvSpPr>
-        <p:spPr>
-          <a:xfrm>
-            <a:off x="6400800" y="1645920"/>
-            <a:ext cx="5059375" cy="4754880"/>
-          </a:xfrm>
-          <a:prstGeom prst="roundRect">
-            <a:avLst/>
-          </a:prstGeom>
-          <a:solidFill>
-            <a:srgbClr val="FFFFFF"/>
-          </a:solidFill>
-          <a:ln w="25400">
-            <a:solidFill>
-              <a:srgbClr val="4F46E5"/>
-            </a:solidFill>
-          </a:ln>
-        </p:spPr>
-        <p:style>
-          <a:lnRef idx="1">
-            <a:schemeClr val="accent1"/>
-          </a:lnRef>
-          <a:fillRef idx="3">
-            <a:schemeClr val="accent1"/>
-          </a:fillRef>
-          <a:effectRef idx="2">
-            <a:schemeClr val="accent1"/>
-          </a:effectRef>
-          <a:fontRef idx="minor">
-            <a:schemeClr val="lt1"/>
-          </a:fontRef>
-        </p:style>
-        <p:txBody>
-          <a:bodyPr rtlCol="0" anchor="ctr"/>
-          <a:lstStyle/>
-          <a:p>
-            <a:pPr algn="ctr"/>
-          </a:p>
-        </p:txBody>
-      </p:sp>
-      <p:sp>
-        <p:nvSpPr>
-          <p:cNvPr id="7" name="Rounded Rectangle 6"/>
-          <p:cNvSpPr/>
-          <p:nvPr/>
-        </p:nvSpPr>
-        <p:spPr>
-          <a:xfrm>
-            <a:off x="6537960" y="1783080"/>
-            <a:ext cx="4785055" cy="4480560"/>
-          </a:xfrm>
-          <a:prstGeom prst="roundRect">
-            <a:avLst/>
-          </a:prstGeom>
-          <a:solidFill>
-            <a:srgbClr val="EEF2FF"/>
-          </a:solidFill>
-          <a:ln w="12700">
-            <a:solidFill>
-              <a:srgbClr val="E2E8F0"/>
-            </a:solidFill>
-          </a:ln>
-        </p:spPr>
-        <p:style>
-          <a:lnRef idx="1">
-            <a:schemeClr val="accent1"/>
-          </a:lnRef>
-          <a:fillRef idx="3">
-            <a:schemeClr val="accent1"/>
-          </a:fillRef>
-          <a:effectRef idx="2">
-            <a:schemeClr val="accent1"/>
-          </a:effectRef>
-          <a:fontRef idx="minor">
-            <a:schemeClr val="lt1"/>
-          </a:fontRef>
-        </p:style>
-        <p:txBody>
-          <a:bodyPr rtlCol="0" anchor="ctr" wrap="square"/>
-          <a:lstStyle/>
-          <a:p>
-            <a:pPr algn="ctr">
-              <a:defRPr sz="1300" b="1">
-                <a:solidFill>
-                  <a:srgbClr val="4F46E5"/>
-                </a:solidFill>
-              </a:defRPr>
-            </a:pPr>
-            <a:br/>
-            <a:br/>
-            <a:br/>
-            <a:br/>
-            <a:r>
-              <a:t>📸 [INSERT SCREENSHOT HERE: Booking Side Panel &amp; Slot Picker]</a:t>
-            </a:r>
-          </a:p>
-        </p:txBody>
-      </p:sp>
+        </p:nvPicPr>
+        <p:blipFill>
+          <a:blip r:embed="rId2"/>
+          <a:stretch>
+            <a:fillRect/>
+          </a:stretch>
+        </p:blipFill>
+        <p:spPr>
+          <a:xfrm>
+            <a:off x="6492240" y="1645920"/>
+            <a:ext cx="4937760" cy="3291840"/>
+          </a:xfrm>
+          <a:prstGeom prst="rect">
+            <a:avLst/>
+          </a:prstGeom>
+        </p:spPr>
+      </p:pic>
     </p:spTree>
   </p:cSld>
   <p:clrMapOvr>
@@ -9848,109 +8595,30 @@
           </a:p>
         </p:txBody>
       </p:sp>
-      <p:sp>
-        <p:nvSpPr>
-          <p:cNvPr id="6" name="Rounded Rectangle 5"/>
-          <p:cNvSpPr/>
+      <p:pic>
+        <p:nvPicPr>
+          <p:cNvPr id="6" name="Picture 5" descr="SLIDE_9_AUTO_APPROVAL.png"/>
+          <p:cNvPicPr>
+            <a:picLocks noChangeAspect="1"/>
+          </p:cNvPicPr>
           <p:nvPr/>
-        </p:nvSpPr>
-        <p:spPr>
-          <a:xfrm>
-            <a:off x="6400800" y="1645920"/>
-            <a:ext cx="5059375" cy="4754880"/>
-          </a:xfrm>
-          <a:prstGeom prst="roundRect">
-            <a:avLst/>
-          </a:prstGeom>
-          <a:solidFill>
-            <a:srgbClr val="FFFFFF"/>
-          </a:solidFill>
-          <a:ln w="25400">
-            <a:solidFill>
-              <a:srgbClr val="4F46E5"/>
-            </a:solidFill>
-          </a:ln>
-        </p:spPr>
-        <p:style>
-          <a:lnRef idx="1">
-            <a:schemeClr val="accent1"/>
-          </a:lnRef>
-          <a:fillRef idx="3">
-            <a:schemeClr val="accent1"/>
-          </a:fillRef>
-          <a:effectRef idx="2">
-            <a:schemeClr val="accent1"/>
-          </a:effectRef>
-          <a:fontRef idx="minor">
-            <a:schemeClr val="lt1"/>
-          </a:fontRef>
-        </p:style>
-        <p:txBody>
-          <a:bodyPr rtlCol="0" anchor="ctr"/>
-          <a:lstStyle/>
-          <a:p>
-            <a:pPr algn="ctr"/>
-          </a:p>
-        </p:txBody>
-      </p:sp>
-      <p:sp>
-        <p:nvSpPr>
-          <p:cNvPr id="7" name="Rounded Rectangle 6"/>
-          <p:cNvSpPr/>
-          <p:nvPr/>
-        </p:nvSpPr>
-        <p:spPr>
-          <a:xfrm>
-            <a:off x="6537960" y="1783080"/>
-            <a:ext cx="4785055" cy="4480560"/>
-          </a:xfrm>
-          <a:prstGeom prst="roundRect">
-            <a:avLst/>
-          </a:prstGeom>
-          <a:solidFill>
-            <a:srgbClr val="EEF2FF"/>
-          </a:solidFill>
-          <a:ln w="12700">
-            <a:solidFill>
-              <a:srgbClr val="E2E8F0"/>
-            </a:solidFill>
-          </a:ln>
-        </p:spPr>
-        <p:style>
-          <a:lnRef idx="1">
-            <a:schemeClr val="accent1"/>
-          </a:lnRef>
-          <a:fillRef idx="3">
-            <a:schemeClr val="accent1"/>
-          </a:fillRef>
-          <a:effectRef idx="2">
-            <a:schemeClr val="accent1"/>
-          </a:effectRef>
-          <a:fontRef idx="minor">
-            <a:schemeClr val="lt1"/>
-          </a:fontRef>
-        </p:style>
-        <p:txBody>
-          <a:bodyPr rtlCol="0" anchor="ctr" wrap="square"/>
-          <a:lstStyle/>
-          <a:p>
-            <a:pPr algn="ctr">
-              <a:defRPr sz="1300" b="1">
-                <a:solidFill>
-                  <a:srgbClr val="4F46E5"/>
-                </a:solidFill>
-              </a:defRPr>
-            </a:pPr>
-            <a:br/>
-            <a:br/>
-            <a:br/>
-            <a:br/>
-            <a:r>
-              <a:t>📸 [INSERT SCREENSHOT HERE: Booking List showing Auto-Approved Badge]</a:t>
-            </a:r>
-          </a:p>
-        </p:txBody>
-      </p:sp>
+        </p:nvPicPr>
+        <p:blipFill>
+          <a:blip r:embed="rId2"/>
+          <a:stretch>
+            <a:fillRect/>
+          </a:stretch>
+        </p:blipFill>
+        <p:spPr>
+          <a:xfrm>
+            <a:off x="6492240" y="1645920"/>
+            <a:ext cx="4937760" cy="2597359"/>
+          </a:xfrm>
+          <a:prstGeom prst="rect">
+            <a:avLst/>
+          </a:prstGeom>
+        </p:spPr>
+      </p:pic>
     </p:spTree>
   </p:cSld>
   <p:clrMapOvr>

</xml_diff>

<commit_message>
docs: restore initial PowerPoint presentation deck with screenshot placeholder cards
</commit_message>
<xml_diff>
--- a/document/PRESENTATION_DECK_SLIDES.pptx
+++ b/document/PRESENTATION_DECK_SLIDES.pptx
@@ -3375,30 +3375,64 @@
           </a:p>
         </p:txBody>
       </p:sp>
-      <p:pic>
-        <p:nvPicPr>
-          <p:cNvPr id="6" name="Picture 5" descr="SLIDE_1_HERO.png"/>
-          <p:cNvPicPr>
-            <a:picLocks noChangeAspect="1"/>
-          </p:cNvPicPr>
-          <p:nvPr/>
-        </p:nvPicPr>
-        <p:blipFill>
-          <a:blip r:embed="rId2"/>
-          <a:stretch>
-            <a:fillRect/>
-          </a:stretch>
-        </p:blipFill>
+      <p:sp>
+        <p:nvSpPr>
+          <p:cNvPr id="6" name="Rounded Rectangle 5"/>
+          <p:cNvSpPr/>
+          <p:nvPr/>
+        </p:nvSpPr>
         <p:spPr>
           <a:xfrm>
             <a:off x="6492240" y="1325880"/>
-            <a:ext cx="4937760" cy="2597359"/>
-          </a:xfrm>
-          <a:prstGeom prst="rect">
-            <a:avLst/>
-          </a:prstGeom>
-        </p:spPr>
-      </p:pic>
+            <a:ext cx="4937760" cy="4983480"/>
+          </a:xfrm>
+          <a:prstGeom prst="roundRect">
+            <a:avLst/>
+          </a:prstGeom>
+          <a:solidFill>
+            <a:srgbClr val="EEF2FF"/>
+          </a:solidFill>
+          <a:ln w="25400">
+            <a:solidFill>
+              <a:srgbClr val="4F46E5"/>
+            </a:solidFill>
+          </a:ln>
+        </p:spPr>
+        <p:style>
+          <a:lnRef idx="1">
+            <a:schemeClr val="accent1"/>
+          </a:lnRef>
+          <a:fillRef idx="3">
+            <a:schemeClr val="accent1"/>
+          </a:fillRef>
+          <a:effectRef idx="2">
+            <a:schemeClr val="accent1"/>
+          </a:effectRef>
+          <a:fontRef idx="minor">
+            <a:schemeClr val="lt1"/>
+          </a:fontRef>
+        </p:style>
+        <p:txBody>
+          <a:bodyPr rtlCol="0" anchor="ctr" wrap="square"/>
+          <a:lstStyle/>
+          <a:p>
+            <a:pPr algn="ctr">
+              <a:defRPr sz="1300" b="1">
+                <a:solidFill>
+                  <a:srgbClr val="4F46E5"/>
+                </a:solidFill>
+              </a:defRPr>
+            </a:pPr>
+            <a:br/>
+            <a:br/>
+            <a:br/>
+            <a:br/>
+            <a:r>
+              <a:t>📸 [INSERT SCREENSHOT HERE: Lumina Reserve App Logo &amp; Hero Homepage]</a:t>
+            </a:r>
+          </a:p>
+        </p:txBody>
+      </p:sp>
     </p:spTree>
   </p:cSld>
   <p:clrMapOvr>
@@ -3678,30 +3712,109 @@
           </a:p>
         </p:txBody>
       </p:sp>
-      <p:pic>
-        <p:nvPicPr>
-          <p:cNvPr id="6" name="Picture 5" descr="SLIDE_9_AUTO_APPROVAL.png"/>
-          <p:cNvPicPr>
-            <a:picLocks noChangeAspect="1"/>
-          </p:cNvPicPr>
-          <p:nvPr/>
-        </p:nvPicPr>
-        <p:blipFill>
-          <a:blip r:embed="rId2"/>
-          <a:stretch>
-            <a:fillRect/>
-          </a:stretch>
-        </p:blipFill>
-        <p:spPr>
-          <a:xfrm>
-            <a:off x="6492240" y="1645920"/>
-            <a:ext cx="4937760" cy="2597359"/>
-          </a:xfrm>
-          <a:prstGeom prst="rect">
-            <a:avLst/>
-          </a:prstGeom>
-        </p:spPr>
-      </p:pic>
+      <p:sp>
+        <p:nvSpPr>
+          <p:cNvPr id="6" name="Rounded Rectangle 5"/>
+          <p:cNvSpPr/>
+          <p:nvPr/>
+        </p:nvSpPr>
+        <p:spPr>
+          <a:xfrm>
+            <a:off x="6400800" y="1645920"/>
+            <a:ext cx="5059375" cy="4754880"/>
+          </a:xfrm>
+          <a:prstGeom prst="roundRect">
+            <a:avLst/>
+          </a:prstGeom>
+          <a:solidFill>
+            <a:srgbClr val="FFFFFF"/>
+          </a:solidFill>
+          <a:ln w="25400">
+            <a:solidFill>
+              <a:srgbClr val="4F46E5"/>
+            </a:solidFill>
+          </a:ln>
+        </p:spPr>
+        <p:style>
+          <a:lnRef idx="1">
+            <a:schemeClr val="accent1"/>
+          </a:lnRef>
+          <a:fillRef idx="3">
+            <a:schemeClr val="accent1"/>
+          </a:fillRef>
+          <a:effectRef idx="2">
+            <a:schemeClr val="accent1"/>
+          </a:effectRef>
+          <a:fontRef idx="minor">
+            <a:schemeClr val="lt1"/>
+          </a:fontRef>
+        </p:style>
+        <p:txBody>
+          <a:bodyPr rtlCol="0" anchor="ctr"/>
+          <a:lstStyle/>
+          <a:p>
+            <a:pPr algn="ctr"/>
+          </a:p>
+        </p:txBody>
+      </p:sp>
+      <p:sp>
+        <p:nvSpPr>
+          <p:cNvPr id="7" name="Rounded Rectangle 6"/>
+          <p:cNvSpPr/>
+          <p:nvPr/>
+        </p:nvSpPr>
+        <p:spPr>
+          <a:xfrm>
+            <a:off x="6537960" y="1783080"/>
+            <a:ext cx="4785055" cy="4480560"/>
+          </a:xfrm>
+          <a:prstGeom prst="roundRect">
+            <a:avLst/>
+          </a:prstGeom>
+          <a:solidFill>
+            <a:srgbClr val="EEF2FF"/>
+          </a:solidFill>
+          <a:ln w="12700">
+            <a:solidFill>
+              <a:srgbClr val="E2E8F0"/>
+            </a:solidFill>
+          </a:ln>
+        </p:spPr>
+        <p:style>
+          <a:lnRef idx="1">
+            <a:schemeClr val="accent1"/>
+          </a:lnRef>
+          <a:fillRef idx="3">
+            <a:schemeClr val="accent1"/>
+          </a:fillRef>
+          <a:effectRef idx="2">
+            <a:schemeClr val="accent1"/>
+          </a:effectRef>
+          <a:fontRef idx="minor">
+            <a:schemeClr val="lt1"/>
+          </a:fontRef>
+        </p:style>
+        <p:txBody>
+          <a:bodyPr rtlCol="0" anchor="ctr" wrap="square"/>
+          <a:lstStyle/>
+          <a:p>
+            <a:pPr algn="ctr">
+              <a:defRPr sz="1300" b="1">
+                <a:solidFill>
+                  <a:srgbClr val="4F46E5"/>
+                </a:solidFill>
+              </a:defRPr>
+            </a:pPr>
+            <a:br/>
+            <a:br/>
+            <a:br/>
+            <a:br/>
+            <a:r>
+              <a:t>📸 [INSERT SCREENSHOT HERE: WhatsApp Button &amp; Pre-Filled Text Preview]</a:t>
+            </a:r>
+          </a:p>
+        </p:txBody>
+      </p:sp>
     </p:spTree>
   </p:cSld>
   <p:clrMapOvr>
@@ -3981,30 +4094,109 @@
           </a:p>
         </p:txBody>
       </p:sp>
-      <p:pic>
-        <p:nvPicPr>
-          <p:cNvPr id="6" name="Picture 5" descr="SLIDE_11_EDIT_MEMBERS.png"/>
-          <p:cNvPicPr>
-            <a:picLocks noChangeAspect="1"/>
-          </p:cNvPicPr>
-          <p:nvPr/>
-        </p:nvPicPr>
-        <p:blipFill>
-          <a:blip r:embed="rId2"/>
-          <a:stretch>
-            <a:fillRect/>
-          </a:stretch>
-        </p:blipFill>
-        <p:spPr>
-          <a:xfrm>
-            <a:off x="6492240" y="1645920"/>
-            <a:ext cx="4937760" cy="3291840"/>
-          </a:xfrm>
-          <a:prstGeom prst="rect">
-            <a:avLst/>
-          </a:prstGeom>
-        </p:spPr>
-      </p:pic>
+      <p:sp>
+        <p:nvSpPr>
+          <p:cNvPr id="6" name="Rounded Rectangle 5"/>
+          <p:cNvSpPr/>
+          <p:nvPr/>
+        </p:nvSpPr>
+        <p:spPr>
+          <a:xfrm>
+            <a:off x="6400800" y="1645920"/>
+            <a:ext cx="5059375" cy="4754880"/>
+          </a:xfrm>
+          <a:prstGeom prst="roundRect">
+            <a:avLst/>
+          </a:prstGeom>
+          <a:solidFill>
+            <a:srgbClr val="FFFFFF"/>
+          </a:solidFill>
+          <a:ln w="25400">
+            <a:solidFill>
+              <a:srgbClr val="4F46E5"/>
+            </a:solidFill>
+          </a:ln>
+        </p:spPr>
+        <p:style>
+          <a:lnRef idx="1">
+            <a:schemeClr val="accent1"/>
+          </a:lnRef>
+          <a:fillRef idx="3">
+            <a:schemeClr val="accent1"/>
+          </a:fillRef>
+          <a:effectRef idx="2">
+            <a:schemeClr val="accent1"/>
+          </a:effectRef>
+          <a:fontRef idx="minor">
+            <a:schemeClr val="lt1"/>
+          </a:fontRef>
+        </p:style>
+        <p:txBody>
+          <a:bodyPr rtlCol="0" anchor="ctr"/>
+          <a:lstStyle/>
+          <a:p>
+            <a:pPr algn="ctr"/>
+          </a:p>
+        </p:txBody>
+      </p:sp>
+      <p:sp>
+        <p:nvSpPr>
+          <p:cNvPr id="7" name="Rounded Rectangle 6"/>
+          <p:cNvSpPr/>
+          <p:nvPr/>
+        </p:nvSpPr>
+        <p:spPr>
+          <a:xfrm>
+            <a:off x="6537960" y="1783080"/>
+            <a:ext cx="4785055" cy="4480560"/>
+          </a:xfrm>
+          <a:prstGeom prst="roundRect">
+            <a:avLst/>
+          </a:prstGeom>
+          <a:solidFill>
+            <a:srgbClr val="EEF2FF"/>
+          </a:solidFill>
+          <a:ln w="12700">
+            <a:solidFill>
+              <a:srgbClr val="E2E8F0"/>
+            </a:solidFill>
+          </a:ln>
+        </p:spPr>
+        <p:style>
+          <a:lnRef idx="1">
+            <a:schemeClr val="accent1"/>
+          </a:lnRef>
+          <a:fillRef idx="3">
+            <a:schemeClr val="accent1"/>
+          </a:fillRef>
+          <a:effectRef idx="2">
+            <a:schemeClr val="accent1"/>
+          </a:effectRef>
+          <a:fontRef idx="minor">
+            <a:schemeClr val="lt1"/>
+          </a:fontRef>
+        </p:style>
+        <p:txBody>
+          <a:bodyPr rtlCol="0" anchor="ctr" wrap="square"/>
+          <a:lstStyle/>
+          <a:p>
+            <a:pPr algn="ctr">
+              <a:defRPr sz="1300" b="1">
+                <a:solidFill>
+                  <a:srgbClr val="4F46E5"/>
+                </a:solidFill>
+              </a:defRPr>
+            </a:pPr>
+            <a:br/>
+            <a:br/>
+            <a:br/>
+            <a:br/>
+            <a:r>
+              <a:t>📸 [INSERT SCREENSHOT HERE: Edit Participants Modal]</a:t>
+            </a:r>
+          </a:p>
+        </p:txBody>
+      </p:sp>
     </p:spTree>
   </p:cSld>
   <p:clrMapOvr>
@@ -4284,30 +4476,109 @@
           </a:p>
         </p:txBody>
       </p:sp>
-      <p:pic>
-        <p:nvPicPr>
-          <p:cNvPr id="6" name="Picture 5" descr="SLIDE_12_MANAGER_QUEUE.png"/>
-          <p:cNvPicPr>
-            <a:picLocks noChangeAspect="1"/>
-          </p:cNvPicPr>
-          <p:nvPr/>
-        </p:nvPicPr>
-        <p:blipFill>
-          <a:blip r:embed="rId2"/>
-          <a:stretch>
-            <a:fillRect/>
-          </a:stretch>
-        </p:blipFill>
-        <p:spPr>
-          <a:xfrm>
-            <a:off x="6492240" y="1645920"/>
-            <a:ext cx="4937760" cy="2597359"/>
-          </a:xfrm>
-          <a:prstGeom prst="rect">
-            <a:avLst/>
-          </a:prstGeom>
-        </p:spPr>
-      </p:pic>
+      <p:sp>
+        <p:nvSpPr>
+          <p:cNvPr id="6" name="Rounded Rectangle 5"/>
+          <p:cNvSpPr/>
+          <p:nvPr/>
+        </p:nvSpPr>
+        <p:spPr>
+          <a:xfrm>
+            <a:off x="6400800" y="1645920"/>
+            <a:ext cx="5059375" cy="4754880"/>
+          </a:xfrm>
+          <a:prstGeom prst="roundRect">
+            <a:avLst/>
+          </a:prstGeom>
+          <a:solidFill>
+            <a:srgbClr val="FFFFFF"/>
+          </a:solidFill>
+          <a:ln w="25400">
+            <a:solidFill>
+              <a:srgbClr val="4F46E5"/>
+            </a:solidFill>
+          </a:ln>
+        </p:spPr>
+        <p:style>
+          <a:lnRef idx="1">
+            <a:schemeClr val="accent1"/>
+          </a:lnRef>
+          <a:fillRef idx="3">
+            <a:schemeClr val="accent1"/>
+          </a:fillRef>
+          <a:effectRef idx="2">
+            <a:schemeClr val="accent1"/>
+          </a:effectRef>
+          <a:fontRef idx="minor">
+            <a:schemeClr val="lt1"/>
+          </a:fontRef>
+        </p:style>
+        <p:txBody>
+          <a:bodyPr rtlCol="0" anchor="ctr"/>
+          <a:lstStyle/>
+          <a:p>
+            <a:pPr algn="ctr"/>
+          </a:p>
+        </p:txBody>
+      </p:sp>
+      <p:sp>
+        <p:nvSpPr>
+          <p:cNvPr id="7" name="Rounded Rectangle 6"/>
+          <p:cNvSpPr/>
+          <p:nvPr/>
+        </p:nvSpPr>
+        <p:spPr>
+          <a:xfrm>
+            <a:off x="6537960" y="1783080"/>
+            <a:ext cx="4785055" cy="4480560"/>
+          </a:xfrm>
+          <a:prstGeom prst="roundRect">
+            <a:avLst/>
+          </a:prstGeom>
+          <a:solidFill>
+            <a:srgbClr val="EEF2FF"/>
+          </a:solidFill>
+          <a:ln w="12700">
+            <a:solidFill>
+              <a:srgbClr val="E2E8F0"/>
+            </a:solidFill>
+          </a:ln>
+        </p:spPr>
+        <p:style>
+          <a:lnRef idx="1">
+            <a:schemeClr val="accent1"/>
+          </a:lnRef>
+          <a:fillRef idx="3">
+            <a:schemeClr val="accent1"/>
+          </a:fillRef>
+          <a:effectRef idx="2">
+            <a:schemeClr val="accent1"/>
+          </a:effectRef>
+          <a:fontRef idx="minor">
+            <a:schemeClr val="lt1"/>
+          </a:fontRef>
+        </p:style>
+        <p:txBody>
+          <a:bodyPr rtlCol="0" anchor="ctr" wrap="square"/>
+          <a:lstStyle/>
+          <a:p>
+            <a:pPr algn="ctr">
+              <a:defRPr sz="1300" b="1">
+                <a:solidFill>
+                  <a:srgbClr val="4F46E5"/>
+                </a:solidFill>
+              </a:defRPr>
+            </a:pPr>
+            <a:br/>
+            <a:br/>
+            <a:br/>
+            <a:br/>
+            <a:r>
+              <a:t>📸 [INSERT SCREENSHOT HERE: Manager Dashboard Approval Queue]</a:t>
+            </a:r>
+          </a:p>
+        </p:txBody>
+      </p:sp>
     </p:spTree>
   </p:cSld>
   <p:clrMapOvr>
@@ -4587,30 +4858,109 @@
           </a:p>
         </p:txBody>
       </p:sp>
-      <p:pic>
-        <p:nvPicPr>
-          <p:cNvPr id="6" name="Picture 5" descr="SLIDE_13_ROOM_HISTORY.png"/>
-          <p:cNvPicPr>
-            <a:picLocks noChangeAspect="1"/>
-          </p:cNvPicPr>
-          <p:nvPr/>
-        </p:nvPicPr>
-        <p:blipFill>
-          <a:blip r:embed="rId2"/>
-          <a:stretch>
-            <a:fillRect/>
-          </a:stretch>
-        </p:blipFill>
-        <p:spPr>
-          <a:xfrm>
-            <a:off x="6492240" y="1645920"/>
-            <a:ext cx="4937760" cy="3291840"/>
-          </a:xfrm>
-          <a:prstGeom prst="rect">
-            <a:avLst/>
-          </a:prstGeom>
-        </p:spPr>
-      </p:pic>
+      <p:sp>
+        <p:nvSpPr>
+          <p:cNvPr id="6" name="Rounded Rectangle 5"/>
+          <p:cNvSpPr/>
+          <p:nvPr/>
+        </p:nvSpPr>
+        <p:spPr>
+          <a:xfrm>
+            <a:off x="6400800" y="1645920"/>
+            <a:ext cx="5059375" cy="4754880"/>
+          </a:xfrm>
+          <a:prstGeom prst="roundRect">
+            <a:avLst/>
+          </a:prstGeom>
+          <a:solidFill>
+            <a:srgbClr val="FFFFFF"/>
+          </a:solidFill>
+          <a:ln w="25400">
+            <a:solidFill>
+              <a:srgbClr val="4F46E5"/>
+            </a:solidFill>
+          </a:ln>
+        </p:spPr>
+        <p:style>
+          <a:lnRef idx="1">
+            <a:schemeClr val="accent1"/>
+          </a:lnRef>
+          <a:fillRef idx="3">
+            <a:schemeClr val="accent1"/>
+          </a:fillRef>
+          <a:effectRef idx="2">
+            <a:schemeClr val="accent1"/>
+          </a:effectRef>
+          <a:fontRef idx="minor">
+            <a:schemeClr val="lt1"/>
+          </a:fontRef>
+        </p:style>
+        <p:txBody>
+          <a:bodyPr rtlCol="0" anchor="ctr"/>
+          <a:lstStyle/>
+          <a:p>
+            <a:pPr algn="ctr"/>
+          </a:p>
+        </p:txBody>
+      </p:sp>
+      <p:sp>
+        <p:nvSpPr>
+          <p:cNvPr id="7" name="Rounded Rectangle 6"/>
+          <p:cNvSpPr/>
+          <p:nvPr/>
+        </p:nvSpPr>
+        <p:spPr>
+          <a:xfrm>
+            <a:off x="6537960" y="1783080"/>
+            <a:ext cx="4785055" cy="4480560"/>
+          </a:xfrm>
+          <a:prstGeom prst="roundRect">
+            <a:avLst/>
+          </a:prstGeom>
+          <a:solidFill>
+            <a:srgbClr val="EEF2FF"/>
+          </a:solidFill>
+          <a:ln w="12700">
+            <a:solidFill>
+              <a:srgbClr val="E2E8F0"/>
+            </a:solidFill>
+          </a:ln>
+        </p:spPr>
+        <p:style>
+          <a:lnRef idx="1">
+            <a:schemeClr val="accent1"/>
+          </a:lnRef>
+          <a:fillRef idx="3">
+            <a:schemeClr val="accent1"/>
+          </a:fillRef>
+          <a:effectRef idx="2">
+            <a:schemeClr val="accent1"/>
+          </a:effectRef>
+          <a:fontRef idx="minor">
+            <a:schemeClr val="lt1"/>
+          </a:fontRef>
+        </p:style>
+        <p:txBody>
+          <a:bodyPr rtlCol="0" anchor="ctr" wrap="square"/>
+          <a:lstStyle/>
+          <a:p>
+            <a:pPr algn="ctr">
+              <a:defRPr sz="1300" b="1">
+                <a:solidFill>
+                  <a:srgbClr val="4F46E5"/>
+                </a:solidFill>
+              </a:defRPr>
+            </a:pPr>
+            <a:br/>
+            <a:br/>
+            <a:br/>
+            <a:br/>
+            <a:r>
+              <a:t>📸 [INSERT SCREENSHOT HERE: Room History Audit Log Modal]</a:t>
+            </a:r>
+          </a:p>
+        </p:txBody>
+      </p:sp>
     </p:spTree>
   </p:cSld>
   <p:clrMapOvr>
@@ -4890,30 +5240,109 @@
           </a:p>
         </p:txBody>
       </p:sp>
-      <p:pic>
-        <p:nvPicPr>
-          <p:cNvPr id="6" name="Picture 5" descr="SLIDE_12_MANAGER_QUEUE.png"/>
-          <p:cNvPicPr>
-            <a:picLocks noChangeAspect="1"/>
-          </p:cNvPicPr>
-          <p:nvPr/>
-        </p:nvPicPr>
-        <p:blipFill>
-          <a:blip r:embed="rId2"/>
-          <a:stretch>
-            <a:fillRect/>
-          </a:stretch>
-        </p:blipFill>
-        <p:spPr>
-          <a:xfrm>
-            <a:off x="6492240" y="1645920"/>
-            <a:ext cx="4937760" cy="2597359"/>
-          </a:xfrm>
-          <a:prstGeom prst="rect">
-            <a:avLst/>
-          </a:prstGeom>
-        </p:spPr>
-      </p:pic>
+      <p:sp>
+        <p:nvSpPr>
+          <p:cNvPr id="6" name="Rounded Rectangle 5"/>
+          <p:cNvSpPr/>
+          <p:nvPr/>
+        </p:nvSpPr>
+        <p:spPr>
+          <a:xfrm>
+            <a:off x="6400800" y="1645920"/>
+            <a:ext cx="5059375" cy="4754880"/>
+          </a:xfrm>
+          <a:prstGeom prst="roundRect">
+            <a:avLst/>
+          </a:prstGeom>
+          <a:solidFill>
+            <a:srgbClr val="FFFFFF"/>
+          </a:solidFill>
+          <a:ln w="25400">
+            <a:solidFill>
+              <a:srgbClr val="4F46E5"/>
+            </a:solidFill>
+          </a:ln>
+        </p:spPr>
+        <p:style>
+          <a:lnRef idx="1">
+            <a:schemeClr val="accent1"/>
+          </a:lnRef>
+          <a:fillRef idx="3">
+            <a:schemeClr val="accent1"/>
+          </a:fillRef>
+          <a:effectRef idx="2">
+            <a:schemeClr val="accent1"/>
+          </a:effectRef>
+          <a:fontRef idx="minor">
+            <a:schemeClr val="lt1"/>
+          </a:fontRef>
+        </p:style>
+        <p:txBody>
+          <a:bodyPr rtlCol="0" anchor="ctr"/>
+          <a:lstStyle/>
+          <a:p>
+            <a:pPr algn="ctr"/>
+          </a:p>
+        </p:txBody>
+      </p:sp>
+      <p:sp>
+        <p:nvSpPr>
+          <p:cNvPr id="7" name="Rounded Rectangle 6"/>
+          <p:cNvSpPr/>
+          <p:nvPr/>
+        </p:nvSpPr>
+        <p:spPr>
+          <a:xfrm>
+            <a:off x="6537960" y="1783080"/>
+            <a:ext cx="4785055" cy="4480560"/>
+          </a:xfrm>
+          <a:prstGeom prst="roundRect">
+            <a:avLst/>
+          </a:prstGeom>
+          <a:solidFill>
+            <a:srgbClr val="EEF2FF"/>
+          </a:solidFill>
+          <a:ln w="12700">
+            <a:solidFill>
+              <a:srgbClr val="E2E8F0"/>
+            </a:solidFill>
+          </a:ln>
+        </p:spPr>
+        <p:style>
+          <a:lnRef idx="1">
+            <a:schemeClr val="accent1"/>
+          </a:lnRef>
+          <a:fillRef idx="3">
+            <a:schemeClr val="accent1"/>
+          </a:fillRef>
+          <a:effectRef idx="2">
+            <a:schemeClr val="accent1"/>
+          </a:effectRef>
+          <a:fontRef idx="minor">
+            <a:schemeClr val="lt1"/>
+          </a:fontRef>
+        </p:style>
+        <p:txBody>
+          <a:bodyPr rtlCol="0" anchor="ctr" wrap="square"/>
+          <a:lstStyle/>
+          <a:p>
+            <a:pPr algn="ctr">
+              <a:defRPr sz="1300" b="1">
+                <a:solidFill>
+                  <a:srgbClr val="4F46E5"/>
+                </a:solidFill>
+              </a:defRPr>
+            </a:pPr>
+            <a:br/>
+            <a:br/>
+            <a:br/>
+            <a:br/>
+            <a:r>
+              <a:t>📸 [INSERT SCREENSHOT HERE: Room Supplies Status Cards Grid]</a:t>
+            </a:r>
+          </a:p>
+        </p:txBody>
+      </p:sp>
     </p:spTree>
   </p:cSld>
   <p:clrMapOvr>
@@ -5193,30 +5622,109 @@
           </a:p>
         </p:txBody>
       </p:sp>
-      <p:pic>
-        <p:nvPicPr>
-          <p:cNvPr id="6" name="Picture 5" descr="SLIDE_15_GMAIL_CALENDAR.png"/>
-          <p:cNvPicPr>
-            <a:picLocks noChangeAspect="1"/>
-          </p:cNvPicPr>
-          <p:nvPr/>
-        </p:nvPicPr>
-        <p:blipFill>
-          <a:blip r:embed="rId2"/>
-          <a:stretch>
-            <a:fillRect/>
-          </a:stretch>
-        </p:blipFill>
-        <p:spPr>
-          <a:xfrm>
-            <a:off x="6492240" y="1645920"/>
-            <a:ext cx="4937760" cy="2597359"/>
-          </a:xfrm>
-          <a:prstGeom prst="rect">
-            <a:avLst/>
-          </a:prstGeom>
-        </p:spPr>
-      </p:pic>
+      <p:sp>
+        <p:nvSpPr>
+          <p:cNvPr id="6" name="Rounded Rectangle 5"/>
+          <p:cNvSpPr/>
+          <p:nvPr/>
+        </p:nvSpPr>
+        <p:spPr>
+          <a:xfrm>
+            <a:off x="6400800" y="1645920"/>
+            <a:ext cx="5059375" cy="4754880"/>
+          </a:xfrm>
+          <a:prstGeom prst="roundRect">
+            <a:avLst/>
+          </a:prstGeom>
+          <a:solidFill>
+            <a:srgbClr val="FFFFFF"/>
+          </a:solidFill>
+          <a:ln w="25400">
+            <a:solidFill>
+              <a:srgbClr val="4F46E5"/>
+            </a:solidFill>
+          </a:ln>
+        </p:spPr>
+        <p:style>
+          <a:lnRef idx="1">
+            <a:schemeClr val="accent1"/>
+          </a:lnRef>
+          <a:fillRef idx="3">
+            <a:schemeClr val="accent1"/>
+          </a:fillRef>
+          <a:effectRef idx="2">
+            <a:schemeClr val="accent1"/>
+          </a:effectRef>
+          <a:fontRef idx="minor">
+            <a:schemeClr val="lt1"/>
+          </a:fontRef>
+        </p:style>
+        <p:txBody>
+          <a:bodyPr rtlCol="0" anchor="ctr"/>
+          <a:lstStyle/>
+          <a:p>
+            <a:pPr algn="ctr"/>
+          </a:p>
+        </p:txBody>
+      </p:sp>
+      <p:sp>
+        <p:nvSpPr>
+          <p:cNvPr id="7" name="Rounded Rectangle 6"/>
+          <p:cNvSpPr/>
+          <p:nvPr/>
+        </p:nvSpPr>
+        <p:spPr>
+          <a:xfrm>
+            <a:off x="6537960" y="1783080"/>
+            <a:ext cx="4785055" cy="4480560"/>
+          </a:xfrm>
+          <a:prstGeom prst="roundRect">
+            <a:avLst/>
+          </a:prstGeom>
+          <a:solidFill>
+            <a:srgbClr val="EEF2FF"/>
+          </a:solidFill>
+          <a:ln w="12700">
+            <a:solidFill>
+              <a:srgbClr val="E2E8F0"/>
+            </a:solidFill>
+          </a:ln>
+        </p:spPr>
+        <p:style>
+          <a:lnRef idx="1">
+            <a:schemeClr val="accent1"/>
+          </a:lnRef>
+          <a:fillRef idx="3">
+            <a:schemeClr val="accent1"/>
+          </a:fillRef>
+          <a:effectRef idx="2">
+            <a:schemeClr val="accent1"/>
+          </a:effectRef>
+          <a:fontRef idx="minor">
+            <a:schemeClr val="lt1"/>
+          </a:fontRef>
+        </p:style>
+        <p:txBody>
+          <a:bodyPr rtlCol="0" anchor="ctr" wrap="square"/>
+          <a:lstStyle/>
+          <a:p>
+            <a:pPr algn="ctr">
+              <a:defRPr sz="1300" b="1">
+                <a:solidFill>
+                  <a:srgbClr val="4F46E5"/>
+                </a:solidFill>
+              </a:defRPr>
+            </a:pPr>
+            <a:br/>
+            <a:br/>
+            <a:br/>
+            <a:br/>
+            <a:r>
+              <a:t>📸 [INSERT SCREENSHOT HERE: Gmail Confirmation Email in Inbox]</a:t>
+            </a:r>
+          </a:p>
+        </p:txBody>
+      </p:sp>
     </p:spTree>
   </p:cSld>
   <p:clrMapOvr>
@@ -5511,30 +6019,109 @@
           </a:p>
         </p:txBody>
       </p:sp>
-      <p:pic>
-        <p:nvPicPr>
-          <p:cNvPr id="6" name="Picture 5" descr="SLIDE_15_GMAIL_CALENDAR.png"/>
-          <p:cNvPicPr>
-            <a:picLocks noChangeAspect="1"/>
-          </p:cNvPicPr>
-          <p:nvPr/>
-        </p:nvPicPr>
-        <p:blipFill>
-          <a:blip r:embed="rId2"/>
-          <a:stretch>
-            <a:fillRect/>
-          </a:stretch>
-        </p:blipFill>
-        <p:spPr>
-          <a:xfrm>
-            <a:off x="6492240" y="1645920"/>
-            <a:ext cx="4937760" cy="2597359"/>
-          </a:xfrm>
-          <a:prstGeom prst="rect">
-            <a:avLst/>
-          </a:prstGeom>
-        </p:spPr>
-      </p:pic>
+      <p:sp>
+        <p:nvSpPr>
+          <p:cNvPr id="6" name="Rounded Rectangle 5"/>
+          <p:cNvSpPr/>
+          <p:nvPr/>
+        </p:nvSpPr>
+        <p:spPr>
+          <a:xfrm>
+            <a:off x="6400800" y="1645920"/>
+            <a:ext cx="5059375" cy="4754880"/>
+          </a:xfrm>
+          <a:prstGeom prst="roundRect">
+            <a:avLst/>
+          </a:prstGeom>
+          <a:solidFill>
+            <a:srgbClr val="FFFFFF"/>
+          </a:solidFill>
+          <a:ln w="25400">
+            <a:solidFill>
+              <a:srgbClr val="4F46E5"/>
+            </a:solidFill>
+          </a:ln>
+        </p:spPr>
+        <p:style>
+          <a:lnRef idx="1">
+            <a:schemeClr val="accent1"/>
+          </a:lnRef>
+          <a:fillRef idx="3">
+            <a:schemeClr val="accent1"/>
+          </a:fillRef>
+          <a:effectRef idx="2">
+            <a:schemeClr val="accent1"/>
+          </a:effectRef>
+          <a:fontRef idx="minor">
+            <a:schemeClr val="lt1"/>
+          </a:fontRef>
+        </p:style>
+        <p:txBody>
+          <a:bodyPr rtlCol="0" anchor="ctr"/>
+          <a:lstStyle/>
+          <a:p>
+            <a:pPr algn="ctr"/>
+          </a:p>
+        </p:txBody>
+      </p:sp>
+      <p:sp>
+        <p:nvSpPr>
+          <p:cNvPr id="7" name="Rounded Rectangle 6"/>
+          <p:cNvSpPr/>
+          <p:nvPr/>
+        </p:nvSpPr>
+        <p:spPr>
+          <a:xfrm>
+            <a:off x="6537960" y="1783080"/>
+            <a:ext cx="4785055" cy="4480560"/>
+          </a:xfrm>
+          <a:prstGeom prst="roundRect">
+            <a:avLst/>
+          </a:prstGeom>
+          <a:solidFill>
+            <a:srgbClr val="EEF2FF"/>
+          </a:solidFill>
+          <a:ln w="12700">
+            <a:solidFill>
+              <a:srgbClr val="E2E8F0"/>
+            </a:solidFill>
+          </a:ln>
+        </p:spPr>
+        <p:style>
+          <a:lnRef idx="1">
+            <a:schemeClr val="accent1"/>
+          </a:lnRef>
+          <a:fillRef idx="3">
+            <a:schemeClr val="accent1"/>
+          </a:fillRef>
+          <a:effectRef idx="2">
+            <a:schemeClr val="accent1"/>
+          </a:effectRef>
+          <a:fontRef idx="minor">
+            <a:schemeClr val="lt1"/>
+          </a:fontRef>
+        </p:style>
+        <p:txBody>
+          <a:bodyPr rtlCol="0" anchor="ctr" wrap="square"/>
+          <a:lstStyle/>
+          <a:p>
+            <a:pPr algn="ctr">
+              <a:defRPr sz="1300" b="1">
+                <a:solidFill>
+                  <a:srgbClr val="4F46E5"/>
+                </a:solidFill>
+              </a:defRPr>
+            </a:pPr>
+            <a:br/>
+            <a:br/>
+            <a:br/>
+            <a:br/>
+            <a:r>
+              <a:t>📸 [INSERT SCREENSHOT HERE: User Roles Matrix Table]</a:t>
+            </a:r>
+          </a:p>
+        </p:txBody>
+      </p:sp>
     </p:spTree>
   </p:cSld>
   <p:clrMapOvr>
@@ -5829,30 +6416,109 @@
           </a:p>
         </p:txBody>
       </p:sp>
-      <p:pic>
-        <p:nvPicPr>
-          <p:cNvPr id="6" name="Picture 5" descr="SLIDE_15_GMAIL_CALENDAR.png"/>
-          <p:cNvPicPr>
-            <a:picLocks noChangeAspect="1"/>
-          </p:cNvPicPr>
-          <p:nvPr/>
-        </p:nvPicPr>
-        <p:blipFill>
-          <a:blip r:embed="rId2"/>
-          <a:stretch>
-            <a:fillRect/>
-          </a:stretch>
-        </p:blipFill>
-        <p:spPr>
-          <a:xfrm>
-            <a:off x="6492240" y="1645920"/>
-            <a:ext cx="4937760" cy="2597359"/>
-          </a:xfrm>
-          <a:prstGeom prst="rect">
-            <a:avLst/>
-          </a:prstGeom>
-        </p:spPr>
-      </p:pic>
+      <p:sp>
+        <p:nvSpPr>
+          <p:cNvPr id="6" name="Rounded Rectangle 5"/>
+          <p:cNvSpPr/>
+          <p:nvPr/>
+        </p:nvSpPr>
+        <p:spPr>
+          <a:xfrm>
+            <a:off x="6400800" y="1645920"/>
+            <a:ext cx="5059375" cy="4754880"/>
+          </a:xfrm>
+          <a:prstGeom prst="roundRect">
+            <a:avLst/>
+          </a:prstGeom>
+          <a:solidFill>
+            <a:srgbClr val="FFFFFF"/>
+          </a:solidFill>
+          <a:ln w="25400">
+            <a:solidFill>
+              <a:srgbClr val="4F46E5"/>
+            </a:solidFill>
+          </a:ln>
+        </p:spPr>
+        <p:style>
+          <a:lnRef idx="1">
+            <a:schemeClr val="accent1"/>
+          </a:lnRef>
+          <a:fillRef idx="3">
+            <a:schemeClr val="accent1"/>
+          </a:fillRef>
+          <a:effectRef idx="2">
+            <a:schemeClr val="accent1"/>
+          </a:effectRef>
+          <a:fontRef idx="minor">
+            <a:schemeClr val="lt1"/>
+          </a:fontRef>
+        </p:style>
+        <p:txBody>
+          <a:bodyPr rtlCol="0" anchor="ctr"/>
+          <a:lstStyle/>
+          <a:p>
+            <a:pPr algn="ctr"/>
+          </a:p>
+        </p:txBody>
+      </p:sp>
+      <p:sp>
+        <p:nvSpPr>
+          <p:cNvPr id="7" name="Rounded Rectangle 6"/>
+          <p:cNvSpPr/>
+          <p:nvPr/>
+        </p:nvSpPr>
+        <p:spPr>
+          <a:xfrm>
+            <a:off x="6537960" y="1783080"/>
+            <a:ext cx="4785055" cy="4480560"/>
+          </a:xfrm>
+          <a:prstGeom prst="roundRect">
+            <a:avLst/>
+          </a:prstGeom>
+          <a:solidFill>
+            <a:srgbClr val="EEF2FF"/>
+          </a:solidFill>
+          <a:ln w="12700">
+            <a:solidFill>
+              <a:srgbClr val="E2E8F0"/>
+            </a:solidFill>
+          </a:ln>
+        </p:spPr>
+        <p:style>
+          <a:lnRef idx="1">
+            <a:schemeClr val="accent1"/>
+          </a:lnRef>
+          <a:fillRef idx="3">
+            <a:schemeClr val="accent1"/>
+          </a:fillRef>
+          <a:effectRef idx="2">
+            <a:schemeClr val="accent1"/>
+          </a:effectRef>
+          <a:fontRef idx="minor">
+            <a:schemeClr val="lt1"/>
+          </a:fontRef>
+        </p:style>
+        <p:txBody>
+          <a:bodyPr rtlCol="0" anchor="ctr" wrap="square"/>
+          <a:lstStyle/>
+          <a:p>
+            <a:pPr algn="ctr">
+              <a:defRPr sz="1300" b="1">
+                <a:solidFill>
+                  <a:srgbClr val="4F46E5"/>
+                </a:solidFill>
+              </a:defRPr>
+            </a:pPr>
+            <a:br/>
+            <a:br/>
+            <a:br/>
+            <a:br/>
+            <a:r>
+              <a:t>📸 [INSERT SCREENSHOT HERE: Multi-Window Demo Overview]</a:t>
+            </a:r>
+          </a:p>
+        </p:txBody>
+      </p:sp>
     </p:spTree>
   </p:cSld>
   <p:clrMapOvr>
@@ -6156,30 +6822,64 @@
           </a:p>
         </p:txBody>
       </p:sp>
-      <p:pic>
-        <p:nvPicPr>
-          <p:cNvPr id="6" name="Picture 5" descr="SLIDE_5_LOGIN_PORTAL.png"/>
-          <p:cNvPicPr>
-            <a:picLocks noChangeAspect="1"/>
-          </p:cNvPicPr>
-          <p:nvPr/>
-        </p:nvPicPr>
-        <p:blipFill>
-          <a:blip r:embed="rId2"/>
-          <a:stretch>
-            <a:fillRect/>
-          </a:stretch>
-        </p:blipFill>
+      <p:sp>
+        <p:nvSpPr>
+          <p:cNvPr id="6" name="Rounded Rectangle 5"/>
+          <p:cNvSpPr/>
+          <p:nvPr/>
+        </p:nvSpPr>
         <p:spPr>
           <a:xfrm>
             <a:off x="6492240" y="1325880"/>
-            <a:ext cx="4937760" cy="2597359"/>
-          </a:xfrm>
-          <a:prstGeom prst="rect">
-            <a:avLst/>
-          </a:prstGeom>
-        </p:spPr>
-      </p:pic>
+            <a:ext cx="4937760" cy="4983480"/>
+          </a:xfrm>
+          <a:prstGeom prst="roundRect">
+            <a:avLst/>
+          </a:prstGeom>
+          <a:solidFill>
+            <a:srgbClr val="EEF2FF"/>
+          </a:solidFill>
+          <a:ln w="25400">
+            <a:solidFill>
+              <a:srgbClr val="4F46E5"/>
+            </a:solidFill>
+          </a:ln>
+        </p:spPr>
+        <p:style>
+          <a:lnRef idx="1">
+            <a:schemeClr val="accent1"/>
+          </a:lnRef>
+          <a:fillRef idx="3">
+            <a:schemeClr val="accent1"/>
+          </a:fillRef>
+          <a:effectRef idx="2">
+            <a:schemeClr val="accent1"/>
+          </a:effectRef>
+          <a:fontRef idx="minor">
+            <a:schemeClr val="lt1"/>
+          </a:fontRef>
+        </p:style>
+        <p:txBody>
+          <a:bodyPr rtlCol="0" anchor="ctr" wrap="square"/>
+          <a:lstStyle/>
+          <a:p>
+            <a:pPr algn="ctr">
+              <a:defRPr sz="1300" b="1">
+                <a:solidFill>
+                  <a:srgbClr val="4F46E5"/>
+                </a:solidFill>
+              </a:defRPr>
+            </a:pPr>
+            <a:br/>
+            <a:br/>
+            <a:br/>
+            <a:br/>
+            <a:r>
+              <a:t>📸 [INSERT SCREENSHOT HERE: Final Closing Slide / Login Portal]</a:t>
+            </a:r>
+          </a:p>
+        </p:txBody>
+      </p:sp>
     </p:spTree>
   </p:cSld>
   <p:clrMapOvr>
@@ -6474,30 +7174,109 @@
           </a:p>
         </p:txBody>
       </p:sp>
-      <p:pic>
-        <p:nvPicPr>
-          <p:cNvPr id="6" name="Picture 5" descr="SLIDE_2_EMPLOYEE_DASHBOARD.png"/>
-          <p:cNvPicPr>
-            <a:picLocks noChangeAspect="1"/>
-          </p:cNvPicPr>
-          <p:nvPr/>
-        </p:nvPicPr>
-        <p:blipFill>
-          <a:blip r:embed="rId2"/>
-          <a:stretch>
-            <a:fillRect/>
-          </a:stretch>
-        </p:blipFill>
-        <p:spPr>
-          <a:xfrm>
-            <a:off x="6492240" y="1645920"/>
-            <a:ext cx="4937760" cy="2597359"/>
-          </a:xfrm>
-          <a:prstGeom prst="rect">
-            <a:avLst/>
-          </a:prstGeom>
-        </p:spPr>
-      </p:pic>
+      <p:sp>
+        <p:nvSpPr>
+          <p:cNvPr id="6" name="Rounded Rectangle 5"/>
+          <p:cNvSpPr/>
+          <p:nvPr/>
+        </p:nvSpPr>
+        <p:spPr>
+          <a:xfrm>
+            <a:off x="6400800" y="1645920"/>
+            <a:ext cx="5059375" cy="4754880"/>
+          </a:xfrm>
+          <a:prstGeom prst="roundRect">
+            <a:avLst/>
+          </a:prstGeom>
+          <a:solidFill>
+            <a:srgbClr val="FFFFFF"/>
+          </a:solidFill>
+          <a:ln w="25400">
+            <a:solidFill>
+              <a:srgbClr val="4F46E5"/>
+            </a:solidFill>
+          </a:ln>
+        </p:spPr>
+        <p:style>
+          <a:lnRef idx="1">
+            <a:schemeClr val="accent1"/>
+          </a:lnRef>
+          <a:fillRef idx="3">
+            <a:schemeClr val="accent1"/>
+          </a:fillRef>
+          <a:effectRef idx="2">
+            <a:schemeClr val="accent1"/>
+          </a:effectRef>
+          <a:fontRef idx="minor">
+            <a:schemeClr val="lt1"/>
+          </a:fontRef>
+        </p:style>
+        <p:txBody>
+          <a:bodyPr rtlCol="0" anchor="ctr"/>
+          <a:lstStyle/>
+          <a:p>
+            <a:pPr algn="ctr"/>
+          </a:p>
+        </p:txBody>
+      </p:sp>
+      <p:sp>
+        <p:nvSpPr>
+          <p:cNvPr id="7" name="Rounded Rectangle 6"/>
+          <p:cNvSpPr/>
+          <p:nvPr/>
+        </p:nvSpPr>
+        <p:spPr>
+          <a:xfrm>
+            <a:off x="6537960" y="1783080"/>
+            <a:ext cx="4785055" cy="4480560"/>
+          </a:xfrm>
+          <a:prstGeom prst="roundRect">
+            <a:avLst/>
+          </a:prstGeom>
+          <a:solidFill>
+            <a:srgbClr val="EEF2FF"/>
+          </a:solidFill>
+          <a:ln w="12700">
+            <a:solidFill>
+              <a:srgbClr val="E2E8F0"/>
+            </a:solidFill>
+          </a:ln>
+        </p:spPr>
+        <p:style>
+          <a:lnRef idx="1">
+            <a:schemeClr val="accent1"/>
+          </a:lnRef>
+          <a:fillRef idx="3">
+            <a:schemeClr val="accent1"/>
+          </a:fillRef>
+          <a:effectRef idx="2">
+            <a:schemeClr val="accent1"/>
+          </a:effectRef>
+          <a:fontRef idx="minor">
+            <a:schemeClr val="lt1"/>
+          </a:fontRef>
+        </p:style>
+        <p:txBody>
+          <a:bodyPr rtlCol="0" anchor="ctr" wrap="square"/>
+          <a:lstStyle/>
+          <a:p>
+            <a:pPr algn="ctr">
+              <a:defRPr sz="1300" b="1">
+                <a:solidFill>
+                  <a:srgbClr val="4F46E5"/>
+                </a:solidFill>
+              </a:defRPr>
+            </a:pPr>
+            <a:br/>
+            <a:br/>
+            <a:br/>
+            <a:br/>
+            <a:r>
+              <a:t>📸 [INSERT SCREENSHOT HERE: Employee Dashboard &amp; Active Reservations]</a:t>
+            </a:r>
+          </a:p>
+        </p:txBody>
+      </p:sp>
     </p:spTree>
   </p:cSld>
   <p:clrMapOvr>
@@ -6777,30 +7556,109 @@
           </a:p>
         </p:txBody>
       </p:sp>
-      <p:pic>
-        <p:nvPicPr>
-          <p:cNvPr id="6" name="Picture 5" descr="SYSTEM_ARCHITECTURE_DIAGRAM.png"/>
-          <p:cNvPicPr>
-            <a:picLocks noChangeAspect="1"/>
-          </p:cNvPicPr>
-          <p:nvPr/>
-        </p:nvPicPr>
-        <p:blipFill>
-          <a:blip r:embed="rId2"/>
-          <a:stretch>
-            <a:fillRect/>
-          </a:stretch>
-        </p:blipFill>
-        <p:spPr>
-          <a:xfrm>
-            <a:off x="6492240" y="1645920"/>
-            <a:ext cx="4937760" cy="3291840"/>
-          </a:xfrm>
-          <a:prstGeom prst="rect">
-            <a:avLst/>
-          </a:prstGeom>
-        </p:spPr>
-      </p:pic>
+      <p:sp>
+        <p:nvSpPr>
+          <p:cNvPr id="6" name="Rounded Rectangle 5"/>
+          <p:cNvSpPr/>
+          <p:nvPr/>
+        </p:nvSpPr>
+        <p:spPr>
+          <a:xfrm>
+            <a:off x="6400800" y="1645920"/>
+            <a:ext cx="5059375" cy="4754880"/>
+          </a:xfrm>
+          <a:prstGeom prst="roundRect">
+            <a:avLst/>
+          </a:prstGeom>
+          <a:solidFill>
+            <a:srgbClr val="FFFFFF"/>
+          </a:solidFill>
+          <a:ln w="25400">
+            <a:solidFill>
+              <a:srgbClr val="4F46E5"/>
+            </a:solidFill>
+          </a:ln>
+        </p:spPr>
+        <p:style>
+          <a:lnRef idx="1">
+            <a:schemeClr val="accent1"/>
+          </a:lnRef>
+          <a:fillRef idx="3">
+            <a:schemeClr val="accent1"/>
+          </a:fillRef>
+          <a:effectRef idx="2">
+            <a:schemeClr val="accent1"/>
+          </a:effectRef>
+          <a:fontRef idx="minor">
+            <a:schemeClr val="lt1"/>
+          </a:fontRef>
+        </p:style>
+        <p:txBody>
+          <a:bodyPr rtlCol="0" anchor="ctr"/>
+          <a:lstStyle/>
+          <a:p>
+            <a:pPr algn="ctr"/>
+          </a:p>
+        </p:txBody>
+      </p:sp>
+      <p:sp>
+        <p:nvSpPr>
+          <p:cNvPr id="7" name="Rounded Rectangle 6"/>
+          <p:cNvSpPr/>
+          <p:nvPr/>
+        </p:nvSpPr>
+        <p:spPr>
+          <a:xfrm>
+            <a:off x="6537960" y="1783080"/>
+            <a:ext cx="4785055" cy="4480560"/>
+          </a:xfrm>
+          <a:prstGeom prst="roundRect">
+            <a:avLst/>
+          </a:prstGeom>
+          <a:solidFill>
+            <a:srgbClr val="EEF2FF"/>
+          </a:solidFill>
+          <a:ln w="12700">
+            <a:solidFill>
+              <a:srgbClr val="E2E8F0"/>
+            </a:solidFill>
+          </a:ln>
+        </p:spPr>
+        <p:style>
+          <a:lnRef idx="1">
+            <a:schemeClr val="accent1"/>
+          </a:lnRef>
+          <a:fillRef idx="3">
+            <a:schemeClr val="accent1"/>
+          </a:fillRef>
+          <a:effectRef idx="2">
+            <a:schemeClr val="accent1"/>
+          </a:effectRef>
+          <a:fontRef idx="minor">
+            <a:schemeClr val="lt1"/>
+          </a:fontRef>
+        </p:style>
+        <p:txBody>
+          <a:bodyPr rtlCol="0" anchor="ctr" wrap="square"/>
+          <a:lstStyle/>
+          <a:p>
+            <a:pPr algn="ctr">
+              <a:defRPr sz="1300" b="1">
+                <a:solidFill>
+                  <a:srgbClr val="4F46E5"/>
+                </a:solidFill>
+              </a:defRPr>
+            </a:pPr>
+            <a:br/>
+            <a:br/>
+            <a:br/>
+            <a:br/>
+            <a:r>
+              <a:t>📸 [INSERT SCREENSHOT HERE: System Architecture &amp; Flow Diagram]</a:t>
+            </a:r>
+          </a:p>
+        </p:txBody>
+      </p:sp>
     </p:spTree>
   </p:cSld>
   <p:clrMapOvr>
@@ -7080,30 +7938,109 @@
           </a:p>
         </p:txBody>
       </p:sp>
-      <p:pic>
-        <p:nvPicPr>
-          <p:cNvPr id="6" name="Picture 5" descr="SLIDE_4_EER_DIAGRAM.png"/>
-          <p:cNvPicPr>
-            <a:picLocks noChangeAspect="1"/>
-          </p:cNvPicPr>
-          <p:nvPr/>
-        </p:nvPicPr>
-        <p:blipFill>
-          <a:blip r:embed="rId2"/>
-          <a:stretch>
-            <a:fillRect/>
-          </a:stretch>
-        </p:blipFill>
-        <p:spPr>
-          <a:xfrm>
-            <a:off x="6492240" y="1645920"/>
-            <a:ext cx="4937760" cy="3291840"/>
-          </a:xfrm>
-          <a:prstGeom prst="rect">
-            <a:avLst/>
-          </a:prstGeom>
-        </p:spPr>
-      </p:pic>
+      <p:sp>
+        <p:nvSpPr>
+          <p:cNvPr id="6" name="Rounded Rectangle 5"/>
+          <p:cNvSpPr/>
+          <p:nvPr/>
+        </p:nvSpPr>
+        <p:spPr>
+          <a:xfrm>
+            <a:off x="6400800" y="1645920"/>
+            <a:ext cx="5059375" cy="4754880"/>
+          </a:xfrm>
+          <a:prstGeom prst="roundRect">
+            <a:avLst/>
+          </a:prstGeom>
+          <a:solidFill>
+            <a:srgbClr val="FFFFFF"/>
+          </a:solidFill>
+          <a:ln w="25400">
+            <a:solidFill>
+              <a:srgbClr val="4F46E5"/>
+            </a:solidFill>
+          </a:ln>
+        </p:spPr>
+        <p:style>
+          <a:lnRef idx="1">
+            <a:schemeClr val="accent1"/>
+          </a:lnRef>
+          <a:fillRef idx="3">
+            <a:schemeClr val="accent1"/>
+          </a:fillRef>
+          <a:effectRef idx="2">
+            <a:schemeClr val="accent1"/>
+          </a:effectRef>
+          <a:fontRef idx="minor">
+            <a:schemeClr val="lt1"/>
+          </a:fontRef>
+        </p:style>
+        <p:txBody>
+          <a:bodyPr rtlCol="0" anchor="ctr"/>
+          <a:lstStyle/>
+          <a:p>
+            <a:pPr algn="ctr"/>
+          </a:p>
+        </p:txBody>
+      </p:sp>
+      <p:sp>
+        <p:nvSpPr>
+          <p:cNvPr id="7" name="Rounded Rectangle 6"/>
+          <p:cNvSpPr/>
+          <p:nvPr/>
+        </p:nvSpPr>
+        <p:spPr>
+          <a:xfrm>
+            <a:off x="6537960" y="1783080"/>
+            <a:ext cx="4785055" cy="4480560"/>
+          </a:xfrm>
+          <a:prstGeom prst="roundRect">
+            <a:avLst/>
+          </a:prstGeom>
+          <a:solidFill>
+            <a:srgbClr val="EEF2FF"/>
+          </a:solidFill>
+          <a:ln w="12700">
+            <a:solidFill>
+              <a:srgbClr val="E2E8F0"/>
+            </a:solidFill>
+          </a:ln>
+        </p:spPr>
+        <p:style>
+          <a:lnRef idx="1">
+            <a:schemeClr val="accent1"/>
+          </a:lnRef>
+          <a:fillRef idx="3">
+            <a:schemeClr val="accent1"/>
+          </a:fillRef>
+          <a:effectRef idx="2">
+            <a:schemeClr val="accent1"/>
+          </a:effectRef>
+          <a:fontRef idx="minor">
+            <a:schemeClr val="lt1"/>
+          </a:fontRef>
+        </p:style>
+        <p:txBody>
+          <a:bodyPr rtlCol="0" anchor="ctr" wrap="square"/>
+          <a:lstStyle/>
+          <a:p>
+            <a:pPr algn="ctr">
+              <a:defRPr sz="1300" b="1">
+                <a:solidFill>
+                  <a:srgbClr val="4F46E5"/>
+                </a:solidFill>
+              </a:defRPr>
+            </a:pPr>
+            <a:br/>
+            <a:br/>
+            <a:br/>
+            <a:br/>
+            <a:r>
+              <a:t>📸 [INSERT SCREENSHOT HERE: MySQL Workbench Ctrl + R EER Diagram]</a:t>
+            </a:r>
+          </a:p>
+        </p:txBody>
+      </p:sp>
     </p:spTree>
   </p:cSld>
   <p:clrMapOvr>
@@ -7383,30 +8320,109 @@
           </a:p>
         </p:txBody>
       </p:sp>
-      <p:pic>
-        <p:nvPicPr>
-          <p:cNvPr id="6" name="Picture 5" descr="SLIDE_5_LOGIN_PORTAL.png"/>
-          <p:cNvPicPr>
-            <a:picLocks noChangeAspect="1"/>
-          </p:cNvPicPr>
-          <p:nvPr/>
-        </p:nvPicPr>
-        <p:blipFill>
-          <a:blip r:embed="rId2"/>
-          <a:stretch>
-            <a:fillRect/>
-          </a:stretch>
-        </p:blipFill>
-        <p:spPr>
-          <a:xfrm>
-            <a:off x="6492240" y="1645920"/>
-            <a:ext cx="4937760" cy="2597359"/>
-          </a:xfrm>
-          <a:prstGeom prst="rect">
-            <a:avLst/>
-          </a:prstGeom>
-        </p:spPr>
-      </p:pic>
+      <p:sp>
+        <p:nvSpPr>
+          <p:cNvPr id="6" name="Rounded Rectangle 5"/>
+          <p:cNvSpPr/>
+          <p:nvPr/>
+        </p:nvSpPr>
+        <p:spPr>
+          <a:xfrm>
+            <a:off x="6400800" y="1645920"/>
+            <a:ext cx="5059375" cy="4754880"/>
+          </a:xfrm>
+          <a:prstGeom prst="roundRect">
+            <a:avLst/>
+          </a:prstGeom>
+          <a:solidFill>
+            <a:srgbClr val="FFFFFF"/>
+          </a:solidFill>
+          <a:ln w="25400">
+            <a:solidFill>
+              <a:srgbClr val="4F46E5"/>
+            </a:solidFill>
+          </a:ln>
+        </p:spPr>
+        <p:style>
+          <a:lnRef idx="1">
+            <a:schemeClr val="accent1"/>
+          </a:lnRef>
+          <a:fillRef idx="3">
+            <a:schemeClr val="accent1"/>
+          </a:fillRef>
+          <a:effectRef idx="2">
+            <a:schemeClr val="accent1"/>
+          </a:effectRef>
+          <a:fontRef idx="minor">
+            <a:schemeClr val="lt1"/>
+          </a:fontRef>
+        </p:style>
+        <p:txBody>
+          <a:bodyPr rtlCol="0" anchor="ctr"/>
+          <a:lstStyle/>
+          <a:p>
+            <a:pPr algn="ctr"/>
+          </a:p>
+        </p:txBody>
+      </p:sp>
+      <p:sp>
+        <p:nvSpPr>
+          <p:cNvPr id="7" name="Rounded Rectangle 6"/>
+          <p:cNvSpPr/>
+          <p:nvPr/>
+        </p:nvSpPr>
+        <p:spPr>
+          <a:xfrm>
+            <a:off x="6537960" y="1783080"/>
+            <a:ext cx="4785055" cy="4480560"/>
+          </a:xfrm>
+          <a:prstGeom prst="roundRect">
+            <a:avLst/>
+          </a:prstGeom>
+          <a:solidFill>
+            <a:srgbClr val="EEF2FF"/>
+          </a:solidFill>
+          <a:ln w="12700">
+            <a:solidFill>
+              <a:srgbClr val="E2E8F0"/>
+            </a:solidFill>
+          </a:ln>
+        </p:spPr>
+        <p:style>
+          <a:lnRef idx="1">
+            <a:schemeClr val="accent1"/>
+          </a:lnRef>
+          <a:fillRef idx="3">
+            <a:schemeClr val="accent1"/>
+          </a:fillRef>
+          <a:effectRef idx="2">
+            <a:schemeClr val="accent1"/>
+          </a:effectRef>
+          <a:fontRef idx="minor">
+            <a:schemeClr val="lt1"/>
+          </a:fontRef>
+        </p:style>
+        <p:txBody>
+          <a:bodyPr rtlCol="0" anchor="ctr" wrap="square"/>
+          <a:lstStyle/>
+          <a:p>
+            <a:pPr algn="ctr">
+              <a:defRPr sz="1300" b="1">
+                <a:solidFill>
+                  <a:srgbClr val="4F46E5"/>
+                </a:solidFill>
+              </a:defRPr>
+            </a:pPr>
+            <a:br/>
+            <a:br/>
+            <a:br/>
+            <a:br/>
+            <a:r>
+              <a:t>📸 [INSERT SCREENSHOT HERE: Login &amp; Sign Up Portal Page]</a:t>
+            </a:r>
+          </a:p>
+        </p:txBody>
+      </p:sp>
     </p:spTree>
   </p:cSld>
   <p:clrMapOvr>
@@ -7686,30 +8702,109 @@
           </a:p>
         </p:txBody>
       </p:sp>
-      <p:pic>
-        <p:nvPicPr>
-          <p:cNvPr id="6" name="Picture 5" descr="SLIDE_6_ROOM_EXPLORER.png"/>
-          <p:cNvPicPr>
-            <a:picLocks noChangeAspect="1"/>
-          </p:cNvPicPr>
-          <p:nvPr/>
-        </p:nvPicPr>
-        <p:blipFill>
-          <a:blip r:embed="rId2"/>
-          <a:stretch>
-            <a:fillRect/>
-          </a:stretch>
-        </p:blipFill>
-        <p:spPr>
-          <a:xfrm>
-            <a:off x="6492240" y="1645920"/>
-            <a:ext cx="4937760" cy="2597359"/>
-          </a:xfrm>
-          <a:prstGeom prst="rect">
-            <a:avLst/>
-          </a:prstGeom>
-        </p:spPr>
-      </p:pic>
+      <p:sp>
+        <p:nvSpPr>
+          <p:cNvPr id="6" name="Rounded Rectangle 5"/>
+          <p:cNvSpPr/>
+          <p:nvPr/>
+        </p:nvSpPr>
+        <p:spPr>
+          <a:xfrm>
+            <a:off x="6400800" y="1645920"/>
+            <a:ext cx="5059375" cy="4754880"/>
+          </a:xfrm>
+          <a:prstGeom prst="roundRect">
+            <a:avLst/>
+          </a:prstGeom>
+          <a:solidFill>
+            <a:srgbClr val="FFFFFF"/>
+          </a:solidFill>
+          <a:ln w="25400">
+            <a:solidFill>
+              <a:srgbClr val="4F46E5"/>
+            </a:solidFill>
+          </a:ln>
+        </p:spPr>
+        <p:style>
+          <a:lnRef idx="1">
+            <a:schemeClr val="accent1"/>
+          </a:lnRef>
+          <a:fillRef idx="3">
+            <a:schemeClr val="accent1"/>
+          </a:fillRef>
+          <a:effectRef idx="2">
+            <a:schemeClr val="accent1"/>
+          </a:effectRef>
+          <a:fontRef idx="minor">
+            <a:schemeClr val="lt1"/>
+          </a:fontRef>
+        </p:style>
+        <p:txBody>
+          <a:bodyPr rtlCol="0" anchor="ctr"/>
+          <a:lstStyle/>
+          <a:p>
+            <a:pPr algn="ctr"/>
+          </a:p>
+        </p:txBody>
+      </p:sp>
+      <p:sp>
+        <p:nvSpPr>
+          <p:cNvPr id="7" name="Rounded Rectangle 6"/>
+          <p:cNvSpPr/>
+          <p:nvPr/>
+        </p:nvSpPr>
+        <p:spPr>
+          <a:xfrm>
+            <a:off x="6537960" y="1783080"/>
+            <a:ext cx="4785055" cy="4480560"/>
+          </a:xfrm>
+          <a:prstGeom prst="roundRect">
+            <a:avLst/>
+          </a:prstGeom>
+          <a:solidFill>
+            <a:srgbClr val="EEF2FF"/>
+          </a:solidFill>
+          <a:ln w="12700">
+            <a:solidFill>
+              <a:srgbClr val="E2E8F0"/>
+            </a:solidFill>
+          </a:ln>
+        </p:spPr>
+        <p:style>
+          <a:lnRef idx="1">
+            <a:schemeClr val="accent1"/>
+          </a:lnRef>
+          <a:fillRef idx="3">
+            <a:schemeClr val="accent1"/>
+          </a:fillRef>
+          <a:effectRef idx="2">
+            <a:schemeClr val="accent1"/>
+          </a:effectRef>
+          <a:fontRef idx="minor">
+            <a:schemeClr val="lt1"/>
+          </a:fontRef>
+        </p:style>
+        <p:txBody>
+          <a:bodyPr rtlCol="0" anchor="ctr" wrap="square"/>
+          <a:lstStyle/>
+          <a:p>
+            <a:pPr algn="ctr">
+              <a:defRPr sz="1300" b="1">
+                <a:solidFill>
+                  <a:srgbClr val="4F46E5"/>
+                </a:solidFill>
+              </a:defRPr>
+            </a:pPr>
+            <a:br/>
+            <a:br/>
+            <a:br/>
+            <a:br/>
+            <a:r>
+              <a:t>📸 [INSERT SCREENSHOT HERE: All-Rooms Explorer Grid View]</a:t>
+            </a:r>
+          </a:p>
+        </p:txBody>
+      </p:sp>
     </p:spTree>
   </p:cSld>
   <p:clrMapOvr>
@@ -7989,30 +9084,109 @@
           </a:p>
         </p:txBody>
       </p:sp>
-      <p:pic>
-        <p:nvPicPr>
-          <p:cNvPr id="6" name="Picture 5" descr="SLIDE_7_FILE_UPLOAD.png"/>
-          <p:cNvPicPr>
-            <a:picLocks noChangeAspect="1"/>
-          </p:cNvPicPr>
-          <p:nvPr/>
-        </p:nvPicPr>
-        <p:blipFill>
-          <a:blip r:embed="rId2"/>
-          <a:stretch>
-            <a:fillRect/>
-          </a:stretch>
-        </p:blipFill>
-        <p:spPr>
-          <a:xfrm>
-            <a:off x="6492240" y="1645920"/>
-            <a:ext cx="4937760" cy="3291840"/>
-          </a:xfrm>
-          <a:prstGeom prst="rect">
-            <a:avLst/>
-          </a:prstGeom>
-        </p:spPr>
-      </p:pic>
+      <p:sp>
+        <p:nvSpPr>
+          <p:cNvPr id="6" name="Rounded Rectangle 5"/>
+          <p:cNvSpPr/>
+          <p:nvPr/>
+        </p:nvSpPr>
+        <p:spPr>
+          <a:xfrm>
+            <a:off x="6400800" y="1645920"/>
+            <a:ext cx="5059375" cy="4754880"/>
+          </a:xfrm>
+          <a:prstGeom prst="roundRect">
+            <a:avLst/>
+          </a:prstGeom>
+          <a:solidFill>
+            <a:srgbClr val="FFFFFF"/>
+          </a:solidFill>
+          <a:ln w="25400">
+            <a:solidFill>
+              <a:srgbClr val="4F46E5"/>
+            </a:solidFill>
+          </a:ln>
+        </p:spPr>
+        <p:style>
+          <a:lnRef idx="1">
+            <a:schemeClr val="accent1"/>
+          </a:lnRef>
+          <a:fillRef idx="3">
+            <a:schemeClr val="accent1"/>
+          </a:fillRef>
+          <a:effectRef idx="2">
+            <a:schemeClr val="accent1"/>
+          </a:effectRef>
+          <a:fontRef idx="minor">
+            <a:schemeClr val="lt1"/>
+          </a:fontRef>
+        </p:style>
+        <p:txBody>
+          <a:bodyPr rtlCol="0" anchor="ctr"/>
+          <a:lstStyle/>
+          <a:p>
+            <a:pPr algn="ctr"/>
+          </a:p>
+        </p:txBody>
+      </p:sp>
+      <p:sp>
+        <p:nvSpPr>
+          <p:cNvPr id="7" name="Rounded Rectangle 6"/>
+          <p:cNvSpPr/>
+          <p:nvPr/>
+        </p:nvSpPr>
+        <p:spPr>
+          <a:xfrm>
+            <a:off x="6537960" y="1783080"/>
+            <a:ext cx="4785055" cy="4480560"/>
+          </a:xfrm>
+          <a:prstGeom prst="roundRect">
+            <a:avLst/>
+          </a:prstGeom>
+          <a:solidFill>
+            <a:srgbClr val="EEF2FF"/>
+          </a:solidFill>
+          <a:ln w="12700">
+            <a:solidFill>
+              <a:srgbClr val="E2E8F0"/>
+            </a:solidFill>
+          </a:ln>
+        </p:spPr>
+        <p:style>
+          <a:lnRef idx="1">
+            <a:schemeClr val="accent1"/>
+          </a:lnRef>
+          <a:fillRef idx="3">
+            <a:schemeClr val="accent1"/>
+          </a:fillRef>
+          <a:effectRef idx="2">
+            <a:schemeClr val="accent1"/>
+          </a:effectRef>
+          <a:fontRef idx="minor">
+            <a:schemeClr val="lt1"/>
+          </a:fontRef>
+        </p:style>
+        <p:txBody>
+          <a:bodyPr rtlCol="0" anchor="ctr" wrap="square"/>
+          <a:lstStyle/>
+          <a:p>
+            <a:pPr algn="ctr">
+              <a:defRPr sz="1300" b="1">
+                <a:solidFill>
+                  <a:srgbClr val="4F46E5"/>
+                </a:solidFill>
+              </a:defRPr>
+            </a:pPr>
+            <a:br/>
+            <a:br/>
+            <a:br/>
+            <a:br/>
+            <a:r>
+              <a:t>📸 [INSERT SCREENSHOT HERE: Add/Edit Room Modal File Picker]</a:t>
+            </a:r>
+          </a:p>
+        </p:txBody>
+      </p:sp>
     </p:spTree>
   </p:cSld>
   <p:clrMapOvr>
@@ -8292,30 +9466,109 @@
           </a:p>
         </p:txBody>
       </p:sp>
-      <p:pic>
-        <p:nvPicPr>
-          <p:cNvPr id="6" name="Picture 5" descr="SLIDE_8_ROOM_BOOKING.png"/>
-          <p:cNvPicPr>
-            <a:picLocks noChangeAspect="1"/>
-          </p:cNvPicPr>
-          <p:nvPr/>
-        </p:nvPicPr>
-        <p:blipFill>
-          <a:blip r:embed="rId2"/>
-          <a:stretch>
-            <a:fillRect/>
-          </a:stretch>
-        </p:blipFill>
-        <p:spPr>
-          <a:xfrm>
-            <a:off x="6492240" y="1645920"/>
-            <a:ext cx="4937760" cy="3291840"/>
-          </a:xfrm>
-          <a:prstGeom prst="rect">
-            <a:avLst/>
-          </a:prstGeom>
-        </p:spPr>
-      </p:pic>
+      <p:sp>
+        <p:nvSpPr>
+          <p:cNvPr id="6" name="Rounded Rectangle 5"/>
+          <p:cNvSpPr/>
+          <p:nvPr/>
+        </p:nvSpPr>
+        <p:spPr>
+          <a:xfrm>
+            <a:off x="6400800" y="1645920"/>
+            <a:ext cx="5059375" cy="4754880"/>
+          </a:xfrm>
+          <a:prstGeom prst="roundRect">
+            <a:avLst/>
+          </a:prstGeom>
+          <a:solidFill>
+            <a:srgbClr val="FFFFFF"/>
+          </a:solidFill>
+          <a:ln w="25400">
+            <a:solidFill>
+              <a:srgbClr val="4F46E5"/>
+            </a:solidFill>
+          </a:ln>
+        </p:spPr>
+        <p:style>
+          <a:lnRef idx="1">
+            <a:schemeClr val="accent1"/>
+          </a:lnRef>
+          <a:fillRef idx="3">
+            <a:schemeClr val="accent1"/>
+          </a:fillRef>
+          <a:effectRef idx="2">
+            <a:schemeClr val="accent1"/>
+          </a:effectRef>
+          <a:fontRef idx="minor">
+            <a:schemeClr val="lt1"/>
+          </a:fontRef>
+        </p:style>
+        <p:txBody>
+          <a:bodyPr rtlCol="0" anchor="ctr"/>
+          <a:lstStyle/>
+          <a:p>
+            <a:pPr algn="ctr"/>
+          </a:p>
+        </p:txBody>
+      </p:sp>
+      <p:sp>
+        <p:nvSpPr>
+          <p:cNvPr id="7" name="Rounded Rectangle 6"/>
+          <p:cNvSpPr/>
+          <p:nvPr/>
+        </p:nvSpPr>
+        <p:spPr>
+          <a:xfrm>
+            <a:off x="6537960" y="1783080"/>
+            <a:ext cx="4785055" cy="4480560"/>
+          </a:xfrm>
+          <a:prstGeom prst="roundRect">
+            <a:avLst/>
+          </a:prstGeom>
+          <a:solidFill>
+            <a:srgbClr val="EEF2FF"/>
+          </a:solidFill>
+          <a:ln w="12700">
+            <a:solidFill>
+              <a:srgbClr val="E2E8F0"/>
+            </a:solidFill>
+          </a:ln>
+        </p:spPr>
+        <p:style>
+          <a:lnRef idx="1">
+            <a:schemeClr val="accent1"/>
+          </a:lnRef>
+          <a:fillRef idx="3">
+            <a:schemeClr val="accent1"/>
+          </a:fillRef>
+          <a:effectRef idx="2">
+            <a:schemeClr val="accent1"/>
+          </a:effectRef>
+          <a:fontRef idx="minor">
+            <a:schemeClr val="lt1"/>
+          </a:fontRef>
+        </p:style>
+        <p:txBody>
+          <a:bodyPr rtlCol="0" anchor="ctr" wrap="square"/>
+          <a:lstStyle/>
+          <a:p>
+            <a:pPr algn="ctr">
+              <a:defRPr sz="1300" b="1">
+                <a:solidFill>
+                  <a:srgbClr val="4F46E5"/>
+                </a:solidFill>
+              </a:defRPr>
+            </a:pPr>
+            <a:br/>
+            <a:br/>
+            <a:br/>
+            <a:br/>
+            <a:r>
+              <a:t>📸 [INSERT SCREENSHOT HERE: Booking Side Panel &amp; Slot Picker]</a:t>
+            </a:r>
+          </a:p>
+        </p:txBody>
+      </p:sp>
     </p:spTree>
   </p:cSld>
   <p:clrMapOvr>
@@ -8595,30 +9848,109 @@
           </a:p>
         </p:txBody>
       </p:sp>
-      <p:pic>
-        <p:nvPicPr>
-          <p:cNvPr id="6" name="Picture 5" descr="SLIDE_9_AUTO_APPROVAL.png"/>
-          <p:cNvPicPr>
-            <a:picLocks noChangeAspect="1"/>
-          </p:cNvPicPr>
-          <p:nvPr/>
-        </p:nvPicPr>
-        <p:blipFill>
-          <a:blip r:embed="rId2"/>
-          <a:stretch>
-            <a:fillRect/>
-          </a:stretch>
-        </p:blipFill>
-        <p:spPr>
-          <a:xfrm>
-            <a:off x="6492240" y="1645920"/>
-            <a:ext cx="4937760" cy="2597359"/>
-          </a:xfrm>
-          <a:prstGeom prst="rect">
-            <a:avLst/>
-          </a:prstGeom>
-        </p:spPr>
-      </p:pic>
+      <p:sp>
+        <p:nvSpPr>
+          <p:cNvPr id="6" name="Rounded Rectangle 5"/>
+          <p:cNvSpPr/>
+          <p:nvPr/>
+        </p:nvSpPr>
+        <p:spPr>
+          <a:xfrm>
+            <a:off x="6400800" y="1645920"/>
+            <a:ext cx="5059375" cy="4754880"/>
+          </a:xfrm>
+          <a:prstGeom prst="roundRect">
+            <a:avLst/>
+          </a:prstGeom>
+          <a:solidFill>
+            <a:srgbClr val="FFFFFF"/>
+          </a:solidFill>
+          <a:ln w="25400">
+            <a:solidFill>
+              <a:srgbClr val="4F46E5"/>
+            </a:solidFill>
+          </a:ln>
+        </p:spPr>
+        <p:style>
+          <a:lnRef idx="1">
+            <a:schemeClr val="accent1"/>
+          </a:lnRef>
+          <a:fillRef idx="3">
+            <a:schemeClr val="accent1"/>
+          </a:fillRef>
+          <a:effectRef idx="2">
+            <a:schemeClr val="accent1"/>
+          </a:effectRef>
+          <a:fontRef idx="minor">
+            <a:schemeClr val="lt1"/>
+          </a:fontRef>
+        </p:style>
+        <p:txBody>
+          <a:bodyPr rtlCol="0" anchor="ctr"/>
+          <a:lstStyle/>
+          <a:p>
+            <a:pPr algn="ctr"/>
+          </a:p>
+        </p:txBody>
+      </p:sp>
+      <p:sp>
+        <p:nvSpPr>
+          <p:cNvPr id="7" name="Rounded Rectangle 6"/>
+          <p:cNvSpPr/>
+          <p:nvPr/>
+        </p:nvSpPr>
+        <p:spPr>
+          <a:xfrm>
+            <a:off x="6537960" y="1783080"/>
+            <a:ext cx="4785055" cy="4480560"/>
+          </a:xfrm>
+          <a:prstGeom prst="roundRect">
+            <a:avLst/>
+          </a:prstGeom>
+          <a:solidFill>
+            <a:srgbClr val="EEF2FF"/>
+          </a:solidFill>
+          <a:ln w="12700">
+            <a:solidFill>
+              <a:srgbClr val="E2E8F0"/>
+            </a:solidFill>
+          </a:ln>
+        </p:spPr>
+        <p:style>
+          <a:lnRef idx="1">
+            <a:schemeClr val="accent1"/>
+          </a:lnRef>
+          <a:fillRef idx="3">
+            <a:schemeClr val="accent1"/>
+          </a:fillRef>
+          <a:effectRef idx="2">
+            <a:schemeClr val="accent1"/>
+          </a:effectRef>
+          <a:fontRef idx="minor">
+            <a:schemeClr val="lt1"/>
+          </a:fontRef>
+        </p:style>
+        <p:txBody>
+          <a:bodyPr rtlCol="0" anchor="ctr" wrap="square"/>
+          <a:lstStyle/>
+          <a:p>
+            <a:pPr algn="ctr">
+              <a:defRPr sz="1300" b="1">
+                <a:solidFill>
+                  <a:srgbClr val="4F46E5"/>
+                </a:solidFill>
+              </a:defRPr>
+            </a:pPr>
+            <a:br/>
+            <a:br/>
+            <a:br/>
+            <a:br/>
+            <a:r>
+              <a:t>📸 [INSERT SCREENSHOT HERE: Booking List showing Auto-Approved Badge]</a:t>
+            </a:r>
+          </a:p>
+        </p:txBody>
+      </p:sp>
     </p:spTree>
   </p:cSld>
   <p:clrMapOvr>

</xml_diff>

<commit_message>
fix: resolve room booking API validation, session fallback, and room ID mapping
</commit_message>
<xml_diff>
--- a/document/PRESENTATION_DECK_SLIDES.pptx
+++ b/document/PRESENTATION_DECK_SLIDES.pptx
@@ -5,26 +5,26 @@
     <p:sldMasterId id="2147483648" r:id="rId1"/>
   </p:sldMasterIdLst>
   <p:sldIdLst>
-    <p:sldId id="256" r:id="rId7"/>
-    <p:sldId id="257" r:id="rId8"/>
-    <p:sldId id="258" r:id="rId9"/>
-    <p:sldId id="259" r:id="rId10"/>
-    <p:sldId id="260" r:id="rId11"/>
-    <p:sldId id="261" r:id="rId12"/>
-    <p:sldId id="262" r:id="rId13"/>
-    <p:sldId id="263" r:id="rId14"/>
-    <p:sldId id="264" r:id="rId15"/>
-    <p:sldId id="265" r:id="rId16"/>
-    <p:sldId id="266" r:id="rId17"/>
-    <p:sldId id="267" r:id="rId18"/>
-    <p:sldId id="268" r:id="rId19"/>
-    <p:sldId id="269" r:id="rId20"/>
-    <p:sldId id="270" r:id="rId21"/>
-    <p:sldId id="271" r:id="rId22"/>
-    <p:sldId id="272" r:id="rId23"/>
-    <p:sldId id="273" r:id="rId24"/>
+    <p:sldId id="256" r:id="rId2"/>
+    <p:sldId id="257" r:id="rId3"/>
+    <p:sldId id="258" r:id="rId4"/>
+    <p:sldId id="259" r:id="rId5"/>
+    <p:sldId id="260" r:id="rId6"/>
+    <p:sldId id="261" r:id="rId7"/>
+    <p:sldId id="262" r:id="rId8"/>
+    <p:sldId id="263" r:id="rId9"/>
+    <p:sldId id="264" r:id="rId10"/>
+    <p:sldId id="265" r:id="rId11"/>
+    <p:sldId id="266" r:id="rId12"/>
+    <p:sldId id="267" r:id="rId13"/>
+    <p:sldId id="268" r:id="rId14"/>
+    <p:sldId id="269" r:id="rId15"/>
+    <p:sldId id="270" r:id="rId16"/>
+    <p:sldId id="271" r:id="rId17"/>
+    <p:sldId id="272" r:id="rId18"/>
+    <p:sldId id="273" r:id="rId19"/>
   </p:sldIdLst>
-  <p:sldSz cx="12191695" cy="6858000" type="screen4x3"/>
+  <p:sldSz cx="12192000" cy="6858000"/>
   <p:notesSz cx="6858000" cy="9144000"/>
   <p:defaultTextStyle>
     <a:defPPr>
@@ -121,7 +121,559 @@
       </a:defRPr>
     </a:lvl9pPr>
   </p:defaultTextStyle>
+  <p:extLst>
+    <p:ext uri="{EFAFB233-063F-42B5-8137-9DF3F51BA10A}">
+      <p15:sldGuideLst xmlns:p15="http://schemas.microsoft.com/office/powerpoint/2012/main">
+        <p15:guide id="1" orient="horz" pos="2160">
+          <p15:clr>
+            <a:srgbClr val="A4A3A4"/>
+          </p15:clr>
+        </p15:guide>
+        <p15:guide id="2" pos="2880">
+          <p15:clr>
+            <a:srgbClr val="A4A3A4"/>
+          </p15:clr>
+        </p15:guide>
+      </p15:sldGuideLst>
+    </p:ext>
+  </p:extLst>
 </p:presentation>
+</file>
+
+<file path=ppt/changesInfos/changesInfo1.xml><?xml version="1.0" encoding="utf-8"?>
+<pc:chgInfo xmlns:a="http://schemas.openxmlformats.org/drawingml/2006/main" xmlns:r="http://schemas.openxmlformats.org/officeDocument/2006/relationships" xmlns:ac="http://schemas.microsoft.com/office/drawing/2013/main/command" xmlns:pc="http://schemas.microsoft.com/office/powerpoint/2013/main/command">
+  <pc:docChgLst>
+    <pc:chgData name="Saimalavika2005@outlook.com" userId="6fcc40f0fe87376b" providerId="LiveId" clId="{B072D48F-653C-4CB2-94AD-3F8ACA905B1B}"/>
+    <pc:docChg chg="undo custSel addSld delSld modSld">
+      <pc:chgData name="Saimalavika2005@outlook.com" userId="6fcc40f0fe87376b" providerId="LiveId" clId="{B072D48F-653C-4CB2-94AD-3F8ACA905B1B}" dt="2026-08-17T14:47:32.368" v="189" actId="14100"/>
+      <pc:docMkLst>
+        <pc:docMk/>
+      </pc:docMkLst>
+      <pc:sldChg chg="addSp delSp modSp mod">
+        <pc:chgData name="Saimalavika2005@outlook.com" userId="6fcc40f0fe87376b" providerId="LiveId" clId="{B072D48F-653C-4CB2-94AD-3F8ACA905B1B}" dt="2026-08-17T14:24:51.729" v="14" actId="478"/>
+        <pc:sldMkLst>
+          <pc:docMk/>
+          <pc:sldMk cId="0" sldId="256"/>
+        </pc:sldMkLst>
+        <pc:spChg chg="mod">
+          <ac:chgData name="Saimalavika2005@outlook.com" userId="6fcc40f0fe87376b" providerId="LiveId" clId="{B072D48F-653C-4CB2-94AD-3F8ACA905B1B}" dt="2026-08-17T14:24:28.284" v="12" actId="1036"/>
+          <ac:spMkLst>
+            <pc:docMk/>
+            <pc:sldMk cId="0" sldId="256"/>
+            <ac:spMk id="2" creationId="{00000000-0000-0000-0000-000000000000}"/>
+          </ac:spMkLst>
+        </pc:spChg>
+        <pc:spChg chg="del mod">
+          <ac:chgData name="Saimalavika2005@outlook.com" userId="6fcc40f0fe87376b" providerId="LiveId" clId="{B072D48F-653C-4CB2-94AD-3F8ACA905B1B}" dt="2026-08-17T14:24:51.729" v="14" actId="478"/>
+          <ac:spMkLst>
+            <pc:docMk/>
+            <pc:sldMk cId="0" sldId="256"/>
+            <ac:spMk id="4" creationId="{00000000-0000-0000-0000-000000000000}"/>
+          </ac:spMkLst>
+        </pc:spChg>
+        <pc:spChg chg="mod">
+          <ac:chgData name="Saimalavika2005@outlook.com" userId="6fcc40f0fe87376b" providerId="LiveId" clId="{B072D48F-653C-4CB2-94AD-3F8ACA905B1B}" dt="2026-08-17T14:22:42.400" v="0" actId="14100"/>
+          <ac:spMkLst>
+            <pc:docMk/>
+            <pc:sldMk cId="0" sldId="256"/>
+            <ac:spMk id="5" creationId="{00000000-0000-0000-0000-000000000000}"/>
+          </ac:spMkLst>
+        </pc:spChg>
+        <pc:spChg chg="add del mod">
+          <ac:chgData name="Saimalavika2005@outlook.com" userId="6fcc40f0fe87376b" providerId="LiveId" clId="{B072D48F-653C-4CB2-94AD-3F8ACA905B1B}" dt="2026-08-17T14:22:56.176" v="4" actId="478"/>
+          <ac:spMkLst>
+            <pc:docMk/>
+            <pc:sldMk cId="0" sldId="256"/>
+            <ac:spMk id="6" creationId="{00000000-0000-0000-0000-000000000000}"/>
+          </ac:spMkLst>
+        </pc:spChg>
+        <pc:picChg chg="add mod">
+          <ac:chgData name="Saimalavika2005@outlook.com" userId="6fcc40f0fe87376b" providerId="LiveId" clId="{B072D48F-653C-4CB2-94AD-3F8ACA905B1B}" dt="2026-08-17T14:24:22.397" v="11" actId="14100"/>
+          <ac:picMkLst>
+            <pc:docMk/>
+            <pc:sldMk cId="0" sldId="256"/>
+            <ac:picMk id="8" creationId="{5EF61963-33CB-EB93-FA7F-048FF994C97D}"/>
+          </ac:picMkLst>
+        </pc:picChg>
+      </pc:sldChg>
+      <pc:sldChg chg="addSp delSp modSp mod">
+        <pc:chgData name="Saimalavika2005@outlook.com" userId="6fcc40f0fe87376b" providerId="LiveId" clId="{B072D48F-653C-4CB2-94AD-3F8ACA905B1B}" dt="2026-08-17T14:26:06.255" v="26" actId="14100"/>
+        <pc:sldMkLst>
+          <pc:docMk/>
+          <pc:sldMk cId="0" sldId="257"/>
+        </pc:sldMkLst>
+        <pc:spChg chg="mod">
+          <ac:chgData name="Saimalavika2005@outlook.com" userId="6fcc40f0fe87376b" providerId="LiveId" clId="{B072D48F-653C-4CB2-94AD-3F8ACA905B1B}" dt="2026-08-17T14:25:14.847" v="16" actId="14100"/>
+          <ac:spMkLst>
+            <pc:docMk/>
+            <pc:sldMk cId="0" sldId="257"/>
+            <ac:spMk id="5" creationId="{00000000-0000-0000-0000-000000000000}"/>
+          </ac:spMkLst>
+        </pc:spChg>
+        <pc:spChg chg="mod">
+          <ac:chgData name="Saimalavika2005@outlook.com" userId="6fcc40f0fe87376b" providerId="LiveId" clId="{B072D48F-653C-4CB2-94AD-3F8ACA905B1B}" dt="2026-08-17T14:25:25.954" v="17" actId="14100"/>
+          <ac:spMkLst>
+            <pc:docMk/>
+            <pc:sldMk cId="0" sldId="257"/>
+            <ac:spMk id="6" creationId="{00000000-0000-0000-0000-000000000000}"/>
+          </ac:spMkLst>
+        </pc:spChg>
+        <pc:spChg chg="del mod">
+          <ac:chgData name="Saimalavika2005@outlook.com" userId="6fcc40f0fe87376b" providerId="LiveId" clId="{B072D48F-653C-4CB2-94AD-3F8ACA905B1B}" dt="2026-08-17T14:25:32.087" v="19" actId="478"/>
+          <ac:spMkLst>
+            <pc:docMk/>
+            <pc:sldMk cId="0" sldId="257"/>
+            <ac:spMk id="7" creationId="{00000000-0000-0000-0000-000000000000}"/>
+          </ac:spMkLst>
+        </pc:spChg>
+        <pc:picChg chg="add mod">
+          <ac:chgData name="Saimalavika2005@outlook.com" userId="6fcc40f0fe87376b" providerId="LiveId" clId="{B072D48F-653C-4CB2-94AD-3F8ACA905B1B}" dt="2026-08-17T14:26:06.255" v="26" actId="14100"/>
+          <ac:picMkLst>
+            <pc:docMk/>
+            <pc:sldMk cId="0" sldId="257"/>
+            <ac:picMk id="9" creationId="{DAC6F162-CDF1-6000-F549-39F935F2E793}"/>
+          </ac:picMkLst>
+        </pc:picChg>
+      </pc:sldChg>
+      <pc:sldChg chg="addSp delSp modSp mod">
+        <pc:chgData name="Saimalavika2005@outlook.com" userId="6fcc40f0fe87376b" providerId="LiveId" clId="{B072D48F-653C-4CB2-94AD-3F8ACA905B1B}" dt="2026-08-17T14:28:16.641" v="38" actId="732"/>
+        <pc:sldMkLst>
+          <pc:docMk/>
+          <pc:sldMk cId="0" sldId="258"/>
+        </pc:sldMkLst>
+        <pc:spChg chg="mod">
+          <ac:chgData name="Saimalavika2005@outlook.com" userId="6fcc40f0fe87376b" providerId="LiveId" clId="{B072D48F-653C-4CB2-94AD-3F8ACA905B1B}" dt="2026-08-17T14:26:24.180" v="28" actId="14100"/>
+          <ac:spMkLst>
+            <pc:docMk/>
+            <pc:sldMk cId="0" sldId="258"/>
+            <ac:spMk id="5" creationId="{00000000-0000-0000-0000-000000000000}"/>
+          </ac:spMkLst>
+        </pc:spChg>
+        <pc:spChg chg="mod">
+          <ac:chgData name="Saimalavika2005@outlook.com" userId="6fcc40f0fe87376b" providerId="LiveId" clId="{B072D48F-653C-4CB2-94AD-3F8ACA905B1B}" dt="2026-08-17T14:26:36.184" v="31" actId="14100"/>
+          <ac:spMkLst>
+            <pc:docMk/>
+            <pc:sldMk cId="0" sldId="258"/>
+            <ac:spMk id="6" creationId="{00000000-0000-0000-0000-000000000000}"/>
+          </ac:spMkLst>
+        </pc:spChg>
+        <pc:spChg chg="del mod">
+          <ac:chgData name="Saimalavika2005@outlook.com" userId="6fcc40f0fe87376b" providerId="LiveId" clId="{B072D48F-653C-4CB2-94AD-3F8ACA905B1B}" dt="2026-08-17T14:26:29.753" v="30" actId="478"/>
+          <ac:spMkLst>
+            <pc:docMk/>
+            <pc:sldMk cId="0" sldId="258"/>
+            <ac:spMk id="7" creationId="{00000000-0000-0000-0000-000000000000}"/>
+          </ac:spMkLst>
+        </pc:spChg>
+        <pc:picChg chg="add mod modCrop">
+          <ac:chgData name="Saimalavika2005@outlook.com" userId="6fcc40f0fe87376b" providerId="LiveId" clId="{B072D48F-653C-4CB2-94AD-3F8ACA905B1B}" dt="2026-08-17T14:28:16.641" v="38" actId="732"/>
+          <ac:picMkLst>
+            <pc:docMk/>
+            <pc:sldMk cId="0" sldId="258"/>
+            <ac:picMk id="9" creationId="{A10E2CC9-E887-6A87-45DA-3973766B875D}"/>
+          </ac:picMkLst>
+        </pc:picChg>
+      </pc:sldChg>
+      <pc:sldChg chg="addSp delSp modSp mod">
+        <pc:chgData name="Saimalavika2005@outlook.com" userId="6fcc40f0fe87376b" providerId="LiveId" clId="{B072D48F-653C-4CB2-94AD-3F8ACA905B1B}" dt="2026-08-17T14:32:57.132" v="84" actId="14100"/>
+        <pc:sldMkLst>
+          <pc:docMk/>
+          <pc:sldMk cId="0" sldId="259"/>
+        </pc:sldMkLst>
+        <pc:spChg chg="mod">
+          <ac:chgData name="Saimalavika2005@outlook.com" userId="6fcc40f0fe87376b" providerId="LiveId" clId="{B072D48F-653C-4CB2-94AD-3F8ACA905B1B}" dt="2026-08-17T14:28:33.904" v="40" actId="14100"/>
+          <ac:spMkLst>
+            <pc:docMk/>
+            <pc:sldMk cId="0" sldId="259"/>
+            <ac:spMk id="5" creationId="{00000000-0000-0000-0000-000000000000}"/>
+          </ac:spMkLst>
+        </pc:spChg>
+        <pc:spChg chg="mod">
+          <ac:chgData name="Saimalavika2005@outlook.com" userId="6fcc40f0fe87376b" providerId="LiveId" clId="{B072D48F-653C-4CB2-94AD-3F8ACA905B1B}" dt="2026-08-17T14:32:30.917" v="77" actId="14100"/>
+          <ac:spMkLst>
+            <pc:docMk/>
+            <pc:sldMk cId="0" sldId="259"/>
+            <ac:spMk id="6" creationId="{00000000-0000-0000-0000-000000000000}"/>
+          </ac:spMkLst>
+        </pc:spChg>
+        <pc:spChg chg="add del">
+          <ac:chgData name="Saimalavika2005@outlook.com" userId="6fcc40f0fe87376b" providerId="LiveId" clId="{B072D48F-653C-4CB2-94AD-3F8ACA905B1B}" dt="2026-08-17T14:32:32.550" v="78" actId="478"/>
+          <ac:spMkLst>
+            <pc:docMk/>
+            <pc:sldMk cId="0" sldId="259"/>
+            <ac:spMk id="7" creationId="{00000000-0000-0000-0000-000000000000}"/>
+          </ac:spMkLst>
+        </pc:spChg>
+        <pc:picChg chg="add del mod">
+          <ac:chgData name="Saimalavika2005@outlook.com" userId="6fcc40f0fe87376b" providerId="LiveId" clId="{B072D48F-653C-4CB2-94AD-3F8ACA905B1B}" dt="2026-08-17T14:32:14.261" v="74" actId="931"/>
+          <ac:picMkLst>
+            <pc:docMk/>
+            <pc:sldMk cId="0" sldId="259"/>
+            <ac:picMk id="9" creationId="{EF945D7E-4FED-79A0-D4EA-F73E5717E475}"/>
+          </ac:picMkLst>
+        </pc:picChg>
+        <pc:picChg chg="add mod">
+          <ac:chgData name="Saimalavika2005@outlook.com" userId="6fcc40f0fe87376b" providerId="LiveId" clId="{B072D48F-653C-4CB2-94AD-3F8ACA905B1B}" dt="2026-08-17T14:32:57.132" v="84" actId="14100"/>
+          <ac:picMkLst>
+            <pc:docMk/>
+            <pc:sldMk cId="0" sldId="259"/>
+            <ac:picMk id="11" creationId="{A3FAA9DB-B71C-0242-ABF1-1E5B7FB1BC38}"/>
+          </ac:picMkLst>
+        </pc:picChg>
+      </pc:sldChg>
+      <pc:sldChg chg="addSp delSp modSp mod">
+        <pc:chgData name="Saimalavika2005@outlook.com" userId="6fcc40f0fe87376b" providerId="LiveId" clId="{B072D48F-653C-4CB2-94AD-3F8ACA905B1B}" dt="2026-08-17T14:34:17.313" v="96" actId="14100"/>
+        <pc:sldMkLst>
+          <pc:docMk/>
+          <pc:sldMk cId="0" sldId="260"/>
+        </pc:sldMkLst>
+        <pc:spChg chg="mod">
+          <ac:chgData name="Saimalavika2005@outlook.com" userId="6fcc40f0fe87376b" providerId="LiveId" clId="{B072D48F-653C-4CB2-94AD-3F8ACA905B1B}" dt="2026-08-17T14:33:14.281" v="86" actId="14100"/>
+          <ac:spMkLst>
+            <pc:docMk/>
+            <pc:sldMk cId="0" sldId="260"/>
+            <ac:spMk id="5" creationId="{00000000-0000-0000-0000-000000000000}"/>
+          </ac:spMkLst>
+        </pc:spChg>
+        <pc:spChg chg="mod">
+          <ac:chgData name="Saimalavika2005@outlook.com" userId="6fcc40f0fe87376b" providerId="LiveId" clId="{B072D48F-653C-4CB2-94AD-3F8ACA905B1B}" dt="2026-08-17T14:33:23.077" v="87" actId="14100"/>
+          <ac:spMkLst>
+            <pc:docMk/>
+            <pc:sldMk cId="0" sldId="260"/>
+            <ac:spMk id="6" creationId="{00000000-0000-0000-0000-000000000000}"/>
+          </ac:spMkLst>
+        </pc:spChg>
+        <pc:spChg chg="add del">
+          <ac:chgData name="Saimalavika2005@outlook.com" userId="6fcc40f0fe87376b" providerId="LiveId" clId="{B072D48F-653C-4CB2-94AD-3F8ACA905B1B}" dt="2026-08-17T14:33:29.408" v="88" actId="478"/>
+          <ac:spMkLst>
+            <pc:docMk/>
+            <pc:sldMk cId="0" sldId="260"/>
+            <ac:spMk id="7" creationId="{00000000-0000-0000-0000-000000000000}"/>
+          </ac:spMkLst>
+        </pc:spChg>
+        <pc:picChg chg="add mod">
+          <ac:chgData name="Saimalavika2005@outlook.com" userId="6fcc40f0fe87376b" providerId="LiveId" clId="{B072D48F-653C-4CB2-94AD-3F8ACA905B1B}" dt="2026-08-17T14:34:17.313" v="96" actId="14100"/>
+          <ac:picMkLst>
+            <pc:docMk/>
+            <pc:sldMk cId="0" sldId="260"/>
+            <ac:picMk id="9" creationId="{A4908E5F-827F-12A9-1F51-88D67C04AAF5}"/>
+          </ac:picMkLst>
+        </pc:picChg>
+      </pc:sldChg>
+      <pc:sldChg chg="addSp delSp modSp mod">
+        <pc:chgData name="Saimalavika2005@outlook.com" userId="6fcc40f0fe87376b" providerId="LiveId" clId="{B072D48F-653C-4CB2-94AD-3F8ACA905B1B}" dt="2026-08-17T14:35:17.309" v="107" actId="14100"/>
+        <pc:sldMkLst>
+          <pc:docMk/>
+          <pc:sldMk cId="0" sldId="261"/>
+        </pc:sldMkLst>
+        <pc:spChg chg="mod">
+          <ac:chgData name="Saimalavika2005@outlook.com" userId="6fcc40f0fe87376b" providerId="LiveId" clId="{B072D48F-653C-4CB2-94AD-3F8ACA905B1B}" dt="2026-08-17T14:34:32.919" v="98" actId="14100"/>
+          <ac:spMkLst>
+            <pc:docMk/>
+            <pc:sldMk cId="0" sldId="261"/>
+            <ac:spMk id="5" creationId="{00000000-0000-0000-0000-000000000000}"/>
+          </ac:spMkLst>
+        </pc:spChg>
+        <pc:spChg chg="mod">
+          <ac:chgData name="Saimalavika2005@outlook.com" userId="6fcc40f0fe87376b" providerId="LiveId" clId="{B072D48F-653C-4CB2-94AD-3F8ACA905B1B}" dt="2026-08-17T14:34:38.689" v="99" actId="14100"/>
+          <ac:spMkLst>
+            <pc:docMk/>
+            <pc:sldMk cId="0" sldId="261"/>
+            <ac:spMk id="6" creationId="{00000000-0000-0000-0000-000000000000}"/>
+          </ac:spMkLst>
+        </pc:spChg>
+        <pc:spChg chg="del">
+          <ac:chgData name="Saimalavika2005@outlook.com" userId="6fcc40f0fe87376b" providerId="LiveId" clId="{B072D48F-653C-4CB2-94AD-3F8ACA905B1B}" dt="2026-08-17T14:34:48.767" v="100" actId="478"/>
+          <ac:spMkLst>
+            <pc:docMk/>
+            <pc:sldMk cId="0" sldId="261"/>
+            <ac:spMk id="7" creationId="{00000000-0000-0000-0000-000000000000}"/>
+          </ac:spMkLst>
+        </pc:spChg>
+        <pc:picChg chg="add mod">
+          <ac:chgData name="Saimalavika2005@outlook.com" userId="6fcc40f0fe87376b" providerId="LiveId" clId="{B072D48F-653C-4CB2-94AD-3F8ACA905B1B}" dt="2026-08-17T14:35:17.309" v="107" actId="14100"/>
+          <ac:picMkLst>
+            <pc:docMk/>
+            <pc:sldMk cId="0" sldId="261"/>
+            <ac:picMk id="9" creationId="{F831F723-62F6-36F4-19E9-0AA5144F4C21}"/>
+          </ac:picMkLst>
+        </pc:picChg>
+      </pc:sldChg>
+      <pc:sldChg chg="addSp delSp modSp mod">
+        <pc:chgData name="Saimalavika2005@outlook.com" userId="6fcc40f0fe87376b" providerId="LiveId" clId="{B072D48F-653C-4CB2-94AD-3F8ACA905B1B}" dt="2026-08-17T14:37:30.943" v="117" actId="1076"/>
+        <pc:sldMkLst>
+          <pc:docMk/>
+          <pc:sldMk cId="0" sldId="262"/>
+        </pc:sldMkLst>
+        <pc:spChg chg="mod">
+          <ac:chgData name="Saimalavika2005@outlook.com" userId="6fcc40f0fe87376b" providerId="LiveId" clId="{B072D48F-653C-4CB2-94AD-3F8ACA905B1B}" dt="2026-08-17T14:35:34.319" v="108" actId="14100"/>
+          <ac:spMkLst>
+            <pc:docMk/>
+            <pc:sldMk cId="0" sldId="262"/>
+            <ac:spMk id="5" creationId="{00000000-0000-0000-0000-000000000000}"/>
+          </ac:spMkLst>
+        </pc:spChg>
+        <pc:spChg chg="mod">
+          <ac:chgData name="Saimalavika2005@outlook.com" userId="6fcc40f0fe87376b" providerId="LiveId" clId="{B072D48F-653C-4CB2-94AD-3F8ACA905B1B}" dt="2026-08-17T14:35:41.387" v="109" actId="14100"/>
+          <ac:spMkLst>
+            <pc:docMk/>
+            <pc:sldMk cId="0" sldId="262"/>
+            <ac:spMk id="6" creationId="{00000000-0000-0000-0000-000000000000}"/>
+          </ac:spMkLst>
+        </pc:spChg>
+        <pc:spChg chg="del">
+          <ac:chgData name="Saimalavika2005@outlook.com" userId="6fcc40f0fe87376b" providerId="LiveId" clId="{B072D48F-653C-4CB2-94AD-3F8ACA905B1B}" dt="2026-08-17T14:35:44.659" v="110" actId="478"/>
+          <ac:spMkLst>
+            <pc:docMk/>
+            <pc:sldMk cId="0" sldId="262"/>
+            <ac:spMk id="7" creationId="{00000000-0000-0000-0000-000000000000}"/>
+          </ac:spMkLst>
+        </pc:spChg>
+        <pc:picChg chg="add mod modCrop">
+          <ac:chgData name="Saimalavika2005@outlook.com" userId="6fcc40f0fe87376b" providerId="LiveId" clId="{B072D48F-653C-4CB2-94AD-3F8ACA905B1B}" dt="2026-08-17T14:37:30.943" v="117" actId="1076"/>
+          <ac:picMkLst>
+            <pc:docMk/>
+            <pc:sldMk cId="0" sldId="262"/>
+            <ac:picMk id="9" creationId="{F988D3C4-6BA1-E77D-00DF-4973980872C4}"/>
+          </ac:picMkLst>
+        </pc:picChg>
+      </pc:sldChg>
+      <pc:sldChg chg="addSp delSp modSp mod">
+        <pc:chgData name="Saimalavika2005@outlook.com" userId="6fcc40f0fe87376b" providerId="LiveId" clId="{B072D48F-653C-4CB2-94AD-3F8ACA905B1B}" dt="2026-08-17T14:41:11.901" v="131" actId="1076"/>
+        <pc:sldMkLst>
+          <pc:docMk/>
+          <pc:sldMk cId="0" sldId="263"/>
+        </pc:sldMkLst>
+        <pc:spChg chg="mod">
+          <ac:chgData name="Saimalavika2005@outlook.com" userId="6fcc40f0fe87376b" providerId="LiveId" clId="{B072D48F-653C-4CB2-94AD-3F8ACA905B1B}" dt="2026-08-17T14:40:23.025" v="121" actId="1076"/>
+          <ac:spMkLst>
+            <pc:docMk/>
+            <pc:sldMk cId="0" sldId="263"/>
+            <ac:spMk id="2" creationId="{00000000-0000-0000-0000-000000000000}"/>
+          </ac:spMkLst>
+        </pc:spChg>
+        <pc:spChg chg="mod">
+          <ac:chgData name="Saimalavika2005@outlook.com" userId="6fcc40f0fe87376b" providerId="LiveId" clId="{B072D48F-653C-4CB2-94AD-3F8ACA905B1B}" dt="2026-08-17T14:40:55.508" v="126" actId="14100"/>
+          <ac:spMkLst>
+            <pc:docMk/>
+            <pc:sldMk cId="0" sldId="263"/>
+            <ac:spMk id="5" creationId="{00000000-0000-0000-0000-000000000000}"/>
+          </ac:spMkLst>
+        </pc:spChg>
+        <pc:spChg chg="mod">
+          <ac:chgData name="Saimalavika2005@outlook.com" userId="6fcc40f0fe87376b" providerId="LiveId" clId="{B072D48F-653C-4CB2-94AD-3F8ACA905B1B}" dt="2026-08-17T14:40:59.262" v="127" actId="14100"/>
+          <ac:spMkLst>
+            <pc:docMk/>
+            <pc:sldMk cId="0" sldId="263"/>
+            <ac:spMk id="6" creationId="{00000000-0000-0000-0000-000000000000}"/>
+          </ac:spMkLst>
+        </pc:spChg>
+        <pc:spChg chg="del">
+          <ac:chgData name="Saimalavika2005@outlook.com" userId="6fcc40f0fe87376b" providerId="LiveId" clId="{B072D48F-653C-4CB2-94AD-3F8ACA905B1B}" dt="2026-08-17T14:40:08.657" v="119" actId="478"/>
+          <ac:spMkLst>
+            <pc:docMk/>
+            <pc:sldMk cId="0" sldId="263"/>
+            <ac:spMk id="7" creationId="{00000000-0000-0000-0000-000000000000}"/>
+          </ac:spMkLst>
+        </pc:spChg>
+        <pc:picChg chg="add mod">
+          <ac:chgData name="Saimalavika2005@outlook.com" userId="6fcc40f0fe87376b" providerId="LiveId" clId="{B072D48F-653C-4CB2-94AD-3F8ACA905B1B}" dt="2026-08-17T14:41:11.901" v="131" actId="1076"/>
+          <ac:picMkLst>
+            <pc:docMk/>
+            <pc:sldMk cId="0" sldId="263"/>
+            <ac:picMk id="9" creationId="{FCD46FDE-DE2E-2C58-A759-FB842293CCEB}"/>
+          </ac:picMkLst>
+        </pc:picChg>
+      </pc:sldChg>
+      <pc:sldChg chg="addSp delSp modSp mod">
+        <pc:chgData name="Saimalavika2005@outlook.com" userId="6fcc40f0fe87376b" providerId="LiveId" clId="{B072D48F-653C-4CB2-94AD-3F8ACA905B1B}" dt="2026-08-17T14:42:45.245" v="147" actId="14100"/>
+        <pc:sldMkLst>
+          <pc:docMk/>
+          <pc:sldMk cId="0" sldId="264"/>
+        </pc:sldMkLst>
+        <pc:spChg chg="mod">
+          <ac:chgData name="Saimalavika2005@outlook.com" userId="6fcc40f0fe87376b" providerId="LiveId" clId="{B072D48F-653C-4CB2-94AD-3F8ACA905B1B}" dt="2026-08-17T14:41:59.856" v="133" actId="14100"/>
+          <ac:spMkLst>
+            <pc:docMk/>
+            <pc:sldMk cId="0" sldId="264"/>
+            <ac:spMk id="5" creationId="{00000000-0000-0000-0000-000000000000}"/>
+          </ac:spMkLst>
+        </pc:spChg>
+        <pc:spChg chg="mod">
+          <ac:chgData name="Saimalavika2005@outlook.com" userId="6fcc40f0fe87376b" providerId="LiveId" clId="{B072D48F-653C-4CB2-94AD-3F8ACA905B1B}" dt="2026-08-17T14:42:11.359" v="139" actId="14100"/>
+          <ac:spMkLst>
+            <pc:docMk/>
+            <pc:sldMk cId="0" sldId="264"/>
+            <ac:spMk id="6" creationId="{00000000-0000-0000-0000-000000000000}"/>
+          </ac:spMkLst>
+        </pc:spChg>
+        <pc:spChg chg="del mod">
+          <ac:chgData name="Saimalavika2005@outlook.com" userId="6fcc40f0fe87376b" providerId="LiveId" clId="{B072D48F-653C-4CB2-94AD-3F8ACA905B1B}" dt="2026-08-17T14:42:04.479" v="136" actId="478"/>
+          <ac:spMkLst>
+            <pc:docMk/>
+            <pc:sldMk cId="0" sldId="264"/>
+            <ac:spMk id="7" creationId="{00000000-0000-0000-0000-000000000000}"/>
+          </ac:spMkLst>
+        </pc:spChg>
+        <pc:picChg chg="add mod">
+          <ac:chgData name="Saimalavika2005@outlook.com" userId="6fcc40f0fe87376b" providerId="LiveId" clId="{B072D48F-653C-4CB2-94AD-3F8ACA905B1B}" dt="2026-08-17T14:42:45.245" v="147" actId="14100"/>
+          <ac:picMkLst>
+            <pc:docMk/>
+            <pc:sldMk cId="0" sldId="264"/>
+            <ac:picMk id="9" creationId="{4530877D-9C0B-F80A-3AC0-53119E655FE0}"/>
+          </ac:picMkLst>
+        </pc:picChg>
+      </pc:sldChg>
+      <pc:sldChg chg="addSp delSp modSp mod">
+        <pc:chgData name="Saimalavika2005@outlook.com" userId="6fcc40f0fe87376b" providerId="LiveId" clId="{B072D48F-653C-4CB2-94AD-3F8ACA905B1B}" dt="2026-08-17T14:44:08.146" v="151" actId="931"/>
+        <pc:sldMkLst>
+          <pc:docMk/>
+          <pc:sldMk cId="0" sldId="265"/>
+        </pc:sldMkLst>
+        <pc:spChg chg="mod">
+          <ac:chgData name="Saimalavika2005@outlook.com" userId="6fcc40f0fe87376b" providerId="LiveId" clId="{B072D48F-653C-4CB2-94AD-3F8ACA905B1B}" dt="2026-08-17T14:43:42.388" v="149" actId="14100"/>
+          <ac:spMkLst>
+            <pc:docMk/>
+            <pc:sldMk cId="0" sldId="265"/>
+            <ac:spMk id="5" creationId="{00000000-0000-0000-0000-000000000000}"/>
+          </ac:spMkLst>
+        </pc:spChg>
+        <pc:picChg chg="add del mod">
+          <ac:chgData name="Saimalavika2005@outlook.com" userId="6fcc40f0fe87376b" providerId="LiveId" clId="{B072D48F-653C-4CB2-94AD-3F8ACA905B1B}" dt="2026-08-17T14:44:08.146" v="151" actId="931"/>
+          <ac:picMkLst>
+            <pc:docMk/>
+            <pc:sldMk cId="0" sldId="265"/>
+            <ac:picMk id="9" creationId="{ABE89728-C811-EFBD-5101-40EFBEB31DE3}"/>
+          </ac:picMkLst>
+        </pc:picChg>
+      </pc:sldChg>
+      <pc:sldChg chg="addSp delSp modSp mod">
+        <pc:chgData name="Saimalavika2005@outlook.com" userId="6fcc40f0fe87376b" providerId="LiveId" clId="{B072D48F-653C-4CB2-94AD-3F8ACA905B1B}" dt="2026-08-17T14:45:24.198" v="164" actId="14100"/>
+        <pc:sldMkLst>
+          <pc:docMk/>
+          <pc:sldMk cId="0" sldId="266"/>
+        </pc:sldMkLst>
+        <pc:spChg chg="mod">
+          <ac:chgData name="Saimalavika2005@outlook.com" userId="6fcc40f0fe87376b" providerId="LiveId" clId="{B072D48F-653C-4CB2-94AD-3F8ACA905B1B}" dt="2026-08-17T14:44:19.192" v="152" actId="14100"/>
+          <ac:spMkLst>
+            <pc:docMk/>
+            <pc:sldMk cId="0" sldId="266"/>
+            <ac:spMk id="5" creationId="{00000000-0000-0000-0000-000000000000}"/>
+          </ac:spMkLst>
+        </pc:spChg>
+        <pc:spChg chg="mod">
+          <ac:chgData name="Saimalavika2005@outlook.com" userId="6fcc40f0fe87376b" providerId="LiveId" clId="{B072D48F-653C-4CB2-94AD-3F8ACA905B1B}" dt="2026-08-17T14:44:28.334" v="153" actId="14100"/>
+          <ac:spMkLst>
+            <pc:docMk/>
+            <pc:sldMk cId="0" sldId="266"/>
+            <ac:spMk id="6" creationId="{00000000-0000-0000-0000-000000000000}"/>
+          </ac:spMkLst>
+        </pc:spChg>
+        <pc:spChg chg="del">
+          <ac:chgData name="Saimalavika2005@outlook.com" userId="6fcc40f0fe87376b" providerId="LiveId" clId="{B072D48F-653C-4CB2-94AD-3F8ACA905B1B}" dt="2026-08-17T14:44:31.966" v="154" actId="478"/>
+          <ac:spMkLst>
+            <pc:docMk/>
+            <pc:sldMk cId="0" sldId="266"/>
+            <ac:spMk id="7" creationId="{00000000-0000-0000-0000-000000000000}"/>
+          </ac:spMkLst>
+        </pc:spChg>
+        <pc:picChg chg="add mod modCrop">
+          <ac:chgData name="Saimalavika2005@outlook.com" userId="6fcc40f0fe87376b" providerId="LiveId" clId="{B072D48F-653C-4CB2-94AD-3F8ACA905B1B}" dt="2026-08-17T14:45:24.198" v="164" actId="14100"/>
+          <ac:picMkLst>
+            <pc:docMk/>
+            <pc:sldMk cId="0" sldId="266"/>
+            <ac:picMk id="9" creationId="{837A7EA3-B248-4A1C-68CA-815BF6A935B8}"/>
+          </ac:picMkLst>
+        </pc:picChg>
+      </pc:sldChg>
+      <pc:sldChg chg="addSp delSp modSp mod">
+        <pc:chgData name="Saimalavika2005@outlook.com" userId="6fcc40f0fe87376b" providerId="LiveId" clId="{B072D48F-653C-4CB2-94AD-3F8ACA905B1B}" dt="2026-08-17T14:46:34.827" v="179" actId="1076"/>
+        <pc:sldMkLst>
+          <pc:docMk/>
+          <pc:sldMk cId="0" sldId="267"/>
+        </pc:sldMkLst>
+        <pc:spChg chg="mod">
+          <ac:chgData name="Saimalavika2005@outlook.com" userId="6fcc40f0fe87376b" providerId="LiveId" clId="{B072D48F-653C-4CB2-94AD-3F8ACA905B1B}" dt="2026-08-17T14:45:40.240" v="166" actId="1076"/>
+          <ac:spMkLst>
+            <pc:docMk/>
+            <pc:sldMk cId="0" sldId="267"/>
+            <ac:spMk id="5" creationId="{00000000-0000-0000-0000-000000000000}"/>
+          </ac:spMkLst>
+        </pc:spChg>
+        <pc:spChg chg="mod">
+          <ac:chgData name="Saimalavika2005@outlook.com" userId="6fcc40f0fe87376b" providerId="LiveId" clId="{B072D48F-653C-4CB2-94AD-3F8ACA905B1B}" dt="2026-08-17T14:45:50.486" v="168" actId="14100"/>
+          <ac:spMkLst>
+            <pc:docMk/>
+            <pc:sldMk cId="0" sldId="267"/>
+            <ac:spMk id="6" creationId="{00000000-0000-0000-0000-000000000000}"/>
+          </ac:spMkLst>
+        </pc:spChg>
+        <pc:spChg chg="del">
+          <ac:chgData name="Saimalavika2005@outlook.com" userId="6fcc40f0fe87376b" providerId="LiveId" clId="{B072D48F-653C-4CB2-94AD-3F8ACA905B1B}" dt="2026-08-17T14:45:46.166" v="167" actId="478"/>
+          <ac:spMkLst>
+            <pc:docMk/>
+            <pc:sldMk cId="0" sldId="267"/>
+            <ac:spMk id="7" creationId="{00000000-0000-0000-0000-000000000000}"/>
+          </ac:spMkLst>
+        </pc:spChg>
+        <pc:picChg chg="add mod">
+          <ac:chgData name="Saimalavika2005@outlook.com" userId="6fcc40f0fe87376b" providerId="LiveId" clId="{B072D48F-653C-4CB2-94AD-3F8ACA905B1B}" dt="2026-08-17T14:46:34.827" v="179" actId="1076"/>
+          <ac:picMkLst>
+            <pc:docMk/>
+            <pc:sldMk cId="0" sldId="267"/>
+            <ac:picMk id="9" creationId="{68A1E83F-EF44-B3F0-296F-41BE8DF88AD0}"/>
+          </ac:picMkLst>
+        </pc:picChg>
+      </pc:sldChg>
+      <pc:sldChg chg="addSp delSp modSp mod">
+        <pc:chgData name="Saimalavika2005@outlook.com" userId="6fcc40f0fe87376b" providerId="LiveId" clId="{B072D48F-653C-4CB2-94AD-3F8ACA905B1B}" dt="2026-08-17T14:47:32.368" v="189" actId="14100"/>
+        <pc:sldMkLst>
+          <pc:docMk/>
+          <pc:sldMk cId="0" sldId="268"/>
+        </pc:sldMkLst>
+        <pc:spChg chg="mod">
+          <ac:chgData name="Saimalavika2005@outlook.com" userId="6fcc40f0fe87376b" providerId="LiveId" clId="{B072D48F-653C-4CB2-94AD-3F8ACA905B1B}" dt="2026-08-17T14:46:56.715" v="181" actId="14100"/>
+          <ac:spMkLst>
+            <pc:docMk/>
+            <pc:sldMk cId="0" sldId="268"/>
+            <ac:spMk id="5" creationId="{00000000-0000-0000-0000-000000000000}"/>
+          </ac:spMkLst>
+        </pc:spChg>
+        <pc:spChg chg="mod">
+          <ac:chgData name="Saimalavika2005@outlook.com" userId="6fcc40f0fe87376b" providerId="LiveId" clId="{B072D48F-653C-4CB2-94AD-3F8ACA905B1B}" dt="2026-08-17T14:47:03.951" v="182" actId="14100"/>
+          <ac:spMkLst>
+            <pc:docMk/>
+            <pc:sldMk cId="0" sldId="268"/>
+            <ac:spMk id="6" creationId="{00000000-0000-0000-0000-000000000000}"/>
+          </ac:spMkLst>
+        </pc:spChg>
+        <pc:spChg chg="del">
+          <ac:chgData name="Saimalavika2005@outlook.com" userId="6fcc40f0fe87376b" providerId="LiveId" clId="{B072D48F-653C-4CB2-94AD-3F8ACA905B1B}" dt="2026-08-17T14:47:06.008" v="183" actId="478"/>
+          <ac:spMkLst>
+            <pc:docMk/>
+            <pc:sldMk cId="0" sldId="268"/>
+            <ac:spMk id="7" creationId="{00000000-0000-0000-0000-000000000000}"/>
+          </ac:spMkLst>
+        </pc:spChg>
+        <pc:picChg chg="add mod">
+          <ac:chgData name="Saimalavika2005@outlook.com" userId="6fcc40f0fe87376b" providerId="LiveId" clId="{B072D48F-653C-4CB2-94AD-3F8ACA905B1B}" dt="2026-08-17T14:47:32.368" v="189" actId="14100"/>
+          <ac:picMkLst>
+            <pc:docMk/>
+            <pc:sldMk cId="0" sldId="268"/>
+            <ac:picMk id="9" creationId="{DA961525-23FE-6F0E-9E2A-6596398C02CB}"/>
+          </ac:picMkLst>
+        </pc:picChg>
+      </pc:sldChg>
+      <pc:sldChg chg="new del">
+        <pc:chgData name="Saimalavika2005@outlook.com" userId="6fcc40f0fe87376b" providerId="LiveId" clId="{B072D48F-653C-4CB2-94AD-3F8ACA905B1B}" dt="2026-08-17T14:30:19.113" v="59" actId="680"/>
+        <pc:sldMkLst>
+          <pc:docMk/>
+          <pc:sldMk cId="1697489935" sldId="274"/>
+        </pc:sldMkLst>
+      </pc:sldChg>
+    </pc:docChg>
+  </pc:docChgLst>
+</pc:chgInfo>
 </file>
 
 <file path=ppt/slideLayouts/slideLayout1.xml><?xml version="1.0" encoding="utf-8"?>
@@ -162,10 +714,9 @@
           <a:lstStyle/>
           <a:p>
             <a:r>
-              <a:rPr lang="en-US" smtClean="0"/>
+              <a:rPr lang="en-US"/>
               <a:t>Click to edit Master title style</a:t>
             </a:r>
-            <a:endParaRPr lang="en-US"/>
           </a:p>
         </p:txBody>
       </p:sp>
@@ -281,10 +832,9 @@
           </a:lstStyle>
           <a:p>
             <a:r>
-              <a:rPr lang="en-US" smtClean="0"/>
+              <a:rPr lang="en-US"/>
               <a:t>Click to edit Master subtitle style</a:t>
             </a:r>
-            <a:endParaRPr lang="en-US"/>
           </a:p>
         </p:txBody>
       </p:sp>
@@ -305,7 +855,7 @@
           <a:p>
             <a:fld id="{5BCAD085-E8A6-8845-BD4E-CB4CCA059FC4}" type="datetimeFigureOut">
               <a:rPr lang="en-US" smtClean="0"/>
-              <a:t>1/27/13</a:t>
+              <a:t>8/17/2026</a:t>
             </a:fld>
             <a:endParaRPr lang="en-US"/>
           </a:p>
@@ -399,10 +949,9 @@
           <a:lstStyle/>
           <a:p>
             <a:r>
-              <a:rPr lang="en-US" smtClean="0"/>
+              <a:rPr lang="en-US"/>
               <a:t>Click to edit Master title style</a:t>
             </a:r>
-            <a:endParaRPr lang="en-US"/>
           </a:p>
         </p:txBody>
       </p:sp>
@@ -423,38 +972,37 @@
           <a:p>
             <a:pPr lvl="0"/>
             <a:r>
-              <a:rPr lang="en-US" smtClean="0"/>
+              <a:rPr lang="en-US"/>
               <a:t>Click to edit Master text styles</a:t>
             </a:r>
           </a:p>
           <a:p>
             <a:pPr lvl="1"/>
             <a:r>
-              <a:rPr lang="en-US" smtClean="0"/>
+              <a:rPr lang="en-US"/>
               <a:t>Second level</a:t>
             </a:r>
           </a:p>
           <a:p>
             <a:pPr lvl="2"/>
             <a:r>
-              <a:rPr lang="en-US" smtClean="0"/>
+              <a:rPr lang="en-US"/>
               <a:t>Third level</a:t>
             </a:r>
           </a:p>
           <a:p>
             <a:pPr lvl="3"/>
             <a:r>
-              <a:rPr lang="en-US" smtClean="0"/>
+              <a:rPr lang="en-US"/>
               <a:t>Fourth level</a:t>
             </a:r>
           </a:p>
           <a:p>
             <a:pPr lvl="4"/>
             <a:r>
-              <a:rPr lang="en-US" smtClean="0"/>
+              <a:rPr lang="en-US"/>
               <a:t>Fifth level</a:t>
             </a:r>
-            <a:endParaRPr lang="en-US"/>
           </a:p>
         </p:txBody>
       </p:sp>
@@ -475,7 +1023,7 @@
           <a:p>
             <a:fld id="{5BCAD085-E8A6-8845-BD4E-CB4CCA059FC4}" type="datetimeFigureOut">
               <a:rPr lang="en-US" smtClean="0"/>
-              <a:t>1/27/13</a:t>
+              <a:t>8/17/2026</a:t>
             </a:fld>
             <a:endParaRPr lang="en-US"/>
           </a:p>
@@ -574,10 +1122,9 @@
           <a:lstStyle/>
           <a:p>
             <a:r>
-              <a:rPr lang="en-US" smtClean="0"/>
+              <a:rPr lang="en-US"/>
               <a:t>Click to edit Master title style</a:t>
             </a:r>
-            <a:endParaRPr lang="en-US"/>
           </a:p>
         </p:txBody>
       </p:sp>
@@ -603,38 +1150,37 @@
           <a:p>
             <a:pPr lvl="0"/>
             <a:r>
-              <a:rPr lang="en-US" smtClean="0"/>
+              <a:rPr lang="en-US"/>
               <a:t>Click to edit Master text styles</a:t>
             </a:r>
           </a:p>
           <a:p>
             <a:pPr lvl="1"/>
             <a:r>
-              <a:rPr lang="en-US" smtClean="0"/>
+              <a:rPr lang="en-US"/>
               <a:t>Second level</a:t>
             </a:r>
           </a:p>
           <a:p>
             <a:pPr lvl="2"/>
             <a:r>
-              <a:rPr lang="en-US" smtClean="0"/>
+              <a:rPr lang="en-US"/>
               <a:t>Third level</a:t>
             </a:r>
           </a:p>
           <a:p>
             <a:pPr lvl="3"/>
             <a:r>
-              <a:rPr lang="en-US" smtClean="0"/>
+              <a:rPr lang="en-US"/>
               <a:t>Fourth level</a:t>
             </a:r>
           </a:p>
           <a:p>
             <a:pPr lvl="4"/>
             <a:r>
-              <a:rPr lang="en-US" smtClean="0"/>
+              <a:rPr lang="en-US"/>
               <a:t>Fifth level</a:t>
             </a:r>
-            <a:endParaRPr lang="en-US"/>
           </a:p>
         </p:txBody>
       </p:sp>
@@ -655,7 +1201,7 @@
           <a:p>
             <a:fld id="{5BCAD085-E8A6-8845-BD4E-CB4CCA059FC4}" type="datetimeFigureOut">
               <a:rPr lang="en-US" smtClean="0"/>
-              <a:t>1/27/13</a:t>
+              <a:t>8/17/2026</a:t>
             </a:fld>
             <a:endParaRPr lang="en-US"/>
           </a:p>
@@ -749,10 +1295,9 @@
           <a:lstStyle/>
           <a:p>
             <a:r>
-              <a:rPr lang="en-US" smtClean="0"/>
+              <a:rPr lang="en-US"/>
               <a:t>Click to edit Master title style</a:t>
             </a:r>
-            <a:endParaRPr lang="en-US"/>
           </a:p>
         </p:txBody>
       </p:sp>
@@ -773,38 +1318,37 @@
           <a:p>
             <a:pPr lvl="0"/>
             <a:r>
-              <a:rPr lang="en-US" smtClean="0"/>
+              <a:rPr lang="en-US"/>
               <a:t>Click to edit Master text styles</a:t>
             </a:r>
           </a:p>
           <a:p>
             <a:pPr lvl="1"/>
             <a:r>
-              <a:rPr lang="en-US" smtClean="0"/>
+              <a:rPr lang="en-US"/>
               <a:t>Second level</a:t>
             </a:r>
           </a:p>
           <a:p>
             <a:pPr lvl="2"/>
             <a:r>
-              <a:rPr lang="en-US" smtClean="0"/>
+              <a:rPr lang="en-US"/>
               <a:t>Third level</a:t>
             </a:r>
           </a:p>
           <a:p>
             <a:pPr lvl="3"/>
             <a:r>
-              <a:rPr lang="en-US" smtClean="0"/>
+              <a:rPr lang="en-US"/>
               <a:t>Fourth level</a:t>
             </a:r>
           </a:p>
           <a:p>
             <a:pPr lvl="4"/>
             <a:r>
-              <a:rPr lang="en-US" smtClean="0"/>
+              <a:rPr lang="en-US"/>
               <a:t>Fifth level</a:t>
             </a:r>
-            <a:endParaRPr lang="en-US"/>
           </a:p>
         </p:txBody>
       </p:sp>
@@ -825,7 +1369,7 @@
           <a:p>
             <a:fld id="{5BCAD085-E8A6-8845-BD4E-CB4CCA059FC4}" type="datetimeFigureOut">
               <a:rPr lang="en-US" smtClean="0"/>
-              <a:t>1/27/13</a:t>
+              <a:t>8/17/2026</a:t>
             </a:fld>
             <a:endParaRPr lang="en-US"/>
           </a:p>
@@ -928,10 +1472,9 @@
           </a:lstStyle>
           <a:p>
             <a:r>
-              <a:rPr lang="en-US" smtClean="0"/>
+              <a:rPr lang="en-US"/>
               <a:t>Click to edit Master title style</a:t>
             </a:r>
-            <a:endParaRPr lang="en-US"/>
           </a:p>
         </p:txBody>
       </p:sp>
@@ -1048,7 +1591,7 @@
           <a:p>
             <a:pPr lvl="0"/>
             <a:r>
-              <a:rPr lang="en-US" smtClean="0"/>
+              <a:rPr lang="en-US"/>
               <a:t>Click to edit Master text styles</a:t>
             </a:r>
           </a:p>
@@ -1071,7 +1614,7 @@
           <a:p>
             <a:fld id="{5BCAD085-E8A6-8845-BD4E-CB4CCA059FC4}" type="datetimeFigureOut">
               <a:rPr lang="en-US" smtClean="0"/>
-              <a:t>1/27/13</a:t>
+              <a:t>8/17/2026</a:t>
             </a:fld>
             <a:endParaRPr lang="en-US"/>
           </a:p>
@@ -1165,10 +1708,9 @@
           <a:lstStyle/>
           <a:p>
             <a:r>
-              <a:rPr lang="en-US" smtClean="0"/>
+              <a:rPr lang="en-US"/>
               <a:t>Click to edit Master title style</a:t>
             </a:r>
-            <a:endParaRPr lang="en-US"/>
           </a:p>
         </p:txBody>
       </p:sp>
@@ -1222,38 +1764,37 @@
           <a:p>
             <a:pPr lvl="0"/>
             <a:r>
-              <a:rPr lang="en-US" smtClean="0"/>
+              <a:rPr lang="en-US"/>
               <a:t>Click to edit Master text styles</a:t>
             </a:r>
           </a:p>
           <a:p>
             <a:pPr lvl="1"/>
             <a:r>
-              <a:rPr lang="en-US" smtClean="0"/>
+              <a:rPr lang="en-US"/>
               <a:t>Second level</a:t>
             </a:r>
           </a:p>
           <a:p>
             <a:pPr lvl="2"/>
             <a:r>
-              <a:rPr lang="en-US" smtClean="0"/>
+              <a:rPr lang="en-US"/>
               <a:t>Third level</a:t>
             </a:r>
           </a:p>
           <a:p>
             <a:pPr lvl="3"/>
             <a:r>
-              <a:rPr lang="en-US" smtClean="0"/>
+              <a:rPr lang="en-US"/>
               <a:t>Fourth level</a:t>
             </a:r>
           </a:p>
           <a:p>
             <a:pPr lvl="4"/>
             <a:r>
-              <a:rPr lang="en-US" smtClean="0"/>
+              <a:rPr lang="en-US"/>
               <a:t>Fifth level</a:t>
             </a:r>
-            <a:endParaRPr lang="en-US"/>
           </a:p>
         </p:txBody>
       </p:sp>
@@ -1307,38 +1848,37 @@
           <a:p>
             <a:pPr lvl="0"/>
             <a:r>
-              <a:rPr lang="en-US" smtClean="0"/>
+              <a:rPr lang="en-US"/>
               <a:t>Click to edit Master text styles</a:t>
             </a:r>
           </a:p>
           <a:p>
             <a:pPr lvl="1"/>
             <a:r>
-              <a:rPr lang="en-US" smtClean="0"/>
+              <a:rPr lang="en-US"/>
               <a:t>Second level</a:t>
             </a:r>
           </a:p>
           <a:p>
             <a:pPr lvl="2"/>
             <a:r>
-              <a:rPr lang="en-US" smtClean="0"/>
+              <a:rPr lang="en-US"/>
               <a:t>Third level</a:t>
             </a:r>
           </a:p>
           <a:p>
             <a:pPr lvl="3"/>
             <a:r>
-              <a:rPr lang="en-US" smtClean="0"/>
+              <a:rPr lang="en-US"/>
               <a:t>Fourth level</a:t>
             </a:r>
           </a:p>
           <a:p>
             <a:pPr lvl="4"/>
             <a:r>
-              <a:rPr lang="en-US" smtClean="0"/>
+              <a:rPr lang="en-US"/>
               <a:t>Fifth level</a:t>
             </a:r>
-            <a:endParaRPr lang="en-US"/>
           </a:p>
         </p:txBody>
       </p:sp>
@@ -1359,7 +1899,7 @@
           <a:p>
             <a:fld id="{5BCAD085-E8A6-8845-BD4E-CB4CCA059FC4}" type="datetimeFigureOut">
               <a:rPr lang="en-US" smtClean="0"/>
-              <a:t>1/27/13</a:t>
+              <a:t>8/17/2026</a:t>
             </a:fld>
             <a:endParaRPr lang="en-US"/>
           </a:p>
@@ -1457,10 +1997,9 @@
           </a:lstStyle>
           <a:p>
             <a:r>
-              <a:rPr lang="en-US" smtClean="0"/>
+              <a:rPr lang="en-US"/>
               <a:t>Click to edit Master title style</a:t>
             </a:r>
-            <a:endParaRPr lang="en-US"/>
           </a:p>
         </p:txBody>
       </p:sp>
@@ -1523,7 +2062,7 @@
           <a:p>
             <a:pPr lvl="0"/>
             <a:r>
-              <a:rPr lang="en-US" smtClean="0"/>
+              <a:rPr lang="en-US"/>
               <a:t>Click to edit Master text styles</a:t>
             </a:r>
           </a:p>
@@ -1579,38 +2118,37 @@
           <a:p>
             <a:pPr lvl="0"/>
             <a:r>
-              <a:rPr lang="en-US" smtClean="0"/>
+              <a:rPr lang="en-US"/>
               <a:t>Click to edit Master text styles</a:t>
             </a:r>
           </a:p>
           <a:p>
             <a:pPr lvl="1"/>
             <a:r>
-              <a:rPr lang="en-US" smtClean="0"/>
+              <a:rPr lang="en-US"/>
               <a:t>Second level</a:t>
             </a:r>
           </a:p>
           <a:p>
             <a:pPr lvl="2"/>
             <a:r>
-              <a:rPr lang="en-US" smtClean="0"/>
+              <a:rPr lang="en-US"/>
               <a:t>Third level</a:t>
             </a:r>
           </a:p>
           <a:p>
             <a:pPr lvl="3"/>
             <a:r>
-              <a:rPr lang="en-US" smtClean="0"/>
+              <a:rPr lang="en-US"/>
               <a:t>Fourth level</a:t>
             </a:r>
           </a:p>
           <a:p>
             <a:pPr lvl="4"/>
             <a:r>
-              <a:rPr lang="en-US" smtClean="0"/>
+              <a:rPr lang="en-US"/>
               <a:t>Fifth level</a:t>
             </a:r>
-            <a:endParaRPr lang="en-US"/>
           </a:p>
         </p:txBody>
       </p:sp>
@@ -1673,7 +2211,7 @@
           <a:p>
             <a:pPr lvl="0"/>
             <a:r>
-              <a:rPr lang="en-US" smtClean="0"/>
+              <a:rPr lang="en-US"/>
               <a:t>Click to edit Master text styles</a:t>
             </a:r>
           </a:p>
@@ -1729,38 +2267,37 @@
           <a:p>
             <a:pPr lvl="0"/>
             <a:r>
-              <a:rPr lang="en-US" smtClean="0"/>
+              <a:rPr lang="en-US"/>
               <a:t>Click to edit Master text styles</a:t>
             </a:r>
           </a:p>
           <a:p>
             <a:pPr lvl="1"/>
             <a:r>
-              <a:rPr lang="en-US" smtClean="0"/>
+              <a:rPr lang="en-US"/>
               <a:t>Second level</a:t>
             </a:r>
           </a:p>
           <a:p>
             <a:pPr lvl="2"/>
             <a:r>
-              <a:rPr lang="en-US" smtClean="0"/>
+              <a:rPr lang="en-US"/>
               <a:t>Third level</a:t>
             </a:r>
           </a:p>
           <a:p>
             <a:pPr lvl="3"/>
             <a:r>
-              <a:rPr lang="en-US" smtClean="0"/>
+              <a:rPr lang="en-US"/>
               <a:t>Fourth level</a:t>
             </a:r>
           </a:p>
           <a:p>
             <a:pPr lvl="4"/>
             <a:r>
-              <a:rPr lang="en-US" smtClean="0"/>
+              <a:rPr lang="en-US"/>
               <a:t>Fifth level</a:t>
             </a:r>
-            <a:endParaRPr lang="en-US"/>
           </a:p>
         </p:txBody>
       </p:sp>
@@ -1781,7 +2318,7 @@
           <a:p>
             <a:fld id="{5BCAD085-E8A6-8845-BD4E-CB4CCA059FC4}" type="datetimeFigureOut">
               <a:rPr lang="en-US" smtClean="0"/>
-              <a:t>1/27/13</a:t>
+              <a:t>8/17/2026</a:t>
             </a:fld>
             <a:endParaRPr lang="en-US"/>
           </a:p>
@@ -1875,10 +2412,9 @@
           <a:lstStyle/>
           <a:p>
             <a:r>
-              <a:rPr lang="en-US" smtClean="0"/>
+              <a:rPr lang="en-US"/>
               <a:t>Click to edit Master title style</a:t>
             </a:r>
-            <a:endParaRPr lang="en-US"/>
           </a:p>
         </p:txBody>
       </p:sp>
@@ -1899,7 +2435,7 @@
           <a:p>
             <a:fld id="{5BCAD085-E8A6-8845-BD4E-CB4CCA059FC4}" type="datetimeFigureOut">
               <a:rPr lang="en-US" smtClean="0"/>
-              <a:t>1/27/13</a:t>
+              <a:t>8/17/2026</a:t>
             </a:fld>
             <a:endParaRPr lang="en-US"/>
           </a:p>
@@ -1994,7 +2530,7 @@
           <a:p>
             <a:fld id="{5BCAD085-E8A6-8845-BD4E-CB4CCA059FC4}" type="datetimeFigureOut">
               <a:rPr lang="en-US" smtClean="0"/>
-              <a:t>1/27/13</a:t>
+              <a:t>8/17/2026</a:t>
             </a:fld>
             <a:endParaRPr lang="en-US"/>
           </a:p>
@@ -2097,10 +2633,9 @@
           </a:lstStyle>
           <a:p>
             <a:r>
-              <a:rPr lang="en-US" smtClean="0"/>
+              <a:rPr lang="en-US"/>
               <a:t>Click to edit Master title style</a:t>
             </a:r>
-            <a:endParaRPr lang="en-US"/>
           </a:p>
         </p:txBody>
       </p:sp>
@@ -2154,38 +2689,37 @@
           <a:p>
             <a:pPr lvl="0"/>
             <a:r>
-              <a:rPr lang="en-US" smtClean="0"/>
+              <a:rPr lang="en-US"/>
               <a:t>Click to edit Master text styles</a:t>
             </a:r>
           </a:p>
           <a:p>
             <a:pPr lvl="1"/>
             <a:r>
-              <a:rPr lang="en-US" smtClean="0"/>
+              <a:rPr lang="en-US"/>
               <a:t>Second level</a:t>
             </a:r>
           </a:p>
           <a:p>
             <a:pPr lvl="2"/>
             <a:r>
-              <a:rPr lang="en-US" smtClean="0"/>
+              <a:rPr lang="en-US"/>
               <a:t>Third level</a:t>
             </a:r>
           </a:p>
           <a:p>
             <a:pPr lvl="3"/>
             <a:r>
-              <a:rPr lang="en-US" smtClean="0"/>
+              <a:rPr lang="en-US"/>
               <a:t>Fourth level</a:t>
             </a:r>
           </a:p>
           <a:p>
             <a:pPr lvl="4"/>
             <a:r>
-              <a:rPr lang="en-US" smtClean="0"/>
+              <a:rPr lang="en-US"/>
               <a:t>Fifth level</a:t>
             </a:r>
-            <a:endParaRPr lang="en-US"/>
           </a:p>
         </p:txBody>
       </p:sp>
@@ -2248,7 +2782,7 @@
           <a:p>
             <a:pPr lvl="0"/>
             <a:r>
-              <a:rPr lang="en-US" smtClean="0"/>
+              <a:rPr lang="en-US"/>
               <a:t>Click to edit Master text styles</a:t>
             </a:r>
           </a:p>
@@ -2271,7 +2805,7 @@
           <a:p>
             <a:fld id="{5BCAD085-E8A6-8845-BD4E-CB4CCA059FC4}" type="datetimeFigureOut">
               <a:rPr lang="en-US" smtClean="0"/>
-              <a:t>1/27/13</a:t>
+              <a:t>8/17/2026</a:t>
             </a:fld>
             <a:endParaRPr lang="en-US"/>
           </a:p>
@@ -2374,10 +2908,9 @@
           </a:lstStyle>
           <a:p>
             <a:r>
-              <a:rPr lang="en-US" smtClean="0"/>
+              <a:rPr lang="en-US"/>
               <a:t>Click to edit Master title style</a:t>
             </a:r>
-            <a:endParaRPr lang="en-US"/>
           </a:p>
         </p:txBody>
       </p:sp>
@@ -2501,7 +3034,7 @@
           <a:p>
             <a:pPr lvl="0"/>
             <a:r>
-              <a:rPr lang="en-US" smtClean="0"/>
+              <a:rPr lang="en-US"/>
               <a:t>Click to edit Master text styles</a:t>
             </a:r>
           </a:p>
@@ -2524,7 +3057,7 @@
           <a:p>
             <a:fld id="{5BCAD085-E8A6-8845-BD4E-CB4CCA059FC4}" type="datetimeFigureOut">
               <a:rPr lang="en-US" smtClean="0"/>
-              <a:t>1/27/13</a:t>
+              <a:t>8/17/2026</a:t>
             </a:fld>
             <a:endParaRPr lang="en-US"/>
           </a:p>
@@ -2633,10 +3166,9 @@
           <a:lstStyle/>
           <a:p>
             <a:r>
-              <a:rPr lang="en-US" smtClean="0"/>
+              <a:rPr lang="en-US"/>
               <a:t>Click to edit Master title style</a:t>
             </a:r>
-            <a:endParaRPr lang="en-US"/>
           </a:p>
         </p:txBody>
       </p:sp>
@@ -2667,38 +3199,37 @@
           <a:p>
             <a:pPr lvl="0"/>
             <a:r>
-              <a:rPr lang="en-US" smtClean="0"/>
+              <a:rPr lang="en-US"/>
               <a:t>Click to edit Master text styles</a:t>
             </a:r>
           </a:p>
           <a:p>
             <a:pPr lvl="1"/>
             <a:r>
-              <a:rPr lang="en-US" smtClean="0"/>
+              <a:rPr lang="en-US"/>
               <a:t>Second level</a:t>
             </a:r>
           </a:p>
           <a:p>
             <a:pPr lvl="2"/>
             <a:r>
-              <a:rPr lang="en-US" smtClean="0"/>
+              <a:rPr lang="en-US"/>
               <a:t>Third level</a:t>
             </a:r>
           </a:p>
           <a:p>
             <a:pPr lvl="3"/>
             <a:r>
-              <a:rPr lang="en-US" smtClean="0"/>
+              <a:rPr lang="en-US"/>
               <a:t>Fourth level</a:t>
             </a:r>
           </a:p>
           <a:p>
             <a:pPr lvl="4"/>
             <a:r>
-              <a:rPr lang="en-US" smtClean="0"/>
+              <a:rPr lang="en-US"/>
               <a:t>Fifth level</a:t>
             </a:r>
-            <a:endParaRPr lang="en-US"/>
           </a:p>
         </p:txBody>
       </p:sp>
@@ -2737,7 +3268,7 @@
           <a:p>
             <a:fld id="{5BCAD085-E8A6-8845-BD4E-CB4CCA059FC4}" type="datetimeFigureOut">
               <a:rPr lang="en-US" smtClean="0"/>
-              <a:t>1/27/13</a:t>
+              <a:t>8/17/2026</a:t>
             </a:fld>
             <a:endParaRPr lang="en-US"/>
           </a:p>
@@ -3096,7 +3627,7 @@
 </file>
 
 <file path=ppt/slides/slide1.xml><?xml version="1.0" encoding="utf-8"?>
-<p:sld xmlns:a="http://schemas.openxmlformats.org/drawingml/2006/main" xmlns:p="http://schemas.openxmlformats.org/presentationml/2006/main" xmlns:r="http://schemas.openxmlformats.org/officeDocument/2006/relationships">
+<p:sld xmlns:a="http://schemas.openxmlformats.org/drawingml/2006/main" xmlns:r="http://schemas.openxmlformats.org/officeDocument/2006/relationships" xmlns:p="http://schemas.openxmlformats.org/presentationml/2006/main">
   <p:cSld>
     <p:spTree>
       <p:nvGrpSpPr>
@@ -3104,7 +3635,14 @@
         <p:cNvGrpSpPr/>
         <p:nvPr/>
       </p:nvGrpSpPr>
-      <p:grpSpPr/>
+      <p:grpSpPr>
+        <a:xfrm>
+          <a:off x="0" y="0"/>
+          <a:ext cx="0" cy="0"/>
+          <a:chOff x="0" y="0"/>
+          <a:chExt cx="0" cy="0"/>
+        </a:xfrm>
+      </p:grpSpPr>
       <p:sp>
         <p:nvSpPr>
           <p:cNvPr id="2" name="Rectangle 1"/>
@@ -3113,7 +3651,7 @@
         </p:nvSpPr>
         <p:spPr>
           <a:xfrm>
-            <a:off x="0" y="0"/>
+            <a:off x="0" y="9832"/>
             <a:ext cx="12191695" cy="6858000"/>
           </a:xfrm>
           <a:prstGeom prst="rect">
@@ -3145,6 +3683,7 @@
           <a:lstStyle/>
           <a:p>
             <a:pPr algn="ctr"/>
+            <a:endParaRPr/>
           </a:p>
         </p:txBody>
       </p:sp>
@@ -3188,29 +3727,30 @@
           <a:lstStyle/>
           <a:p>
             <a:pPr algn="ctr"/>
-          </a:p>
-        </p:txBody>
-      </p:sp>
-      <p:sp>
-        <p:nvSpPr>
-          <p:cNvPr id="4" name="Rounded Rectangle 3"/>
+            <a:endParaRPr/>
+          </a:p>
+        </p:txBody>
+      </p:sp>
+      <p:sp>
+        <p:nvSpPr>
+          <p:cNvPr id="5" name="Rounded Rectangle 4"/>
           <p:cNvSpPr/>
           <p:nvPr/>
         </p:nvSpPr>
         <p:spPr>
           <a:xfrm>
-            <a:off x="731520" y="685800"/>
-            <a:ext cx="2926080" cy="457200"/>
+            <a:off x="731520" y="1325880"/>
+            <a:ext cx="4371422" cy="4983480"/>
           </a:xfrm>
           <a:prstGeom prst="roundRect">
             <a:avLst/>
           </a:prstGeom>
           <a:solidFill>
-            <a:srgbClr val="EEF2FF"/>
+            <a:srgbClr val="FFFFFF"/>
           </a:solidFill>
           <a:ln w="19050">
             <a:solidFill>
-              <a:srgbClr val="4F46E5"/>
+              <a:srgbClr val="E2E8F0"/>
             </a:solidFill>
           </a:ln>
         </p:spPr>
@@ -3229,42 +3769,108 @@
           </a:fontRef>
         </p:style>
         <p:txBody>
-          <a:bodyPr rtlCol="0" anchor="ctr"/>
+          <a:bodyPr wrap="square" rtlCol="0" anchor="ctr"/>
           <a:lstStyle/>
           <a:p>
             <a:pPr algn="ctr">
-              <a:defRPr sz="1100" b="1">
-                <a:solidFill>
-                  <a:srgbClr val="4F46E5"/>
-                </a:solidFill>
-              </a:defRPr>
-            </a:pPr>
-            <a:r>
-              <a:t>ENTERPRISE PLATFORM</a:t>
-            </a:r>
-          </a:p>
-        </p:txBody>
-      </p:sp>
-      <p:sp>
-        <p:nvSpPr>
-          <p:cNvPr id="5" name="Rounded Rectangle 4"/>
+              <a:defRPr sz="2800" b="1">
+                <a:solidFill>
+                  <a:srgbClr val="1E293B"/>
+                </a:solidFill>
+              </a:defRPr>
+            </a:pPr>
+            <a:r>
+              <a:t>Lumina Reserve</a:t>
+            </a:r>
+          </a:p>
+          <a:p>
+            <a:pPr>
+              <a:spcBef>
+                <a:spcPts val="800"/>
+              </a:spcBef>
+              <a:defRPr sz="1300">
+                <a:solidFill>
+                  <a:srgbClr val="2563EB"/>
+                </a:solidFill>
+              </a:defRPr>
+            </a:pPr>
+            <a:r>
+              <a:t>Corporate Spatial Management &amp; Meeting Room Reservation Suite</a:t>
+            </a:r>
+          </a:p>
+          <a:p>
+            <a:br/>
+            <a:r>
+              <a:t>KEY SYSTEM HIGHLIGHTS:</a:t>
+            </a:r>
+          </a:p>
+          <a:p>
+            <a:pPr>
+              <a:spcBef>
+                <a:spcPts val="800"/>
+              </a:spcBef>
+              <a:defRPr sz="1150">
+                <a:solidFill>
+                  <a:srgbClr val="334155"/>
+                </a:solidFill>
+              </a:defRPr>
+            </a:pPr>
+            <a:r>
+              <a:t>✔  Strict Relational Database Engine (MySQL 8.0 InnoDB)</a:t>
+            </a:r>
+          </a:p>
+          <a:p>
+            <a:pPr>
+              <a:spcBef>
+                <a:spcPts val="800"/>
+              </a:spcBef>
+              <a:defRPr sz="1150">
+                <a:solidFill>
+                  <a:srgbClr val="334155"/>
+                </a:solidFill>
+              </a:defRPr>
+            </a:pPr>
+            <a:r>
+              <a:t>✔  Automated 15-Minute Approval Window Engine</a:t>
+            </a:r>
+          </a:p>
+          <a:p>
+            <a:pPr>
+              <a:spcBef>
+                <a:spcPts val="800"/>
+              </a:spcBef>
+              <a:defRPr sz="1150">
+                <a:solidFill>
+                  <a:srgbClr val="334155"/>
+                </a:solidFill>
+              </a:defRPr>
+            </a:pPr>
+            <a:r>
+              <a:t>✔  Multi-Channel Automated WhatsApp (Green API) &amp; Gmail Calendar Emailing</a:t>
+            </a:r>
+          </a:p>
+        </p:txBody>
+      </p:sp>
+      <p:sp>
+        <p:nvSpPr>
+          <p:cNvPr id="6" name="Rounded Rectangle 5"/>
           <p:cNvSpPr/>
           <p:nvPr/>
         </p:nvSpPr>
         <p:spPr>
           <a:xfrm>
-            <a:off x="731520" y="1325880"/>
-            <a:ext cx="5486400" cy="4983480"/>
+            <a:off x="5279923" y="1325880"/>
+            <a:ext cx="6150077" cy="4983480"/>
           </a:xfrm>
           <a:prstGeom prst="roundRect">
             <a:avLst/>
           </a:prstGeom>
           <a:solidFill>
-            <a:srgbClr val="FFFFFF"/>
-          </a:solidFill>
-          <a:ln w="19050">
+            <a:srgbClr val="EEF2FF"/>
+          </a:solidFill>
+          <a:ln w="25400">
             <a:solidFill>
-              <a:srgbClr val="E2E8F0"/>
+              <a:srgbClr val="4F46E5"/>
             </a:solidFill>
           </a:ln>
         </p:spPr>
@@ -3283,137 +3889,7 @@
           </a:fontRef>
         </p:style>
         <p:txBody>
-          <a:bodyPr rtlCol="0" anchor="ctr" wrap="square"/>
-          <a:lstStyle/>
-          <a:p>
-            <a:pPr algn="ctr">
-              <a:defRPr sz="2800" b="1">
-                <a:solidFill>
-                  <a:srgbClr val="1E293B"/>
-                </a:solidFill>
-              </a:defRPr>
-            </a:pPr>
-            <a:r>
-              <a:t>Lumina Reserve</a:t>
-            </a:r>
-          </a:p>
-          <a:p>
-            <a:pPr>
-              <a:spcBef>
-                <a:spcPts val="800"/>
-              </a:spcBef>
-              <a:defRPr sz="1300">
-                <a:solidFill>
-                  <a:srgbClr val="2563EB"/>
-                </a:solidFill>
-              </a:defRPr>
-            </a:pPr>
-            <a:r>
-              <a:t>Corporate Spatial Management &amp; Meeting Room Reservation Suite</a:t>
-            </a:r>
-          </a:p>
-          <a:p>
-            <a:br/>
-            <a:pPr>
-              <a:spcBef>
-                <a:spcPts val="1400"/>
-              </a:spcBef>
-              <a:defRPr sz="1200" b="1">
-                <a:solidFill>
-                  <a:srgbClr val="10B981"/>
-                </a:solidFill>
-              </a:defRPr>
-            </a:pPr>
-            <a:r>
-              <a:t>KEY SYSTEM HIGHLIGHTS:</a:t>
-            </a:r>
-          </a:p>
-          <a:p>
-            <a:pPr>
-              <a:spcBef>
-                <a:spcPts val="800"/>
-              </a:spcBef>
-              <a:defRPr sz="1150">
-                <a:solidFill>
-                  <a:srgbClr val="334155"/>
-                </a:solidFill>
-              </a:defRPr>
-            </a:pPr>
-            <a:r>
-              <a:t>✔  Strict Relational Database Engine (MySQL 8.0 InnoDB)</a:t>
-            </a:r>
-          </a:p>
-          <a:p>
-            <a:pPr>
-              <a:spcBef>
-                <a:spcPts val="800"/>
-              </a:spcBef>
-              <a:defRPr sz="1150">
-                <a:solidFill>
-                  <a:srgbClr val="334155"/>
-                </a:solidFill>
-              </a:defRPr>
-            </a:pPr>
-            <a:r>
-              <a:t>✔  Automated 15-Minute Approval Window Engine</a:t>
-            </a:r>
-          </a:p>
-          <a:p>
-            <a:pPr>
-              <a:spcBef>
-                <a:spcPts val="800"/>
-              </a:spcBef>
-              <a:defRPr sz="1150">
-                <a:solidFill>
-                  <a:srgbClr val="334155"/>
-                </a:solidFill>
-              </a:defRPr>
-            </a:pPr>
-            <a:r>
-              <a:t>✔  Multi-Channel Automated WhatsApp (Green API) &amp; Gmail Calendar Emailing</a:t>
-            </a:r>
-          </a:p>
-        </p:txBody>
-      </p:sp>
-      <p:sp>
-        <p:nvSpPr>
-          <p:cNvPr id="6" name="Rounded Rectangle 5"/>
-          <p:cNvSpPr/>
-          <p:nvPr/>
-        </p:nvSpPr>
-        <p:spPr>
-          <a:xfrm>
-            <a:off x="6492240" y="1325880"/>
-            <a:ext cx="4937760" cy="4983480"/>
-          </a:xfrm>
-          <a:prstGeom prst="roundRect">
-            <a:avLst/>
-          </a:prstGeom>
-          <a:solidFill>
-            <a:srgbClr val="EEF2FF"/>
-          </a:solidFill>
-          <a:ln w="25400">
-            <a:solidFill>
-              <a:srgbClr val="4F46E5"/>
-            </a:solidFill>
-          </a:ln>
-        </p:spPr>
-        <p:style>
-          <a:lnRef idx="1">
-            <a:schemeClr val="accent1"/>
-          </a:lnRef>
-          <a:fillRef idx="3">
-            <a:schemeClr val="accent1"/>
-          </a:fillRef>
-          <a:effectRef idx="2">
-            <a:schemeClr val="accent1"/>
-          </a:effectRef>
-          <a:fontRef idx="minor">
-            <a:schemeClr val="lt1"/>
-          </a:fontRef>
-        </p:style>
-        <p:txBody>
-          <a:bodyPr rtlCol="0" anchor="ctr" wrap="square"/>
+          <a:bodyPr wrap="square" rtlCol="0" anchor="ctr"/>
           <a:lstStyle/>
           <a:p>
             <a:pPr algn="ctr">
@@ -3423,16 +3899,52 @@
                 </a:solidFill>
               </a:defRPr>
             </a:pPr>
-            <a:br/>
-            <a:br/>
-            <a:br/>
-            <a:br/>
-            <a:r>
+            <a:br>
+              <a:rPr dirty="0"/>
+            </a:br>
+            <a:br>
+              <a:rPr dirty="0"/>
+            </a:br>
+            <a:br>
+              <a:rPr dirty="0"/>
+            </a:br>
+            <a:r>
+              <a:rPr dirty="0"/>
               <a:t>📸 [INSERT SCREENSHOT HERE: Lumina Reserve App Logo &amp; Hero Homepage]</a:t>
             </a:r>
           </a:p>
         </p:txBody>
       </p:sp>
+      <p:pic>
+        <p:nvPicPr>
+          <p:cNvPr id="8" name="Picture 7">
+            <a:extLst>
+              <a:ext uri="{FF2B5EF4-FFF2-40B4-BE49-F238E27FC236}">
+                <a16:creationId xmlns:a16="http://schemas.microsoft.com/office/drawing/2014/main" id="{5EF61963-33CB-EB93-FA7F-048FF994C97D}"/>
+              </a:ext>
+            </a:extLst>
+          </p:cNvPr>
+          <p:cNvPicPr>
+            <a:picLocks noChangeAspect="1"/>
+          </p:cNvPicPr>
+          <p:nvPr/>
+        </p:nvPicPr>
+        <p:blipFill>
+          <a:blip r:embed="rId2"/>
+          <a:stretch>
+            <a:fillRect/>
+          </a:stretch>
+        </p:blipFill>
+        <p:spPr>
+          <a:xfrm>
+            <a:off x="5588936" y="2212258"/>
+            <a:ext cx="5610006" cy="3319862"/>
+          </a:xfrm>
+          <a:prstGeom prst="rect">
+            <a:avLst/>
+          </a:prstGeom>
+        </p:spPr>
+      </p:pic>
     </p:spTree>
   </p:cSld>
   <p:clrMapOvr>
@@ -3442,7 +3954,7 @@
 </file>
 
 <file path=ppt/slides/slide10.xml><?xml version="1.0" encoding="utf-8"?>
-<p:sld xmlns:a="http://schemas.openxmlformats.org/drawingml/2006/main" xmlns:p="http://schemas.openxmlformats.org/presentationml/2006/main" xmlns:r="http://schemas.openxmlformats.org/officeDocument/2006/relationships">
+<p:sld xmlns:a="http://schemas.openxmlformats.org/drawingml/2006/main" xmlns:r="http://schemas.openxmlformats.org/officeDocument/2006/relationships" xmlns:p="http://schemas.openxmlformats.org/presentationml/2006/main">
   <p:cSld>
     <p:spTree>
       <p:nvGrpSpPr>
@@ -3450,7 +3962,14 @@
         <p:cNvGrpSpPr/>
         <p:nvPr/>
       </p:nvGrpSpPr>
-      <p:grpSpPr/>
+      <p:grpSpPr>
+        <a:xfrm>
+          <a:off x="0" y="0"/>
+          <a:ext cx="0" cy="0"/>
+          <a:chOff x="0" y="0"/>
+          <a:chExt cx="0" cy="0"/>
+        </a:xfrm>
+      </p:grpSpPr>
       <p:sp>
         <p:nvSpPr>
           <p:cNvPr id="2" name="Rectangle 1"/>
@@ -3491,6 +4010,7 @@
           <a:lstStyle/>
           <a:p>
             <a:pPr algn="ctr"/>
+            <a:endParaRPr/>
           </a:p>
         </p:txBody>
       </p:sp>
@@ -3534,6 +4054,7 @@
           <a:lstStyle/>
           <a:p>
             <a:pPr algn="ctr"/>
+            <a:endParaRPr/>
           </a:p>
         </p:txBody>
       </p:sp>
@@ -3573,7 +4094,7 @@
           </a:fontRef>
         </p:style>
         <p:txBody>
-          <a:bodyPr rtlCol="0" anchor="ctr" wrap="square"/>
+          <a:bodyPr wrap="square" rtlCol="0" anchor="ctr"/>
           <a:lstStyle/>
           <a:p>
             <a:pPr algn="ctr">
@@ -3622,7 +4143,7 @@
         <p:spPr>
           <a:xfrm>
             <a:off x="731520" y="1645920"/>
-            <a:ext cx="5486400" cy="4754880"/>
+            <a:ext cx="4391086" cy="4754880"/>
           </a:xfrm>
           <a:prstGeom prst="roundRect">
             <a:avLst/>
@@ -3651,7 +4172,7 @@
           </a:fontRef>
         </p:style>
         <p:txBody>
-          <a:bodyPr rtlCol="0" anchor="ctr" wrap="square"/>
+          <a:bodyPr wrap="square" rtlCol="0" anchor="ctr"/>
           <a:lstStyle/>
           <a:p>
             <a:pPr algn="ctr">
@@ -3662,6 +4183,7 @@
               </a:defRPr>
             </a:pPr>
             <a:r>
+              <a:rPr dirty="0"/>
               <a:t>KEY ARCHITECTURE &amp; HIGHLIGHTS:</a:t>
             </a:r>
           </a:p>
@@ -3677,6 +4199,7 @@
               </a:defRPr>
             </a:pPr>
             <a:r>
+              <a:rPr dirty="0"/>
               <a:t>🔹 Green API Integration: Automated background WhatsApp message dispatch</a:t>
             </a:r>
           </a:p>
@@ -3692,6 +4215,7 @@
               </a:defRPr>
             </a:pPr>
             <a:r>
+              <a:rPr dirty="0"/>
               <a:t>🔹 Designated Chats: Sends to Primary (+919652456879), Vishal, &amp; Malavika</a:t>
             </a:r>
           </a:p>
@@ -3707,6 +4231,7 @@
               </a:defRPr>
             </a:pPr>
             <a:r>
+              <a:rPr dirty="0"/>
               <a:t>🔹 1-Click Web Link: Fallback button opens WhatsApp Web with formatted text</a:t>
             </a:r>
           </a:p>
@@ -3754,6 +4279,7 @@
           <a:lstStyle/>
           <a:p>
             <a:pPr algn="ctr"/>
+            <a:endParaRPr/>
           </a:p>
         </p:txBody>
       </p:sp>
@@ -3795,7 +4321,7 @@
           </a:fontRef>
         </p:style>
         <p:txBody>
-          <a:bodyPr rtlCol="0" anchor="ctr" wrap="square"/>
+          <a:bodyPr wrap="square" rtlCol="0" anchor="ctr"/>
           <a:lstStyle/>
           <a:p>
             <a:pPr algn="ctr">
@@ -3805,11 +4331,20 @@
                 </a:solidFill>
               </a:defRPr>
             </a:pPr>
-            <a:br/>
-            <a:br/>
-            <a:br/>
-            <a:br/>
-            <a:r>
+            <a:br>
+              <a:rPr dirty="0"/>
+            </a:br>
+            <a:br>
+              <a:rPr dirty="0"/>
+            </a:br>
+            <a:br>
+              <a:rPr dirty="0"/>
+            </a:br>
+            <a:br>
+              <a:rPr dirty="0"/>
+            </a:br>
+            <a:r>
+              <a:rPr dirty="0"/>
               <a:t>📸 [INSERT SCREENSHOT HERE: WhatsApp Button &amp; Pre-Filled Text Preview]</a:t>
             </a:r>
           </a:p>
@@ -3824,7 +4359,7 @@
 </file>
 
 <file path=ppt/slides/slide11.xml><?xml version="1.0" encoding="utf-8"?>
-<p:sld xmlns:a="http://schemas.openxmlformats.org/drawingml/2006/main" xmlns:p="http://schemas.openxmlformats.org/presentationml/2006/main" xmlns:r="http://schemas.openxmlformats.org/officeDocument/2006/relationships">
+<p:sld xmlns:a="http://schemas.openxmlformats.org/drawingml/2006/main" xmlns:r="http://schemas.openxmlformats.org/officeDocument/2006/relationships" xmlns:p="http://schemas.openxmlformats.org/presentationml/2006/main">
   <p:cSld>
     <p:spTree>
       <p:nvGrpSpPr>
@@ -3832,7 +4367,14 @@
         <p:cNvGrpSpPr/>
         <p:nvPr/>
       </p:nvGrpSpPr>
-      <p:grpSpPr/>
+      <p:grpSpPr>
+        <a:xfrm>
+          <a:off x="0" y="0"/>
+          <a:ext cx="0" cy="0"/>
+          <a:chOff x="0" y="0"/>
+          <a:chExt cx="0" cy="0"/>
+        </a:xfrm>
+      </p:grpSpPr>
       <p:sp>
         <p:nvSpPr>
           <p:cNvPr id="2" name="Rectangle 1"/>
@@ -3873,6 +4415,7 @@
           <a:lstStyle/>
           <a:p>
             <a:pPr algn="ctr"/>
+            <a:endParaRPr/>
           </a:p>
         </p:txBody>
       </p:sp>
@@ -3916,6 +4459,7 @@
           <a:lstStyle/>
           <a:p>
             <a:pPr algn="ctr"/>
+            <a:endParaRPr/>
           </a:p>
         </p:txBody>
       </p:sp>
@@ -3955,7 +4499,7 @@
           </a:fontRef>
         </p:style>
         <p:txBody>
-          <a:bodyPr rtlCol="0" anchor="ctr" wrap="square"/>
+          <a:bodyPr wrap="square" rtlCol="0" anchor="ctr"/>
           <a:lstStyle/>
           <a:p>
             <a:pPr algn="ctr">
@@ -4004,7 +4548,7 @@
         <p:spPr>
           <a:xfrm>
             <a:off x="731520" y="1645920"/>
-            <a:ext cx="5486400" cy="4754880"/>
+            <a:ext cx="4341925" cy="4754880"/>
           </a:xfrm>
           <a:prstGeom prst="roundRect">
             <a:avLst/>
@@ -4033,7 +4577,7 @@
           </a:fontRef>
         </p:style>
         <p:txBody>
-          <a:bodyPr rtlCol="0" anchor="ctr" wrap="square"/>
+          <a:bodyPr wrap="square" rtlCol="0" anchor="ctr"/>
           <a:lstStyle/>
           <a:p>
             <a:pPr algn="ctr">
@@ -4044,6 +4588,7 @@
               </a:defRPr>
             </a:pPr>
             <a:r>
+              <a:rPr dirty="0"/>
               <a:t>KEY ARCHITECTURE &amp; HIGHLIGHTS:</a:t>
             </a:r>
           </a:p>
@@ -4059,6 +4604,7 @@
               </a:defRPr>
             </a:pPr>
             <a:r>
+              <a:rPr dirty="0"/>
               <a:t>🔹 Edit Members Button: Modify attendee lists on active reservations</a:t>
             </a:r>
           </a:p>
@@ -4074,6 +4620,7 @@
               </a:defRPr>
             </a:pPr>
             <a:r>
+              <a:rPr dirty="0"/>
               <a:t>🔹 Flexibility: Add late invitees or remove members without canceling meeting</a:t>
             </a:r>
           </a:p>
@@ -4089,6 +4636,7 @@
               </a:defRPr>
             </a:pPr>
             <a:r>
+              <a:rPr dirty="0"/>
               <a:t>🔹 Audit Persistence: Saves member modification events in history log</a:t>
             </a:r>
           </a:p>
@@ -4102,8 +4650,8 @@
         </p:nvSpPr>
         <p:spPr>
           <a:xfrm>
-            <a:off x="6400800" y="1645920"/>
-            <a:ext cx="5059375" cy="4754880"/>
+            <a:off x="5201266" y="1645920"/>
+            <a:ext cx="6258910" cy="4754880"/>
           </a:xfrm>
           <a:prstGeom prst="roundRect">
             <a:avLst/>
@@ -4136,67 +4684,41 @@
           <a:lstStyle/>
           <a:p>
             <a:pPr algn="ctr"/>
-          </a:p>
-        </p:txBody>
-      </p:sp>
-      <p:sp>
-        <p:nvSpPr>
-          <p:cNvPr id="7" name="Rounded Rectangle 6"/>
-          <p:cNvSpPr/>
+            <a:endParaRPr/>
+          </a:p>
+        </p:txBody>
+      </p:sp>
+      <p:pic>
+        <p:nvPicPr>
+          <p:cNvPr id="9" name="Picture 8">
+            <a:extLst>
+              <a:ext uri="{FF2B5EF4-FFF2-40B4-BE49-F238E27FC236}">
+                <a16:creationId xmlns:a16="http://schemas.microsoft.com/office/drawing/2014/main" id="{837A7EA3-B248-4A1C-68CA-815BF6A935B8}"/>
+              </a:ext>
+            </a:extLst>
+          </p:cNvPr>
+          <p:cNvPicPr>
+            <a:picLocks noChangeAspect="1"/>
+          </p:cNvPicPr>
           <p:nvPr/>
-        </p:nvSpPr>
-        <p:spPr>
-          <a:xfrm>
-            <a:off x="6537960" y="1783080"/>
-            <a:ext cx="4785055" cy="4480560"/>
-          </a:xfrm>
-          <a:prstGeom prst="roundRect">
-            <a:avLst/>
-          </a:prstGeom>
-          <a:solidFill>
-            <a:srgbClr val="EEF2FF"/>
-          </a:solidFill>
-          <a:ln w="12700">
-            <a:solidFill>
-              <a:srgbClr val="E2E8F0"/>
-            </a:solidFill>
-          </a:ln>
-        </p:spPr>
-        <p:style>
-          <a:lnRef idx="1">
-            <a:schemeClr val="accent1"/>
-          </a:lnRef>
-          <a:fillRef idx="3">
-            <a:schemeClr val="accent1"/>
-          </a:fillRef>
-          <a:effectRef idx="2">
-            <a:schemeClr val="accent1"/>
-          </a:effectRef>
-          <a:fontRef idx="minor">
-            <a:schemeClr val="lt1"/>
-          </a:fontRef>
-        </p:style>
-        <p:txBody>
-          <a:bodyPr rtlCol="0" anchor="ctr" wrap="square"/>
-          <a:lstStyle/>
-          <a:p>
-            <a:pPr algn="ctr">
-              <a:defRPr sz="1300" b="1">
-                <a:solidFill>
-                  <a:srgbClr val="4F46E5"/>
-                </a:solidFill>
-              </a:defRPr>
-            </a:pPr>
-            <a:br/>
-            <a:br/>
-            <a:br/>
-            <a:br/>
-            <a:r>
-              <a:t>📸 [INSERT SCREENSHOT HERE: Edit Participants Modal]</a:t>
-            </a:r>
-          </a:p>
-        </p:txBody>
-      </p:sp>
+        </p:nvPicPr>
+        <p:blipFill>
+          <a:blip r:embed="rId2"/>
+          <a:srcRect l="2579" b="3585"/>
+          <a:stretch>
+            <a:fillRect/>
+          </a:stretch>
+        </p:blipFill>
+        <p:spPr>
+          <a:xfrm>
+            <a:off x="5919019" y="2341414"/>
+            <a:ext cx="4840527" cy="3243310"/>
+          </a:xfrm>
+          <a:prstGeom prst="rect">
+            <a:avLst/>
+          </a:prstGeom>
+        </p:spPr>
+      </p:pic>
     </p:spTree>
   </p:cSld>
   <p:clrMapOvr>
@@ -4206,7 +4728,7 @@
 </file>
 
 <file path=ppt/slides/slide12.xml><?xml version="1.0" encoding="utf-8"?>
-<p:sld xmlns:a="http://schemas.openxmlformats.org/drawingml/2006/main" xmlns:p="http://schemas.openxmlformats.org/presentationml/2006/main" xmlns:r="http://schemas.openxmlformats.org/officeDocument/2006/relationships">
+<p:sld xmlns:a="http://schemas.openxmlformats.org/drawingml/2006/main" xmlns:r="http://schemas.openxmlformats.org/officeDocument/2006/relationships" xmlns:p="http://schemas.openxmlformats.org/presentationml/2006/main">
   <p:cSld>
     <p:spTree>
       <p:nvGrpSpPr>
@@ -4214,7 +4736,14 @@
         <p:cNvGrpSpPr/>
         <p:nvPr/>
       </p:nvGrpSpPr>
-      <p:grpSpPr/>
+      <p:grpSpPr>
+        <a:xfrm>
+          <a:off x="0" y="0"/>
+          <a:ext cx="0" cy="0"/>
+          <a:chOff x="0" y="0"/>
+          <a:chExt cx="0" cy="0"/>
+        </a:xfrm>
+      </p:grpSpPr>
       <p:sp>
         <p:nvSpPr>
           <p:cNvPr id="2" name="Rectangle 1"/>
@@ -4255,6 +4784,7 @@
           <a:lstStyle/>
           <a:p>
             <a:pPr algn="ctr"/>
+            <a:endParaRPr/>
           </a:p>
         </p:txBody>
       </p:sp>
@@ -4298,6 +4828,7 @@
           <a:lstStyle/>
           <a:p>
             <a:pPr algn="ctr"/>
+            <a:endParaRPr/>
           </a:p>
         </p:txBody>
       </p:sp>
@@ -4337,7 +4868,7 @@
           </a:fontRef>
         </p:style>
         <p:txBody>
-          <a:bodyPr rtlCol="0" anchor="ctr" wrap="square"/>
+          <a:bodyPr wrap="square" rtlCol="0" anchor="ctr"/>
           <a:lstStyle/>
           <a:p>
             <a:pPr algn="ctr">
@@ -4385,8 +4916,8 @@
         </p:nvSpPr>
         <p:spPr>
           <a:xfrm>
-            <a:off x="731520" y="1645920"/>
-            <a:ext cx="5486400" cy="4754880"/>
+            <a:off x="643030" y="1645920"/>
+            <a:ext cx="4587732" cy="4754880"/>
           </a:xfrm>
           <a:prstGeom prst="roundRect">
             <a:avLst/>
@@ -4415,7 +4946,7 @@
           </a:fontRef>
         </p:style>
         <p:txBody>
-          <a:bodyPr rtlCol="0" anchor="ctr" wrap="square"/>
+          <a:bodyPr wrap="square" rtlCol="0" anchor="ctr"/>
           <a:lstStyle/>
           <a:p>
             <a:pPr algn="ctr">
@@ -4484,8 +5015,8 @@
         </p:nvSpPr>
         <p:spPr>
           <a:xfrm>
-            <a:off x="6400800" y="1645920"/>
-            <a:ext cx="5059375" cy="4754880"/>
+            <a:off x="5378246" y="1645920"/>
+            <a:ext cx="6081930" cy="4754880"/>
           </a:xfrm>
           <a:prstGeom prst="roundRect">
             <a:avLst/>
@@ -4518,67 +5049,40 @@
           <a:lstStyle/>
           <a:p>
             <a:pPr algn="ctr"/>
-          </a:p>
-        </p:txBody>
-      </p:sp>
-      <p:sp>
-        <p:nvSpPr>
-          <p:cNvPr id="7" name="Rounded Rectangle 6"/>
-          <p:cNvSpPr/>
+            <a:endParaRPr dirty="0"/>
+          </a:p>
+        </p:txBody>
+      </p:sp>
+      <p:pic>
+        <p:nvPicPr>
+          <p:cNvPr id="9" name="Picture 8">
+            <a:extLst>
+              <a:ext uri="{FF2B5EF4-FFF2-40B4-BE49-F238E27FC236}">
+                <a16:creationId xmlns:a16="http://schemas.microsoft.com/office/drawing/2014/main" id="{68A1E83F-EF44-B3F0-296F-41BE8DF88AD0}"/>
+              </a:ext>
+            </a:extLst>
+          </p:cNvPr>
+          <p:cNvPicPr>
+            <a:picLocks noChangeAspect="1"/>
+          </p:cNvPicPr>
           <p:nvPr/>
-        </p:nvSpPr>
-        <p:spPr>
-          <a:xfrm>
-            <a:off x="6537960" y="1783080"/>
-            <a:ext cx="4785055" cy="4480560"/>
-          </a:xfrm>
-          <a:prstGeom prst="roundRect">
-            <a:avLst/>
-          </a:prstGeom>
-          <a:solidFill>
-            <a:srgbClr val="EEF2FF"/>
-          </a:solidFill>
-          <a:ln w="12700">
-            <a:solidFill>
-              <a:srgbClr val="E2E8F0"/>
-            </a:solidFill>
-          </a:ln>
-        </p:spPr>
-        <p:style>
-          <a:lnRef idx="1">
-            <a:schemeClr val="accent1"/>
-          </a:lnRef>
-          <a:fillRef idx="3">
-            <a:schemeClr val="accent1"/>
-          </a:fillRef>
-          <a:effectRef idx="2">
-            <a:schemeClr val="accent1"/>
-          </a:effectRef>
-          <a:fontRef idx="minor">
-            <a:schemeClr val="lt1"/>
-          </a:fontRef>
-        </p:style>
-        <p:txBody>
-          <a:bodyPr rtlCol="0" anchor="ctr" wrap="square"/>
-          <a:lstStyle/>
-          <a:p>
-            <a:pPr algn="ctr">
-              <a:defRPr sz="1300" b="1">
-                <a:solidFill>
-                  <a:srgbClr val="4F46E5"/>
-                </a:solidFill>
-              </a:defRPr>
-            </a:pPr>
-            <a:br/>
-            <a:br/>
-            <a:br/>
-            <a:br/>
-            <a:r>
-              <a:t>📸 [INSERT SCREENSHOT HERE: Manager Dashboard Approval Queue]</a:t>
-            </a:r>
-          </a:p>
-        </p:txBody>
-      </p:sp>
+        </p:nvPicPr>
+        <p:blipFill>
+          <a:blip r:embed="rId2"/>
+          <a:stretch>
+            <a:fillRect/>
+          </a:stretch>
+        </p:blipFill>
+        <p:spPr>
+          <a:xfrm>
+            <a:off x="5582604" y="2339832"/>
+            <a:ext cx="5673213" cy="3687096"/>
+          </a:xfrm>
+          <a:prstGeom prst="rect">
+            <a:avLst/>
+          </a:prstGeom>
+        </p:spPr>
+      </p:pic>
     </p:spTree>
   </p:cSld>
   <p:clrMapOvr>
@@ -4588,7 +5092,7 @@
 </file>
 
 <file path=ppt/slides/slide13.xml><?xml version="1.0" encoding="utf-8"?>
-<p:sld xmlns:a="http://schemas.openxmlformats.org/drawingml/2006/main" xmlns:p="http://schemas.openxmlformats.org/presentationml/2006/main" xmlns:r="http://schemas.openxmlformats.org/officeDocument/2006/relationships">
+<p:sld xmlns:a="http://schemas.openxmlformats.org/drawingml/2006/main" xmlns:r="http://schemas.openxmlformats.org/officeDocument/2006/relationships" xmlns:p="http://schemas.openxmlformats.org/presentationml/2006/main">
   <p:cSld>
     <p:spTree>
       <p:nvGrpSpPr>
@@ -4596,7 +5100,14 @@
         <p:cNvGrpSpPr/>
         <p:nvPr/>
       </p:nvGrpSpPr>
-      <p:grpSpPr/>
+      <p:grpSpPr>
+        <a:xfrm>
+          <a:off x="0" y="0"/>
+          <a:ext cx="0" cy="0"/>
+          <a:chOff x="0" y="0"/>
+          <a:chExt cx="0" cy="0"/>
+        </a:xfrm>
+      </p:grpSpPr>
       <p:sp>
         <p:nvSpPr>
           <p:cNvPr id="2" name="Rectangle 1"/>
@@ -4637,6 +5148,7 @@
           <a:lstStyle/>
           <a:p>
             <a:pPr algn="ctr"/>
+            <a:endParaRPr/>
           </a:p>
         </p:txBody>
       </p:sp>
@@ -4680,6 +5192,7 @@
           <a:lstStyle/>
           <a:p>
             <a:pPr algn="ctr"/>
+            <a:endParaRPr/>
           </a:p>
         </p:txBody>
       </p:sp>
@@ -4719,7 +5232,7 @@
           </a:fontRef>
         </p:style>
         <p:txBody>
-          <a:bodyPr rtlCol="0" anchor="ctr" wrap="square"/>
+          <a:bodyPr wrap="square" rtlCol="0" anchor="ctr"/>
           <a:lstStyle/>
           <a:p>
             <a:pPr algn="ctr">
@@ -4768,7 +5281,7 @@
         <p:spPr>
           <a:xfrm>
             <a:off x="731520" y="1645920"/>
-            <a:ext cx="5486400" cy="4754880"/>
+            <a:ext cx="4607396" cy="4754880"/>
           </a:xfrm>
           <a:prstGeom prst="roundRect">
             <a:avLst/>
@@ -4797,7 +5310,7 @@
           </a:fontRef>
         </p:style>
         <p:txBody>
-          <a:bodyPr rtlCol="0" anchor="ctr" wrap="square"/>
+          <a:bodyPr wrap="square" rtlCol="0" anchor="ctr"/>
           <a:lstStyle/>
           <a:p>
             <a:pPr algn="ctr">
@@ -4808,6 +5321,7 @@
               </a:defRPr>
             </a:pPr>
             <a:r>
+              <a:rPr dirty="0"/>
               <a:t>KEY ARCHITECTURE &amp; HIGHLIGHTS:</a:t>
             </a:r>
           </a:p>
@@ -4823,6 +5337,7 @@
               </a:defRPr>
             </a:pPr>
             <a:r>
+              <a:rPr dirty="0"/>
               <a:t>🔹 Room History Modal: Click any room card to open its dedicated audit log</a:t>
             </a:r>
           </a:p>
@@ -4838,6 +5353,7 @@
               </a:defRPr>
             </a:pPr>
             <a:r>
+              <a:rPr dirty="0"/>
               <a:t>🔹 Full Timeline: Displays booking creations, edits, cancellations, and notes</a:t>
             </a:r>
           </a:p>
@@ -4853,7 +5369,16 @@
               </a:defRPr>
             </a:pPr>
             <a:r>
-              <a:t>🔹 SQL Persistence: Stored permanently in the booking_histories table</a:t>
+              <a:rPr dirty="0"/>
+              <a:t>🔹 SQL Persistence: Stored permanently in the </a:t>
+            </a:r>
+            <a:r>
+              <a:rPr dirty="0" err="1"/>
+              <a:t>booking_histories</a:t>
+            </a:r>
+            <a:r>
+              <a:rPr dirty="0"/>
+              <a:t> table</a:t>
             </a:r>
           </a:p>
         </p:txBody>
@@ -4866,8 +5391,8 @@
         </p:nvSpPr>
         <p:spPr>
           <a:xfrm>
-            <a:off x="6400800" y="1645920"/>
-            <a:ext cx="5059375" cy="4754880"/>
+            <a:off x="5506066" y="1645920"/>
+            <a:ext cx="5954110" cy="4754880"/>
           </a:xfrm>
           <a:prstGeom prst="roundRect">
             <a:avLst/>
@@ -4900,67 +5425,40 @@
           <a:lstStyle/>
           <a:p>
             <a:pPr algn="ctr"/>
-          </a:p>
-        </p:txBody>
-      </p:sp>
-      <p:sp>
-        <p:nvSpPr>
-          <p:cNvPr id="7" name="Rounded Rectangle 6"/>
-          <p:cNvSpPr/>
+            <a:endParaRPr/>
+          </a:p>
+        </p:txBody>
+      </p:sp>
+      <p:pic>
+        <p:nvPicPr>
+          <p:cNvPr id="9" name="Picture 8">
+            <a:extLst>
+              <a:ext uri="{FF2B5EF4-FFF2-40B4-BE49-F238E27FC236}">
+                <a16:creationId xmlns:a16="http://schemas.microsoft.com/office/drawing/2014/main" id="{DA961525-23FE-6F0E-9E2A-6596398C02CB}"/>
+              </a:ext>
+            </a:extLst>
+          </p:cNvPr>
+          <p:cNvPicPr>
+            <a:picLocks noChangeAspect="1"/>
+          </p:cNvPicPr>
           <p:nvPr/>
-        </p:nvSpPr>
-        <p:spPr>
-          <a:xfrm>
-            <a:off x="6537960" y="1783080"/>
-            <a:ext cx="4785055" cy="4480560"/>
-          </a:xfrm>
-          <a:prstGeom prst="roundRect">
-            <a:avLst/>
-          </a:prstGeom>
-          <a:solidFill>
-            <a:srgbClr val="EEF2FF"/>
-          </a:solidFill>
-          <a:ln w="12700">
-            <a:solidFill>
-              <a:srgbClr val="E2E8F0"/>
-            </a:solidFill>
-          </a:ln>
-        </p:spPr>
-        <p:style>
-          <a:lnRef idx="1">
-            <a:schemeClr val="accent1"/>
-          </a:lnRef>
-          <a:fillRef idx="3">
-            <a:schemeClr val="accent1"/>
-          </a:fillRef>
-          <a:effectRef idx="2">
-            <a:schemeClr val="accent1"/>
-          </a:effectRef>
-          <a:fontRef idx="minor">
-            <a:schemeClr val="lt1"/>
-          </a:fontRef>
-        </p:style>
-        <p:txBody>
-          <a:bodyPr rtlCol="0" anchor="ctr" wrap="square"/>
-          <a:lstStyle/>
-          <a:p>
-            <a:pPr algn="ctr">
-              <a:defRPr sz="1300" b="1">
-                <a:solidFill>
-                  <a:srgbClr val="4F46E5"/>
-                </a:solidFill>
-              </a:defRPr>
-            </a:pPr>
-            <a:br/>
-            <a:br/>
-            <a:br/>
-            <a:br/>
-            <a:r>
-              <a:t>📸 [INSERT SCREENSHOT HERE: Room History Audit Log Modal]</a:t>
-            </a:r>
-          </a:p>
-        </p:txBody>
-      </p:sp>
+        </p:nvPicPr>
+        <p:blipFill>
+          <a:blip r:embed="rId2"/>
+          <a:stretch>
+            <a:fillRect/>
+          </a:stretch>
+        </p:blipFill>
+        <p:spPr>
+          <a:xfrm>
+            <a:off x="5889083" y="2035278"/>
+            <a:ext cx="5188076" cy="3765754"/>
+          </a:xfrm>
+          <a:prstGeom prst="rect">
+            <a:avLst/>
+          </a:prstGeom>
+        </p:spPr>
+      </p:pic>
     </p:spTree>
   </p:cSld>
   <p:clrMapOvr>
@@ -4970,7 +5468,7 @@
 </file>
 
 <file path=ppt/slides/slide14.xml><?xml version="1.0" encoding="utf-8"?>
-<p:sld xmlns:a="http://schemas.openxmlformats.org/drawingml/2006/main" xmlns:p="http://schemas.openxmlformats.org/presentationml/2006/main" xmlns:r="http://schemas.openxmlformats.org/officeDocument/2006/relationships">
+<p:sld xmlns:a="http://schemas.openxmlformats.org/drawingml/2006/main" xmlns:r="http://schemas.openxmlformats.org/officeDocument/2006/relationships" xmlns:p="http://schemas.openxmlformats.org/presentationml/2006/main">
   <p:cSld>
     <p:spTree>
       <p:nvGrpSpPr>
@@ -4978,7 +5476,14 @@
         <p:cNvGrpSpPr/>
         <p:nvPr/>
       </p:nvGrpSpPr>
-      <p:grpSpPr/>
+      <p:grpSpPr>
+        <a:xfrm>
+          <a:off x="0" y="0"/>
+          <a:ext cx="0" cy="0"/>
+          <a:chOff x="0" y="0"/>
+          <a:chExt cx="0" cy="0"/>
+        </a:xfrm>
+      </p:grpSpPr>
       <p:sp>
         <p:nvSpPr>
           <p:cNvPr id="2" name="Rectangle 1"/>
@@ -5019,6 +5524,7 @@
           <a:lstStyle/>
           <a:p>
             <a:pPr algn="ctr"/>
+            <a:endParaRPr/>
           </a:p>
         </p:txBody>
       </p:sp>
@@ -5062,6 +5568,7 @@
           <a:lstStyle/>
           <a:p>
             <a:pPr algn="ctr"/>
+            <a:endParaRPr/>
           </a:p>
         </p:txBody>
       </p:sp>
@@ -5101,7 +5608,7 @@
           </a:fontRef>
         </p:style>
         <p:txBody>
-          <a:bodyPr rtlCol="0" anchor="ctr" wrap="square"/>
+          <a:bodyPr wrap="square" rtlCol="0" anchor="ctr"/>
           <a:lstStyle/>
           <a:p>
             <a:pPr algn="ctr">
@@ -5179,7 +5686,7 @@
           </a:fontRef>
         </p:style>
         <p:txBody>
-          <a:bodyPr rtlCol="0" anchor="ctr" wrap="square"/>
+          <a:bodyPr wrap="square" rtlCol="0" anchor="ctr"/>
           <a:lstStyle/>
           <a:p>
             <a:pPr algn="ctr">
@@ -5282,6 +5789,7 @@
           <a:lstStyle/>
           <a:p>
             <a:pPr algn="ctr"/>
+            <a:endParaRPr/>
           </a:p>
         </p:txBody>
       </p:sp>
@@ -5323,7 +5831,7 @@
           </a:fontRef>
         </p:style>
         <p:txBody>
-          <a:bodyPr rtlCol="0" anchor="ctr" wrap="square"/>
+          <a:bodyPr wrap="square" rtlCol="0" anchor="ctr"/>
           <a:lstStyle/>
           <a:p>
             <a:pPr algn="ctr">
@@ -5352,7 +5860,7 @@
 </file>
 
 <file path=ppt/slides/slide15.xml><?xml version="1.0" encoding="utf-8"?>
-<p:sld xmlns:a="http://schemas.openxmlformats.org/drawingml/2006/main" xmlns:p="http://schemas.openxmlformats.org/presentationml/2006/main" xmlns:r="http://schemas.openxmlformats.org/officeDocument/2006/relationships">
+<p:sld xmlns:a="http://schemas.openxmlformats.org/drawingml/2006/main" xmlns:r="http://schemas.openxmlformats.org/officeDocument/2006/relationships" xmlns:p="http://schemas.openxmlformats.org/presentationml/2006/main">
   <p:cSld>
     <p:spTree>
       <p:nvGrpSpPr>
@@ -5360,7 +5868,14 @@
         <p:cNvGrpSpPr/>
         <p:nvPr/>
       </p:nvGrpSpPr>
-      <p:grpSpPr/>
+      <p:grpSpPr>
+        <a:xfrm>
+          <a:off x="0" y="0"/>
+          <a:ext cx="0" cy="0"/>
+          <a:chOff x="0" y="0"/>
+          <a:chExt cx="0" cy="0"/>
+        </a:xfrm>
+      </p:grpSpPr>
       <p:sp>
         <p:nvSpPr>
           <p:cNvPr id="2" name="Rectangle 1"/>
@@ -5401,6 +5916,7 @@
           <a:lstStyle/>
           <a:p>
             <a:pPr algn="ctr"/>
+            <a:endParaRPr/>
           </a:p>
         </p:txBody>
       </p:sp>
@@ -5444,6 +5960,7 @@
           <a:lstStyle/>
           <a:p>
             <a:pPr algn="ctr"/>
+            <a:endParaRPr/>
           </a:p>
         </p:txBody>
       </p:sp>
@@ -5483,7 +6000,7 @@
           </a:fontRef>
         </p:style>
         <p:txBody>
-          <a:bodyPr rtlCol="0" anchor="ctr" wrap="square"/>
+          <a:bodyPr wrap="square" rtlCol="0" anchor="ctr"/>
           <a:lstStyle/>
           <a:p>
             <a:pPr algn="ctr">
@@ -5561,7 +6078,7 @@
           </a:fontRef>
         </p:style>
         <p:txBody>
-          <a:bodyPr rtlCol="0" anchor="ctr" wrap="square"/>
+          <a:bodyPr wrap="square" rtlCol="0" anchor="ctr"/>
           <a:lstStyle/>
           <a:p>
             <a:pPr algn="ctr">
@@ -5664,6 +6181,7 @@
           <a:lstStyle/>
           <a:p>
             <a:pPr algn="ctr"/>
+            <a:endParaRPr/>
           </a:p>
         </p:txBody>
       </p:sp>
@@ -5705,7 +6223,7 @@
           </a:fontRef>
         </p:style>
         <p:txBody>
-          <a:bodyPr rtlCol="0" anchor="ctr" wrap="square"/>
+          <a:bodyPr wrap="square" rtlCol="0" anchor="ctr"/>
           <a:lstStyle/>
           <a:p>
             <a:pPr algn="ctr">
@@ -5734,7 +6252,7 @@
 </file>
 
 <file path=ppt/slides/slide16.xml><?xml version="1.0" encoding="utf-8"?>
-<p:sld xmlns:a="http://schemas.openxmlformats.org/drawingml/2006/main" xmlns:p="http://schemas.openxmlformats.org/presentationml/2006/main" xmlns:r="http://schemas.openxmlformats.org/officeDocument/2006/relationships">
+<p:sld xmlns:a="http://schemas.openxmlformats.org/drawingml/2006/main" xmlns:r="http://schemas.openxmlformats.org/officeDocument/2006/relationships" xmlns:p="http://schemas.openxmlformats.org/presentationml/2006/main">
   <p:cSld>
     <p:spTree>
       <p:nvGrpSpPr>
@@ -5742,7 +6260,14 @@
         <p:cNvGrpSpPr/>
         <p:nvPr/>
       </p:nvGrpSpPr>
-      <p:grpSpPr/>
+      <p:grpSpPr>
+        <a:xfrm>
+          <a:off x="0" y="0"/>
+          <a:ext cx="0" cy="0"/>
+          <a:chOff x="0" y="0"/>
+          <a:chExt cx="0" cy="0"/>
+        </a:xfrm>
+      </p:grpSpPr>
       <p:sp>
         <p:nvSpPr>
           <p:cNvPr id="2" name="Rectangle 1"/>
@@ -5783,6 +6308,7 @@
           <a:lstStyle/>
           <a:p>
             <a:pPr algn="ctr"/>
+            <a:endParaRPr/>
           </a:p>
         </p:txBody>
       </p:sp>
@@ -5826,6 +6352,7 @@
           <a:lstStyle/>
           <a:p>
             <a:pPr algn="ctr"/>
+            <a:endParaRPr/>
           </a:p>
         </p:txBody>
       </p:sp>
@@ -5865,7 +6392,7 @@
           </a:fontRef>
         </p:style>
         <p:txBody>
-          <a:bodyPr rtlCol="0" anchor="ctr" wrap="square"/>
+          <a:bodyPr wrap="square" rtlCol="0" anchor="ctr"/>
           <a:lstStyle/>
           <a:p>
             <a:pPr algn="ctr">
@@ -5943,7 +6470,7 @@
           </a:fontRef>
         </p:style>
         <p:txBody>
-          <a:bodyPr rtlCol="0" anchor="ctr" wrap="square"/>
+          <a:bodyPr wrap="square" rtlCol="0" anchor="ctr"/>
           <a:lstStyle/>
           <a:p>
             <a:pPr algn="ctr">
@@ -6061,6 +6588,7 @@
           <a:lstStyle/>
           <a:p>
             <a:pPr algn="ctr"/>
+            <a:endParaRPr/>
           </a:p>
         </p:txBody>
       </p:sp>
@@ -6102,7 +6630,7 @@
           </a:fontRef>
         </p:style>
         <p:txBody>
-          <a:bodyPr rtlCol="0" anchor="ctr" wrap="square"/>
+          <a:bodyPr wrap="square" rtlCol="0" anchor="ctr"/>
           <a:lstStyle/>
           <a:p>
             <a:pPr algn="ctr">
@@ -6131,7 +6659,7 @@
 </file>
 
 <file path=ppt/slides/slide17.xml><?xml version="1.0" encoding="utf-8"?>
-<p:sld xmlns:a="http://schemas.openxmlformats.org/drawingml/2006/main" xmlns:p="http://schemas.openxmlformats.org/presentationml/2006/main" xmlns:r="http://schemas.openxmlformats.org/officeDocument/2006/relationships">
+<p:sld xmlns:a="http://schemas.openxmlformats.org/drawingml/2006/main" xmlns:r="http://schemas.openxmlformats.org/officeDocument/2006/relationships" xmlns:p="http://schemas.openxmlformats.org/presentationml/2006/main">
   <p:cSld>
     <p:spTree>
       <p:nvGrpSpPr>
@@ -6139,7 +6667,14 @@
         <p:cNvGrpSpPr/>
         <p:nvPr/>
       </p:nvGrpSpPr>
-      <p:grpSpPr/>
+      <p:grpSpPr>
+        <a:xfrm>
+          <a:off x="0" y="0"/>
+          <a:ext cx="0" cy="0"/>
+          <a:chOff x="0" y="0"/>
+          <a:chExt cx="0" cy="0"/>
+        </a:xfrm>
+      </p:grpSpPr>
       <p:sp>
         <p:nvSpPr>
           <p:cNvPr id="2" name="Rectangle 1"/>
@@ -6180,6 +6715,7 @@
           <a:lstStyle/>
           <a:p>
             <a:pPr algn="ctr"/>
+            <a:endParaRPr/>
           </a:p>
         </p:txBody>
       </p:sp>
@@ -6223,6 +6759,7 @@
           <a:lstStyle/>
           <a:p>
             <a:pPr algn="ctr"/>
+            <a:endParaRPr/>
           </a:p>
         </p:txBody>
       </p:sp>
@@ -6262,7 +6799,7 @@
           </a:fontRef>
         </p:style>
         <p:txBody>
-          <a:bodyPr rtlCol="0" anchor="ctr" wrap="square"/>
+          <a:bodyPr wrap="square" rtlCol="0" anchor="ctr"/>
           <a:lstStyle/>
           <a:p>
             <a:pPr algn="ctr">
@@ -6340,7 +6877,7 @@
           </a:fontRef>
         </p:style>
         <p:txBody>
-          <a:bodyPr rtlCol="0" anchor="ctr" wrap="square"/>
+          <a:bodyPr wrap="square" rtlCol="0" anchor="ctr"/>
           <a:lstStyle/>
           <a:p>
             <a:pPr algn="ctr">
@@ -6458,6 +6995,7 @@
           <a:lstStyle/>
           <a:p>
             <a:pPr algn="ctr"/>
+            <a:endParaRPr/>
           </a:p>
         </p:txBody>
       </p:sp>
@@ -6499,7 +7037,7 @@
           </a:fontRef>
         </p:style>
         <p:txBody>
-          <a:bodyPr rtlCol="0" anchor="ctr" wrap="square"/>
+          <a:bodyPr wrap="square" rtlCol="0" anchor="ctr"/>
           <a:lstStyle/>
           <a:p>
             <a:pPr algn="ctr">
@@ -6528,7 +7066,7 @@
 </file>
 
 <file path=ppt/slides/slide18.xml><?xml version="1.0" encoding="utf-8"?>
-<p:sld xmlns:a="http://schemas.openxmlformats.org/drawingml/2006/main" xmlns:p="http://schemas.openxmlformats.org/presentationml/2006/main" xmlns:r="http://schemas.openxmlformats.org/officeDocument/2006/relationships">
+<p:sld xmlns:a="http://schemas.openxmlformats.org/drawingml/2006/main" xmlns:r="http://schemas.openxmlformats.org/officeDocument/2006/relationships" xmlns:p="http://schemas.openxmlformats.org/presentationml/2006/main">
   <p:cSld>
     <p:spTree>
       <p:nvGrpSpPr>
@@ -6536,7 +7074,14 @@
         <p:cNvGrpSpPr/>
         <p:nvPr/>
       </p:nvGrpSpPr>
-      <p:grpSpPr/>
+      <p:grpSpPr>
+        <a:xfrm>
+          <a:off x="0" y="0"/>
+          <a:ext cx="0" cy="0"/>
+          <a:chOff x="0" y="0"/>
+          <a:chExt cx="0" cy="0"/>
+        </a:xfrm>
+      </p:grpSpPr>
       <p:sp>
         <p:nvSpPr>
           <p:cNvPr id="2" name="Rectangle 1"/>
@@ -6577,6 +7122,7 @@
           <a:lstStyle/>
           <a:p>
             <a:pPr algn="ctr"/>
+            <a:endParaRPr/>
           </a:p>
         </p:txBody>
       </p:sp>
@@ -6620,6 +7166,7 @@
           <a:lstStyle/>
           <a:p>
             <a:pPr algn="ctr"/>
+            <a:endParaRPr/>
           </a:p>
         </p:txBody>
       </p:sp>
@@ -6715,7 +7262,7 @@
           </a:fontRef>
         </p:style>
         <p:txBody>
-          <a:bodyPr rtlCol="0" anchor="ctr" wrap="square"/>
+          <a:bodyPr wrap="square" rtlCol="0" anchor="ctr"/>
           <a:lstStyle/>
           <a:p>
             <a:pPr algn="ctr">
@@ -6746,16 +7293,6 @@
           </a:p>
           <a:p>
             <a:br/>
-            <a:pPr>
-              <a:spcBef>
-                <a:spcPts val="1400"/>
-              </a:spcBef>
-              <a:defRPr sz="1200" b="1">
-                <a:solidFill>
-                  <a:srgbClr val="10B981"/>
-                </a:solidFill>
-              </a:defRPr>
-            </a:pPr>
             <a:r>
               <a:t>KEY SYSTEM HIGHLIGHTS:</a:t>
             </a:r>
@@ -6860,7 +7397,7 @@
           </a:fontRef>
         </p:style>
         <p:txBody>
-          <a:bodyPr rtlCol="0" anchor="ctr" wrap="square"/>
+          <a:bodyPr wrap="square" rtlCol="0" anchor="ctr"/>
           <a:lstStyle/>
           <a:p>
             <a:pPr algn="ctr">
@@ -6889,7 +7426,7 @@
 </file>
 
 <file path=ppt/slides/slide2.xml><?xml version="1.0" encoding="utf-8"?>
-<p:sld xmlns:a="http://schemas.openxmlformats.org/drawingml/2006/main" xmlns:p="http://schemas.openxmlformats.org/presentationml/2006/main" xmlns:r="http://schemas.openxmlformats.org/officeDocument/2006/relationships">
+<p:sld xmlns:a="http://schemas.openxmlformats.org/drawingml/2006/main" xmlns:r="http://schemas.openxmlformats.org/officeDocument/2006/relationships" xmlns:p="http://schemas.openxmlformats.org/presentationml/2006/main">
   <p:cSld>
     <p:spTree>
       <p:nvGrpSpPr>
@@ -6897,7 +7434,14 @@
         <p:cNvGrpSpPr/>
         <p:nvPr/>
       </p:nvGrpSpPr>
-      <p:grpSpPr/>
+      <p:grpSpPr>
+        <a:xfrm>
+          <a:off x="0" y="0"/>
+          <a:ext cx="0" cy="0"/>
+          <a:chOff x="0" y="0"/>
+          <a:chExt cx="0" cy="0"/>
+        </a:xfrm>
+      </p:grpSpPr>
       <p:sp>
         <p:nvSpPr>
           <p:cNvPr id="2" name="Rectangle 1"/>
@@ -6938,6 +7482,7 @@
           <a:lstStyle/>
           <a:p>
             <a:pPr algn="ctr"/>
+            <a:endParaRPr/>
           </a:p>
         </p:txBody>
       </p:sp>
@@ -6981,6 +7526,7 @@
           <a:lstStyle/>
           <a:p>
             <a:pPr algn="ctr"/>
+            <a:endParaRPr/>
           </a:p>
         </p:txBody>
       </p:sp>
@@ -7020,7 +7566,7 @@
           </a:fontRef>
         </p:style>
         <p:txBody>
-          <a:bodyPr rtlCol="0" anchor="ctr" wrap="square"/>
+          <a:bodyPr wrap="square" rtlCol="0" anchor="ctr"/>
           <a:lstStyle/>
           <a:p>
             <a:pPr algn="ctr">
@@ -7068,8 +7614,8 @@
         </p:nvSpPr>
         <p:spPr>
           <a:xfrm>
-            <a:off x="731520" y="1645920"/>
-            <a:ext cx="5486400" cy="4754880"/>
+            <a:off x="731521" y="1645920"/>
+            <a:ext cx="4518906" cy="4754880"/>
           </a:xfrm>
           <a:prstGeom prst="roundRect">
             <a:avLst/>
@@ -7098,7 +7644,7 @@
           </a:fontRef>
         </p:style>
         <p:txBody>
-          <a:bodyPr rtlCol="0" anchor="ctr" wrap="square"/>
+          <a:bodyPr wrap="square" rtlCol="0" anchor="ctr"/>
           <a:lstStyle/>
           <a:p>
             <a:pPr algn="ctr">
@@ -7182,8 +7728,8 @@
         </p:nvSpPr>
         <p:spPr>
           <a:xfrm>
-            <a:off x="6400800" y="1645920"/>
-            <a:ext cx="5059375" cy="4754880"/>
+            <a:off x="5476568" y="1645920"/>
+            <a:ext cx="5983607" cy="4754880"/>
           </a:xfrm>
           <a:prstGeom prst="roundRect">
             <a:avLst/>
@@ -7216,67 +7762,40 @@
           <a:lstStyle/>
           <a:p>
             <a:pPr algn="ctr"/>
-          </a:p>
-        </p:txBody>
-      </p:sp>
-      <p:sp>
-        <p:nvSpPr>
-          <p:cNvPr id="7" name="Rounded Rectangle 6"/>
-          <p:cNvSpPr/>
+            <a:endParaRPr/>
+          </a:p>
+        </p:txBody>
+      </p:sp>
+      <p:pic>
+        <p:nvPicPr>
+          <p:cNvPr id="9" name="Picture 8">
+            <a:extLst>
+              <a:ext uri="{FF2B5EF4-FFF2-40B4-BE49-F238E27FC236}">
+                <a16:creationId xmlns:a16="http://schemas.microsoft.com/office/drawing/2014/main" id="{DAC6F162-CDF1-6000-F549-39F935F2E793}"/>
+              </a:ext>
+            </a:extLst>
+          </p:cNvPr>
+          <p:cNvPicPr>
+            <a:picLocks noChangeAspect="1"/>
+          </p:cNvPicPr>
           <p:nvPr/>
-        </p:nvSpPr>
-        <p:spPr>
-          <a:xfrm>
-            <a:off x="6537960" y="1783080"/>
-            <a:ext cx="4785055" cy="4480560"/>
-          </a:xfrm>
-          <a:prstGeom prst="roundRect">
-            <a:avLst/>
-          </a:prstGeom>
-          <a:solidFill>
-            <a:srgbClr val="EEF2FF"/>
-          </a:solidFill>
-          <a:ln w="12700">
-            <a:solidFill>
-              <a:srgbClr val="E2E8F0"/>
-            </a:solidFill>
-          </a:ln>
-        </p:spPr>
-        <p:style>
-          <a:lnRef idx="1">
-            <a:schemeClr val="accent1"/>
-          </a:lnRef>
-          <a:fillRef idx="3">
-            <a:schemeClr val="accent1"/>
-          </a:fillRef>
-          <a:effectRef idx="2">
-            <a:schemeClr val="accent1"/>
-          </a:effectRef>
-          <a:fontRef idx="minor">
-            <a:schemeClr val="lt1"/>
-          </a:fontRef>
-        </p:style>
-        <p:txBody>
-          <a:bodyPr rtlCol="0" anchor="ctr" wrap="square"/>
-          <a:lstStyle/>
-          <a:p>
-            <a:pPr algn="ctr">
-              <a:defRPr sz="1300" b="1">
-                <a:solidFill>
-                  <a:srgbClr val="4F46E5"/>
-                </a:solidFill>
-              </a:defRPr>
-            </a:pPr>
-            <a:br/>
-            <a:br/>
-            <a:br/>
-            <a:br/>
-            <a:r>
-              <a:t>📸 [INSERT SCREENSHOT HERE: Employee Dashboard &amp; Active Reservations]</a:t>
-            </a:r>
-          </a:p>
-        </p:txBody>
-      </p:sp>
+        </p:nvPicPr>
+        <p:blipFill>
+          <a:blip r:embed="rId2"/>
+          <a:stretch>
+            <a:fillRect/>
+          </a:stretch>
+        </p:blipFill>
+        <p:spPr>
+          <a:xfrm>
+            <a:off x="5686979" y="2251587"/>
+            <a:ext cx="5478227" cy="3303639"/>
+          </a:xfrm>
+          <a:prstGeom prst="rect">
+            <a:avLst/>
+          </a:prstGeom>
+        </p:spPr>
+      </p:pic>
     </p:spTree>
   </p:cSld>
   <p:clrMapOvr>
@@ -7286,7 +7805,7 @@
 </file>
 
 <file path=ppt/slides/slide3.xml><?xml version="1.0" encoding="utf-8"?>
-<p:sld xmlns:a="http://schemas.openxmlformats.org/drawingml/2006/main" xmlns:p="http://schemas.openxmlformats.org/presentationml/2006/main" xmlns:r="http://schemas.openxmlformats.org/officeDocument/2006/relationships">
+<p:sld xmlns:a="http://schemas.openxmlformats.org/drawingml/2006/main" xmlns:r="http://schemas.openxmlformats.org/officeDocument/2006/relationships" xmlns:p="http://schemas.openxmlformats.org/presentationml/2006/main">
   <p:cSld>
     <p:spTree>
       <p:nvGrpSpPr>
@@ -7294,7 +7813,14 @@
         <p:cNvGrpSpPr/>
         <p:nvPr/>
       </p:nvGrpSpPr>
-      <p:grpSpPr/>
+      <p:grpSpPr>
+        <a:xfrm>
+          <a:off x="0" y="0"/>
+          <a:ext cx="0" cy="0"/>
+          <a:chOff x="0" y="0"/>
+          <a:chExt cx="0" cy="0"/>
+        </a:xfrm>
+      </p:grpSpPr>
       <p:sp>
         <p:nvSpPr>
           <p:cNvPr id="2" name="Rectangle 1"/>
@@ -7335,6 +7861,7 @@
           <a:lstStyle/>
           <a:p>
             <a:pPr algn="ctr"/>
+            <a:endParaRPr/>
           </a:p>
         </p:txBody>
       </p:sp>
@@ -7378,6 +7905,7 @@
           <a:lstStyle/>
           <a:p>
             <a:pPr algn="ctr"/>
+            <a:endParaRPr/>
           </a:p>
         </p:txBody>
       </p:sp>
@@ -7417,7 +7945,7 @@
           </a:fontRef>
         </p:style>
         <p:txBody>
-          <a:bodyPr rtlCol="0" anchor="ctr" wrap="square"/>
+          <a:bodyPr wrap="square" rtlCol="0" anchor="ctr"/>
           <a:lstStyle/>
           <a:p>
             <a:pPr algn="ctr">
@@ -7466,7 +7994,7 @@
         <p:spPr>
           <a:xfrm>
             <a:off x="731520" y="1645920"/>
-            <a:ext cx="5486400" cy="4754880"/>
+            <a:ext cx="4440248" cy="4754880"/>
           </a:xfrm>
           <a:prstGeom prst="roundRect">
             <a:avLst/>
@@ -7495,7 +8023,7 @@
           </a:fontRef>
         </p:style>
         <p:txBody>
-          <a:bodyPr rtlCol="0" anchor="ctr" wrap="square"/>
+          <a:bodyPr wrap="square" rtlCol="0" anchor="ctr"/>
           <a:lstStyle/>
           <a:p>
             <a:pPr algn="ctr">
@@ -7564,8 +8092,8 @@
         </p:nvSpPr>
         <p:spPr>
           <a:xfrm>
-            <a:off x="6400800" y="1645920"/>
-            <a:ext cx="5059375" cy="4754880"/>
+            <a:off x="5388078" y="1645920"/>
+            <a:ext cx="6072098" cy="4754880"/>
           </a:xfrm>
           <a:prstGeom prst="roundRect">
             <a:avLst/>
@@ -7598,67 +8126,41 @@
           <a:lstStyle/>
           <a:p>
             <a:pPr algn="ctr"/>
-          </a:p>
-        </p:txBody>
-      </p:sp>
-      <p:sp>
-        <p:nvSpPr>
-          <p:cNvPr id="7" name="Rounded Rectangle 6"/>
-          <p:cNvSpPr/>
+            <a:endParaRPr/>
+          </a:p>
+        </p:txBody>
+      </p:sp>
+      <p:pic>
+        <p:nvPicPr>
+          <p:cNvPr id="9" name="Picture 8">
+            <a:extLst>
+              <a:ext uri="{FF2B5EF4-FFF2-40B4-BE49-F238E27FC236}">
+                <a16:creationId xmlns:a16="http://schemas.microsoft.com/office/drawing/2014/main" id="{A10E2CC9-E887-6A87-45DA-3973766B875D}"/>
+              </a:ext>
+            </a:extLst>
+          </p:cNvPr>
+          <p:cNvPicPr>
+            <a:picLocks noChangeAspect="1"/>
+          </p:cNvPicPr>
           <p:nvPr/>
-        </p:nvSpPr>
-        <p:spPr>
-          <a:xfrm>
-            <a:off x="6537960" y="1783080"/>
-            <a:ext cx="4785055" cy="4480560"/>
-          </a:xfrm>
-          <a:prstGeom prst="roundRect">
-            <a:avLst/>
-          </a:prstGeom>
-          <a:solidFill>
-            <a:srgbClr val="EEF2FF"/>
-          </a:solidFill>
-          <a:ln w="12700">
-            <a:solidFill>
-              <a:srgbClr val="E2E8F0"/>
-            </a:solidFill>
-          </a:ln>
-        </p:spPr>
-        <p:style>
-          <a:lnRef idx="1">
-            <a:schemeClr val="accent1"/>
-          </a:lnRef>
-          <a:fillRef idx="3">
-            <a:schemeClr val="accent1"/>
-          </a:fillRef>
-          <a:effectRef idx="2">
-            <a:schemeClr val="accent1"/>
-          </a:effectRef>
-          <a:fontRef idx="minor">
-            <a:schemeClr val="lt1"/>
-          </a:fontRef>
-        </p:style>
-        <p:txBody>
-          <a:bodyPr rtlCol="0" anchor="ctr" wrap="square"/>
-          <a:lstStyle/>
-          <a:p>
-            <a:pPr algn="ctr">
-              <a:defRPr sz="1300" b="1">
-                <a:solidFill>
-                  <a:srgbClr val="4F46E5"/>
-                </a:solidFill>
-              </a:defRPr>
-            </a:pPr>
-            <a:br/>
-            <a:br/>
-            <a:br/>
-            <a:br/>
-            <a:r>
-              <a:t>📸 [INSERT SCREENSHOT HERE: System Architecture &amp; Flow Diagram]</a:t>
-            </a:r>
-          </a:p>
-        </p:txBody>
-      </p:sp>
+        </p:nvPicPr>
+        <p:blipFill>
+          <a:blip r:embed="rId2"/>
+          <a:srcRect t="3514"/>
+          <a:stretch>
+            <a:fillRect/>
+          </a:stretch>
+        </p:blipFill>
+        <p:spPr>
+          <a:xfrm>
+            <a:off x="5582429" y="2251587"/>
+            <a:ext cx="5606681" cy="3510116"/>
+          </a:xfrm>
+          <a:prstGeom prst="rect">
+            <a:avLst/>
+          </a:prstGeom>
+        </p:spPr>
+      </p:pic>
     </p:spTree>
   </p:cSld>
   <p:clrMapOvr>
@@ -7668,7 +8170,7 @@
 </file>
 
 <file path=ppt/slides/slide4.xml><?xml version="1.0" encoding="utf-8"?>
-<p:sld xmlns:a="http://schemas.openxmlformats.org/drawingml/2006/main" xmlns:p="http://schemas.openxmlformats.org/presentationml/2006/main" xmlns:r="http://schemas.openxmlformats.org/officeDocument/2006/relationships">
+<p:sld xmlns:a="http://schemas.openxmlformats.org/drawingml/2006/main" xmlns:r="http://schemas.openxmlformats.org/officeDocument/2006/relationships" xmlns:p="http://schemas.openxmlformats.org/presentationml/2006/main">
   <p:cSld>
     <p:spTree>
       <p:nvGrpSpPr>
@@ -7676,7 +8178,14 @@
         <p:cNvGrpSpPr/>
         <p:nvPr/>
       </p:nvGrpSpPr>
-      <p:grpSpPr/>
+      <p:grpSpPr>
+        <a:xfrm>
+          <a:off x="0" y="0"/>
+          <a:ext cx="0" cy="0"/>
+          <a:chOff x="0" y="0"/>
+          <a:chExt cx="0" cy="0"/>
+        </a:xfrm>
+      </p:grpSpPr>
       <p:sp>
         <p:nvSpPr>
           <p:cNvPr id="2" name="Rectangle 1"/>
@@ -7717,6 +8226,7 @@
           <a:lstStyle/>
           <a:p>
             <a:pPr algn="ctr"/>
+            <a:endParaRPr/>
           </a:p>
         </p:txBody>
       </p:sp>
@@ -7760,6 +8270,7 @@
           <a:lstStyle/>
           <a:p>
             <a:pPr algn="ctr"/>
+            <a:endParaRPr/>
           </a:p>
         </p:txBody>
       </p:sp>
@@ -7799,7 +8310,7 @@
           </a:fontRef>
         </p:style>
         <p:txBody>
-          <a:bodyPr rtlCol="0" anchor="ctr" wrap="square"/>
+          <a:bodyPr wrap="square" rtlCol="0" anchor="ctr"/>
           <a:lstStyle/>
           <a:p>
             <a:pPr algn="ctr">
@@ -7848,7 +8359,7 @@
         <p:spPr>
           <a:xfrm>
             <a:off x="731520" y="1645920"/>
-            <a:ext cx="5486400" cy="4754880"/>
+            <a:ext cx="4450080" cy="4754880"/>
           </a:xfrm>
           <a:prstGeom prst="roundRect">
             <a:avLst/>
@@ -7877,7 +8388,7 @@
           </a:fontRef>
         </p:style>
         <p:txBody>
-          <a:bodyPr rtlCol="0" anchor="ctr" wrap="square"/>
+          <a:bodyPr wrap="square" rtlCol="0" anchor="ctr"/>
           <a:lstStyle/>
           <a:p>
             <a:pPr algn="ctr">
@@ -7946,8 +8457,8 @@
         </p:nvSpPr>
         <p:spPr>
           <a:xfrm>
-            <a:off x="6400800" y="1645920"/>
-            <a:ext cx="5059375" cy="4754880"/>
+            <a:off x="5329084" y="1645920"/>
+            <a:ext cx="6131091" cy="4754880"/>
           </a:xfrm>
           <a:prstGeom prst="roundRect">
             <a:avLst/>
@@ -7980,67 +8491,40 @@
           <a:lstStyle/>
           <a:p>
             <a:pPr algn="ctr"/>
-          </a:p>
-        </p:txBody>
-      </p:sp>
-      <p:sp>
-        <p:nvSpPr>
-          <p:cNvPr id="7" name="Rounded Rectangle 6"/>
-          <p:cNvSpPr/>
+            <a:endParaRPr/>
+          </a:p>
+        </p:txBody>
+      </p:sp>
+      <p:pic>
+        <p:nvPicPr>
+          <p:cNvPr id="11" name="Picture 10">
+            <a:extLst>
+              <a:ext uri="{FF2B5EF4-FFF2-40B4-BE49-F238E27FC236}">
+                <a16:creationId xmlns:a16="http://schemas.microsoft.com/office/drawing/2014/main" id="{A3FAA9DB-B71C-0242-ABF1-1E5B7FB1BC38}"/>
+              </a:ext>
+            </a:extLst>
+          </p:cNvPr>
+          <p:cNvPicPr>
+            <a:picLocks noChangeAspect="1"/>
+          </p:cNvPicPr>
           <p:nvPr/>
-        </p:nvSpPr>
-        <p:spPr>
-          <a:xfrm>
-            <a:off x="6537960" y="1783080"/>
-            <a:ext cx="4785055" cy="4480560"/>
-          </a:xfrm>
-          <a:prstGeom prst="roundRect">
-            <a:avLst/>
-          </a:prstGeom>
-          <a:solidFill>
-            <a:srgbClr val="EEF2FF"/>
-          </a:solidFill>
-          <a:ln w="12700">
-            <a:solidFill>
-              <a:srgbClr val="E2E8F0"/>
-            </a:solidFill>
-          </a:ln>
-        </p:spPr>
-        <p:style>
-          <a:lnRef idx="1">
-            <a:schemeClr val="accent1"/>
-          </a:lnRef>
-          <a:fillRef idx="3">
-            <a:schemeClr val="accent1"/>
-          </a:fillRef>
-          <a:effectRef idx="2">
-            <a:schemeClr val="accent1"/>
-          </a:effectRef>
-          <a:fontRef idx="minor">
-            <a:schemeClr val="lt1"/>
-          </a:fontRef>
-        </p:style>
-        <p:txBody>
-          <a:bodyPr rtlCol="0" anchor="ctr" wrap="square"/>
-          <a:lstStyle/>
-          <a:p>
-            <a:pPr algn="ctr">
-              <a:defRPr sz="1300" b="1">
-                <a:solidFill>
-                  <a:srgbClr val="4F46E5"/>
-                </a:solidFill>
-              </a:defRPr>
-            </a:pPr>
-            <a:br/>
-            <a:br/>
-            <a:br/>
-            <a:br/>
-            <a:r>
-              <a:t>📸 [INSERT SCREENSHOT HERE: MySQL Workbench Ctrl + R EER Diagram]</a:t>
-            </a:r>
-          </a:p>
-        </p:txBody>
-      </p:sp>
+        </p:nvPicPr>
+        <p:blipFill>
+          <a:blip r:embed="rId2"/>
+          <a:stretch>
+            <a:fillRect/>
+          </a:stretch>
+        </p:blipFill>
+        <p:spPr>
+          <a:xfrm>
+            <a:off x="5913121" y="1740310"/>
+            <a:ext cx="4926034" cy="4493342"/>
+          </a:xfrm>
+          <a:prstGeom prst="rect">
+            <a:avLst/>
+          </a:prstGeom>
+        </p:spPr>
+      </p:pic>
     </p:spTree>
   </p:cSld>
   <p:clrMapOvr>
@@ -8050,7 +8534,7 @@
 </file>
 
 <file path=ppt/slides/slide5.xml><?xml version="1.0" encoding="utf-8"?>
-<p:sld xmlns:a="http://schemas.openxmlformats.org/drawingml/2006/main" xmlns:p="http://schemas.openxmlformats.org/presentationml/2006/main" xmlns:r="http://schemas.openxmlformats.org/officeDocument/2006/relationships">
+<p:sld xmlns:a="http://schemas.openxmlformats.org/drawingml/2006/main" xmlns:r="http://schemas.openxmlformats.org/officeDocument/2006/relationships" xmlns:p="http://schemas.openxmlformats.org/presentationml/2006/main">
   <p:cSld>
     <p:spTree>
       <p:nvGrpSpPr>
@@ -8058,7 +8542,14 @@
         <p:cNvGrpSpPr/>
         <p:nvPr/>
       </p:nvGrpSpPr>
-      <p:grpSpPr/>
+      <p:grpSpPr>
+        <a:xfrm>
+          <a:off x="0" y="0"/>
+          <a:ext cx="0" cy="0"/>
+          <a:chOff x="0" y="0"/>
+          <a:chExt cx="0" cy="0"/>
+        </a:xfrm>
+      </p:grpSpPr>
       <p:sp>
         <p:nvSpPr>
           <p:cNvPr id="2" name="Rectangle 1"/>
@@ -8099,6 +8590,7 @@
           <a:lstStyle/>
           <a:p>
             <a:pPr algn="ctr"/>
+            <a:endParaRPr/>
           </a:p>
         </p:txBody>
       </p:sp>
@@ -8142,6 +8634,7 @@
           <a:lstStyle/>
           <a:p>
             <a:pPr algn="ctr"/>
+            <a:endParaRPr/>
           </a:p>
         </p:txBody>
       </p:sp>
@@ -8181,7 +8674,7 @@
           </a:fontRef>
         </p:style>
         <p:txBody>
-          <a:bodyPr rtlCol="0" anchor="ctr" wrap="square"/>
+          <a:bodyPr wrap="square" rtlCol="0" anchor="ctr"/>
           <a:lstStyle/>
           <a:p>
             <a:pPr algn="ctr">
@@ -8230,7 +8723,7 @@
         <p:spPr>
           <a:xfrm>
             <a:off x="731520" y="1645920"/>
-            <a:ext cx="5486400" cy="4754880"/>
+            <a:ext cx="4440248" cy="4754880"/>
           </a:xfrm>
           <a:prstGeom prst="roundRect">
             <a:avLst/>
@@ -8259,7 +8752,7 @@
           </a:fontRef>
         </p:style>
         <p:txBody>
-          <a:bodyPr rtlCol="0" anchor="ctr" wrap="square"/>
+          <a:bodyPr wrap="square" rtlCol="0" anchor="ctr"/>
           <a:lstStyle/>
           <a:p>
             <a:pPr algn="ctr">
@@ -8328,8 +8821,8 @@
         </p:nvSpPr>
         <p:spPr>
           <a:xfrm>
-            <a:off x="6400800" y="1645920"/>
-            <a:ext cx="5059375" cy="4754880"/>
+            <a:off x="5348748" y="1645920"/>
+            <a:ext cx="6111427" cy="4754880"/>
           </a:xfrm>
           <a:prstGeom prst="roundRect">
             <a:avLst/>
@@ -8362,67 +8855,40 @@
           <a:lstStyle/>
           <a:p>
             <a:pPr algn="ctr"/>
-          </a:p>
-        </p:txBody>
-      </p:sp>
-      <p:sp>
-        <p:nvSpPr>
-          <p:cNvPr id="7" name="Rounded Rectangle 6"/>
-          <p:cNvSpPr/>
+            <a:endParaRPr/>
+          </a:p>
+        </p:txBody>
+      </p:sp>
+      <p:pic>
+        <p:nvPicPr>
+          <p:cNvPr id="9" name="Picture 8">
+            <a:extLst>
+              <a:ext uri="{FF2B5EF4-FFF2-40B4-BE49-F238E27FC236}">
+                <a16:creationId xmlns:a16="http://schemas.microsoft.com/office/drawing/2014/main" id="{A4908E5F-827F-12A9-1F51-88D67C04AAF5}"/>
+              </a:ext>
+            </a:extLst>
+          </p:cNvPr>
+          <p:cNvPicPr>
+            <a:picLocks noChangeAspect="1"/>
+          </p:cNvPicPr>
           <p:nvPr/>
-        </p:nvSpPr>
-        <p:spPr>
-          <a:xfrm>
-            <a:off x="6537960" y="1783080"/>
-            <a:ext cx="4785055" cy="4480560"/>
-          </a:xfrm>
-          <a:prstGeom prst="roundRect">
-            <a:avLst/>
-          </a:prstGeom>
-          <a:solidFill>
-            <a:srgbClr val="EEF2FF"/>
-          </a:solidFill>
-          <a:ln w="12700">
-            <a:solidFill>
-              <a:srgbClr val="E2E8F0"/>
-            </a:solidFill>
-          </a:ln>
-        </p:spPr>
-        <p:style>
-          <a:lnRef idx="1">
-            <a:schemeClr val="accent1"/>
-          </a:lnRef>
-          <a:fillRef idx="3">
-            <a:schemeClr val="accent1"/>
-          </a:fillRef>
-          <a:effectRef idx="2">
-            <a:schemeClr val="accent1"/>
-          </a:effectRef>
-          <a:fontRef idx="minor">
-            <a:schemeClr val="lt1"/>
-          </a:fontRef>
-        </p:style>
-        <p:txBody>
-          <a:bodyPr rtlCol="0" anchor="ctr" wrap="square"/>
-          <a:lstStyle/>
-          <a:p>
-            <a:pPr algn="ctr">
-              <a:defRPr sz="1300" b="1">
-                <a:solidFill>
-                  <a:srgbClr val="4F46E5"/>
-                </a:solidFill>
-              </a:defRPr>
-            </a:pPr>
-            <a:br/>
-            <a:br/>
-            <a:br/>
-            <a:br/>
-            <a:r>
-              <a:t>📸 [INSERT SCREENSHOT HERE: Login &amp; Sign Up Portal Page]</a:t>
-            </a:r>
-          </a:p>
-        </p:txBody>
-      </p:sp>
+        </p:nvPicPr>
+        <p:blipFill>
+          <a:blip r:embed="rId2"/>
+          <a:stretch>
+            <a:fillRect/>
+          </a:stretch>
+        </p:blipFill>
+        <p:spPr>
+          <a:xfrm>
+            <a:off x="5584722" y="2054942"/>
+            <a:ext cx="5683045" cy="3844413"/>
+          </a:xfrm>
+          <a:prstGeom prst="rect">
+            <a:avLst/>
+          </a:prstGeom>
+        </p:spPr>
+      </p:pic>
     </p:spTree>
   </p:cSld>
   <p:clrMapOvr>
@@ -8432,7 +8898,7 @@
 </file>
 
 <file path=ppt/slides/slide6.xml><?xml version="1.0" encoding="utf-8"?>
-<p:sld xmlns:a="http://schemas.openxmlformats.org/drawingml/2006/main" xmlns:p="http://schemas.openxmlformats.org/presentationml/2006/main" xmlns:r="http://schemas.openxmlformats.org/officeDocument/2006/relationships">
+<p:sld xmlns:a="http://schemas.openxmlformats.org/drawingml/2006/main" xmlns:r="http://schemas.openxmlformats.org/officeDocument/2006/relationships" xmlns:p="http://schemas.openxmlformats.org/presentationml/2006/main">
   <p:cSld>
     <p:spTree>
       <p:nvGrpSpPr>
@@ -8440,7 +8906,14 @@
         <p:cNvGrpSpPr/>
         <p:nvPr/>
       </p:nvGrpSpPr>
-      <p:grpSpPr/>
+      <p:grpSpPr>
+        <a:xfrm>
+          <a:off x="0" y="0"/>
+          <a:ext cx="0" cy="0"/>
+          <a:chOff x="0" y="0"/>
+          <a:chExt cx="0" cy="0"/>
+        </a:xfrm>
+      </p:grpSpPr>
       <p:sp>
         <p:nvSpPr>
           <p:cNvPr id="2" name="Rectangle 1"/>
@@ -8481,6 +8954,7 @@
           <a:lstStyle/>
           <a:p>
             <a:pPr algn="ctr"/>
+            <a:endParaRPr/>
           </a:p>
         </p:txBody>
       </p:sp>
@@ -8524,6 +8998,7 @@
           <a:lstStyle/>
           <a:p>
             <a:pPr algn="ctr"/>
+            <a:endParaRPr/>
           </a:p>
         </p:txBody>
       </p:sp>
@@ -8563,7 +9038,7 @@
           </a:fontRef>
         </p:style>
         <p:txBody>
-          <a:bodyPr rtlCol="0" anchor="ctr" wrap="square"/>
+          <a:bodyPr wrap="square" rtlCol="0" anchor="ctr"/>
           <a:lstStyle/>
           <a:p>
             <a:pPr algn="ctr">
@@ -8611,8 +9086,8 @@
         </p:nvSpPr>
         <p:spPr>
           <a:xfrm>
-            <a:off x="731520" y="1645920"/>
-            <a:ext cx="5486400" cy="4754880"/>
+            <a:off x="731519" y="1645920"/>
+            <a:ext cx="4351757" cy="4754880"/>
           </a:xfrm>
           <a:prstGeom prst="roundRect">
             <a:avLst/>
@@ -8641,7 +9116,7 @@
           </a:fontRef>
         </p:style>
         <p:txBody>
-          <a:bodyPr rtlCol="0" anchor="ctr" wrap="square"/>
+          <a:bodyPr wrap="square" rtlCol="0" anchor="ctr"/>
           <a:lstStyle/>
           <a:p>
             <a:pPr algn="ctr">
@@ -8652,6 +9127,7 @@
               </a:defRPr>
             </a:pPr>
             <a:r>
+              <a:rPr dirty="0"/>
               <a:t>KEY ARCHITECTURE &amp; HIGHLIGHTS:</a:t>
             </a:r>
           </a:p>
@@ -8667,6 +9143,7 @@
               </a:defRPr>
             </a:pPr>
             <a:r>
+              <a:rPr dirty="0"/>
               <a:t>🔹 Default Open View: All rooms displayed immediately upon page load</a:t>
             </a:r>
           </a:p>
@@ -8682,6 +9159,7 @@
               </a:defRPr>
             </a:pPr>
             <a:r>
+              <a:rPr dirty="0"/>
               <a:t>🔹 Search Engine: Search rooms by designation or floor location</a:t>
             </a:r>
           </a:p>
@@ -8697,6 +9175,7 @@
               </a:defRPr>
             </a:pPr>
             <a:r>
+              <a:rPr dirty="0"/>
               <a:t>🔹 Filter Pills: Instant filtering by seats (All, 2-5, 6-12, 12+) or amenities</a:t>
             </a:r>
           </a:p>
@@ -8710,8 +9189,8 @@
         </p:nvSpPr>
         <p:spPr>
           <a:xfrm>
-            <a:off x="6400800" y="1645920"/>
-            <a:ext cx="5059375" cy="4754880"/>
+            <a:off x="5201266" y="1645920"/>
+            <a:ext cx="6258910" cy="4754880"/>
           </a:xfrm>
           <a:prstGeom prst="roundRect">
             <a:avLst/>
@@ -8744,67 +9223,40 @@
           <a:lstStyle/>
           <a:p>
             <a:pPr algn="ctr"/>
-          </a:p>
-        </p:txBody>
-      </p:sp>
-      <p:sp>
-        <p:nvSpPr>
-          <p:cNvPr id="7" name="Rounded Rectangle 6"/>
-          <p:cNvSpPr/>
+            <a:endParaRPr/>
+          </a:p>
+        </p:txBody>
+      </p:sp>
+      <p:pic>
+        <p:nvPicPr>
+          <p:cNvPr id="9" name="Picture 8">
+            <a:extLst>
+              <a:ext uri="{FF2B5EF4-FFF2-40B4-BE49-F238E27FC236}">
+                <a16:creationId xmlns:a16="http://schemas.microsoft.com/office/drawing/2014/main" id="{F831F723-62F6-36F4-19E9-0AA5144F4C21}"/>
+              </a:ext>
+            </a:extLst>
+          </p:cNvPr>
+          <p:cNvPicPr>
+            <a:picLocks noChangeAspect="1"/>
+          </p:cNvPicPr>
           <p:nvPr/>
-        </p:nvSpPr>
-        <p:spPr>
-          <a:xfrm>
-            <a:off x="6537960" y="1783080"/>
-            <a:ext cx="4785055" cy="4480560"/>
-          </a:xfrm>
-          <a:prstGeom prst="roundRect">
-            <a:avLst/>
-          </a:prstGeom>
-          <a:solidFill>
-            <a:srgbClr val="EEF2FF"/>
-          </a:solidFill>
-          <a:ln w="12700">
-            <a:solidFill>
-              <a:srgbClr val="E2E8F0"/>
-            </a:solidFill>
-          </a:ln>
-        </p:spPr>
-        <p:style>
-          <a:lnRef idx="1">
-            <a:schemeClr val="accent1"/>
-          </a:lnRef>
-          <a:fillRef idx="3">
-            <a:schemeClr val="accent1"/>
-          </a:fillRef>
-          <a:effectRef idx="2">
-            <a:schemeClr val="accent1"/>
-          </a:effectRef>
-          <a:fontRef idx="minor">
-            <a:schemeClr val="lt1"/>
-          </a:fontRef>
-        </p:style>
-        <p:txBody>
-          <a:bodyPr rtlCol="0" anchor="ctr" wrap="square"/>
-          <a:lstStyle/>
-          <a:p>
-            <a:pPr algn="ctr">
-              <a:defRPr sz="1300" b="1">
-                <a:solidFill>
-                  <a:srgbClr val="4F46E5"/>
-                </a:solidFill>
-              </a:defRPr>
-            </a:pPr>
-            <a:br/>
-            <a:br/>
-            <a:br/>
-            <a:br/>
-            <a:r>
-              <a:t>📸 [INSERT SCREENSHOT HERE: All-Rooms Explorer Grid View]</a:t>
-            </a:r>
-          </a:p>
-        </p:txBody>
-      </p:sp>
+        </p:nvPicPr>
+        <p:blipFill>
+          <a:blip r:embed="rId2"/>
+          <a:stretch>
+            <a:fillRect/>
+          </a:stretch>
+        </p:blipFill>
+        <p:spPr>
+          <a:xfrm>
+            <a:off x="5447071" y="2084440"/>
+            <a:ext cx="5791200" cy="3647766"/>
+          </a:xfrm>
+          <a:prstGeom prst="rect">
+            <a:avLst/>
+          </a:prstGeom>
+        </p:spPr>
+      </p:pic>
     </p:spTree>
   </p:cSld>
   <p:clrMapOvr>
@@ -8814,7 +9266,7 @@
 </file>
 
 <file path=ppt/slides/slide7.xml><?xml version="1.0" encoding="utf-8"?>
-<p:sld xmlns:a="http://schemas.openxmlformats.org/drawingml/2006/main" xmlns:p="http://schemas.openxmlformats.org/presentationml/2006/main" xmlns:r="http://schemas.openxmlformats.org/officeDocument/2006/relationships">
+<p:sld xmlns:a="http://schemas.openxmlformats.org/drawingml/2006/main" xmlns:r="http://schemas.openxmlformats.org/officeDocument/2006/relationships" xmlns:p="http://schemas.openxmlformats.org/presentationml/2006/main">
   <p:cSld>
     <p:spTree>
       <p:nvGrpSpPr>
@@ -8822,7 +9274,14 @@
         <p:cNvGrpSpPr/>
         <p:nvPr/>
       </p:nvGrpSpPr>
-      <p:grpSpPr/>
+      <p:grpSpPr>
+        <a:xfrm>
+          <a:off x="0" y="0"/>
+          <a:ext cx="0" cy="0"/>
+          <a:chOff x="0" y="0"/>
+          <a:chExt cx="0" cy="0"/>
+        </a:xfrm>
+      </p:grpSpPr>
       <p:sp>
         <p:nvSpPr>
           <p:cNvPr id="2" name="Rectangle 1"/>
@@ -8863,6 +9322,7 @@
           <a:lstStyle/>
           <a:p>
             <a:pPr algn="ctr"/>
+            <a:endParaRPr/>
           </a:p>
         </p:txBody>
       </p:sp>
@@ -8906,6 +9366,7 @@
           <a:lstStyle/>
           <a:p>
             <a:pPr algn="ctr"/>
+            <a:endParaRPr/>
           </a:p>
         </p:txBody>
       </p:sp>
@@ -8945,7 +9406,7 @@
           </a:fontRef>
         </p:style>
         <p:txBody>
-          <a:bodyPr rtlCol="0" anchor="ctr" wrap="square"/>
+          <a:bodyPr wrap="square" rtlCol="0" anchor="ctr"/>
           <a:lstStyle/>
           <a:p>
             <a:pPr algn="ctr">
@@ -8994,7 +9455,7 @@
         <p:spPr>
           <a:xfrm>
             <a:off x="731520" y="1645920"/>
-            <a:ext cx="5486400" cy="4754880"/>
+            <a:ext cx="4440248" cy="4754880"/>
           </a:xfrm>
           <a:prstGeom prst="roundRect">
             <a:avLst/>
@@ -9023,7 +9484,7 @@
           </a:fontRef>
         </p:style>
         <p:txBody>
-          <a:bodyPr rtlCol="0" anchor="ctr" wrap="square"/>
+          <a:bodyPr wrap="square" rtlCol="0" anchor="ctr"/>
           <a:lstStyle/>
           <a:p>
             <a:pPr algn="ctr">
@@ -9034,6 +9495,7 @@
               </a:defRPr>
             </a:pPr>
             <a:r>
+              <a:rPr dirty="0"/>
               <a:t>KEY ARCHITECTURE &amp; HIGHLIGHTS:</a:t>
             </a:r>
           </a:p>
@@ -9049,6 +9511,7 @@
               </a:defRPr>
             </a:pPr>
             <a:r>
+              <a:rPr dirty="0"/>
               <a:t>🔹 Computer File Picker: Admins click 'Choose File' to pick local photos</a:t>
             </a:r>
           </a:p>
@@ -9064,6 +9527,7 @@
               </a:defRPr>
             </a:pPr>
             <a:r>
+              <a:rPr dirty="0"/>
               <a:t>🔹 Base64 Conversion: Converts images to Data URLs stored in MySQL</a:t>
             </a:r>
           </a:p>
@@ -9079,6 +9543,7 @@
               </a:defRPr>
             </a:pPr>
             <a:r>
+              <a:rPr dirty="0"/>
               <a:t>🔹 Flexible Options: Web image links are also fully supported</a:t>
             </a:r>
           </a:p>
@@ -9092,8 +9557,8 @@
         </p:nvSpPr>
         <p:spPr>
           <a:xfrm>
-            <a:off x="6400800" y="1645920"/>
-            <a:ext cx="5059375" cy="4754880"/>
+            <a:off x="5329084" y="1645920"/>
+            <a:ext cx="6131091" cy="4754880"/>
           </a:xfrm>
           <a:prstGeom prst="roundRect">
             <a:avLst/>
@@ -9126,67 +9591,41 @@
           <a:lstStyle/>
           <a:p>
             <a:pPr algn="ctr"/>
-          </a:p>
-        </p:txBody>
-      </p:sp>
-      <p:sp>
-        <p:nvSpPr>
-          <p:cNvPr id="7" name="Rounded Rectangle 6"/>
-          <p:cNvSpPr/>
+            <a:endParaRPr/>
+          </a:p>
+        </p:txBody>
+      </p:sp>
+      <p:pic>
+        <p:nvPicPr>
+          <p:cNvPr id="9" name="Picture 8">
+            <a:extLst>
+              <a:ext uri="{FF2B5EF4-FFF2-40B4-BE49-F238E27FC236}">
+                <a16:creationId xmlns:a16="http://schemas.microsoft.com/office/drawing/2014/main" id="{F988D3C4-6BA1-E77D-00DF-4973980872C4}"/>
+              </a:ext>
+            </a:extLst>
+          </p:cNvPr>
+          <p:cNvPicPr>
+            <a:picLocks noChangeAspect="1"/>
+          </p:cNvPicPr>
           <p:nvPr/>
-        </p:nvSpPr>
-        <p:spPr>
-          <a:xfrm>
-            <a:off x="6537960" y="1783080"/>
-            <a:ext cx="4785055" cy="4480560"/>
-          </a:xfrm>
-          <a:prstGeom prst="roundRect">
-            <a:avLst/>
-          </a:prstGeom>
-          <a:solidFill>
-            <a:srgbClr val="EEF2FF"/>
-          </a:solidFill>
-          <a:ln w="12700">
-            <a:solidFill>
-              <a:srgbClr val="E2E8F0"/>
-            </a:solidFill>
-          </a:ln>
-        </p:spPr>
-        <p:style>
-          <a:lnRef idx="1">
-            <a:schemeClr val="accent1"/>
-          </a:lnRef>
-          <a:fillRef idx="3">
-            <a:schemeClr val="accent1"/>
-          </a:fillRef>
-          <a:effectRef idx="2">
-            <a:schemeClr val="accent1"/>
-          </a:effectRef>
-          <a:fontRef idx="minor">
-            <a:schemeClr val="lt1"/>
-          </a:fontRef>
-        </p:style>
-        <p:txBody>
-          <a:bodyPr rtlCol="0" anchor="ctr" wrap="square"/>
-          <a:lstStyle/>
-          <a:p>
-            <a:pPr algn="ctr">
-              <a:defRPr sz="1300" b="1">
-                <a:solidFill>
-                  <a:srgbClr val="4F46E5"/>
-                </a:solidFill>
-              </a:defRPr>
-            </a:pPr>
-            <a:br/>
-            <a:br/>
-            <a:br/>
-            <a:br/>
-            <a:r>
-              <a:t>📸 [INSERT SCREENSHOT HERE: Add/Edit Room Modal File Picker]</a:t>
-            </a:r>
-          </a:p>
-        </p:txBody>
-      </p:sp>
+        </p:nvPicPr>
+        <p:blipFill>
+          <a:blip r:embed="rId2"/>
+          <a:srcRect b="2540"/>
+          <a:stretch>
+            <a:fillRect/>
+          </a:stretch>
+        </p:blipFill>
+        <p:spPr>
+          <a:xfrm>
+            <a:off x="5936564" y="1996211"/>
+            <a:ext cx="4916129" cy="4054298"/>
+          </a:xfrm>
+          <a:prstGeom prst="rect">
+            <a:avLst/>
+          </a:prstGeom>
+        </p:spPr>
+      </p:pic>
     </p:spTree>
   </p:cSld>
   <p:clrMapOvr>
@@ -9196,7 +9635,7 @@
 </file>
 
 <file path=ppt/slides/slide8.xml><?xml version="1.0" encoding="utf-8"?>
-<p:sld xmlns:a="http://schemas.openxmlformats.org/drawingml/2006/main" xmlns:p="http://schemas.openxmlformats.org/presentationml/2006/main" xmlns:r="http://schemas.openxmlformats.org/officeDocument/2006/relationships">
+<p:sld xmlns:a="http://schemas.openxmlformats.org/drawingml/2006/main" xmlns:r="http://schemas.openxmlformats.org/officeDocument/2006/relationships" xmlns:p="http://schemas.openxmlformats.org/presentationml/2006/main">
   <p:cSld>
     <p:spTree>
       <p:nvGrpSpPr>
@@ -9204,7 +9643,14 @@
         <p:cNvGrpSpPr/>
         <p:nvPr/>
       </p:nvGrpSpPr>
-      <p:grpSpPr/>
+      <p:grpSpPr>
+        <a:xfrm>
+          <a:off x="0" y="0"/>
+          <a:ext cx="0" cy="0"/>
+          <a:chOff x="0" y="0"/>
+          <a:chExt cx="0" cy="0"/>
+        </a:xfrm>
+      </p:grpSpPr>
       <p:sp>
         <p:nvSpPr>
           <p:cNvPr id="2" name="Rectangle 1"/>
@@ -9245,6 +9691,7 @@
           <a:lstStyle/>
           <a:p>
             <a:pPr algn="ctr"/>
+            <a:endParaRPr/>
           </a:p>
         </p:txBody>
       </p:sp>
@@ -9288,6 +9735,7 @@
           <a:lstStyle/>
           <a:p>
             <a:pPr algn="ctr"/>
+            <a:endParaRPr/>
           </a:p>
         </p:txBody>
       </p:sp>
@@ -9327,7 +9775,7 @@
           </a:fontRef>
         </p:style>
         <p:txBody>
-          <a:bodyPr rtlCol="0" anchor="ctr" wrap="square"/>
+          <a:bodyPr wrap="square" rtlCol="0" anchor="ctr"/>
           <a:lstStyle/>
           <a:p>
             <a:pPr algn="ctr">
@@ -9376,7 +9824,7 @@
         <p:spPr>
           <a:xfrm>
             <a:off x="731520" y="1645920"/>
-            <a:ext cx="5486400" cy="4754880"/>
+            <a:ext cx="4358434" cy="4754880"/>
           </a:xfrm>
           <a:prstGeom prst="roundRect">
             <a:avLst/>
@@ -9405,7 +9853,7 @@
           </a:fontRef>
         </p:style>
         <p:txBody>
-          <a:bodyPr rtlCol="0" anchor="ctr" wrap="square"/>
+          <a:bodyPr wrap="square" rtlCol="0" anchor="ctr"/>
           <a:lstStyle/>
           <a:p>
             <a:pPr algn="ctr">
@@ -9474,8 +9922,8 @@
         </p:nvSpPr>
         <p:spPr>
           <a:xfrm>
-            <a:off x="6400800" y="1645920"/>
-            <a:ext cx="5059375" cy="4754880"/>
+            <a:off x="5250426" y="1645920"/>
+            <a:ext cx="6209749" cy="4754880"/>
           </a:xfrm>
           <a:prstGeom prst="roundRect">
             <a:avLst/>
@@ -9508,67 +9956,40 @@
           <a:lstStyle/>
           <a:p>
             <a:pPr algn="ctr"/>
-          </a:p>
-        </p:txBody>
-      </p:sp>
-      <p:sp>
-        <p:nvSpPr>
-          <p:cNvPr id="7" name="Rounded Rectangle 6"/>
-          <p:cNvSpPr/>
+            <a:endParaRPr/>
+          </a:p>
+        </p:txBody>
+      </p:sp>
+      <p:pic>
+        <p:nvPicPr>
+          <p:cNvPr id="9" name="Picture 8">
+            <a:extLst>
+              <a:ext uri="{FF2B5EF4-FFF2-40B4-BE49-F238E27FC236}">
+                <a16:creationId xmlns:a16="http://schemas.microsoft.com/office/drawing/2014/main" id="{FCD46FDE-DE2E-2C58-A759-FB842293CCEB}"/>
+              </a:ext>
+            </a:extLst>
+          </p:cNvPr>
+          <p:cNvPicPr>
+            <a:picLocks noChangeAspect="1"/>
+          </p:cNvPicPr>
           <p:nvPr/>
-        </p:nvSpPr>
-        <p:spPr>
-          <a:xfrm>
-            <a:off x="6537960" y="1783080"/>
-            <a:ext cx="4785055" cy="4480560"/>
-          </a:xfrm>
-          <a:prstGeom prst="roundRect">
-            <a:avLst/>
-          </a:prstGeom>
-          <a:solidFill>
-            <a:srgbClr val="EEF2FF"/>
-          </a:solidFill>
-          <a:ln w="12700">
-            <a:solidFill>
-              <a:srgbClr val="E2E8F0"/>
-            </a:solidFill>
-          </a:ln>
-        </p:spPr>
-        <p:style>
-          <a:lnRef idx="1">
-            <a:schemeClr val="accent1"/>
-          </a:lnRef>
-          <a:fillRef idx="3">
-            <a:schemeClr val="accent1"/>
-          </a:fillRef>
-          <a:effectRef idx="2">
-            <a:schemeClr val="accent1"/>
-          </a:effectRef>
-          <a:fontRef idx="minor">
-            <a:schemeClr val="lt1"/>
-          </a:fontRef>
-        </p:style>
-        <p:txBody>
-          <a:bodyPr rtlCol="0" anchor="ctr" wrap="square"/>
-          <a:lstStyle/>
-          <a:p>
-            <a:pPr algn="ctr">
-              <a:defRPr sz="1300" b="1">
-                <a:solidFill>
-                  <a:srgbClr val="4F46E5"/>
-                </a:solidFill>
-              </a:defRPr>
-            </a:pPr>
-            <a:br/>
-            <a:br/>
-            <a:br/>
-            <a:br/>
-            <a:r>
-              <a:t>📸 [INSERT SCREENSHOT HERE: Booking Side Panel &amp; Slot Picker]</a:t>
-            </a:r>
-          </a:p>
-        </p:txBody>
-      </p:sp>
+        </p:nvPicPr>
+        <p:blipFill>
+          <a:blip r:embed="rId2"/>
+          <a:stretch>
+            <a:fillRect/>
+          </a:stretch>
+        </p:blipFill>
+        <p:spPr>
+          <a:xfrm>
+            <a:off x="6520061" y="1917923"/>
+            <a:ext cx="3834580" cy="4210873"/>
+          </a:xfrm>
+          <a:prstGeom prst="rect">
+            <a:avLst/>
+          </a:prstGeom>
+        </p:spPr>
+      </p:pic>
     </p:spTree>
   </p:cSld>
   <p:clrMapOvr>
@@ -9578,7 +9999,7 @@
 </file>
 
 <file path=ppt/slides/slide9.xml><?xml version="1.0" encoding="utf-8"?>
-<p:sld xmlns:a="http://schemas.openxmlformats.org/drawingml/2006/main" xmlns:p="http://schemas.openxmlformats.org/presentationml/2006/main" xmlns:r="http://schemas.openxmlformats.org/officeDocument/2006/relationships">
+<p:sld xmlns:a="http://schemas.openxmlformats.org/drawingml/2006/main" xmlns:r="http://schemas.openxmlformats.org/officeDocument/2006/relationships" xmlns:p="http://schemas.openxmlformats.org/presentationml/2006/main">
   <p:cSld>
     <p:spTree>
       <p:nvGrpSpPr>
@@ -9586,7 +10007,14 @@
         <p:cNvGrpSpPr/>
         <p:nvPr/>
       </p:nvGrpSpPr>
-      <p:grpSpPr/>
+      <p:grpSpPr>
+        <a:xfrm>
+          <a:off x="0" y="0"/>
+          <a:ext cx="0" cy="0"/>
+          <a:chOff x="0" y="0"/>
+          <a:chExt cx="0" cy="0"/>
+        </a:xfrm>
+      </p:grpSpPr>
       <p:sp>
         <p:nvSpPr>
           <p:cNvPr id="2" name="Rectangle 1"/>
@@ -9627,6 +10055,7 @@
           <a:lstStyle/>
           <a:p>
             <a:pPr algn="ctr"/>
+            <a:endParaRPr/>
           </a:p>
         </p:txBody>
       </p:sp>
@@ -9670,6 +10099,7 @@
           <a:lstStyle/>
           <a:p>
             <a:pPr algn="ctr"/>
+            <a:endParaRPr/>
           </a:p>
         </p:txBody>
       </p:sp>
@@ -9709,7 +10139,7 @@
           </a:fontRef>
         </p:style>
         <p:txBody>
-          <a:bodyPr rtlCol="0" anchor="ctr" wrap="square"/>
+          <a:bodyPr wrap="square" rtlCol="0" anchor="ctr"/>
           <a:lstStyle/>
           <a:p>
             <a:pPr algn="ctr">
@@ -9758,7 +10188,7 @@
         <p:spPr>
           <a:xfrm>
             <a:off x="731520" y="1645920"/>
-            <a:ext cx="5486400" cy="4754880"/>
+            <a:ext cx="4440248" cy="4754880"/>
           </a:xfrm>
           <a:prstGeom prst="roundRect">
             <a:avLst/>
@@ -9787,7 +10217,7 @@
           </a:fontRef>
         </p:style>
         <p:txBody>
-          <a:bodyPr rtlCol="0" anchor="ctr" wrap="square"/>
+          <a:bodyPr wrap="square" rtlCol="0" anchor="ctr"/>
           <a:lstStyle/>
           <a:p>
             <a:pPr algn="ctr">
@@ -9856,8 +10286,8 @@
         </p:nvSpPr>
         <p:spPr>
           <a:xfrm>
-            <a:off x="6400800" y="1645920"/>
-            <a:ext cx="5059375" cy="4754880"/>
+            <a:off x="5378246" y="1645920"/>
+            <a:ext cx="6081930" cy="4754880"/>
           </a:xfrm>
           <a:prstGeom prst="roundRect">
             <a:avLst/>
@@ -9890,67 +10320,40 @@
           <a:lstStyle/>
           <a:p>
             <a:pPr algn="ctr"/>
-          </a:p>
-        </p:txBody>
-      </p:sp>
-      <p:sp>
-        <p:nvSpPr>
-          <p:cNvPr id="7" name="Rounded Rectangle 6"/>
-          <p:cNvSpPr/>
+            <a:endParaRPr/>
+          </a:p>
+        </p:txBody>
+      </p:sp>
+      <p:pic>
+        <p:nvPicPr>
+          <p:cNvPr id="9" name="Picture 8">
+            <a:extLst>
+              <a:ext uri="{FF2B5EF4-FFF2-40B4-BE49-F238E27FC236}">
+                <a16:creationId xmlns:a16="http://schemas.microsoft.com/office/drawing/2014/main" id="{4530877D-9C0B-F80A-3AC0-53119E655FE0}"/>
+              </a:ext>
+            </a:extLst>
+          </p:cNvPr>
+          <p:cNvPicPr>
+            <a:picLocks noChangeAspect="1"/>
+          </p:cNvPicPr>
           <p:nvPr/>
-        </p:nvSpPr>
-        <p:spPr>
-          <a:xfrm>
-            <a:off x="6537960" y="1783080"/>
-            <a:ext cx="4785055" cy="4480560"/>
-          </a:xfrm>
-          <a:prstGeom prst="roundRect">
-            <a:avLst/>
-          </a:prstGeom>
-          <a:solidFill>
-            <a:srgbClr val="EEF2FF"/>
-          </a:solidFill>
-          <a:ln w="12700">
-            <a:solidFill>
-              <a:srgbClr val="E2E8F0"/>
-            </a:solidFill>
-          </a:ln>
-        </p:spPr>
-        <p:style>
-          <a:lnRef idx="1">
-            <a:schemeClr val="accent1"/>
-          </a:lnRef>
-          <a:fillRef idx="3">
-            <a:schemeClr val="accent1"/>
-          </a:fillRef>
-          <a:effectRef idx="2">
-            <a:schemeClr val="accent1"/>
-          </a:effectRef>
-          <a:fontRef idx="minor">
-            <a:schemeClr val="lt1"/>
-          </a:fontRef>
-        </p:style>
-        <p:txBody>
-          <a:bodyPr rtlCol="0" anchor="ctr" wrap="square"/>
-          <a:lstStyle/>
-          <a:p>
-            <a:pPr algn="ctr">
-              <a:defRPr sz="1300" b="1">
-                <a:solidFill>
-                  <a:srgbClr val="4F46E5"/>
-                </a:solidFill>
-              </a:defRPr>
-            </a:pPr>
-            <a:br/>
-            <a:br/>
-            <a:br/>
-            <a:br/>
-            <a:r>
-              <a:t>📸 [INSERT SCREENSHOT HERE: Booking List showing Auto-Approved Badge]</a:t>
-            </a:r>
-          </a:p>
-        </p:txBody>
-      </p:sp>
+        </p:nvPicPr>
+        <p:blipFill>
+          <a:blip r:embed="rId2"/>
+          <a:stretch>
+            <a:fillRect/>
+          </a:stretch>
+        </p:blipFill>
+        <p:spPr>
+          <a:xfrm>
+            <a:off x="5537528" y="2566219"/>
+            <a:ext cx="5763366" cy="2880852"/>
+          </a:xfrm>
+          <a:prstGeom prst="rect">
+            <a:avLst/>
+          </a:prstGeom>
+        </p:spPr>
+      </p:pic>
     </p:spTree>
   </p:cSld>
   <p:clrMapOvr>

</xml_diff>

<commit_message>
feat: update rooms to Floor 5, add booking audit trail filters, and enhance date/time slot validation
</commit_message>
<xml_diff>
--- a/document/PRESENTATION_DECK_SLIDES.pptx
+++ b/document/PRESENTATION_DECK_SLIDES.pptx
@@ -144,27 +144,19 @@
 <pc:chgInfo xmlns:a="http://schemas.openxmlformats.org/drawingml/2006/main" xmlns:r="http://schemas.openxmlformats.org/officeDocument/2006/relationships" xmlns:ac="http://schemas.microsoft.com/office/drawing/2013/main/command" xmlns:pc="http://schemas.microsoft.com/office/powerpoint/2013/main/command">
   <pc:docChgLst>
     <pc:chgData name="Saimalavika2005@outlook.com" userId="6fcc40f0fe87376b" providerId="LiveId" clId="{B072D48F-653C-4CB2-94AD-3F8ACA905B1B}"/>
-    <pc:docChg chg="undo custSel addSld delSld modSld">
-      <pc:chgData name="Saimalavika2005@outlook.com" userId="6fcc40f0fe87376b" providerId="LiveId" clId="{B072D48F-653C-4CB2-94AD-3F8ACA905B1B}" dt="2026-08-17T14:47:32.368" v="189" actId="14100"/>
+    <pc:docChg chg="undo custSel modSld">
+      <pc:chgData name="Saimalavika2005@outlook.com" userId="6fcc40f0fe87376b" providerId="LiveId" clId="{B072D48F-653C-4CB2-94AD-3F8ACA905B1B}" dt="2026-08-17T15:28:52.669" v="187" actId="14100"/>
       <pc:docMkLst>
         <pc:docMk/>
       </pc:docMkLst>
       <pc:sldChg chg="addSp delSp modSp mod">
-        <pc:chgData name="Saimalavika2005@outlook.com" userId="6fcc40f0fe87376b" providerId="LiveId" clId="{B072D48F-653C-4CB2-94AD-3F8ACA905B1B}" dt="2026-08-17T14:24:51.729" v="14" actId="478"/>
+        <pc:chgData name="Saimalavika2005@outlook.com" userId="6fcc40f0fe87376b" providerId="LiveId" clId="{B072D48F-653C-4CB2-94AD-3F8ACA905B1B}" dt="2026-08-17T15:05:55.036" v="19" actId="1076"/>
         <pc:sldMkLst>
           <pc:docMk/>
           <pc:sldMk cId="0" sldId="256"/>
         </pc:sldMkLst>
-        <pc:spChg chg="mod">
-          <ac:chgData name="Saimalavika2005@outlook.com" userId="6fcc40f0fe87376b" providerId="LiveId" clId="{B072D48F-653C-4CB2-94AD-3F8ACA905B1B}" dt="2026-08-17T14:24:28.284" v="12" actId="1036"/>
-          <ac:spMkLst>
-            <pc:docMk/>
-            <pc:sldMk cId="0" sldId="256"/>
-            <ac:spMk id="2" creationId="{00000000-0000-0000-0000-000000000000}"/>
-          </ac:spMkLst>
-        </pc:spChg>
-        <pc:spChg chg="del mod">
-          <ac:chgData name="Saimalavika2005@outlook.com" userId="6fcc40f0fe87376b" providerId="LiveId" clId="{B072D48F-653C-4CB2-94AD-3F8ACA905B1B}" dt="2026-08-17T14:24:51.729" v="14" actId="478"/>
+        <pc:spChg chg="del">
+          <ac:chgData name="Saimalavika2005@outlook.com" userId="6fcc40f0fe87376b" providerId="LiveId" clId="{B072D48F-653C-4CB2-94AD-3F8ACA905B1B}" dt="2026-08-17T15:03:47.518" v="0" actId="478"/>
           <ac:spMkLst>
             <pc:docMk/>
             <pc:sldMk cId="0" sldId="256"/>
@@ -172,7 +164,7 @@
           </ac:spMkLst>
         </pc:spChg>
         <pc:spChg chg="mod">
-          <ac:chgData name="Saimalavika2005@outlook.com" userId="6fcc40f0fe87376b" providerId="LiveId" clId="{B072D48F-653C-4CB2-94AD-3F8ACA905B1B}" dt="2026-08-17T14:22:42.400" v="0" actId="14100"/>
+          <ac:chgData name="Saimalavika2005@outlook.com" userId="6fcc40f0fe87376b" providerId="LiveId" clId="{B072D48F-653C-4CB2-94AD-3F8ACA905B1B}" dt="2026-08-17T15:03:58.717" v="1" actId="14100"/>
           <ac:spMkLst>
             <pc:docMk/>
             <pc:sldMk cId="0" sldId="256"/>
@@ -180,30 +172,38 @@
           </ac:spMkLst>
         </pc:spChg>
         <pc:spChg chg="add del mod">
-          <ac:chgData name="Saimalavika2005@outlook.com" userId="6fcc40f0fe87376b" providerId="LiveId" clId="{B072D48F-653C-4CB2-94AD-3F8ACA905B1B}" dt="2026-08-17T14:22:56.176" v="4" actId="478"/>
+          <ac:chgData name="Saimalavika2005@outlook.com" userId="6fcc40f0fe87376b" providerId="LiveId" clId="{B072D48F-653C-4CB2-94AD-3F8ACA905B1B}" dt="2026-08-17T15:04:10.987" v="5" actId="478"/>
           <ac:spMkLst>
             <pc:docMk/>
             <pc:sldMk cId="0" sldId="256"/>
             <ac:spMk id="6" creationId="{00000000-0000-0000-0000-000000000000}"/>
           </ac:spMkLst>
         </pc:spChg>
-        <pc:picChg chg="add mod">
-          <ac:chgData name="Saimalavika2005@outlook.com" userId="6fcc40f0fe87376b" providerId="LiveId" clId="{B072D48F-653C-4CB2-94AD-3F8ACA905B1B}" dt="2026-08-17T14:24:22.397" v="11" actId="14100"/>
+        <pc:picChg chg="add del mod modCrop">
+          <ac:chgData name="Saimalavika2005@outlook.com" userId="6fcc40f0fe87376b" providerId="LiveId" clId="{B072D48F-653C-4CB2-94AD-3F8ACA905B1B}" dt="2026-08-17T15:05:15.055" v="10" actId="478"/>
           <ac:picMkLst>
             <pc:docMk/>
             <pc:sldMk cId="0" sldId="256"/>
-            <ac:picMk id="8" creationId="{5EF61963-33CB-EB93-FA7F-048FF994C97D}"/>
+            <ac:picMk id="8" creationId="{8F3FA0A6-8E14-7119-8A08-8095F19F9AF7}"/>
+          </ac:picMkLst>
+        </pc:picChg>
+        <pc:picChg chg="add mod">
+          <ac:chgData name="Saimalavika2005@outlook.com" userId="6fcc40f0fe87376b" providerId="LiveId" clId="{B072D48F-653C-4CB2-94AD-3F8ACA905B1B}" dt="2026-08-17T15:05:55.036" v="19" actId="1076"/>
+          <ac:picMkLst>
+            <pc:docMk/>
+            <pc:sldMk cId="0" sldId="256"/>
+            <ac:picMk id="10" creationId="{800C15E3-B683-7DC9-2AEA-9516DC0C62EB}"/>
           </ac:picMkLst>
         </pc:picChg>
       </pc:sldChg>
       <pc:sldChg chg="addSp delSp modSp mod">
-        <pc:chgData name="Saimalavika2005@outlook.com" userId="6fcc40f0fe87376b" providerId="LiveId" clId="{B072D48F-653C-4CB2-94AD-3F8ACA905B1B}" dt="2026-08-17T14:26:06.255" v="26" actId="14100"/>
+        <pc:chgData name="Saimalavika2005@outlook.com" userId="6fcc40f0fe87376b" providerId="LiveId" clId="{B072D48F-653C-4CB2-94AD-3F8ACA905B1B}" dt="2026-08-17T15:07:26.223" v="33" actId="14100"/>
         <pc:sldMkLst>
           <pc:docMk/>
           <pc:sldMk cId="0" sldId="257"/>
         </pc:sldMkLst>
         <pc:spChg chg="mod">
-          <ac:chgData name="Saimalavika2005@outlook.com" userId="6fcc40f0fe87376b" providerId="LiveId" clId="{B072D48F-653C-4CB2-94AD-3F8ACA905B1B}" dt="2026-08-17T14:25:14.847" v="16" actId="14100"/>
+          <ac:chgData name="Saimalavika2005@outlook.com" userId="6fcc40f0fe87376b" providerId="LiveId" clId="{B072D48F-653C-4CB2-94AD-3F8ACA905B1B}" dt="2026-08-17T15:06:30.426" v="21" actId="14100"/>
           <ac:spMkLst>
             <pc:docMk/>
             <pc:sldMk cId="0" sldId="257"/>
@@ -211,15 +211,15 @@
           </ac:spMkLst>
         </pc:spChg>
         <pc:spChg chg="mod">
-          <ac:chgData name="Saimalavika2005@outlook.com" userId="6fcc40f0fe87376b" providerId="LiveId" clId="{B072D48F-653C-4CB2-94AD-3F8ACA905B1B}" dt="2026-08-17T14:25:25.954" v="17" actId="14100"/>
+          <ac:chgData name="Saimalavika2005@outlook.com" userId="6fcc40f0fe87376b" providerId="LiveId" clId="{B072D48F-653C-4CB2-94AD-3F8ACA905B1B}" dt="2026-08-17T15:07:09.160" v="28" actId="1076"/>
           <ac:spMkLst>
             <pc:docMk/>
             <pc:sldMk cId="0" sldId="257"/>
             <ac:spMk id="6" creationId="{00000000-0000-0000-0000-000000000000}"/>
           </ac:spMkLst>
         </pc:spChg>
-        <pc:spChg chg="del mod">
-          <ac:chgData name="Saimalavika2005@outlook.com" userId="6fcc40f0fe87376b" providerId="LiveId" clId="{B072D48F-653C-4CB2-94AD-3F8ACA905B1B}" dt="2026-08-17T14:25:32.087" v="19" actId="478"/>
+        <pc:spChg chg="del">
+          <ac:chgData name="Saimalavika2005@outlook.com" userId="6fcc40f0fe87376b" providerId="LiveId" clId="{B072D48F-653C-4CB2-94AD-3F8ACA905B1B}" dt="2026-08-17T15:06:39.583" v="23" actId="478"/>
           <ac:spMkLst>
             <pc:docMk/>
             <pc:sldMk cId="0" sldId="257"/>
@@ -227,22 +227,22 @@
           </ac:spMkLst>
         </pc:spChg>
         <pc:picChg chg="add mod">
-          <ac:chgData name="Saimalavika2005@outlook.com" userId="6fcc40f0fe87376b" providerId="LiveId" clId="{B072D48F-653C-4CB2-94AD-3F8ACA905B1B}" dt="2026-08-17T14:26:06.255" v="26" actId="14100"/>
+          <ac:chgData name="Saimalavika2005@outlook.com" userId="6fcc40f0fe87376b" providerId="LiveId" clId="{B072D48F-653C-4CB2-94AD-3F8ACA905B1B}" dt="2026-08-17T15:07:26.223" v="33" actId="14100"/>
           <ac:picMkLst>
             <pc:docMk/>
             <pc:sldMk cId="0" sldId="257"/>
-            <ac:picMk id="9" creationId="{DAC6F162-CDF1-6000-F549-39F935F2E793}"/>
+            <ac:picMk id="9" creationId="{FA9A62BB-E65A-89BC-DFDA-ECF5B44B6293}"/>
           </ac:picMkLst>
         </pc:picChg>
       </pc:sldChg>
       <pc:sldChg chg="addSp delSp modSp mod">
-        <pc:chgData name="Saimalavika2005@outlook.com" userId="6fcc40f0fe87376b" providerId="LiveId" clId="{B072D48F-653C-4CB2-94AD-3F8ACA905B1B}" dt="2026-08-17T14:28:16.641" v="38" actId="732"/>
+        <pc:chgData name="Saimalavika2005@outlook.com" userId="6fcc40f0fe87376b" providerId="LiveId" clId="{B072D48F-653C-4CB2-94AD-3F8ACA905B1B}" dt="2026-08-17T15:11:20.406" v="64" actId="732"/>
         <pc:sldMkLst>
           <pc:docMk/>
           <pc:sldMk cId="0" sldId="258"/>
         </pc:sldMkLst>
         <pc:spChg chg="mod">
-          <ac:chgData name="Saimalavika2005@outlook.com" userId="6fcc40f0fe87376b" providerId="LiveId" clId="{B072D48F-653C-4CB2-94AD-3F8ACA905B1B}" dt="2026-08-17T14:26:24.180" v="28" actId="14100"/>
+          <ac:chgData name="Saimalavika2005@outlook.com" userId="6fcc40f0fe87376b" providerId="LiveId" clId="{B072D48F-653C-4CB2-94AD-3F8ACA905B1B}" dt="2026-08-17T15:07:33.871" v="34" actId="14100"/>
           <ac:spMkLst>
             <pc:docMk/>
             <pc:sldMk cId="0" sldId="258"/>
@@ -250,38 +250,54 @@
           </ac:spMkLst>
         </pc:spChg>
         <pc:spChg chg="mod">
-          <ac:chgData name="Saimalavika2005@outlook.com" userId="6fcc40f0fe87376b" providerId="LiveId" clId="{B072D48F-653C-4CB2-94AD-3F8ACA905B1B}" dt="2026-08-17T14:26:36.184" v="31" actId="14100"/>
+          <ac:chgData name="Saimalavika2005@outlook.com" userId="6fcc40f0fe87376b" providerId="LiveId" clId="{B072D48F-653C-4CB2-94AD-3F8ACA905B1B}" dt="2026-08-17T15:08:29.837" v="42" actId="1076"/>
           <ac:spMkLst>
             <pc:docMk/>
             <pc:sldMk cId="0" sldId="258"/>
             <ac:spMk id="6" creationId="{00000000-0000-0000-0000-000000000000}"/>
           </ac:spMkLst>
         </pc:spChg>
-        <pc:spChg chg="del mod">
-          <ac:chgData name="Saimalavika2005@outlook.com" userId="6fcc40f0fe87376b" providerId="LiveId" clId="{B072D48F-653C-4CB2-94AD-3F8ACA905B1B}" dt="2026-08-17T14:26:29.753" v="30" actId="478"/>
+        <pc:spChg chg="del">
+          <ac:chgData name="Saimalavika2005@outlook.com" userId="6fcc40f0fe87376b" providerId="LiveId" clId="{B072D48F-653C-4CB2-94AD-3F8ACA905B1B}" dt="2026-08-17T15:07:38.259" v="35" actId="478"/>
           <ac:spMkLst>
             <pc:docMk/>
             <pc:sldMk cId="0" sldId="258"/>
             <ac:spMk id="7" creationId="{00000000-0000-0000-0000-000000000000}"/>
           </ac:spMkLst>
         </pc:spChg>
-        <pc:picChg chg="add mod modCrop">
-          <ac:chgData name="Saimalavika2005@outlook.com" userId="6fcc40f0fe87376b" providerId="LiveId" clId="{B072D48F-653C-4CB2-94AD-3F8ACA905B1B}" dt="2026-08-17T14:28:16.641" v="38" actId="732"/>
+        <pc:picChg chg="add del mod">
+          <ac:chgData name="Saimalavika2005@outlook.com" userId="6fcc40f0fe87376b" providerId="LiveId" clId="{B072D48F-653C-4CB2-94AD-3F8ACA905B1B}" dt="2026-08-17T15:10:58.306" v="59" actId="478"/>
           <ac:picMkLst>
             <pc:docMk/>
             <pc:sldMk cId="0" sldId="258"/>
-            <ac:picMk id="9" creationId="{A10E2CC9-E887-6A87-45DA-3973766B875D}"/>
+            <ac:picMk id="9" creationId="{68789BE4-3951-6F9B-35D4-970C5BE6BD17}"/>
+          </ac:picMkLst>
+        </pc:picChg>
+        <pc:picChg chg="add del mod">
+          <ac:chgData name="Saimalavika2005@outlook.com" userId="6fcc40f0fe87376b" providerId="LiveId" clId="{B072D48F-653C-4CB2-94AD-3F8ACA905B1B}" dt="2026-08-17T15:09:48.630" v="48" actId="931"/>
+          <ac:picMkLst>
+            <pc:docMk/>
+            <pc:sldMk cId="0" sldId="258"/>
+            <ac:picMk id="11" creationId="{F1FF8915-C4EE-9E1B-6C70-369A98456DAC}"/>
+          </ac:picMkLst>
+        </pc:picChg>
+        <pc:picChg chg="add mod modCrop">
+          <ac:chgData name="Saimalavika2005@outlook.com" userId="6fcc40f0fe87376b" providerId="LiveId" clId="{B072D48F-653C-4CB2-94AD-3F8ACA905B1B}" dt="2026-08-17T15:11:20.406" v="64" actId="732"/>
+          <ac:picMkLst>
+            <pc:docMk/>
+            <pc:sldMk cId="0" sldId="258"/>
+            <ac:picMk id="13" creationId="{9BA6551C-AEBF-0985-2182-957E9AD5B02E}"/>
           </ac:picMkLst>
         </pc:picChg>
       </pc:sldChg>
       <pc:sldChg chg="addSp delSp modSp mod">
-        <pc:chgData name="Saimalavika2005@outlook.com" userId="6fcc40f0fe87376b" providerId="LiveId" clId="{B072D48F-653C-4CB2-94AD-3F8ACA905B1B}" dt="2026-08-17T14:32:57.132" v="84" actId="14100"/>
+        <pc:chgData name="Saimalavika2005@outlook.com" userId="6fcc40f0fe87376b" providerId="LiveId" clId="{B072D48F-653C-4CB2-94AD-3F8ACA905B1B}" dt="2026-08-17T15:10:49.782" v="58" actId="1076"/>
         <pc:sldMkLst>
           <pc:docMk/>
           <pc:sldMk cId="0" sldId="259"/>
         </pc:sldMkLst>
         <pc:spChg chg="mod">
-          <ac:chgData name="Saimalavika2005@outlook.com" userId="6fcc40f0fe87376b" providerId="LiveId" clId="{B072D48F-653C-4CB2-94AD-3F8ACA905B1B}" dt="2026-08-17T14:28:33.904" v="40" actId="14100"/>
+          <ac:chgData name="Saimalavika2005@outlook.com" userId="6fcc40f0fe87376b" providerId="LiveId" clId="{B072D48F-653C-4CB2-94AD-3F8ACA905B1B}" dt="2026-08-17T15:08:49.834" v="46" actId="14100"/>
           <ac:spMkLst>
             <pc:docMk/>
             <pc:sldMk cId="0" sldId="259"/>
@@ -289,46 +305,38 @@
           </ac:spMkLst>
         </pc:spChg>
         <pc:spChg chg="mod">
-          <ac:chgData name="Saimalavika2005@outlook.com" userId="6fcc40f0fe87376b" providerId="LiveId" clId="{B072D48F-653C-4CB2-94AD-3F8ACA905B1B}" dt="2026-08-17T14:32:30.917" v="77" actId="14100"/>
+          <ac:chgData name="Saimalavika2005@outlook.com" userId="6fcc40f0fe87376b" providerId="LiveId" clId="{B072D48F-653C-4CB2-94AD-3F8ACA905B1B}" dt="2026-08-17T15:10:44.620" v="56" actId="14100"/>
           <ac:spMkLst>
             <pc:docMk/>
             <pc:sldMk cId="0" sldId="259"/>
             <ac:spMk id="6" creationId="{00000000-0000-0000-0000-000000000000}"/>
           </ac:spMkLst>
         </pc:spChg>
-        <pc:spChg chg="add del">
-          <ac:chgData name="Saimalavika2005@outlook.com" userId="6fcc40f0fe87376b" providerId="LiveId" clId="{B072D48F-653C-4CB2-94AD-3F8ACA905B1B}" dt="2026-08-17T14:32:32.550" v="78" actId="478"/>
+        <pc:spChg chg="del mod">
+          <ac:chgData name="Saimalavika2005@outlook.com" userId="6fcc40f0fe87376b" providerId="LiveId" clId="{B072D48F-653C-4CB2-94AD-3F8ACA905B1B}" dt="2026-08-17T15:10:35.320" v="53" actId="478"/>
           <ac:spMkLst>
             <pc:docMk/>
             <pc:sldMk cId="0" sldId="259"/>
             <ac:spMk id="7" creationId="{00000000-0000-0000-0000-000000000000}"/>
           </ac:spMkLst>
         </pc:spChg>
-        <pc:picChg chg="add del mod">
-          <ac:chgData name="Saimalavika2005@outlook.com" userId="6fcc40f0fe87376b" providerId="LiveId" clId="{B072D48F-653C-4CB2-94AD-3F8ACA905B1B}" dt="2026-08-17T14:32:14.261" v="74" actId="931"/>
+        <pc:picChg chg="add mod">
+          <ac:chgData name="Saimalavika2005@outlook.com" userId="6fcc40f0fe87376b" providerId="LiveId" clId="{B072D48F-653C-4CB2-94AD-3F8ACA905B1B}" dt="2026-08-17T15:10:49.782" v="58" actId="1076"/>
           <ac:picMkLst>
             <pc:docMk/>
             <pc:sldMk cId="0" sldId="259"/>
-            <ac:picMk id="9" creationId="{EF945D7E-4FED-79A0-D4EA-F73E5717E475}"/>
-          </ac:picMkLst>
-        </pc:picChg>
-        <pc:picChg chg="add mod">
-          <ac:chgData name="Saimalavika2005@outlook.com" userId="6fcc40f0fe87376b" providerId="LiveId" clId="{B072D48F-653C-4CB2-94AD-3F8ACA905B1B}" dt="2026-08-17T14:32:57.132" v="84" actId="14100"/>
-          <ac:picMkLst>
-            <pc:docMk/>
-            <pc:sldMk cId="0" sldId="259"/>
-            <ac:picMk id="11" creationId="{A3FAA9DB-B71C-0242-ABF1-1E5B7FB1BC38}"/>
+            <ac:picMk id="9" creationId="{D6DF4370-4A97-3D8C-F940-4C8F84BACDA4}"/>
           </ac:picMkLst>
         </pc:picChg>
       </pc:sldChg>
       <pc:sldChg chg="addSp delSp modSp mod">
-        <pc:chgData name="Saimalavika2005@outlook.com" userId="6fcc40f0fe87376b" providerId="LiveId" clId="{B072D48F-653C-4CB2-94AD-3F8ACA905B1B}" dt="2026-08-17T14:34:17.313" v="96" actId="14100"/>
+        <pc:chgData name="Saimalavika2005@outlook.com" userId="6fcc40f0fe87376b" providerId="LiveId" clId="{B072D48F-653C-4CB2-94AD-3F8ACA905B1B}" dt="2026-08-17T15:12:14.588" v="74" actId="14100"/>
         <pc:sldMkLst>
           <pc:docMk/>
           <pc:sldMk cId="0" sldId="260"/>
         </pc:sldMkLst>
         <pc:spChg chg="mod">
-          <ac:chgData name="Saimalavika2005@outlook.com" userId="6fcc40f0fe87376b" providerId="LiveId" clId="{B072D48F-653C-4CB2-94AD-3F8ACA905B1B}" dt="2026-08-17T14:33:14.281" v="86" actId="14100"/>
+          <ac:chgData name="Saimalavika2005@outlook.com" userId="6fcc40f0fe87376b" providerId="LiveId" clId="{B072D48F-653C-4CB2-94AD-3F8ACA905B1B}" dt="2026-08-17T15:11:33.142" v="66" actId="14100"/>
           <ac:spMkLst>
             <pc:docMk/>
             <pc:sldMk cId="0" sldId="260"/>
@@ -336,15 +344,15 @@
           </ac:spMkLst>
         </pc:spChg>
         <pc:spChg chg="mod">
-          <ac:chgData name="Saimalavika2005@outlook.com" userId="6fcc40f0fe87376b" providerId="LiveId" clId="{B072D48F-653C-4CB2-94AD-3F8ACA905B1B}" dt="2026-08-17T14:33:23.077" v="87" actId="14100"/>
+          <ac:chgData name="Saimalavika2005@outlook.com" userId="6fcc40f0fe87376b" providerId="LiveId" clId="{B072D48F-653C-4CB2-94AD-3F8ACA905B1B}" dt="2026-08-17T15:11:37.141" v="67" actId="14100"/>
           <ac:spMkLst>
             <pc:docMk/>
             <pc:sldMk cId="0" sldId="260"/>
             <ac:spMk id="6" creationId="{00000000-0000-0000-0000-000000000000}"/>
           </ac:spMkLst>
         </pc:spChg>
-        <pc:spChg chg="add del">
-          <ac:chgData name="Saimalavika2005@outlook.com" userId="6fcc40f0fe87376b" providerId="LiveId" clId="{B072D48F-653C-4CB2-94AD-3F8ACA905B1B}" dt="2026-08-17T14:33:29.408" v="88" actId="478"/>
+        <pc:spChg chg="del">
+          <ac:chgData name="Saimalavika2005@outlook.com" userId="6fcc40f0fe87376b" providerId="LiveId" clId="{B072D48F-653C-4CB2-94AD-3F8ACA905B1B}" dt="2026-08-17T15:11:39.859" v="68" actId="478"/>
           <ac:spMkLst>
             <pc:docMk/>
             <pc:sldMk cId="0" sldId="260"/>
@@ -352,22 +360,22 @@
           </ac:spMkLst>
         </pc:spChg>
         <pc:picChg chg="add mod">
-          <ac:chgData name="Saimalavika2005@outlook.com" userId="6fcc40f0fe87376b" providerId="LiveId" clId="{B072D48F-653C-4CB2-94AD-3F8ACA905B1B}" dt="2026-08-17T14:34:17.313" v="96" actId="14100"/>
+          <ac:chgData name="Saimalavika2005@outlook.com" userId="6fcc40f0fe87376b" providerId="LiveId" clId="{B072D48F-653C-4CB2-94AD-3F8ACA905B1B}" dt="2026-08-17T15:12:14.588" v="74" actId="14100"/>
           <ac:picMkLst>
             <pc:docMk/>
             <pc:sldMk cId="0" sldId="260"/>
-            <ac:picMk id="9" creationId="{A4908E5F-827F-12A9-1F51-88D67C04AAF5}"/>
+            <ac:picMk id="9" creationId="{BE31E9B0-780C-FDF5-81B9-6C45F1F3D952}"/>
           </ac:picMkLst>
         </pc:picChg>
       </pc:sldChg>
       <pc:sldChg chg="addSp delSp modSp mod">
-        <pc:chgData name="Saimalavika2005@outlook.com" userId="6fcc40f0fe87376b" providerId="LiveId" clId="{B072D48F-653C-4CB2-94AD-3F8ACA905B1B}" dt="2026-08-17T14:35:17.309" v="107" actId="14100"/>
+        <pc:chgData name="Saimalavika2005@outlook.com" userId="6fcc40f0fe87376b" providerId="LiveId" clId="{B072D48F-653C-4CB2-94AD-3F8ACA905B1B}" dt="2026-08-17T15:13:11.803" v="85" actId="14100"/>
         <pc:sldMkLst>
           <pc:docMk/>
           <pc:sldMk cId="0" sldId="261"/>
         </pc:sldMkLst>
         <pc:spChg chg="mod">
-          <ac:chgData name="Saimalavika2005@outlook.com" userId="6fcc40f0fe87376b" providerId="LiveId" clId="{B072D48F-653C-4CB2-94AD-3F8ACA905B1B}" dt="2026-08-17T14:34:32.919" v="98" actId="14100"/>
+          <ac:chgData name="Saimalavika2005@outlook.com" userId="6fcc40f0fe87376b" providerId="LiveId" clId="{B072D48F-653C-4CB2-94AD-3F8ACA905B1B}" dt="2026-08-17T15:12:24.223" v="76" actId="14100"/>
           <ac:spMkLst>
             <pc:docMk/>
             <pc:sldMk cId="0" sldId="261"/>
@@ -375,7 +383,7 @@
           </ac:spMkLst>
         </pc:spChg>
         <pc:spChg chg="mod">
-          <ac:chgData name="Saimalavika2005@outlook.com" userId="6fcc40f0fe87376b" providerId="LiveId" clId="{B072D48F-653C-4CB2-94AD-3F8ACA905B1B}" dt="2026-08-17T14:34:38.689" v="99" actId="14100"/>
+          <ac:chgData name="Saimalavika2005@outlook.com" userId="6fcc40f0fe87376b" providerId="LiveId" clId="{B072D48F-653C-4CB2-94AD-3F8ACA905B1B}" dt="2026-08-17T15:12:30.245" v="77" actId="14100"/>
           <ac:spMkLst>
             <pc:docMk/>
             <pc:sldMk cId="0" sldId="261"/>
@@ -383,7 +391,7 @@
           </ac:spMkLst>
         </pc:spChg>
         <pc:spChg chg="del">
-          <ac:chgData name="Saimalavika2005@outlook.com" userId="6fcc40f0fe87376b" providerId="LiveId" clId="{B072D48F-653C-4CB2-94AD-3F8ACA905B1B}" dt="2026-08-17T14:34:48.767" v="100" actId="478"/>
+          <ac:chgData name="Saimalavika2005@outlook.com" userId="6fcc40f0fe87376b" providerId="LiveId" clId="{B072D48F-653C-4CB2-94AD-3F8ACA905B1B}" dt="2026-08-17T15:12:34.978" v="78" actId="478"/>
           <ac:spMkLst>
             <pc:docMk/>
             <pc:sldMk cId="0" sldId="261"/>
@@ -391,22 +399,22 @@
           </ac:spMkLst>
         </pc:spChg>
         <pc:picChg chg="add mod">
-          <ac:chgData name="Saimalavika2005@outlook.com" userId="6fcc40f0fe87376b" providerId="LiveId" clId="{B072D48F-653C-4CB2-94AD-3F8ACA905B1B}" dt="2026-08-17T14:35:17.309" v="107" actId="14100"/>
+          <ac:chgData name="Saimalavika2005@outlook.com" userId="6fcc40f0fe87376b" providerId="LiveId" clId="{B072D48F-653C-4CB2-94AD-3F8ACA905B1B}" dt="2026-08-17T15:13:11.803" v="85" actId="14100"/>
           <ac:picMkLst>
             <pc:docMk/>
             <pc:sldMk cId="0" sldId="261"/>
-            <ac:picMk id="9" creationId="{F831F723-62F6-36F4-19E9-0AA5144F4C21}"/>
+            <ac:picMk id="9" creationId="{28BFF6AE-73A0-FE73-631A-4257C60A837B}"/>
           </ac:picMkLst>
         </pc:picChg>
       </pc:sldChg>
       <pc:sldChg chg="addSp delSp modSp mod">
-        <pc:chgData name="Saimalavika2005@outlook.com" userId="6fcc40f0fe87376b" providerId="LiveId" clId="{B072D48F-653C-4CB2-94AD-3F8ACA905B1B}" dt="2026-08-17T14:37:30.943" v="117" actId="1076"/>
+        <pc:chgData name="Saimalavika2005@outlook.com" userId="6fcc40f0fe87376b" providerId="LiveId" clId="{B072D48F-653C-4CB2-94AD-3F8ACA905B1B}" dt="2026-08-17T15:14:46.087" v="98" actId="14100"/>
         <pc:sldMkLst>
           <pc:docMk/>
           <pc:sldMk cId="0" sldId="262"/>
         </pc:sldMkLst>
         <pc:spChg chg="mod">
-          <ac:chgData name="Saimalavika2005@outlook.com" userId="6fcc40f0fe87376b" providerId="LiveId" clId="{B072D48F-653C-4CB2-94AD-3F8ACA905B1B}" dt="2026-08-17T14:35:34.319" v="108" actId="14100"/>
+          <ac:chgData name="Saimalavika2005@outlook.com" userId="6fcc40f0fe87376b" providerId="LiveId" clId="{B072D48F-653C-4CB2-94AD-3F8ACA905B1B}" dt="2026-08-17T15:13:25.102" v="87" actId="14100"/>
           <ac:spMkLst>
             <pc:docMk/>
             <pc:sldMk cId="0" sldId="262"/>
@@ -414,7 +422,7 @@
           </ac:spMkLst>
         </pc:spChg>
         <pc:spChg chg="mod">
-          <ac:chgData name="Saimalavika2005@outlook.com" userId="6fcc40f0fe87376b" providerId="LiveId" clId="{B072D48F-653C-4CB2-94AD-3F8ACA905B1B}" dt="2026-08-17T14:35:41.387" v="109" actId="14100"/>
+          <ac:chgData name="Saimalavika2005@outlook.com" userId="6fcc40f0fe87376b" providerId="LiveId" clId="{B072D48F-653C-4CB2-94AD-3F8ACA905B1B}" dt="2026-08-17T15:13:30.375" v="88" actId="14100"/>
           <ac:spMkLst>
             <pc:docMk/>
             <pc:sldMk cId="0" sldId="262"/>
@@ -422,7 +430,7 @@
           </ac:spMkLst>
         </pc:spChg>
         <pc:spChg chg="del">
-          <ac:chgData name="Saimalavika2005@outlook.com" userId="6fcc40f0fe87376b" providerId="LiveId" clId="{B072D48F-653C-4CB2-94AD-3F8ACA905B1B}" dt="2026-08-17T14:35:44.659" v="110" actId="478"/>
+          <ac:chgData name="Saimalavika2005@outlook.com" userId="6fcc40f0fe87376b" providerId="LiveId" clId="{B072D48F-653C-4CB2-94AD-3F8ACA905B1B}" dt="2026-08-17T15:13:32.722" v="89" actId="478"/>
           <ac:spMkLst>
             <pc:docMk/>
             <pc:sldMk cId="0" sldId="262"/>
@@ -430,30 +438,22 @@
           </ac:spMkLst>
         </pc:spChg>
         <pc:picChg chg="add mod modCrop">
-          <ac:chgData name="Saimalavika2005@outlook.com" userId="6fcc40f0fe87376b" providerId="LiveId" clId="{B072D48F-653C-4CB2-94AD-3F8ACA905B1B}" dt="2026-08-17T14:37:30.943" v="117" actId="1076"/>
+          <ac:chgData name="Saimalavika2005@outlook.com" userId="6fcc40f0fe87376b" providerId="LiveId" clId="{B072D48F-653C-4CB2-94AD-3F8ACA905B1B}" dt="2026-08-17T15:14:46.087" v="98" actId="14100"/>
           <ac:picMkLst>
             <pc:docMk/>
             <pc:sldMk cId="0" sldId="262"/>
-            <ac:picMk id="9" creationId="{F988D3C4-6BA1-E77D-00DF-4973980872C4}"/>
+            <ac:picMk id="9" creationId="{53816E3F-F386-F872-486C-A9302B378BEE}"/>
           </ac:picMkLst>
         </pc:picChg>
       </pc:sldChg>
       <pc:sldChg chg="addSp delSp modSp mod">
-        <pc:chgData name="Saimalavika2005@outlook.com" userId="6fcc40f0fe87376b" providerId="LiveId" clId="{B072D48F-653C-4CB2-94AD-3F8ACA905B1B}" dt="2026-08-17T14:41:11.901" v="131" actId="1076"/>
+        <pc:chgData name="Saimalavika2005@outlook.com" userId="6fcc40f0fe87376b" providerId="LiveId" clId="{B072D48F-653C-4CB2-94AD-3F8ACA905B1B}" dt="2026-08-17T15:15:54.037" v="112" actId="1076"/>
         <pc:sldMkLst>
           <pc:docMk/>
           <pc:sldMk cId="0" sldId="263"/>
         </pc:sldMkLst>
         <pc:spChg chg="mod">
-          <ac:chgData name="Saimalavika2005@outlook.com" userId="6fcc40f0fe87376b" providerId="LiveId" clId="{B072D48F-653C-4CB2-94AD-3F8ACA905B1B}" dt="2026-08-17T14:40:23.025" v="121" actId="1076"/>
-          <ac:spMkLst>
-            <pc:docMk/>
-            <pc:sldMk cId="0" sldId="263"/>
-            <ac:spMk id="2" creationId="{00000000-0000-0000-0000-000000000000}"/>
-          </ac:spMkLst>
-        </pc:spChg>
-        <pc:spChg chg="mod">
-          <ac:chgData name="Saimalavika2005@outlook.com" userId="6fcc40f0fe87376b" providerId="LiveId" clId="{B072D48F-653C-4CB2-94AD-3F8ACA905B1B}" dt="2026-08-17T14:40:55.508" v="126" actId="14100"/>
+          <ac:chgData name="Saimalavika2005@outlook.com" userId="6fcc40f0fe87376b" providerId="LiveId" clId="{B072D48F-653C-4CB2-94AD-3F8ACA905B1B}" dt="2026-08-17T15:15:11.170" v="101" actId="14100"/>
           <ac:spMkLst>
             <pc:docMk/>
             <pc:sldMk cId="0" sldId="263"/>
@@ -461,7 +461,7 @@
           </ac:spMkLst>
         </pc:spChg>
         <pc:spChg chg="mod">
-          <ac:chgData name="Saimalavika2005@outlook.com" userId="6fcc40f0fe87376b" providerId="LiveId" clId="{B072D48F-653C-4CB2-94AD-3F8ACA905B1B}" dt="2026-08-17T14:40:59.262" v="127" actId="14100"/>
+          <ac:chgData name="Saimalavika2005@outlook.com" userId="6fcc40f0fe87376b" providerId="LiveId" clId="{B072D48F-653C-4CB2-94AD-3F8ACA905B1B}" dt="2026-08-17T15:15:15.864" v="102" actId="14100"/>
           <ac:spMkLst>
             <pc:docMk/>
             <pc:sldMk cId="0" sldId="263"/>
@@ -469,7 +469,7 @@
           </ac:spMkLst>
         </pc:spChg>
         <pc:spChg chg="del">
-          <ac:chgData name="Saimalavika2005@outlook.com" userId="6fcc40f0fe87376b" providerId="LiveId" clId="{B072D48F-653C-4CB2-94AD-3F8ACA905B1B}" dt="2026-08-17T14:40:08.657" v="119" actId="478"/>
+          <ac:chgData name="Saimalavika2005@outlook.com" userId="6fcc40f0fe87376b" providerId="LiveId" clId="{B072D48F-653C-4CB2-94AD-3F8ACA905B1B}" dt="2026-08-17T15:15:21.928" v="103" actId="478"/>
           <ac:spMkLst>
             <pc:docMk/>
             <pc:sldMk cId="0" sldId="263"/>
@@ -477,22 +477,22 @@
           </ac:spMkLst>
         </pc:spChg>
         <pc:picChg chg="add mod">
-          <ac:chgData name="Saimalavika2005@outlook.com" userId="6fcc40f0fe87376b" providerId="LiveId" clId="{B072D48F-653C-4CB2-94AD-3F8ACA905B1B}" dt="2026-08-17T14:41:11.901" v="131" actId="1076"/>
+          <ac:chgData name="Saimalavika2005@outlook.com" userId="6fcc40f0fe87376b" providerId="LiveId" clId="{B072D48F-653C-4CB2-94AD-3F8ACA905B1B}" dt="2026-08-17T15:15:54.037" v="112" actId="1076"/>
           <ac:picMkLst>
             <pc:docMk/>
             <pc:sldMk cId="0" sldId="263"/>
-            <ac:picMk id="9" creationId="{FCD46FDE-DE2E-2C58-A759-FB842293CCEB}"/>
+            <ac:picMk id="9" creationId="{A225A11A-1D12-5226-3C68-E4111DA50F12}"/>
           </ac:picMkLst>
         </pc:picChg>
       </pc:sldChg>
       <pc:sldChg chg="addSp delSp modSp mod">
-        <pc:chgData name="Saimalavika2005@outlook.com" userId="6fcc40f0fe87376b" providerId="LiveId" clId="{B072D48F-653C-4CB2-94AD-3F8ACA905B1B}" dt="2026-08-17T14:42:45.245" v="147" actId="14100"/>
+        <pc:chgData name="Saimalavika2005@outlook.com" userId="6fcc40f0fe87376b" providerId="LiveId" clId="{B072D48F-653C-4CB2-94AD-3F8ACA905B1B}" dt="2026-08-17T15:17:07.660" v="122" actId="14100"/>
         <pc:sldMkLst>
           <pc:docMk/>
           <pc:sldMk cId="0" sldId="264"/>
         </pc:sldMkLst>
         <pc:spChg chg="mod">
-          <ac:chgData name="Saimalavika2005@outlook.com" userId="6fcc40f0fe87376b" providerId="LiveId" clId="{B072D48F-653C-4CB2-94AD-3F8ACA905B1B}" dt="2026-08-17T14:41:59.856" v="133" actId="14100"/>
+          <ac:chgData name="Saimalavika2005@outlook.com" userId="6fcc40f0fe87376b" providerId="LiveId" clId="{B072D48F-653C-4CB2-94AD-3F8ACA905B1B}" dt="2026-08-17T15:16:04.974" v="113" actId="14100"/>
           <ac:spMkLst>
             <pc:docMk/>
             <pc:sldMk cId="0" sldId="264"/>
@@ -500,15 +500,15 @@
           </ac:spMkLst>
         </pc:spChg>
         <pc:spChg chg="mod">
-          <ac:chgData name="Saimalavika2005@outlook.com" userId="6fcc40f0fe87376b" providerId="LiveId" clId="{B072D48F-653C-4CB2-94AD-3F8ACA905B1B}" dt="2026-08-17T14:42:11.359" v="139" actId="14100"/>
+          <ac:chgData name="Saimalavika2005@outlook.com" userId="6fcc40f0fe87376b" providerId="LiveId" clId="{B072D48F-653C-4CB2-94AD-3F8ACA905B1B}" dt="2026-08-17T15:16:15.888" v="115" actId="14100"/>
           <ac:spMkLst>
             <pc:docMk/>
             <pc:sldMk cId="0" sldId="264"/>
             <ac:spMk id="6" creationId="{00000000-0000-0000-0000-000000000000}"/>
           </ac:spMkLst>
         </pc:spChg>
-        <pc:spChg chg="del mod">
-          <ac:chgData name="Saimalavika2005@outlook.com" userId="6fcc40f0fe87376b" providerId="LiveId" clId="{B072D48F-653C-4CB2-94AD-3F8ACA905B1B}" dt="2026-08-17T14:42:04.479" v="136" actId="478"/>
+        <pc:spChg chg="del">
+          <ac:chgData name="Saimalavika2005@outlook.com" userId="6fcc40f0fe87376b" providerId="LiveId" clId="{B072D48F-653C-4CB2-94AD-3F8ACA905B1B}" dt="2026-08-17T15:16:11.912" v="114" actId="478"/>
           <ac:spMkLst>
             <pc:docMk/>
             <pc:sldMk cId="0" sldId="264"/>
@@ -516,45 +516,61 @@
           </ac:spMkLst>
         </pc:spChg>
         <pc:picChg chg="add mod">
-          <ac:chgData name="Saimalavika2005@outlook.com" userId="6fcc40f0fe87376b" providerId="LiveId" clId="{B072D48F-653C-4CB2-94AD-3F8ACA905B1B}" dt="2026-08-17T14:42:45.245" v="147" actId="14100"/>
+          <ac:chgData name="Saimalavika2005@outlook.com" userId="6fcc40f0fe87376b" providerId="LiveId" clId="{B072D48F-653C-4CB2-94AD-3F8ACA905B1B}" dt="2026-08-17T15:17:07.660" v="122" actId="14100"/>
           <ac:picMkLst>
             <pc:docMk/>
             <pc:sldMk cId="0" sldId="264"/>
-            <ac:picMk id="9" creationId="{4530877D-9C0B-F80A-3AC0-53119E655FE0}"/>
+            <ac:picMk id="9" creationId="{AA86128B-68CD-B1A5-A01A-32D3B93708E3}"/>
           </ac:picMkLst>
         </pc:picChg>
       </pc:sldChg>
-      <pc:sldChg chg="addSp delSp modSp mod">
-        <pc:chgData name="Saimalavika2005@outlook.com" userId="6fcc40f0fe87376b" providerId="LiveId" clId="{B072D48F-653C-4CB2-94AD-3F8ACA905B1B}" dt="2026-08-17T14:44:08.146" v="151" actId="931"/>
+      <pc:sldChg chg="delSp modSp mod">
+        <pc:chgData name="Saimalavika2005@outlook.com" userId="6fcc40f0fe87376b" providerId="LiveId" clId="{B072D48F-653C-4CB2-94AD-3F8ACA905B1B}" dt="2026-08-17T15:17:36.376" v="128" actId="478"/>
         <pc:sldMkLst>
           <pc:docMk/>
           <pc:sldMk cId="0" sldId="265"/>
         </pc:sldMkLst>
         <pc:spChg chg="mod">
-          <ac:chgData name="Saimalavika2005@outlook.com" userId="6fcc40f0fe87376b" providerId="LiveId" clId="{B072D48F-653C-4CB2-94AD-3F8ACA905B1B}" dt="2026-08-17T14:43:42.388" v="149" actId="14100"/>
+          <ac:chgData name="Saimalavika2005@outlook.com" userId="6fcc40f0fe87376b" providerId="LiveId" clId="{B072D48F-653C-4CB2-94AD-3F8ACA905B1B}" dt="2026-08-17T15:17:22.762" v="125" actId="1076"/>
+          <ac:spMkLst>
+            <pc:docMk/>
+            <pc:sldMk cId="0" sldId="265"/>
+            <ac:spMk id="2" creationId="{00000000-0000-0000-0000-000000000000}"/>
+          </ac:spMkLst>
+        </pc:spChg>
+        <pc:spChg chg="mod">
+          <ac:chgData name="Saimalavika2005@outlook.com" userId="6fcc40f0fe87376b" providerId="LiveId" clId="{B072D48F-653C-4CB2-94AD-3F8ACA905B1B}" dt="2026-08-17T15:17:26.197" v="126" actId="14100"/>
           <ac:spMkLst>
             <pc:docMk/>
             <pc:sldMk cId="0" sldId="265"/>
             <ac:spMk id="5" creationId="{00000000-0000-0000-0000-000000000000}"/>
           </ac:spMkLst>
         </pc:spChg>
-        <pc:picChg chg="add del mod">
-          <ac:chgData name="Saimalavika2005@outlook.com" userId="6fcc40f0fe87376b" providerId="LiveId" clId="{B072D48F-653C-4CB2-94AD-3F8ACA905B1B}" dt="2026-08-17T14:44:08.146" v="151" actId="931"/>
-          <ac:picMkLst>
+        <pc:spChg chg="mod">
+          <ac:chgData name="Saimalavika2005@outlook.com" userId="6fcc40f0fe87376b" providerId="LiveId" clId="{B072D48F-653C-4CB2-94AD-3F8ACA905B1B}" dt="2026-08-17T15:17:32.961" v="127" actId="14100"/>
+          <ac:spMkLst>
             <pc:docMk/>
             <pc:sldMk cId="0" sldId="265"/>
-            <ac:picMk id="9" creationId="{ABE89728-C811-EFBD-5101-40EFBEB31DE3}"/>
-          </ac:picMkLst>
-        </pc:picChg>
+            <ac:spMk id="6" creationId="{00000000-0000-0000-0000-000000000000}"/>
+          </ac:spMkLst>
+        </pc:spChg>
+        <pc:spChg chg="del">
+          <ac:chgData name="Saimalavika2005@outlook.com" userId="6fcc40f0fe87376b" providerId="LiveId" clId="{B072D48F-653C-4CB2-94AD-3F8ACA905B1B}" dt="2026-08-17T15:17:36.376" v="128" actId="478"/>
+          <ac:spMkLst>
+            <pc:docMk/>
+            <pc:sldMk cId="0" sldId="265"/>
+            <ac:spMk id="7" creationId="{00000000-0000-0000-0000-000000000000}"/>
+          </ac:spMkLst>
+        </pc:spChg>
       </pc:sldChg>
       <pc:sldChg chg="addSp delSp modSp mod">
-        <pc:chgData name="Saimalavika2005@outlook.com" userId="6fcc40f0fe87376b" providerId="LiveId" clId="{B072D48F-653C-4CB2-94AD-3F8ACA905B1B}" dt="2026-08-17T14:45:24.198" v="164" actId="14100"/>
+        <pc:chgData name="Saimalavika2005@outlook.com" userId="6fcc40f0fe87376b" providerId="LiveId" clId="{B072D48F-653C-4CB2-94AD-3F8ACA905B1B}" dt="2026-08-17T15:19:29.236" v="140" actId="732"/>
         <pc:sldMkLst>
           <pc:docMk/>
           <pc:sldMk cId="0" sldId="266"/>
         </pc:sldMkLst>
         <pc:spChg chg="mod">
-          <ac:chgData name="Saimalavika2005@outlook.com" userId="6fcc40f0fe87376b" providerId="LiveId" clId="{B072D48F-653C-4CB2-94AD-3F8ACA905B1B}" dt="2026-08-17T14:44:19.192" v="152" actId="14100"/>
+          <ac:chgData name="Saimalavika2005@outlook.com" userId="6fcc40f0fe87376b" providerId="LiveId" clId="{B072D48F-653C-4CB2-94AD-3F8ACA905B1B}" dt="2026-08-17T15:18:19.692" v="130" actId="14100"/>
           <ac:spMkLst>
             <pc:docMk/>
             <pc:sldMk cId="0" sldId="266"/>
@@ -562,7 +578,7 @@
           </ac:spMkLst>
         </pc:spChg>
         <pc:spChg chg="mod">
-          <ac:chgData name="Saimalavika2005@outlook.com" userId="6fcc40f0fe87376b" providerId="LiveId" clId="{B072D48F-653C-4CB2-94AD-3F8ACA905B1B}" dt="2026-08-17T14:44:28.334" v="153" actId="14100"/>
+          <ac:chgData name="Saimalavika2005@outlook.com" userId="6fcc40f0fe87376b" providerId="LiveId" clId="{B072D48F-653C-4CB2-94AD-3F8ACA905B1B}" dt="2026-08-17T15:18:24.447" v="131" actId="14100"/>
           <ac:spMkLst>
             <pc:docMk/>
             <pc:sldMk cId="0" sldId="266"/>
@@ -570,7 +586,7 @@
           </ac:spMkLst>
         </pc:spChg>
         <pc:spChg chg="del">
-          <ac:chgData name="Saimalavika2005@outlook.com" userId="6fcc40f0fe87376b" providerId="LiveId" clId="{B072D48F-653C-4CB2-94AD-3F8ACA905B1B}" dt="2026-08-17T14:44:31.966" v="154" actId="478"/>
+          <ac:chgData name="Saimalavika2005@outlook.com" userId="6fcc40f0fe87376b" providerId="LiveId" clId="{B072D48F-653C-4CB2-94AD-3F8ACA905B1B}" dt="2026-08-17T15:18:26.654" v="132" actId="478"/>
           <ac:spMkLst>
             <pc:docMk/>
             <pc:sldMk cId="0" sldId="266"/>
@@ -578,22 +594,22 @@
           </ac:spMkLst>
         </pc:spChg>
         <pc:picChg chg="add mod modCrop">
-          <ac:chgData name="Saimalavika2005@outlook.com" userId="6fcc40f0fe87376b" providerId="LiveId" clId="{B072D48F-653C-4CB2-94AD-3F8ACA905B1B}" dt="2026-08-17T14:45:24.198" v="164" actId="14100"/>
+          <ac:chgData name="Saimalavika2005@outlook.com" userId="6fcc40f0fe87376b" providerId="LiveId" clId="{B072D48F-653C-4CB2-94AD-3F8ACA905B1B}" dt="2026-08-17T15:19:29.236" v="140" actId="732"/>
           <ac:picMkLst>
             <pc:docMk/>
             <pc:sldMk cId="0" sldId="266"/>
-            <ac:picMk id="9" creationId="{837A7EA3-B248-4A1C-68CA-815BF6A935B8}"/>
+            <ac:picMk id="9" creationId="{E122DFE1-8F04-F5D0-BB8C-279509B0B92F}"/>
           </ac:picMkLst>
         </pc:picChg>
       </pc:sldChg>
       <pc:sldChg chg="addSp delSp modSp mod">
-        <pc:chgData name="Saimalavika2005@outlook.com" userId="6fcc40f0fe87376b" providerId="LiveId" clId="{B072D48F-653C-4CB2-94AD-3F8ACA905B1B}" dt="2026-08-17T14:46:34.827" v="179" actId="1076"/>
+        <pc:chgData name="Saimalavika2005@outlook.com" userId="6fcc40f0fe87376b" providerId="LiveId" clId="{B072D48F-653C-4CB2-94AD-3F8ACA905B1B}" dt="2026-08-17T15:20:26.571" v="155" actId="1076"/>
         <pc:sldMkLst>
           <pc:docMk/>
           <pc:sldMk cId="0" sldId="267"/>
         </pc:sldMkLst>
         <pc:spChg chg="mod">
-          <ac:chgData name="Saimalavika2005@outlook.com" userId="6fcc40f0fe87376b" providerId="LiveId" clId="{B072D48F-653C-4CB2-94AD-3F8ACA905B1B}" dt="2026-08-17T14:45:40.240" v="166" actId="1076"/>
+          <ac:chgData name="Saimalavika2005@outlook.com" userId="6fcc40f0fe87376b" providerId="LiveId" clId="{B072D48F-653C-4CB2-94AD-3F8ACA905B1B}" dt="2026-08-17T15:19:43.527" v="142" actId="14100"/>
           <ac:spMkLst>
             <pc:docMk/>
             <pc:sldMk cId="0" sldId="267"/>
@@ -601,15 +617,15 @@
           </ac:spMkLst>
         </pc:spChg>
         <pc:spChg chg="mod">
-          <ac:chgData name="Saimalavika2005@outlook.com" userId="6fcc40f0fe87376b" providerId="LiveId" clId="{B072D48F-653C-4CB2-94AD-3F8ACA905B1B}" dt="2026-08-17T14:45:50.486" v="168" actId="14100"/>
+          <ac:chgData name="Saimalavika2005@outlook.com" userId="6fcc40f0fe87376b" providerId="LiveId" clId="{B072D48F-653C-4CB2-94AD-3F8ACA905B1B}" dt="2026-08-17T15:19:49.310" v="143" actId="14100"/>
           <ac:spMkLst>
             <pc:docMk/>
             <pc:sldMk cId="0" sldId="267"/>
             <ac:spMk id="6" creationId="{00000000-0000-0000-0000-000000000000}"/>
           </ac:spMkLst>
         </pc:spChg>
-        <pc:spChg chg="del">
-          <ac:chgData name="Saimalavika2005@outlook.com" userId="6fcc40f0fe87376b" providerId="LiveId" clId="{B072D48F-653C-4CB2-94AD-3F8ACA905B1B}" dt="2026-08-17T14:45:46.166" v="167" actId="478"/>
+        <pc:spChg chg="del mod">
+          <ac:chgData name="Saimalavika2005@outlook.com" userId="6fcc40f0fe87376b" providerId="LiveId" clId="{B072D48F-653C-4CB2-94AD-3F8ACA905B1B}" dt="2026-08-17T15:19:55.668" v="145" actId="478"/>
           <ac:spMkLst>
             <pc:docMk/>
             <pc:sldMk cId="0" sldId="267"/>
@@ -617,22 +633,22 @@
           </ac:spMkLst>
         </pc:spChg>
         <pc:picChg chg="add mod">
-          <ac:chgData name="Saimalavika2005@outlook.com" userId="6fcc40f0fe87376b" providerId="LiveId" clId="{B072D48F-653C-4CB2-94AD-3F8ACA905B1B}" dt="2026-08-17T14:46:34.827" v="179" actId="1076"/>
+          <ac:chgData name="Saimalavika2005@outlook.com" userId="6fcc40f0fe87376b" providerId="LiveId" clId="{B072D48F-653C-4CB2-94AD-3F8ACA905B1B}" dt="2026-08-17T15:20:26.571" v="155" actId="1076"/>
           <ac:picMkLst>
             <pc:docMk/>
             <pc:sldMk cId="0" sldId="267"/>
-            <ac:picMk id="9" creationId="{68A1E83F-EF44-B3F0-296F-41BE8DF88AD0}"/>
+            <ac:picMk id="9" creationId="{FFA8AE93-5F5A-E01E-4E29-3BBCB5E9C0FA}"/>
           </ac:picMkLst>
         </pc:picChg>
       </pc:sldChg>
       <pc:sldChg chg="addSp delSp modSp mod">
-        <pc:chgData name="Saimalavika2005@outlook.com" userId="6fcc40f0fe87376b" providerId="LiveId" clId="{B072D48F-653C-4CB2-94AD-3F8ACA905B1B}" dt="2026-08-17T14:47:32.368" v="189" actId="14100"/>
+        <pc:chgData name="Saimalavika2005@outlook.com" userId="6fcc40f0fe87376b" providerId="LiveId" clId="{B072D48F-653C-4CB2-94AD-3F8ACA905B1B}" dt="2026-08-17T15:21:17.182" v="166" actId="14100"/>
         <pc:sldMkLst>
           <pc:docMk/>
           <pc:sldMk cId="0" sldId="268"/>
         </pc:sldMkLst>
         <pc:spChg chg="mod">
-          <ac:chgData name="Saimalavika2005@outlook.com" userId="6fcc40f0fe87376b" providerId="LiveId" clId="{B072D48F-653C-4CB2-94AD-3F8ACA905B1B}" dt="2026-08-17T14:46:56.715" v="181" actId="14100"/>
+          <ac:chgData name="Saimalavika2005@outlook.com" userId="6fcc40f0fe87376b" providerId="LiveId" clId="{B072D48F-653C-4CB2-94AD-3F8ACA905B1B}" dt="2026-08-17T15:20:42.883" v="156" actId="14100"/>
           <ac:spMkLst>
             <pc:docMk/>
             <pc:sldMk cId="0" sldId="268"/>
@@ -640,15 +656,15 @@
           </ac:spMkLst>
         </pc:spChg>
         <pc:spChg chg="mod">
-          <ac:chgData name="Saimalavika2005@outlook.com" userId="6fcc40f0fe87376b" providerId="LiveId" clId="{B072D48F-653C-4CB2-94AD-3F8ACA905B1B}" dt="2026-08-17T14:47:03.951" v="182" actId="14100"/>
+          <ac:chgData name="Saimalavika2005@outlook.com" userId="6fcc40f0fe87376b" providerId="LiveId" clId="{B072D48F-653C-4CB2-94AD-3F8ACA905B1B}" dt="2026-08-17T15:20:48.383" v="157" actId="14100"/>
           <ac:spMkLst>
             <pc:docMk/>
             <pc:sldMk cId="0" sldId="268"/>
             <ac:spMk id="6" creationId="{00000000-0000-0000-0000-000000000000}"/>
           </ac:spMkLst>
         </pc:spChg>
-        <pc:spChg chg="del">
-          <ac:chgData name="Saimalavika2005@outlook.com" userId="6fcc40f0fe87376b" providerId="LiveId" clId="{B072D48F-653C-4CB2-94AD-3F8ACA905B1B}" dt="2026-08-17T14:47:06.008" v="183" actId="478"/>
+        <pc:spChg chg="del mod">
+          <ac:chgData name="Saimalavika2005@outlook.com" userId="6fcc40f0fe87376b" providerId="LiveId" clId="{B072D48F-653C-4CB2-94AD-3F8ACA905B1B}" dt="2026-08-17T15:20:52.711" v="159" actId="478"/>
           <ac:spMkLst>
             <pc:docMk/>
             <pc:sldMk cId="0" sldId="268"/>
@@ -656,20 +672,91 @@
           </ac:spMkLst>
         </pc:spChg>
         <pc:picChg chg="add mod">
-          <ac:chgData name="Saimalavika2005@outlook.com" userId="6fcc40f0fe87376b" providerId="LiveId" clId="{B072D48F-653C-4CB2-94AD-3F8ACA905B1B}" dt="2026-08-17T14:47:32.368" v="189" actId="14100"/>
+          <ac:chgData name="Saimalavika2005@outlook.com" userId="6fcc40f0fe87376b" providerId="LiveId" clId="{B072D48F-653C-4CB2-94AD-3F8ACA905B1B}" dt="2026-08-17T15:21:17.182" v="166" actId="14100"/>
           <ac:picMkLst>
             <pc:docMk/>
             <pc:sldMk cId="0" sldId="268"/>
-            <ac:picMk id="9" creationId="{DA961525-23FE-6F0E-9E2A-6596398C02CB}"/>
+            <ac:picMk id="9" creationId="{1A0305B9-C7DB-DC8F-CA35-EE09845DA87D}"/>
           </ac:picMkLst>
         </pc:picChg>
       </pc:sldChg>
-      <pc:sldChg chg="new del">
-        <pc:chgData name="Saimalavika2005@outlook.com" userId="6fcc40f0fe87376b" providerId="LiveId" clId="{B072D48F-653C-4CB2-94AD-3F8ACA905B1B}" dt="2026-08-17T14:30:19.113" v="59" actId="680"/>
+      <pc:sldChg chg="addSp delSp modSp mod">
+        <pc:chgData name="Saimalavika2005@outlook.com" userId="6fcc40f0fe87376b" providerId="LiveId" clId="{B072D48F-653C-4CB2-94AD-3F8ACA905B1B}" dt="2026-08-17T15:28:08.680" v="175" actId="1076"/>
         <pc:sldMkLst>
           <pc:docMk/>
-          <pc:sldMk cId="1697489935" sldId="274"/>
+          <pc:sldMk cId="0" sldId="269"/>
         </pc:sldMkLst>
+        <pc:spChg chg="mod">
+          <ac:chgData name="Saimalavika2005@outlook.com" userId="6fcc40f0fe87376b" providerId="LiveId" clId="{B072D48F-653C-4CB2-94AD-3F8ACA905B1B}" dt="2026-08-17T15:25:19.215" v="169" actId="14100"/>
+          <ac:spMkLst>
+            <pc:docMk/>
+            <pc:sldMk cId="0" sldId="269"/>
+            <ac:spMk id="5" creationId="{00000000-0000-0000-0000-000000000000}"/>
+          </ac:spMkLst>
+        </pc:spChg>
+        <pc:spChg chg="mod">
+          <ac:chgData name="Saimalavika2005@outlook.com" userId="6fcc40f0fe87376b" providerId="LiveId" clId="{B072D48F-653C-4CB2-94AD-3F8ACA905B1B}" dt="2026-08-17T15:25:27.591" v="170" actId="14100"/>
+          <ac:spMkLst>
+            <pc:docMk/>
+            <pc:sldMk cId="0" sldId="269"/>
+            <ac:spMk id="6" creationId="{00000000-0000-0000-0000-000000000000}"/>
+          </ac:spMkLst>
+        </pc:spChg>
+        <pc:spChg chg="del">
+          <ac:chgData name="Saimalavika2005@outlook.com" userId="6fcc40f0fe87376b" providerId="LiveId" clId="{B072D48F-653C-4CB2-94AD-3F8ACA905B1B}" dt="2026-08-17T15:27:49.364" v="171" actId="478"/>
+          <ac:spMkLst>
+            <pc:docMk/>
+            <pc:sldMk cId="0" sldId="269"/>
+            <ac:spMk id="7" creationId="{00000000-0000-0000-0000-000000000000}"/>
+          </ac:spMkLst>
+        </pc:spChg>
+        <pc:picChg chg="add mod">
+          <ac:chgData name="Saimalavika2005@outlook.com" userId="6fcc40f0fe87376b" providerId="LiveId" clId="{B072D48F-653C-4CB2-94AD-3F8ACA905B1B}" dt="2026-08-17T15:28:08.680" v="175" actId="1076"/>
+          <ac:picMkLst>
+            <pc:docMk/>
+            <pc:sldMk cId="0" sldId="269"/>
+            <ac:picMk id="9" creationId="{D6664D55-DB86-B7A6-19F7-7D45C32B0711}"/>
+          </ac:picMkLst>
+        </pc:picChg>
+      </pc:sldChg>
+      <pc:sldChg chg="addSp delSp modSp mod">
+        <pc:chgData name="Saimalavika2005@outlook.com" userId="6fcc40f0fe87376b" providerId="LiveId" clId="{B072D48F-653C-4CB2-94AD-3F8ACA905B1B}" dt="2026-08-17T15:28:52.669" v="187" actId="14100"/>
+        <pc:sldMkLst>
+          <pc:docMk/>
+          <pc:sldMk cId="0" sldId="270"/>
+        </pc:sldMkLst>
+        <pc:spChg chg="mod">
+          <ac:chgData name="Saimalavika2005@outlook.com" userId="6fcc40f0fe87376b" providerId="LiveId" clId="{B072D48F-653C-4CB2-94AD-3F8ACA905B1B}" dt="2026-08-17T15:28:18.627" v="176" actId="14100"/>
+          <ac:spMkLst>
+            <pc:docMk/>
+            <pc:sldMk cId="0" sldId="270"/>
+            <ac:spMk id="5" creationId="{00000000-0000-0000-0000-000000000000}"/>
+          </ac:spMkLst>
+        </pc:spChg>
+        <pc:spChg chg="mod">
+          <ac:chgData name="Saimalavika2005@outlook.com" userId="6fcc40f0fe87376b" providerId="LiveId" clId="{B072D48F-653C-4CB2-94AD-3F8ACA905B1B}" dt="2026-08-17T15:28:25.315" v="177" actId="14100"/>
+          <ac:spMkLst>
+            <pc:docMk/>
+            <pc:sldMk cId="0" sldId="270"/>
+            <ac:spMk id="6" creationId="{00000000-0000-0000-0000-000000000000}"/>
+          </ac:spMkLst>
+        </pc:spChg>
+        <pc:spChg chg="del">
+          <ac:chgData name="Saimalavika2005@outlook.com" userId="6fcc40f0fe87376b" providerId="LiveId" clId="{B072D48F-653C-4CB2-94AD-3F8ACA905B1B}" dt="2026-08-17T15:28:27.453" v="178" actId="478"/>
+          <ac:spMkLst>
+            <pc:docMk/>
+            <pc:sldMk cId="0" sldId="270"/>
+            <ac:spMk id="7" creationId="{00000000-0000-0000-0000-000000000000}"/>
+          </ac:spMkLst>
+        </pc:spChg>
+        <pc:picChg chg="add mod">
+          <ac:chgData name="Saimalavika2005@outlook.com" userId="6fcc40f0fe87376b" providerId="LiveId" clId="{B072D48F-653C-4CB2-94AD-3F8ACA905B1B}" dt="2026-08-17T15:28:52.669" v="187" actId="14100"/>
+          <ac:picMkLst>
+            <pc:docMk/>
+            <pc:sldMk cId="0" sldId="270"/>
+            <ac:picMk id="9" creationId="{01E1FA61-20BC-91F2-A391-5B0350D784C2}"/>
+          </ac:picMkLst>
+        </pc:picChg>
       </pc:sldChg>
     </pc:docChg>
   </pc:docChgLst>
@@ -3651,7 +3738,7 @@
         </p:nvSpPr>
         <p:spPr>
           <a:xfrm>
-            <a:off x="0" y="9832"/>
+            <a:off x="0" y="0"/>
             <a:ext cx="12191695" cy="6858000"/>
           </a:xfrm>
           <a:prstGeom prst="rect">
@@ -3740,7 +3827,7 @@
         <p:spPr>
           <a:xfrm>
             <a:off x="731520" y="1325880"/>
-            <a:ext cx="4371422" cy="4983480"/>
+            <a:ext cx="4312428" cy="4983480"/>
           </a:xfrm>
           <a:prstGeom prst="roundRect">
             <a:avLst/>
@@ -3859,8 +3946,8 @@
         </p:nvSpPr>
         <p:spPr>
           <a:xfrm>
-            <a:off x="5279923" y="1325880"/>
-            <a:ext cx="6150077" cy="4983480"/>
+            <a:off x="5260258" y="1325880"/>
+            <a:ext cx="6169742" cy="4983480"/>
           </a:xfrm>
           <a:prstGeom prst="roundRect">
             <a:avLst/>
@@ -3917,10 +4004,10 @@
       </p:sp>
       <p:pic>
         <p:nvPicPr>
-          <p:cNvPr id="8" name="Picture 7">
+          <p:cNvPr id="10" name="Picture 9">
             <a:extLst>
               <a:ext uri="{FF2B5EF4-FFF2-40B4-BE49-F238E27FC236}">
-                <a16:creationId xmlns:a16="http://schemas.microsoft.com/office/drawing/2014/main" id="{5EF61963-33CB-EB93-FA7F-048FF994C97D}"/>
+                <a16:creationId xmlns:a16="http://schemas.microsoft.com/office/drawing/2014/main" id="{800C15E3-B683-7DC9-2AEA-9516DC0C62EB}"/>
               </a:ext>
             </a:extLst>
           </p:cNvPr>
@@ -3937,8 +4024,8 @@
         </p:blipFill>
         <p:spPr>
           <a:xfrm>
-            <a:off x="5588936" y="2212258"/>
-            <a:ext cx="5610006" cy="3319862"/>
+            <a:off x="5496232" y="1821671"/>
+            <a:ext cx="5722374" cy="3991897"/>
           </a:xfrm>
           <a:prstGeom prst="rect">
             <a:avLst/>
@@ -4143,7 +4230,7 @@
         <p:spPr>
           <a:xfrm>
             <a:off x="731520" y="1645920"/>
-            <a:ext cx="4391086" cy="4754880"/>
+            <a:ext cx="4518906" cy="4754880"/>
           </a:xfrm>
           <a:prstGeom prst="roundRect">
             <a:avLst/>
@@ -4183,7 +4270,6 @@
               </a:defRPr>
             </a:pPr>
             <a:r>
-              <a:rPr dirty="0"/>
               <a:t>KEY ARCHITECTURE &amp; HIGHLIGHTS:</a:t>
             </a:r>
           </a:p>
@@ -4199,7 +4285,6 @@
               </a:defRPr>
             </a:pPr>
             <a:r>
-              <a:rPr dirty="0"/>
               <a:t>🔹 Green API Integration: Automated background WhatsApp message dispatch</a:t>
             </a:r>
           </a:p>
@@ -4215,7 +4300,6 @@
               </a:defRPr>
             </a:pPr>
             <a:r>
-              <a:rPr dirty="0"/>
               <a:t>🔹 Designated Chats: Sends to Primary (+919652456879), Vishal, &amp; Malavika</a:t>
             </a:r>
           </a:p>
@@ -4231,7 +4315,6 @@
               </a:defRPr>
             </a:pPr>
             <a:r>
-              <a:rPr dirty="0"/>
               <a:t>🔹 1-Click Web Link: Fallback button opens WhatsApp Web with formatted text</a:t>
             </a:r>
           </a:p>
@@ -4245,8 +4328,8 @@
         </p:nvSpPr>
         <p:spPr>
           <a:xfrm>
-            <a:off x="6400800" y="1645920"/>
-            <a:ext cx="5059375" cy="4754880"/>
+            <a:off x="5417574" y="1645920"/>
+            <a:ext cx="6042601" cy="4754880"/>
           </a:xfrm>
           <a:prstGeom prst="roundRect">
             <a:avLst/>
@@ -4254,7 +4337,7 @@
           <a:solidFill>
             <a:srgbClr val="FFFFFF"/>
           </a:solidFill>
-          <a:ln w="25400">
+          <a:ln w="31750">
             <a:solidFill>
               <a:srgbClr val="4F46E5"/>
             </a:solidFill>
@@ -4280,73 +4363,6 @@
           <a:p>
             <a:pPr algn="ctr"/>
             <a:endParaRPr/>
-          </a:p>
-        </p:txBody>
-      </p:sp>
-      <p:sp>
-        <p:nvSpPr>
-          <p:cNvPr id="7" name="Rounded Rectangle 6"/>
-          <p:cNvSpPr/>
-          <p:nvPr/>
-        </p:nvSpPr>
-        <p:spPr>
-          <a:xfrm>
-            <a:off x="6537960" y="1783080"/>
-            <a:ext cx="4785055" cy="4480560"/>
-          </a:xfrm>
-          <a:prstGeom prst="roundRect">
-            <a:avLst/>
-          </a:prstGeom>
-          <a:solidFill>
-            <a:srgbClr val="EEF2FF"/>
-          </a:solidFill>
-          <a:ln w="12700">
-            <a:solidFill>
-              <a:srgbClr val="E2E8F0"/>
-            </a:solidFill>
-          </a:ln>
-        </p:spPr>
-        <p:style>
-          <a:lnRef idx="1">
-            <a:schemeClr val="accent1"/>
-          </a:lnRef>
-          <a:fillRef idx="3">
-            <a:schemeClr val="accent1"/>
-          </a:fillRef>
-          <a:effectRef idx="2">
-            <a:schemeClr val="accent1"/>
-          </a:effectRef>
-          <a:fontRef idx="minor">
-            <a:schemeClr val="lt1"/>
-          </a:fontRef>
-        </p:style>
-        <p:txBody>
-          <a:bodyPr wrap="square" rtlCol="0" anchor="ctr"/>
-          <a:lstStyle/>
-          <a:p>
-            <a:pPr algn="ctr">
-              <a:defRPr sz="1300" b="1">
-                <a:solidFill>
-                  <a:srgbClr val="4F46E5"/>
-                </a:solidFill>
-              </a:defRPr>
-            </a:pPr>
-            <a:br>
-              <a:rPr dirty="0"/>
-            </a:br>
-            <a:br>
-              <a:rPr dirty="0"/>
-            </a:br>
-            <a:br>
-              <a:rPr dirty="0"/>
-            </a:br>
-            <a:br>
-              <a:rPr dirty="0"/>
-            </a:br>
-            <a:r>
-              <a:rPr dirty="0"/>
-              <a:t>📸 [INSERT SCREENSHOT HERE: WhatsApp Button &amp; Pre-Filled Text Preview]</a:t>
-            </a:r>
           </a:p>
         </p:txBody>
       </p:sp>
@@ -4548,7 +4564,7 @@
         <p:spPr>
           <a:xfrm>
             <a:off x="731520" y="1645920"/>
-            <a:ext cx="4341925" cy="4754880"/>
+            <a:ext cx="4607396" cy="4754880"/>
           </a:xfrm>
           <a:prstGeom prst="roundRect">
             <a:avLst/>
@@ -4588,7 +4604,6 @@
               </a:defRPr>
             </a:pPr>
             <a:r>
-              <a:rPr dirty="0"/>
               <a:t>KEY ARCHITECTURE &amp; HIGHLIGHTS:</a:t>
             </a:r>
           </a:p>
@@ -4604,7 +4619,6 @@
               </a:defRPr>
             </a:pPr>
             <a:r>
-              <a:rPr dirty="0"/>
               <a:t>🔹 Edit Members Button: Modify attendee lists on active reservations</a:t>
             </a:r>
           </a:p>
@@ -4620,7 +4634,6 @@
               </a:defRPr>
             </a:pPr>
             <a:r>
-              <a:rPr dirty="0"/>
               <a:t>🔹 Flexibility: Add late invitees or remove members without canceling meeting</a:t>
             </a:r>
           </a:p>
@@ -4636,7 +4649,6 @@
               </a:defRPr>
             </a:pPr>
             <a:r>
-              <a:rPr dirty="0"/>
               <a:t>🔹 Audit Persistence: Saves member modification events in history log</a:t>
             </a:r>
           </a:p>
@@ -4650,8 +4662,8 @@
         </p:nvSpPr>
         <p:spPr>
           <a:xfrm>
-            <a:off x="5201266" y="1645920"/>
-            <a:ext cx="6258910" cy="4754880"/>
+            <a:off x="5496232" y="1645920"/>
+            <a:ext cx="5963943" cy="4754880"/>
           </a:xfrm>
           <a:prstGeom prst="roundRect">
             <a:avLst/>
@@ -4659,7 +4671,7 @@
           <a:solidFill>
             <a:srgbClr val="FFFFFF"/>
           </a:solidFill>
-          <a:ln w="25400">
+          <a:ln w="31750">
             <a:solidFill>
               <a:srgbClr val="4F46E5"/>
             </a:solidFill>
@@ -4693,7 +4705,7 @@
           <p:cNvPr id="9" name="Picture 8">
             <a:extLst>
               <a:ext uri="{FF2B5EF4-FFF2-40B4-BE49-F238E27FC236}">
-                <a16:creationId xmlns:a16="http://schemas.microsoft.com/office/drawing/2014/main" id="{837A7EA3-B248-4A1C-68CA-815BF6A935B8}"/>
+                <a16:creationId xmlns:a16="http://schemas.microsoft.com/office/drawing/2014/main" id="{E122DFE1-8F04-F5D0-BB8C-279509B0B92F}"/>
               </a:ext>
             </a:extLst>
           </p:cNvPr>
@@ -4704,15 +4716,15 @@
         </p:nvPicPr>
         <p:blipFill>
           <a:blip r:embed="rId2"/>
-          <a:srcRect l="2579" b="3585"/>
+          <a:srcRect l="2097" r="2685" b="3864"/>
           <a:stretch>
             <a:fillRect/>
           </a:stretch>
         </p:blipFill>
         <p:spPr>
           <a:xfrm>
-            <a:off x="5919019" y="2341414"/>
-            <a:ext cx="4840527" cy="3243310"/>
+            <a:off x="5801031" y="2268206"/>
+            <a:ext cx="5230763" cy="3424671"/>
           </a:xfrm>
           <a:prstGeom prst="rect">
             <a:avLst/>
@@ -4879,6 +4891,7 @@
               </a:defRPr>
             </a:pPr>
             <a:r>
+              <a:rPr dirty="0"/>
               <a:t>[ MANAGER SUITE ] — SLIDE 12</a:t>
             </a:r>
           </a:p>
@@ -4891,6 +4904,7 @@
               </a:defRPr>
             </a:pPr>
             <a:r>
+              <a:rPr dirty="0"/>
               <a:t>Manager Approval Suite &amp; Priority Requests</a:t>
             </a:r>
           </a:p>
@@ -4903,6 +4917,7 @@
               </a:defRPr>
             </a:pPr>
             <a:r>
+              <a:rPr dirty="0"/>
               <a:t>Real-Time Priority Queue for Operations Leadership</a:t>
             </a:r>
           </a:p>
@@ -4916,8 +4931,8 @@
         </p:nvSpPr>
         <p:spPr>
           <a:xfrm>
-            <a:off x="643030" y="1645920"/>
-            <a:ext cx="4587732" cy="4754880"/>
+            <a:off x="731520" y="1645920"/>
+            <a:ext cx="4705719" cy="4754880"/>
           </a:xfrm>
           <a:prstGeom prst="roundRect">
             <a:avLst/>
@@ -5015,8 +5030,8 @@
         </p:nvSpPr>
         <p:spPr>
           <a:xfrm>
-            <a:off x="5378246" y="1645920"/>
-            <a:ext cx="6081930" cy="4754880"/>
+            <a:off x="5545394" y="1645920"/>
+            <a:ext cx="5914781" cy="4754880"/>
           </a:xfrm>
           <a:prstGeom prst="roundRect">
             <a:avLst/>
@@ -5024,7 +5039,7 @@
           <a:solidFill>
             <a:srgbClr val="FFFFFF"/>
           </a:solidFill>
-          <a:ln w="25400">
+          <a:ln w="31750">
             <a:solidFill>
               <a:srgbClr val="4F46E5"/>
             </a:solidFill>
@@ -5049,7 +5064,7 @@
           <a:lstStyle/>
           <a:p>
             <a:pPr algn="ctr"/>
-            <a:endParaRPr dirty="0"/>
+            <a:endParaRPr/>
           </a:p>
         </p:txBody>
       </p:sp>
@@ -5058,7 +5073,7 @@
           <p:cNvPr id="9" name="Picture 8">
             <a:extLst>
               <a:ext uri="{FF2B5EF4-FFF2-40B4-BE49-F238E27FC236}">
-                <a16:creationId xmlns:a16="http://schemas.microsoft.com/office/drawing/2014/main" id="{68A1E83F-EF44-B3F0-296F-41BE8DF88AD0}"/>
+                <a16:creationId xmlns:a16="http://schemas.microsoft.com/office/drawing/2014/main" id="{FFA8AE93-5F5A-E01E-4E29-3BBCB5E9C0FA}"/>
               </a:ext>
             </a:extLst>
           </p:cNvPr>
@@ -5075,8 +5090,8 @@
         </p:blipFill>
         <p:spPr>
           <a:xfrm>
-            <a:off x="5582604" y="2339832"/>
-            <a:ext cx="5673213" cy="3687096"/>
+            <a:off x="5759584" y="2268302"/>
+            <a:ext cx="5486400" cy="3510116"/>
           </a:xfrm>
           <a:prstGeom prst="rect">
             <a:avLst/>
@@ -5281,7 +5296,7 @@
         <p:spPr>
           <a:xfrm>
             <a:off x="731520" y="1645920"/>
-            <a:ext cx="4607396" cy="4754880"/>
+            <a:ext cx="4725383" cy="4754880"/>
           </a:xfrm>
           <a:prstGeom prst="roundRect">
             <a:avLst/>
@@ -5321,7 +5336,6 @@
               </a:defRPr>
             </a:pPr>
             <a:r>
-              <a:rPr dirty="0"/>
               <a:t>KEY ARCHITECTURE &amp; HIGHLIGHTS:</a:t>
             </a:r>
           </a:p>
@@ -5337,7 +5351,6 @@
               </a:defRPr>
             </a:pPr>
             <a:r>
-              <a:rPr dirty="0"/>
               <a:t>🔹 Room History Modal: Click any room card to open its dedicated audit log</a:t>
             </a:r>
           </a:p>
@@ -5353,7 +5366,6 @@
               </a:defRPr>
             </a:pPr>
             <a:r>
-              <a:rPr dirty="0"/>
               <a:t>🔹 Full Timeline: Displays booking creations, edits, cancellations, and notes</a:t>
             </a:r>
           </a:p>
@@ -5369,16 +5381,7 @@
               </a:defRPr>
             </a:pPr>
             <a:r>
-              <a:rPr dirty="0"/>
-              <a:t>🔹 SQL Persistence: Stored permanently in the </a:t>
-            </a:r>
-            <a:r>
-              <a:rPr dirty="0" err="1"/>
-              <a:t>booking_histories</a:t>
-            </a:r>
-            <a:r>
-              <a:rPr dirty="0"/>
-              <a:t> table</a:t>
+              <a:t>🔹 SQL Persistence: Stored permanently in the booking_histories table</a:t>
             </a:r>
           </a:p>
         </p:txBody>
@@ -5391,8 +5394,8 @@
         </p:nvSpPr>
         <p:spPr>
           <a:xfrm>
-            <a:off x="5506066" y="1645920"/>
-            <a:ext cx="5954110" cy="4754880"/>
+            <a:off x="5555226" y="1645920"/>
+            <a:ext cx="5904949" cy="4754880"/>
           </a:xfrm>
           <a:prstGeom prst="roundRect">
             <a:avLst/>
@@ -5400,7 +5403,7 @@
           <a:solidFill>
             <a:srgbClr val="FFFFFF"/>
           </a:solidFill>
-          <a:ln w="25400">
+          <a:ln w="31750">
             <a:solidFill>
               <a:srgbClr val="4F46E5"/>
             </a:solidFill>
@@ -5434,7 +5437,7 @@
           <p:cNvPr id="9" name="Picture 8">
             <a:extLst>
               <a:ext uri="{FF2B5EF4-FFF2-40B4-BE49-F238E27FC236}">
-                <a16:creationId xmlns:a16="http://schemas.microsoft.com/office/drawing/2014/main" id="{DA961525-23FE-6F0E-9E2A-6596398C02CB}"/>
+                <a16:creationId xmlns:a16="http://schemas.microsoft.com/office/drawing/2014/main" id="{1A0305B9-C7DB-DC8F-CA35-EE09845DA87D}"/>
               </a:ext>
             </a:extLst>
           </p:cNvPr>
@@ -5451,8 +5454,8 @@
         </p:blipFill>
         <p:spPr>
           <a:xfrm>
-            <a:off x="5889083" y="2035278"/>
-            <a:ext cx="5188076" cy="3765754"/>
+            <a:off x="5723866" y="2182761"/>
+            <a:ext cx="5567668" cy="3765755"/>
           </a:xfrm>
           <a:prstGeom prst="rect">
             <a:avLst/>
@@ -5657,7 +5660,7 @@
         <p:spPr>
           <a:xfrm>
             <a:off x="731520" y="1645920"/>
-            <a:ext cx="5486400" cy="4754880"/>
+            <a:ext cx="4813874" cy="4754880"/>
           </a:xfrm>
           <a:prstGeom prst="roundRect">
             <a:avLst/>
@@ -5755,8 +5758,8 @@
         </p:nvSpPr>
         <p:spPr>
           <a:xfrm>
-            <a:off x="6400800" y="1645920"/>
-            <a:ext cx="5059375" cy="4754880"/>
+            <a:off x="5653548" y="1645920"/>
+            <a:ext cx="5806627" cy="4754880"/>
           </a:xfrm>
           <a:prstGeom prst="roundRect">
             <a:avLst/>
@@ -5764,7 +5767,7 @@
           <a:solidFill>
             <a:srgbClr val="FFFFFF"/>
           </a:solidFill>
-          <a:ln w="25400">
+          <a:ln w="31750">
             <a:solidFill>
               <a:srgbClr val="4F46E5"/>
             </a:solidFill>
@@ -5793,64 +5796,36 @@
           </a:p>
         </p:txBody>
       </p:sp>
-      <p:sp>
-        <p:nvSpPr>
-          <p:cNvPr id="7" name="Rounded Rectangle 6"/>
-          <p:cNvSpPr/>
+      <p:pic>
+        <p:nvPicPr>
+          <p:cNvPr id="9" name="Picture 8">
+            <a:extLst>
+              <a:ext uri="{FF2B5EF4-FFF2-40B4-BE49-F238E27FC236}">
+                <a16:creationId xmlns:a16="http://schemas.microsoft.com/office/drawing/2014/main" id="{D6664D55-DB86-B7A6-19F7-7D45C32B0711}"/>
+              </a:ext>
+            </a:extLst>
+          </p:cNvPr>
+          <p:cNvPicPr>
+            <a:picLocks noChangeAspect="1"/>
+          </p:cNvPicPr>
           <p:nvPr/>
-        </p:nvSpPr>
-        <p:spPr>
-          <a:xfrm>
-            <a:off x="6537960" y="1783080"/>
-            <a:ext cx="4785055" cy="4480560"/>
-          </a:xfrm>
-          <a:prstGeom prst="roundRect">
-            <a:avLst/>
-          </a:prstGeom>
-          <a:solidFill>
-            <a:srgbClr val="EEF2FF"/>
-          </a:solidFill>
-          <a:ln w="12700">
-            <a:solidFill>
-              <a:srgbClr val="E2E8F0"/>
-            </a:solidFill>
-          </a:ln>
-        </p:spPr>
-        <p:style>
-          <a:lnRef idx="1">
-            <a:schemeClr val="accent1"/>
-          </a:lnRef>
-          <a:fillRef idx="3">
-            <a:schemeClr val="accent1"/>
-          </a:fillRef>
-          <a:effectRef idx="2">
-            <a:schemeClr val="accent1"/>
-          </a:effectRef>
-          <a:fontRef idx="minor">
-            <a:schemeClr val="lt1"/>
-          </a:fontRef>
-        </p:style>
-        <p:txBody>
-          <a:bodyPr wrap="square" rtlCol="0" anchor="ctr"/>
-          <a:lstStyle/>
-          <a:p>
-            <a:pPr algn="ctr">
-              <a:defRPr sz="1300" b="1">
-                <a:solidFill>
-                  <a:srgbClr val="4F46E5"/>
-                </a:solidFill>
-              </a:defRPr>
-            </a:pPr>
-            <a:br/>
-            <a:br/>
-            <a:br/>
-            <a:br/>
-            <a:r>
-              <a:t>📸 [INSERT SCREENSHOT HERE: Room Supplies Status Cards Grid]</a:t>
-            </a:r>
-          </a:p>
-        </p:txBody>
-      </p:sp>
+        </p:nvPicPr>
+        <p:blipFill>
+          <a:blip r:embed="rId2"/>
+          <a:stretch>
+            <a:fillRect/>
+          </a:stretch>
+        </p:blipFill>
+        <p:spPr>
+          <a:xfrm>
+            <a:off x="5960936" y="2018067"/>
+            <a:ext cx="5191850" cy="4010585"/>
+          </a:xfrm>
+          <a:prstGeom prst="rect">
+            <a:avLst/>
+          </a:prstGeom>
+        </p:spPr>
+      </p:pic>
     </p:spTree>
   </p:cSld>
   <p:clrMapOvr>
@@ -6049,7 +6024,7 @@
         <p:spPr>
           <a:xfrm>
             <a:off x="731520" y="1645920"/>
-            <a:ext cx="5486400" cy="4754880"/>
+            <a:ext cx="4715551" cy="4754880"/>
           </a:xfrm>
           <a:prstGeom prst="roundRect">
             <a:avLst/>
@@ -6147,8 +6122,8 @@
         </p:nvSpPr>
         <p:spPr>
           <a:xfrm>
-            <a:off x="6400800" y="1645920"/>
-            <a:ext cx="5059375" cy="4754880"/>
+            <a:off x="5545394" y="1645920"/>
+            <a:ext cx="5914781" cy="4754880"/>
           </a:xfrm>
           <a:prstGeom prst="roundRect">
             <a:avLst/>
@@ -6156,7 +6131,7 @@
           <a:solidFill>
             <a:srgbClr val="FFFFFF"/>
           </a:solidFill>
-          <a:ln w="25400">
+          <a:ln w="31750">
             <a:solidFill>
               <a:srgbClr val="4F46E5"/>
             </a:solidFill>
@@ -6185,64 +6160,36 @@
           </a:p>
         </p:txBody>
       </p:sp>
-      <p:sp>
-        <p:nvSpPr>
-          <p:cNvPr id="7" name="Rounded Rectangle 6"/>
-          <p:cNvSpPr/>
+      <p:pic>
+        <p:nvPicPr>
+          <p:cNvPr id="9" name="Picture 8">
+            <a:extLst>
+              <a:ext uri="{FF2B5EF4-FFF2-40B4-BE49-F238E27FC236}">
+                <a16:creationId xmlns:a16="http://schemas.microsoft.com/office/drawing/2014/main" id="{01E1FA61-20BC-91F2-A391-5B0350D784C2}"/>
+              </a:ext>
+            </a:extLst>
+          </p:cNvPr>
+          <p:cNvPicPr>
+            <a:picLocks noChangeAspect="1"/>
+          </p:cNvPicPr>
           <p:nvPr/>
-        </p:nvSpPr>
-        <p:spPr>
-          <a:xfrm>
-            <a:off x="6537960" y="1783080"/>
-            <a:ext cx="4785055" cy="4480560"/>
-          </a:xfrm>
-          <a:prstGeom prst="roundRect">
-            <a:avLst/>
-          </a:prstGeom>
-          <a:solidFill>
-            <a:srgbClr val="EEF2FF"/>
-          </a:solidFill>
-          <a:ln w="12700">
-            <a:solidFill>
-              <a:srgbClr val="E2E8F0"/>
-            </a:solidFill>
-          </a:ln>
-        </p:spPr>
-        <p:style>
-          <a:lnRef idx="1">
-            <a:schemeClr val="accent1"/>
-          </a:lnRef>
-          <a:fillRef idx="3">
-            <a:schemeClr val="accent1"/>
-          </a:fillRef>
-          <a:effectRef idx="2">
-            <a:schemeClr val="accent1"/>
-          </a:effectRef>
-          <a:fontRef idx="minor">
-            <a:schemeClr val="lt1"/>
-          </a:fontRef>
-        </p:style>
-        <p:txBody>
-          <a:bodyPr wrap="square" rtlCol="0" anchor="ctr"/>
-          <a:lstStyle/>
-          <a:p>
-            <a:pPr algn="ctr">
-              <a:defRPr sz="1300" b="1">
-                <a:solidFill>
-                  <a:srgbClr val="4F46E5"/>
-                </a:solidFill>
-              </a:defRPr>
-            </a:pPr>
-            <a:br/>
-            <a:br/>
-            <a:br/>
-            <a:br/>
-            <a:r>
-              <a:t>📸 [INSERT SCREENSHOT HERE: Gmail Confirmation Email in Inbox]</a:t>
-            </a:r>
-          </a:p>
-        </p:txBody>
-      </p:sp>
+        </p:nvPicPr>
+        <p:blipFill>
+          <a:blip r:embed="rId2"/>
+          <a:stretch>
+            <a:fillRect/>
+          </a:stretch>
+        </p:blipFill>
+        <p:spPr>
+          <a:xfrm>
+            <a:off x="5928852" y="2155231"/>
+            <a:ext cx="5132438" cy="3736258"/>
+          </a:xfrm>
+          <a:prstGeom prst="rect">
+            <a:avLst/>
+          </a:prstGeom>
+        </p:spPr>
+      </p:pic>
     </p:spTree>
   </p:cSld>
   <p:clrMapOvr>
@@ -6563,7 +6510,7 @@
           <a:solidFill>
             <a:srgbClr val="FFFFFF"/>
           </a:solidFill>
-          <a:ln w="25400">
+          <a:ln w="31750">
             <a:solidFill>
               <a:srgbClr val="4F46E5"/>
             </a:solidFill>
@@ -6607,11 +6554,11 @@
             <a:avLst/>
           </a:prstGeom>
           <a:solidFill>
-            <a:srgbClr val="EEF2FF"/>
-          </a:solidFill>
-          <a:ln w="12700">
+            <a:srgbClr val="F1F5F9"/>
+          </a:solidFill>
+          <a:ln w="19050">
             <a:solidFill>
-              <a:srgbClr val="E2E8F0"/>
+              <a:srgbClr val="CBD5E1"/>
             </a:solidFill>
           </a:ln>
         </p:spPr>
@@ -6642,8 +6589,21 @@
             </a:pPr>
             <a:br/>
             <a:br/>
-            <a:br/>
-            <a:br/>
+            <a:r>
+              <a:t>📷 SCREENSHOT INSERTION FRAME</a:t>
+            </a:r>
+          </a:p>
+          <a:p>
+            <a:pPr algn="ctr">
+              <a:spcBef>
+                <a:spcPts val="1400"/>
+              </a:spcBef>
+              <a:defRPr sz="1300" b="1">
+                <a:solidFill>
+                  <a:srgbClr val="0F172A"/>
+                </a:solidFill>
+              </a:defRPr>
+            </a:pPr>
             <a:r>
               <a:t>📸 [INSERT SCREENSHOT HERE: User Roles Matrix Table]</a:t>
             </a:r>
@@ -6970,7 +6930,7 @@
           <a:solidFill>
             <a:srgbClr val="FFFFFF"/>
           </a:solidFill>
-          <a:ln w="25400">
+          <a:ln w="31750">
             <a:solidFill>
               <a:srgbClr val="4F46E5"/>
             </a:solidFill>
@@ -7014,11 +6974,11 @@
             <a:avLst/>
           </a:prstGeom>
           <a:solidFill>
-            <a:srgbClr val="EEF2FF"/>
-          </a:solidFill>
-          <a:ln w="12700">
+            <a:srgbClr val="F1F5F9"/>
+          </a:solidFill>
+          <a:ln w="19050">
             <a:solidFill>
-              <a:srgbClr val="E2E8F0"/>
+              <a:srgbClr val="CBD5E1"/>
             </a:solidFill>
           </a:ln>
         </p:spPr>
@@ -7049,8 +7009,21 @@
             </a:pPr>
             <a:br/>
             <a:br/>
-            <a:br/>
-            <a:br/>
+            <a:r>
+              <a:t>📷 SCREENSHOT INSERTION FRAME</a:t>
+            </a:r>
+          </a:p>
+          <a:p>
+            <a:pPr algn="ctr">
+              <a:spcBef>
+                <a:spcPts val="1400"/>
+              </a:spcBef>
+              <a:defRPr sz="1300" b="1">
+                <a:solidFill>
+                  <a:srgbClr val="0F172A"/>
+                </a:solidFill>
+              </a:defRPr>
+            </a:pPr>
             <a:r>
               <a:t>📸 [INSERT SCREENSHOT HERE: Multi-Window Demo Overview]</a:t>
             </a:r>
@@ -7614,8 +7587,8 @@
         </p:nvSpPr>
         <p:spPr>
           <a:xfrm>
-            <a:off x="731521" y="1645920"/>
-            <a:ext cx="4518906" cy="4754880"/>
+            <a:off x="731519" y="1645920"/>
+            <a:ext cx="4184609" cy="4754880"/>
           </a:xfrm>
           <a:prstGeom prst="roundRect">
             <a:avLst/>
@@ -7655,6 +7628,7 @@
               </a:defRPr>
             </a:pPr>
             <a:r>
+              <a:rPr dirty="0"/>
               <a:t>KEY ARCHITECTURE &amp; HIGHLIGHTS:</a:t>
             </a:r>
           </a:p>
@@ -7670,6 +7644,7 @@
               </a:defRPr>
             </a:pPr>
             <a:r>
+              <a:rPr dirty="0"/>
               <a:t>🔹 The Problem: Meeting room double-bookings cause meeting delays and friction.</a:t>
             </a:r>
           </a:p>
@@ -7685,6 +7660,7 @@
               </a:defRPr>
             </a:pPr>
             <a:r>
+              <a:rPr dirty="0"/>
               <a:t>🔹 The Problem: Managers tied up in manual approval queues.</a:t>
             </a:r>
           </a:p>
@@ -7700,6 +7676,7 @@
               </a:defRPr>
             </a:pPr>
             <a:r>
+              <a:rPr dirty="0"/>
               <a:t>🔹 The Solution: Real-time slot locking with zero conflicts guaranteed.</a:t>
             </a:r>
           </a:p>
@@ -7715,6 +7692,7 @@
               </a:defRPr>
             </a:pPr>
             <a:r>
+              <a:rPr dirty="0"/>
               <a:t>🔹 Business Impact: 100% elimination of room scheduling collisions.</a:t>
             </a:r>
           </a:p>
@@ -7728,8 +7706,8 @@
         </p:nvSpPr>
         <p:spPr>
           <a:xfrm>
-            <a:off x="5476568" y="1645920"/>
-            <a:ext cx="5983607" cy="4754880"/>
+            <a:off x="5093110" y="1645920"/>
+            <a:ext cx="6367065" cy="4754880"/>
           </a:xfrm>
           <a:prstGeom prst="roundRect">
             <a:avLst/>
@@ -7737,7 +7715,7 @@
           <a:solidFill>
             <a:srgbClr val="FFFFFF"/>
           </a:solidFill>
-          <a:ln w="25400">
+          <a:ln w="31750">
             <a:solidFill>
               <a:srgbClr val="4F46E5"/>
             </a:solidFill>
@@ -7771,7 +7749,7 @@
           <p:cNvPr id="9" name="Picture 8">
             <a:extLst>
               <a:ext uri="{FF2B5EF4-FFF2-40B4-BE49-F238E27FC236}">
-                <a16:creationId xmlns:a16="http://schemas.microsoft.com/office/drawing/2014/main" id="{DAC6F162-CDF1-6000-F549-39F935F2E793}"/>
+                <a16:creationId xmlns:a16="http://schemas.microsoft.com/office/drawing/2014/main" id="{FA9A62BB-E65A-89BC-DFDA-ECF5B44B6293}"/>
               </a:ext>
             </a:extLst>
           </p:cNvPr>
@@ -7788,8 +7766,8 @@
         </p:blipFill>
         <p:spPr>
           <a:xfrm>
-            <a:off x="5686979" y="2251587"/>
-            <a:ext cx="5478227" cy="3303639"/>
+            <a:off x="5422316" y="2202426"/>
+            <a:ext cx="5708652" cy="3578942"/>
           </a:xfrm>
           <a:prstGeom prst="rect">
             <a:avLst/>
@@ -7994,7 +7972,7 @@
         <p:spPr>
           <a:xfrm>
             <a:off x="731520" y="1645920"/>
-            <a:ext cx="4440248" cy="4754880"/>
+            <a:ext cx="4105951" cy="4754880"/>
           </a:xfrm>
           <a:prstGeom prst="roundRect">
             <a:avLst/>
@@ -8092,8 +8070,8 @@
         </p:nvSpPr>
         <p:spPr>
           <a:xfrm>
-            <a:off x="5388078" y="1645920"/>
-            <a:ext cx="6072098" cy="4754880"/>
+            <a:off x="5073446" y="1645920"/>
+            <a:ext cx="6386730" cy="4754880"/>
           </a:xfrm>
           <a:prstGeom prst="roundRect">
             <a:avLst/>
@@ -8101,7 +8079,7 @@
           <a:solidFill>
             <a:srgbClr val="FFFFFF"/>
           </a:solidFill>
-          <a:ln w="25400">
+          <a:ln w="31750">
             <a:solidFill>
               <a:srgbClr val="4F46E5"/>
             </a:solidFill>
@@ -8132,10 +8110,10 @@
       </p:sp>
       <p:pic>
         <p:nvPicPr>
-          <p:cNvPr id="9" name="Picture 8">
+          <p:cNvPr id="13" name="Picture 12">
             <a:extLst>
               <a:ext uri="{FF2B5EF4-FFF2-40B4-BE49-F238E27FC236}">
-                <a16:creationId xmlns:a16="http://schemas.microsoft.com/office/drawing/2014/main" id="{A10E2CC9-E887-6A87-45DA-3973766B875D}"/>
+                <a16:creationId xmlns:a16="http://schemas.microsoft.com/office/drawing/2014/main" id="{9BA6551C-AEBF-0985-2182-957E9AD5B02E}"/>
               </a:ext>
             </a:extLst>
           </p:cNvPr>
@@ -8146,15 +8124,15 @@
         </p:nvPicPr>
         <p:blipFill>
           <a:blip r:embed="rId2"/>
-          <a:srcRect t="3514"/>
+          <a:srcRect t="4336"/>
           <a:stretch>
             <a:fillRect/>
           </a:stretch>
         </p:blipFill>
         <p:spPr>
           <a:xfrm>
-            <a:off x="5582429" y="2251587"/>
-            <a:ext cx="5606681" cy="3510116"/>
+            <a:off x="5205035" y="2340077"/>
+            <a:ext cx="6123551" cy="3470787"/>
           </a:xfrm>
           <a:prstGeom prst="rect">
             <a:avLst/>
@@ -8359,7 +8337,7 @@
         <p:spPr>
           <a:xfrm>
             <a:off x="731520" y="1645920"/>
-            <a:ext cx="4450080" cy="4754880"/>
+            <a:ext cx="4400919" cy="4754880"/>
           </a:xfrm>
           <a:prstGeom prst="roundRect">
             <a:avLst/>
@@ -8399,6 +8377,7 @@
               </a:defRPr>
             </a:pPr>
             <a:r>
+              <a:rPr dirty="0"/>
               <a:t>KEY ARCHITECTURE &amp; HIGHLIGHTS:</a:t>
             </a:r>
           </a:p>
@@ -8414,6 +8393,7 @@
               </a:defRPr>
             </a:pPr>
             <a:r>
+              <a:rPr dirty="0"/>
               <a:t>🔹 Structured Tables: users, rooms, bookings, attendees, supplies, histories</a:t>
             </a:r>
           </a:p>
@@ -8429,6 +8409,7 @@
               </a:defRPr>
             </a:pPr>
             <a:r>
+              <a:rPr dirty="0"/>
               <a:t>🔹 Workbench Ready: Press Ctrl + R in MySQL Workbench to generate visual map</a:t>
             </a:r>
           </a:p>
@@ -8444,6 +8425,7 @@
               </a:defRPr>
             </a:pPr>
             <a:r>
+              <a:rPr dirty="0"/>
               <a:t>🔹 Data Integrity: Foreign key constraints prevent orphaned records</a:t>
             </a:r>
           </a:p>
@@ -8457,8 +8439,8 @@
         </p:nvSpPr>
         <p:spPr>
           <a:xfrm>
-            <a:off x="5329084" y="1645920"/>
-            <a:ext cx="6131091" cy="4754880"/>
+            <a:off x="5279924" y="1645920"/>
+            <a:ext cx="6180252" cy="4754880"/>
           </a:xfrm>
           <a:prstGeom prst="roundRect">
             <a:avLst/>
@@ -8466,7 +8448,7 @@
           <a:solidFill>
             <a:srgbClr val="FFFFFF"/>
           </a:solidFill>
-          <a:ln w="25400">
+          <a:ln w="31750">
             <a:solidFill>
               <a:srgbClr val="4F46E5"/>
             </a:solidFill>
@@ -8497,10 +8479,10 @@
       </p:sp>
       <p:pic>
         <p:nvPicPr>
-          <p:cNvPr id="11" name="Picture 10">
+          <p:cNvPr id="9" name="Picture 8">
             <a:extLst>
               <a:ext uri="{FF2B5EF4-FFF2-40B4-BE49-F238E27FC236}">
-                <a16:creationId xmlns:a16="http://schemas.microsoft.com/office/drawing/2014/main" id="{A3FAA9DB-B71C-0242-ABF1-1E5B7FB1BC38}"/>
+                <a16:creationId xmlns:a16="http://schemas.microsoft.com/office/drawing/2014/main" id="{D6DF4370-4A97-3D8C-F940-4C8F84BACDA4}"/>
               </a:ext>
             </a:extLst>
           </p:cNvPr>
@@ -8517,8 +8499,8 @@
         </p:blipFill>
         <p:spPr>
           <a:xfrm>
-            <a:off x="5913121" y="1740310"/>
-            <a:ext cx="4926034" cy="4493342"/>
+            <a:off x="5722223" y="1949330"/>
+            <a:ext cx="5295653" cy="4148060"/>
           </a:xfrm>
           <a:prstGeom prst="rect">
             <a:avLst/>
@@ -8723,7 +8705,7 @@
         <p:spPr>
           <a:xfrm>
             <a:off x="731520" y="1645920"/>
-            <a:ext cx="4440248" cy="4754880"/>
+            <a:ext cx="4568067" cy="4754880"/>
           </a:xfrm>
           <a:prstGeom prst="roundRect">
             <a:avLst/>
@@ -8763,6 +8745,7 @@
               </a:defRPr>
             </a:pPr>
             <a:r>
+              <a:rPr dirty="0"/>
               <a:t>KEY ARCHITECTURE &amp; HIGHLIGHTS:</a:t>
             </a:r>
           </a:p>
@@ -8778,7 +8761,16 @@
               </a:defRPr>
             </a:pPr>
             <a:r>
-              <a:t>🔹 Sign In Tab: Auto-trims email inputs and validates bcrypt password hash</a:t>
+              <a:rPr dirty="0"/>
+              <a:t>🔹 Sign In Tab: Auto-trims email inputs and validates </a:t>
+            </a:r>
+            <a:r>
+              <a:rPr dirty="0" err="1"/>
+              <a:t>bcrypt</a:t>
+            </a:r>
+            <a:r>
+              <a:rPr dirty="0"/>
+              <a:t> password hash</a:t>
             </a:r>
           </a:p>
           <a:p>
@@ -8793,6 +8785,7 @@
               </a:defRPr>
             </a:pPr>
             <a:r>
+              <a:rPr dirty="0"/>
               <a:t>🔹 Sign Up Tab: Self-registration for new employees into MySQL database</a:t>
             </a:r>
           </a:p>
@@ -8808,6 +8801,7 @@
               </a:defRPr>
             </a:pPr>
             <a:r>
+              <a:rPr dirty="0"/>
               <a:t>🔹 Role Routing: Automatic redirection to Employee (/), Manager (/manager), or Admin (/admin)</a:t>
             </a:r>
           </a:p>
@@ -8821,8 +8815,8 @@
         </p:nvSpPr>
         <p:spPr>
           <a:xfrm>
-            <a:off x="5348748" y="1645920"/>
-            <a:ext cx="6111427" cy="4754880"/>
+            <a:off x="5397910" y="1645920"/>
+            <a:ext cx="6062265" cy="4754880"/>
           </a:xfrm>
           <a:prstGeom prst="roundRect">
             <a:avLst/>
@@ -8830,7 +8824,7 @@
           <a:solidFill>
             <a:srgbClr val="FFFFFF"/>
           </a:solidFill>
-          <a:ln w="25400">
+          <a:ln w="31750">
             <a:solidFill>
               <a:srgbClr val="4F46E5"/>
             </a:solidFill>
@@ -8864,7 +8858,7 @@
           <p:cNvPr id="9" name="Picture 8">
             <a:extLst>
               <a:ext uri="{FF2B5EF4-FFF2-40B4-BE49-F238E27FC236}">
-                <a16:creationId xmlns:a16="http://schemas.microsoft.com/office/drawing/2014/main" id="{A4908E5F-827F-12A9-1F51-88D67C04AAF5}"/>
+                <a16:creationId xmlns:a16="http://schemas.microsoft.com/office/drawing/2014/main" id="{BE31E9B0-780C-FDF5-81B9-6C45F1F3D952}"/>
               </a:ext>
             </a:extLst>
           </p:cNvPr>
@@ -8881,8 +8875,8 @@
         </p:blipFill>
         <p:spPr>
           <a:xfrm>
-            <a:off x="5584722" y="2054942"/>
-            <a:ext cx="5683045" cy="3844413"/>
+            <a:off x="5624052" y="2133600"/>
+            <a:ext cx="5683045" cy="3696929"/>
           </a:xfrm>
           <a:prstGeom prst="rect">
             <a:avLst/>
@@ -9087,7 +9081,7 @@
         <p:spPr>
           <a:xfrm>
             <a:off x="731519" y="1645920"/>
-            <a:ext cx="4351757" cy="4754880"/>
+            <a:ext cx="4430415" cy="4754880"/>
           </a:xfrm>
           <a:prstGeom prst="roundRect">
             <a:avLst/>
@@ -9127,7 +9121,6 @@
               </a:defRPr>
             </a:pPr>
             <a:r>
-              <a:rPr dirty="0"/>
               <a:t>KEY ARCHITECTURE &amp; HIGHLIGHTS:</a:t>
             </a:r>
           </a:p>
@@ -9143,7 +9136,6 @@
               </a:defRPr>
             </a:pPr>
             <a:r>
-              <a:rPr dirty="0"/>
               <a:t>🔹 Default Open View: All rooms displayed immediately upon page load</a:t>
             </a:r>
           </a:p>
@@ -9159,7 +9151,6 @@
               </a:defRPr>
             </a:pPr>
             <a:r>
-              <a:rPr dirty="0"/>
               <a:t>🔹 Search Engine: Search rooms by designation or floor location</a:t>
             </a:r>
           </a:p>
@@ -9175,7 +9166,6 @@
               </a:defRPr>
             </a:pPr>
             <a:r>
-              <a:rPr dirty="0"/>
               <a:t>🔹 Filter Pills: Instant filtering by seats (All, 2-5, 6-12, 12+) or amenities</a:t>
             </a:r>
           </a:p>
@@ -9189,8 +9179,8 @@
         </p:nvSpPr>
         <p:spPr>
           <a:xfrm>
-            <a:off x="5201266" y="1645920"/>
-            <a:ext cx="6258910" cy="4754880"/>
+            <a:off x="5309420" y="1645920"/>
+            <a:ext cx="6150756" cy="4754880"/>
           </a:xfrm>
           <a:prstGeom prst="roundRect">
             <a:avLst/>
@@ -9198,7 +9188,7 @@
           <a:solidFill>
             <a:srgbClr val="FFFFFF"/>
           </a:solidFill>
-          <a:ln w="25400">
+          <a:ln w="31750">
             <a:solidFill>
               <a:srgbClr val="4F46E5"/>
             </a:solidFill>
@@ -9232,7 +9222,7 @@
           <p:cNvPr id="9" name="Picture 8">
             <a:extLst>
               <a:ext uri="{FF2B5EF4-FFF2-40B4-BE49-F238E27FC236}">
-                <a16:creationId xmlns:a16="http://schemas.microsoft.com/office/drawing/2014/main" id="{F831F723-62F6-36F4-19E9-0AA5144F4C21}"/>
+                <a16:creationId xmlns:a16="http://schemas.microsoft.com/office/drawing/2014/main" id="{28BFF6AE-73A0-FE73-631A-4257C60A837B}"/>
               </a:ext>
             </a:extLst>
           </p:cNvPr>
@@ -9249,8 +9239,8 @@
         </p:blipFill>
         <p:spPr>
           <a:xfrm>
-            <a:off x="5447071" y="2084440"/>
-            <a:ext cx="5791200" cy="3647766"/>
+            <a:off x="5476568" y="2123768"/>
+            <a:ext cx="5771535" cy="3746090"/>
           </a:xfrm>
           <a:prstGeom prst="rect">
             <a:avLst/>
@@ -9455,7 +9445,7 @@
         <p:spPr>
           <a:xfrm>
             <a:off x="731520" y="1645920"/>
-            <a:ext cx="4440248" cy="4754880"/>
+            <a:ext cx="4646725" cy="4754880"/>
           </a:xfrm>
           <a:prstGeom prst="roundRect">
             <a:avLst/>
@@ -9495,7 +9485,6 @@
               </a:defRPr>
             </a:pPr>
             <a:r>
-              <a:rPr dirty="0"/>
               <a:t>KEY ARCHITECTURE &amp; HIGHLIGHTS:</a:t>
             </a:r>
           </a:p>
@@ -9511,7 +9500,6 @@
               </a:defRPr>
             </a:pPr>
             <a:r>
-              <a:rPr dirty="0"/>
               <a:t>🔹 Computer File Picker: Admins click 'Choose File' to pick local photos</a:t>
             </a:r>
           </a:p>
@@ -9527,7 +9515,6 @@
               </a:defRPr>
             </a:pPr>
             <a:r>
-              <a:rPr dirty="0"/>
               <a:t>🔹 Base64 Conversion: Converts images to Data URLs stored in MySQL</a:t>
             </a:r>
           </a:p>
@@ -9543,7 +9530,6 @@
               </a:defRPr>
             </a:pPr>
             <a:r>
-              <a:rPr dirty="0"/>
               <a:t>🔹 Flexible Options: Web image links are also fully supported</a:t>
             </a:r>
           </a:p>
@@ -9557,8 +9543,8 @@
         </p:nvSpPr>
         <p:spPr>
           <a:xfrm>
-            <a:off x="5329084" y="1645920"/>
-            <a:ext cx="6131091" cy="4754880"/>
+            <a:off x="5525730" y="1645920"/>
+            <a:ext cx="5934446" cy="4754880"/>
           </a:xfrm>
           <a:prstGeom prst="roundRect">
             <a:avLst/>
@@ -9566,7 +9552,7 @@
           <a:solidFill>
             <a:srgbClr val="FFFFFF"/>
           </a:solidFill>
-          <a:ln w="25400">
+          <a:ln w="31750">
             <a:solidFill>
               <a:srgbClr val="4F46E5"/>
             </a:solidFill>
@@ -9600,7 +9586,7 @@
           <p:cNvPr id="9" name="Picture 8">
             <a:extLst>
               <a:ext uri="{FF2B5EF4-FFF2-40B4-BE49-F238E27FC236}">
-                <a16:creationId xmlns:a16="http://schemas.microsoft.com/office/drawing/2014/main" id="{F988D3C4-6BA1-E77D-00DF-4973980872C4}"/>
+                <a16:creationId xmlns:a16="http://schemas.microsoft.com/office/drawing/2014/main" id="{53816E3F-F386-F872-486C-A9302B378BEE}"/>
               </a:ext>
             </a:extLst>
           </p:cNvPr>
@@ -9611,15 +9597,15 @@
         </p:nvPicPr>
         <p:blipFill>
           <a:blip r:embed="rId2"/>
-          <a:srcRect b="2540"/>
+          <a:srcRect b="2502"/>
           <a:stretch>
             <a:fillRect/>
           </a:stretch>
         </p:blipFill>
         <p:spPr>
           <a:xfrm>
-            <a:off x="5936564" y="1996211"/>
-            <a:ext cx="4916129" cy="4054298"/>
+            <a:off x="6302477" y="1895807"/>
+            <a:ext cx="4454013" cy="4328012"/>
           </a:xfrm>
           <a:prstGeom prst="rect">
             <a:avLst/>
@@ -9823,8 +9809,8 @@
         </p:nvSpPr>
         <p:spPr>
           <a:xfrm>
-            <a:off x="731520" y="1645920"/>
-            <a:ext cx="4358434" cy="4754880"/>
+            <a:off x="731519" y="1645920"/>
+            <a:ext cx="4705719" cy="4754880"/>
           </a:xfrm>
           <a:prstGeom prst="roundRect">
             <a:avLst/>
@@ -9922,8 +9908,8 @@
         </p:nvSpPr>
         <p:spPr>
           <a:xfrm>
-            <a:off x="5250426" y="1645920"/>
-            <a:ext cx="6209749" cy="4754880"/>
+            <a:off x="5555226" y="1645920"/>
+            <a:ext cx="5904949" cy="4754880"/>
           </a:xfrm>
           <a:prstGeom prst="roundRect">
             <a:avLst/>
@@ -9931,7 +9917,7 @@
           <a:solidFill>
             <a:srgbClr val="FFFFFF"/>
           </a:solidFill>
-          <a:ln w="25400">
+          <a:ln w="31750">
             <a:solidFill>
               <a:srgbClr val="4F46E5"/>
             </a:solidFill>
@@ -9965,7 +9951,7 @@
           <p:cNvPr id="9" name="Picture 8">
             <a:extLst>
               <a:ext uri="{FF2B5EF4-FFF2-40B4-BE49-F238E27FC236}">
-                <a16:creationId xmlns:a16="http://schemas.microsoft.com/office/drawing/2014/main" id="{FCD46FDE-DE2E-2C58-A759-FB842293CCEB}"/>
+                <a16:creationId xmlns:a16="http://schemas.microsoft.com/office/drawing/2014/main" id="{A225A11A-1D12-5226-3C68-E4111DA50F12}"/>
               </a:ext>
             </a:extLst>
           </p:cNvPr>
@@ -9982,8 +9968,8 @@
         </p:blipFill>
         <p:spPr>
           <a:xfrm>
-            <a:off x="6520061" y="1917923"/>
-            <a:ext cx="3834580" cy="4210873"/>
+            <a:off x="6661050" y="1974886"/>
+            <a:ext cx="3726426" cy="4271406"/>
           </a:xfrm>
           <a:prstGeom prst="rect">
             <a:avLst/>
@@ -10188,7 +10174,7 @@
         <p:spPr>
           <a:xfrm>
             <a:off x="731520" y="1645920"/>
-            <a:ext cx="4440248" cy="4754880"/>
+            <a:ext cx="4636893" cy="4754880"/>
           </a:xfrm>
           <a:prstGeom prst="roundRect">
             <a:avLst/>
@@ -10286,8 +10272,8 @@
         </p:nvSpPr>
         <p:spPr>
           <a:xfrm>
-            <a:off x="5378246" y="1645920"/>
-            <a:ext cx="6081930" cy="4754880"/>
+            <a:off x="5535562" y="1645920"/>
+            <a:ext cx="5924614" cy="4754880"/>
           </a:xfrm>
           <a:prstGeom prst="roundRect">
             <a:avLst/>
@@ -10295,7 +10281,7 @@
           <a:solidFill>
             <a:srgbClr val="FFFFFF"/>
           </a:solidFill>
-          <a:ln w="25400">
+          <a:ln w="31750">
             <a:solidFill>
               <a:srgbClr val="4F46E5"/>
             </a:solidFill>
@@ -10329,7 +10315,7 @@
           <p:cNvPr id="9" name="Picture 8">
             <a:extLst>
               <a:ext uri="{FF2B5EF4-FFF2-40B4-BE49-F238E27FC236}">
-                <a16:creationId xmlns:a16="http://schemas.microsoft.com/office/drawing/2014/main" id="{4530877D-9C0B-F80A-3AC0-53119E655FE0}"/>
+                <a16:creationId xmlns:a16="http://schemas.microsoft.com/office/drawing/2014/main" id="{AA86128B-68CD-B1A5-A01A-32D3B93708E3}"/>
               </a:ext>
             </a:extLst>
           </p:cNvPr>
@@ -10346,8 +10332,8 @@
         </p:blipFill>
         <p:spPr>
           <a:xfrm>
-            <a:off x="5537528" y="2566219"/>
-            <a:ext cx="5763366" cy="2880852"/>
+            <a:off x="5722374" y="2507226"/>
+            <a:ext cx="5515897" cy="2930013"/>
           </a:xfrm>
           <a:prstGeom prst="rect">
             <a:avLst/>

</xml_diff>